<commit_message>
study(version-control): 加 TOC 與 Recap、去縮寫、地圖標非窮舉
- 標題後加「本場大綱」TOC（兩段 + 隨堂考），結尾 Takeaways 改為 Recap 對映兩段
- Fetch 舉例改用全名（consumer/replica、client↔broker/broker↔broker），不用 cb/bb
- 地圖標明 broker↔controller 等各列為代表性、非窮舉（加 AlterPartition、轉發 admin…）；16 張
- talk-outline.md 同步
</commit_message>
<xml_diff>
--- a/study/version-control/kafka-version-negotiation.pptx
+++ b/study/version-control/kafka-version-negotiation.pptx
@@ -20,6 +20,7 @@
     <p:sldId id="268" r:id="rId19"/>
     <p:sldId id="269" r:id="rId20"/>
     <p:sldId id="270" r:id="rId21"/>
+    <p:sldId id="271" r:id="rId22"/>
   </p:sldIdLst>
   <p:sldSz cx="12191695" cy="6858000" type="screen4x3"/>
   <p:notesSz cx="6858000" cy="9144000"/>
@@ -3328,7 +3329,7 @@
                 </a:solidFill>
                 <a:latin typeface="Calibri"/>
               </a:rPr>
-              <a:t>隨堂考 · 核心　（正解）</a:t>
+              <a:t>隨堂考 · 核心</a:t>
             </a:r>
           </a:p>
         </p:txBody>
@@ -3424,36 +3425,31 @@
           <a:prstGeom prst="rect">
             <a:avLst/>
           </a:prstGeom>
-          <a:solidFill>
-            <a:srgbClr val="E9F3DE"/>
-          </a:solidFill>
-          <a:ln>
-            <a:noFill/>
-          </a:ln>
-        </p:spPr>
-        <p:txBody>
-          <a:bodyPr wrap="square" lIns="128016" tIns="54864">
-            <a:noAutofit/>
-          </a:bodyPr>
-          <a:lstStyle/>
-          <a:p>
-            <a:r>
-              <a:rPr sz="1600" b="1">
-                <a:solidFill>
-                  <a:srgbClr val="27500A"/>
+          <a:noFill/>
+        </p:spPr>
+        <p:txBody>
+          <a:bodyPr wrap="square">
+            <a:noAutofit/>
+          </a:bodyPr>
+          <a:lstStyle/>
+          <a:p>
+            <a:r>
+              <a:rPr sz="1600" b="0">
+                <a:solidFill>
+                  <a:srgbClr val="1E2024"/>
                 </a:solidFill>
                 <a:latin typeface="Calibri"/>
               </a:rPr>
               <a:t>B.  </a:t>
             </a:r>
             <a:r>
-              <a:rPr sz="1600" b="1">
-                <a:solidFill>
-                  <a:srgbClr val="27500A"/>
-                </a:solidFill>
-                <a:latin typeface="Calibri"/>
-              </a:rPr>
-              <a:t>由 finalized metadata.version 決定   ✓</a:t>
+              <a:rPr sz="1600" b="0">
+                <a:solidFill>
+                  <a:srgbClr val="1E2024"/>
+                </a:solidFill>
+                <a:latin typeface="Calibri"/>
+              </a:rPr>
+              <a:t>由 finalized metadata.version 決定</a:t>
             </a:r>
           </a:p>
         </p:txBody>
@@ -3567,85 +3563,13 @@
           <a:lstStyle/>
           <a:p>
             <a:r>
-              <a:rPr sz="1400" b="1">
-                <a:solidFill>
-                  <a:srgbClr val="27500A"/>
-                </a:solidFill>
-                <a:latin typeface="Calibri"/>
-              </a:rPr>
-              <a:t>正解 B — </a:t>
-            </a:r>
-            <a:r>
               <a:rPr sz="1400" b="0">
                 <a:solidFill>
-                  <a:srgbClr val="1E2024"/>
-                </a:solidFill>
-                <a:latin typeface="Calibri"/>
-              </a:rPr>
-              <a:t>fetchRequestVersion(MV)：MV 是集中共識，不做 per-connection 協商。</a:t>
-            </a:r>
-          </a:p>
-        </p:txBody>
-      </p:sp>
-      <p:sp>
-        <p:nvSpPr>
-          <p:cNvPr id="9" name="TextBox 8"/>
-          <p:cNvSpPr txBox="1"/>
-          <p:nvPr/>
-        </p:nvSpPr>
-        <p:spPr>
-          <a:xfrm>
-            <a:off x="640080" y="6400800"/>
-            <a:ext cx="10972800" cy="384048"/>
-          </a:xfrm>
-          <a:prstGeom prst="rect">
-            <a:avLst/>
-          </a:prstGeom>
-          <a:noFill/>
-        </p:spPr>
-        <p:txBody>
-          <a:bodyPr wrap="square">
-            <a:noAutofit/>
-          </a:bodyPr>
-          <a:lstStyle/>
-          <a:p>
-            <a:r>
-              <a:rPr sz="1200" b="1">
-                <a:solidFill>
                   <a:srgbClr val="8A8A8A"/>
                 </a:solidFill>
                 <a:latin typeface="Calibri"/>
               </a:rPr>
-              <a:t>REF   </a:t>
-            </a:r>
-            <a:r>
-              <a:rPr sz="1200" b="0" u="sng">
-                <a:solidFill>
-                  <a:srgbClr val="185FA5"/>
-                </a:solidFill>
-                <a:latin typeface="Courier New"/>
-                <a:hlinkClick r:id="rId2"/>
-              </a:rPr>
-              <a:t>RemoteLeaderEndPoint.scala:215</a:t>
-            </a:r>
-            <a:r>
-              <a:rPr sz="1200" b="0">
-                <a:solidFill>
-                  <a:srgbClr val="8A8A8A"/>
-                </a:solidFill>
-                <a:latin typeface="Calibri"/>
-              </a:rPr>
-              <a:t>   ·   </a:t>
-            </a:r>
-            <a:r>
-              <a:rPr sz="1200" b="0" u="sng">
-                <a:solidFill>
-                  <a:srgbClr val="185FA5"/>
-                </a:solidFill>
-                <a:latin typeface="Courier New"/>
-                <a:hlinkClick r:id="rId3"/>
-              </a:rPr>
-              <a:t>MetadataVersion.java:273</a:t>
+              <a:t>想一想 —— 下一頁公布答案</a:t>
             </a:r>
           </a:p>
         </p:txBody>
@@ -3697,7 +3621,7 @@
                 </a:solidFill>
                 <a:latin typeface="Calibri"/>
               </a:rPr>
-              <a:t>Part 2 · 失敗訊息</a:t>
+              <a:t>隨堂考 · 核心　（正解）</a:t>
             </a:r>
           </a:p>
         </p:txBody>
@@ -3711,27 +3635,27 @@
         <p:spPr>
           <a:xfrm>
             <a:off x="640080" y="841248"/>
-            <a:ext cx="10972800" cy="1005840"/>
-          </a:xfrm>
-          <a:prstGeom prst="rect">
-            <a:avLst/>
-          </a:prstGeom>
-          <a:noFill/>
-        </p:spPr>
-        <p:txBody>
-          <a:bodyPr wrap="square">
-            <a:noAutofit/>
-          </a:bodyPr>
-          <a:lstStyle/>
-          <a:p>
-            <a:r>
-              <a:rPr sz="3200" b="1">
+            <a:ext cx="10972800" cy="1188720"/>
+          </a:xfrm>
+          <a:prstGeom prst="rect">
+            <a:avLst/>
+          </a:prstGeom>
+          <a:noFill/>
+        </p:spPr>
+        <p:txBody>
+          <a:bodyPr wrap="square">
+            <a:noAutofit/>
+          </a:bodyPr>
+          <a:lstStyle/>
+          <a:p>
+            <a:r>
+              <a:rPr sz="2600" b="1">
                 <a:solidFill>
                   <a:srgbClr val="1E2024"/>
                 </a:solidFill>
                 <a:latin typeface="Calibri"/>
               </a:rPr>
-              <a:t>通訊當下協商不出版本，會看到什麼</a:t>
+              <a:t>replica fetch（broker↔broker）的 Fetch 版本怎麼決定？</a:t>
             </a:r>
           </a:p>
         </p:txBody>
@@ -3744,85 +3668,89 @@
         </p:nvSpPr>
         <p:spPr>
           <a:xfrm>
-            <a:off x="640080" y="2148840"/>
-            <a:ext cx="10972800" cy="1371600"/>
+            <a:off x="822960" y="2331720"/>
+            <a:ext cx="10515600" cy="493776"/>
+          </a:xfrm>
+          <a:prstGeom prst="rect">
+            <a:avLst/>
+          </a:prstGeom>
+          <a:noFill/>
+        </p:spPr>
+        <p:txBody>
+          <a:bodyPr wrap="square">
+            <a:noAutofit/>
+          </a:bodyPr>
+          <a:lstStyle/>
+          <a:p>
+            <a:r>
+              <a:rPr sz="1600" b="0">
+                <a:solidFill>
+                  <a:srgbClr val="1E2024"/>
+                </a:solidFill>
+                <a:latin typeface="Calibri"/>
+              </a:rPr>
+              <a:t>A.  </a:t>
+            </a:r>
+            <a:r>
+              <a:rPr sz="1600" b="0">
+                <a:solidFill>
+                  <a:srgbClr val="1E2024"/>
+                </a:solidFill>
+                <a:latin typeface="Calibri"/>
+              </a:rPr>
+              <a:t>兩 broker ApiVersions 協商取交集</a:t>
+            </a:r>
+          </a:p>
+        </p:txBody>
+      </p:sp>
+      <p:sp>
+        <p:nvSpPr>
+          <p:cNvPr id="5" name="TextBox 4"/>
+          <p:cNvSpPr txBox="1"/>
+          <p:nvPr/>
+        </p:nvSpPr>
+        <p:spPr>
+          <a:xfrm>
+            <a:off x="822960" y="2953512"/>
+            <a:ext cx="10515600" cy="493776"/>
           </a:xfrm>
           <a:prstGeom prst="rect">
             <a:avLst/>
           </a:prstGeom>
           <a:solidFill>
-            <a:srgbClr val="F3F1EC"/>
+            <a:srgbClr val="E9F3DE"/>
           </a:solidFill>
-          <a:ln w="6350">
-            <a:solidFill>
-              <a:srgbClr val="E3E0D8"/>
-            </a:solidFill>
+          <a:ln>
+            <a:noFill/>
           </a:ln>
         </p:spPr>
         <p:txBody>
-          <a:bodyPr wrap="square" lIns="146304" tIns="91440" bIns="91440">
-            <a:noAutofit/>
-          </a:bodyPr>
-          <a:lstStyle/>
-          <a:p>
-            <a:r>
-              <a:rPr sz="1350" b="0">
-                <a:solidFill>
-                  <a:srgbClr val="2C2C2A"/>
-                </a:solidFill>
-                <a:latin typeface="Calibri"/>
-              </a:rPr>
-              <a:t>交集空        → client 端 UnsupportedVersionException（送出前 abort）</a:t>
-            </a:r>
-          </a:p>
-          <a:p>
-            <a:r>
-              <a:rPr sz="1350" b="0">
-                <a:solidFill>
-                  <a:srgbClr val="2C2C2A"/>
-                </a:solidFill>
-                <a:latin typeface="Calibri"/>
-              </a:rPr>
-              <a:t>繞過協商自刻  → broker 丟 UnsupportedVersionException + 關線</a:t>
-            </a:r>
-          </a:p>
-          <a:p>
-            <a:r>
-              <a:rPr sz="1350" b="0">
-                <a:solidFill>
-                  <a:srgbClr val="2C2C2A"/>
-                </a:solidFill>
-                <a:latin typeface="Calibri"/>
-              </a:rPr>
-              <a:t>（ApiVersions 例外：回 v0 + UNSUPPORTED_VERSION 錯誤碼）</a:t>
-            </a:r>
-          </a:p>
-        </p:txBody>
-      </p:sp>
-      <p:pic>
-        <p:nvPicPr>
-          <p:cNvPr id="5" name="Picture 4" descr="ban.png"/>
-          <p:cNvPicPr>
-            <a:picLocks noChangeAspect="1"/>
-          </p:cNvPicPr>
-          <p:nvPr/>
-        </p:nvPicPr>
-        <p:blipFill>
-          <a:blip r:embed="rId2"/>
-          <a:stretch>
-            <a:fillRect/>
-          </a:stretch>
-        </p:blipFill>
-        <p:spPr>
-          <a:xfrm>
-            <a:off x="658368" y="3749040"/>
-            <a:ext cx="274320" cy="274320"/>
-          </a:xfrm>
-          <a:prstGeom prst="rect">
-            <a:avLst/>
-          </a:prstGeom>
-        </p:spPr>
-      </p:pic>
+          <a:bodyPr wrap="square" lIns="128016" tIns="54864">
+            <a:noAutofit/>
+          </a:bodyPr>
+          <a:lstStyle/>
+          <a:p>
+            <a:r>
+              <a:rPr sz="1600" b="1">
+                <a:solidFill>
+                  <a:srgbClr val="27500A"/>
+                </a:solidFill>
+                <a:latin typeface="Calibri"/>
+              </a:rPr>
+              <a:t>B.  </a:t>
+            </a:r>
+            <a:r>
+              <a:rPr sz="1600" b="1">
+                <a:solidFill>
+                  <a:srgbClr val="27500A"/>
+                </a:solidFill>
+                <a:latin typeface="Calibri"/>
+              </a:rPr>
+              <a:t>由 finalized metadata.version 決定   ✓</a:t>
+            </a:r>
+          </a:p>
+        </p:txBody>
+      </p:sp>
       <p:sp>
         <p:nvSpPr>
           <p:cNvPr id="6" name="TextBox 5"/>
@@ -3831,7 +3759,7 @@
         </p:nvSpPr>
         <p:spPr>
           <a:xfrm>
-            <a:off x="1078992" y="3721608"/>
+            <a:off x="822960" y="3575304"/>
             <a:ext cx="10515600" cy="493776"/>
           </a:xfrm>
           <a:prstGeom prst="rect">
@@ -3846,13 +3774,22 @@
           <a:lstStyle/>
           <a:p>
             <a:r>
-              <a:rPr sz="1650" b="0">
+              <a:rPr sz="1600" b="0">
                 <a:solidFill>
                   <a:srgbClr val="1E2024"/>
                 </a:solidFill>
                 <a:latin typeface="Calibri"/>
               </a:rPr>
-              <a:t>多數情況 client 在送出前就本地中止，根本沒上網路</a:t>
+              <a:t>C.  </a:t>
+            </a:r>
+            <a:r>
+              <a:rPr sz="1600" b="0">
+                <a:solidFill>
+                  <a:srgbClr val="1E2024"/>
+                </a:solidFill>
+                <a:latin typeface="Calibri"/>
+              </a:rPr>
+              <a:t>永遠用最新版</a:t>
             </a:r>
           </a:p>
         </p:txBody>
@@ -3860,6 +3797,92 @@
       <p:sp>
         <p:nvSpPr>
           <p:cNvPr id="7" name="TextBox 6"/>
+          <p:cNvSpPr txBox="1"/>
+          <p:nvPr/>
+        </p:nvSpPr>
+        <p:spPr>
+          <a:xfrm>
+            <a:off x="822960" y="4197096"/>
+            <a:ext cx="10515600" cy="493776"/>
+          </a:xfrm>
+          <a:prstGeom prst="rect">
+            <a:avLst/>
+          </a:prstGeom>
+          <a:noFill/>
+        </p:spPr>
+        <p:txBody>
+          <a:bodyPr wrap="square">
+            <a:noAutofit/>
+          </a:bodyPr>
+          <a:lstStyle/>
+          <a:p>
+            <a:r>
+              <a:rPr sz="1600" b="0">
+                <a:solidFill>
+                  <a:srgbClr val="1E2024"/>
+                </a:solidFill>
+                <a:latin typeface="Calibri"/>
+              </a:rPr>
+              <a:t>D.  </a:t>
+            </a:r>
+            <a:r>
+              <a:rPr sz="1600" b="0">
+                <a:solidFill>
+                  <a:srgbClr val="1E2024"/>
+                </a:solidFill>
+                <a:latin typeface="Calibri"/>
+              </a:rPr>
+              <a:t>controller 每次指定</a:t>
+            </a:r>
+          </a:p>
+        </p:txBody>
+      </p:sp>
+      <p:sp>
+        <p:nvSpPr>
+          <p:cNvPr id="8" name="TextBox 7"/>
+          <p:cNvSpPr txBox="1"/>
+          <p:nvPr/>
+        </p:nvSpPr>
+        <p:spPr>
+          <a:xfrm>
+            <a:off x="640080" y="4910327"/>
+            <a:ext cx="10972800" cy="914400"/>
+          </a:xfrm>
+          <a:prstGeom prst="rect">
+            <a:avLst/>
+          </a:prstGeom>
+          <a:noFill/>
+        </p:spPr>
+        <p:txBody>
+          <a:bodyPr wrap="square">
+            <a:noAutofit/>
+          </a:bodyPr>
+          <a:lstStyle/>
+          <a:p>
+            <a:r>
+              <a:rPr sz="1400" b="1">
+                <a:solidFill>
+                  <a:srgbClr val="27500A"/>
+                </a:solidFill>
+                <a:latin typeface="Calibri"/>
+              </a:rPr>
+              <a:t>正解 B — </a:t>
+            </a:r>
+            <a:r>
+              <a:rPr sz="1400" b="0">
+                <a:solidFill>
+                  <a:srgbClr val="1E2024"/>
+                </a:solidFill>
+                <a:latin typeface="Calibri"/>
+              </a:rPr>
+              <a:t>fetchRequestVersion(MV)：MV 是集中共識，不做 per-connection 協商。</a:t>
+            </a:r>
+          </a:p>
+        </p:txBody>
+      </p:sp>
+      <p:sp>
+        <p:nvSpPr>
+          <p:cNvPr id="9" name="TextBox 8"/>
           <p:cNvSpPr txBox="1"/>
           <p:nvPr/>
         </p:nvSpPr>
@@ -3894,47 +3917,28 @@
                   <a:srgbClr val="185FA5"/>
                 </a:solidFill>
                 <a:latin typeface="Courier New"/>
+                <a:hlinkClick r:id="rId2"/>
+              </a:rPr>
+              <a:t>RemoteLeaderEndPoint.scala:215</a:t>
+            </a:r>
+            <a:r>
+              <a:rPr sz="1200" b="0">
+                <a:solidFill>
+                  <a:srgbClr val="8A8A8A"/>
+                </a:solidFill>
+                <a:latin typeface="Calibri"/>
+              </a:rPr>
+              <a:t>   ·   </a:t>
+            </a:r>
+            <a:r>
+              <a:rPr sz="1200" b="0" u="sng">
+                <a:solidFill>
+                  <a:srgbClr val="185FA5"/>
+                </a:solidFill>
+                <a:latin typeface="Courier New"/>
                 <a:hlinkClick r:id="rId3"/>
               </a:rPr>
-              <a:t>latestUsableVersion</a:t>
-            </a:r>
-            <a:r>
-              <a:rPr sz="1200" b="0">
-                <a:solidFill>
-                  <a:srgbClr val="8A8A8A"/>
-                </a:solidFill>
-                <a:latin typeface="Calibri"/>
-              </a:rPr>
-              <a:t>   ·   </a:t>
-            </a:r>
-            <a:r>
-              <a:rPr sz="1200" b="0" u="sng">
-                <a:solidFill>
-                  <a:srgbClr val="185FA5"/>
-                </a:solidFill>
-                <a:latin typeface="Courier New"/>
-                <a:hlinkClick r:id="rId4"/>
-              </a:rPr>
-              <a:t>NetworkClient</a:t>
-            </a:r>
-            <a:r>
-              <a:rPr sz="1200" b="0">
-                <a:solidFill>
-                  <a:srgbClr val="8A8A8A"/>
-                </a:solidFill>
-                <a:latin typeface="Calibri"/>
-              </a:rPr>
-              <a:t>   ·   </a:t>
-            </a:r>
-            <a:r>
-              <a:rPr sz="1200" b="0" u="sng">
-                <a:solidFill>
-                  <a:srgbClr val="185FA5"/>
-                </a:solidFill>
-                <a:latin typeface="Courier New"/>
-                <a:hlinkClick r:id="rId5"/>
-              </a:rPr>
-              <a:t>RequestContext</a:t>
+              <a:t>MetadataVersion.java:273</a:t>
             </a:r>
           </a:p>
         </p:txBody>
@@ -4020,7 +4024,7 @@
                 </a:solidFill>
                 <a:latin typeface="Calibri"/>
               </a:rPr>
-              <a:t>版本截斷：為什麼「升一點點」不夠</a:t>
+              <a:t>通訊當下協商不出版本，會看到什麼</a:t>
             </a:r>
           </a:p>
         </p:txBody>
@@ -4034,7 +4038,7 @@
         <p:spPr>
           <a:xfrm>
             <a:off x="640080" y="2148840"/>
-            <a:ext cx="10972800" cy="822959"/>
+            <a:ext cx="10972800" cy="1371600"/>
           </a:xfrm>
           <a:prstGeom prst="rect">
             <a:avLst/>
@@ -4061,7 +4065,7 @@
                 </a:solidFill>
                 <a:latin typeface="Calibri"/>
               </a:rPr>
-              <a:t>舊 wire API version 被整個移除，min 可 &gt; 0</a:t>
+              <a:t>交集空        → client 端 UnsupportedVersionException（送出前 abort）</a:t>
             </a:r>
           </a:p>
           <a:p>
@@ -4072,50 +4076,46 @@
                 </a:solidFill>
                 <a:latin typeface="Calibri"/>
               </a:rPr>
-              <a:t>  Fetch：4–18（v0–3 在 4.0 移除）</a:t>
-            </a:r>
-          </a:p>
-        </p:txBody>
-      </p:sp>
-      <p:sp>
-        <p:nvSpPr>
-          <p:cNvPr id="5" name="TextBox 4"/>
-          <p:cNvSpPr txBox="1"/>
-          <p:nvPr/>
-        </p:nvSpPr>
-        <p:spPr>
-          <a:xfrm>
-            <a:off x="640080" y="3172968"/>
-            <a:ext cx="10972800" cy="566928"/>
-          </a:xfrm>
-          <a:prstGeom prst="rect">
-            <a:avLst/>
-          </a:prstGeom>
-          <a:solidFill>
-            <a:srgbClr val="E9F3DE"/>
-          </a:solidFill>
-          <a:ln>
-            <a:noFill/>
-          </a:ln>
-        </p:spPr>
-        <p:txBody>
-          <a:bodyPr wrap="square" lIns="146304" tIns="82296">
-            <a:noAutofit/>
-          </a:bodyPr>
-          <a:lstStyle/>
-          <a:p>
-            <a:r>
-              <a:rPr sz="1500" b="0">
-                <a:solidFill>
-                  <a:srgbClr val="27500A"/>
-                </a:solidFill>
-                <a:latin typeface="Calibri"/>
-              </a:rPr>
-              <a:t>解法：升級前確認兩端都跨過版本下限（升 4.0 需至少 2.1），否則協商結果沒有可用版本</a:t>
-            </a:r>
-          </a:p>
-        </p:txBody>
-      </p:sp>
+              <a:t>繞過協商自刻  → broker 丟 UnsupportedVersionException + 關線</a:t>
+            </a:r>
+          </a:p>
+          <a:p>
+            <a:r>
+              <a:rPr sz="1350" b="0">
+                <a:solidFill>
+                  <a:srgbClr val="2C2C2A"/>
+                </a:solidFill>
+                <a:latin typeface="Calibri"/>
+              </a:rPr>
+              <a:t>（ApiVersions 例外：回 v0 + UNSUPPORTED_VERSION 錯誤碼）</a:t>
+            </a:r>
+          </a:p>
+        </p:txBody>
+      </p:sp>
+      <p:pic>
+        <p:nvPicPr>
+          <p:cNvPr id="5" name="Picture 4" descr="ban.png"/>
+          <p:cNvPicPr>
+            <a:picLocks noChangeAspect="1"/>
+          </p:cNvPicPr>
+          <p:nvPr/>
+        </p:nvPicPr>
+        <p:blipFill>
+          <a:blip r:embed="rId2"/>
+          <a:stretch>
+            <a:fillRect/>
+          </a:stretch>
+        </p:blipFill>
+        <p:spPr>
+          <a:xfrm>
+            <a:off x="658368" y="3749040"/>
+            <a:ext cx="274320" cy="274320"/>
+          </a:xfrm>
+          <a:prstGeom prst="rect">
+            <a:avLst/>
+          </a:prstGeom>
+        </p:spPr>
+      </p:pic>
       <p:sp>
         <p:nvSpPr>
           <p:cNvPr id="6" name="TextBox 5"/>
@@ -4124,28 +4124,28 @@
         </p:nvSpPr>
         <p:spPr>
           <a:xfrm>
-            <a:off x="640080" y="3922776"/>
-            <a:ext cx="10972800" cy="731520"/>
-          </a:xfrm>
-          <a:prstGeom prst="rect">
-            <a:avLst/>
-          </a:prstGeom>
-          <a:noFill/>
-        </p:spPr>
-        <p:txBody>
-          <a:bodyPr wrap="square">
-            <a:noAutofit/>
-          </a:bodyPr>
-          <a:lstStyle/>
-          <a:p>
-            <a:r>
-              <a:rPr sz="1500" b="0">
-                <a:solidFill>
-                  <a:srgbClr val="5F5E5A"/>
-                </a:solidFill>
-                <a:latin typeface="Calibri"/>
-              </a:rPr>
-              <a:t>銜接（非本場）：finalize / 升降當下的錯誤（INVALID_UPDATE_VERSION 等）屬「運行時的版本升降」那場，本場不展開。</a:t>
+            <a:off x="1078992" y="3721608"/>
+            <a:ext cx="10515600" cy="493776"/>
+          </a:xfrm>
+          <a:prstGeom prst="rect">
+            <a:avLst/>
+          </a:prstGeom>
+          <a:noFill/>
+        </p:spPr>
+        <p:txBody>
+          <a:bodyPr wrap="square">
+            <a:noAutofit/>
+          </a:bodyPr>
+          <a:lstStyle/>
+          <a:p>
+            <a:r>
+              <a:rPr sz="1650" b="0">
+                <a:solidFill>
+                  <a:srgbClr val="1E2024"/>
+                </a:solidFill>
+                <a:latin typeface="Calibri"/>
+              </a:rPr>
+              <a:t>多數情況 client 在送出前就本地中止，根本沒上網路</a:t>
             </a:r>
           </a:p>
         </p:txBody>
@@ -4187,9 +4187,9 @@
                   <a:srgbClr val="185FA5"/>
                 </a:solidFill>
                 <a:latin typeface="Courier New"/>
-                <a:hlinkClick r:id="rId2"/>
-              </a:rPr>
-              <a:t>upgrade.md:229</a:t>
+                <a:hlinkClick r:id="rId3"/>
+              </a:rPr>
+              <a:t>latestUsableVersion</a:t>
             </a:r>
             <a:r>
               <a:rPr sz="1200" b="0">
@@ -4206,9 +4206,28 @@
                   <a:srgbClr val="185FA5"/>
                 </a:solidFill>
                 <a:latin typeface="Courier New"/>
-                <a:hlinkClick r:id="rId3"/>
-              </a:rPr>
-              <a:t>FetchRequest.json validVersions</a:t>
+                <a:hlinkClick r:id="rId4"/>
+              </a:rPr>
+              <a:t>NetworkClient</a:t>
+            </a:r>
+            <a:r>
+              <a:rPr sz="1200" b="0">
+                <a:solidFill>
+                  <a:srgbClr val="8A8A8A"/>
+                </a:solidFill>
+                <a:latin typeface="Calibri"/>
+              </a:rPr>
+              <a:t>   ·   </a:t>
+            </a:r>
+            <a:r>
+              <a:rPr sz="1200" b="0" u="sng">
+                <a:solidFill>
+                  <a:srgbClr val="185FA5"/>
+                </a:solidFill>
+                <a:latin typeface="Courier New"/>
+                <a:hlinkClick r:id="rId5"/>
+              </a:rPr>
+              <a:t>RequestContext</a:t>
             </a:r>
           </a:p>
         </p:txBody>
@@ -4260,7 +4279,7 @@
                 </a:solidFill>
                 <a:latin typeface="Calibri"/>
               </a:rPr>
-              <a:t>隨堂考 · 核心</a:t>
+              <a:t>Part 2 · 失敗訊息</a:t>
             </a:r>
           </a:p>
         </p:txBody>
@@ -4274,27 +4293,27 @@
         <p:spPr>
           <a:xfrm>
             <a:off x="640080" y="841248"/>
-            <a:ext cx="10972800" cy="1188720"/>
-          </a:xfrm>
-          <a:prstGeom prst="rect">
-            <a:avLst/>
-          </a:prstGeom>
-          <a:noFill/>
-        </p:spPr>
-        <p:txBody>
-          <a:bodyPr wrap="square">
-            <a:noAutofit/>
-          </a:bodyPr>
-          <a:lstStyle/>
-          <a:p>
-            <a:r>
-              <a:rPr sz="2600" b="1">
+            <a:ext cx="10972800" cy="1005840"/>
+          </a:xfrm>
+          <a:prstGeom prst="rect">
+            <a:avLst/>
+          </a:prstGeom>
+          <a:noFill/>
+        </p:spPr>
+        <p:txBody>
+          <a:bodyPr wrap="square">
+            <a:noAutofit/>
+          </a:bodyPr>
+          <a:lstStyle/>
+          <a:p>
+            <a:r>
+              <a:rPr sz="3200" b="1">
                 <a:solidFill>
                   <a:srgbClr val="1E2024"/>
                 </a:solidFill>
                 <a:latin typeface="Calibri"/>
               </a:rPr>
-              <a:t>自刻 client 送了不支援的 API version，會怎樣？</a:t>
+              <a:t>版本截斷：為什麼「升一點點」不夠</a:t>
             </a:r>
           </a:p>
         </p:txBody>
@@ -4307,37 +4326,46 @@
         </p:nvSpPr>
         <p:spPr>
           <a:xfrm>
-            <a:off x="822960" y="2331720"/>
-            <a:ext cx="10515600" cy="493776"/>
-          </a:xfrm>
-          <a:prstGeom prst="rect">
-            <a:avLst/>
-          </a:prstGeom>
-          <a:noFill/>
-        </p:spPr>
-        <p:txBody>
-          <a:bodyPr wrap="square">
-            <a:noAutofit/>
-          </a:bodyPr>
-          <a:lstStyle/>
-          <a:p>
-            <a:r>
-              <a:rPr sz="1600" b="0">
-                <a:solidFill>
-                  <a:srgbClr val="1E2024"/>
-                </a:solidFill>
-                <a:latin typeface="Calibri"/>
-              </a:rPr>
-              <a:t>A.  </a:t>
-            </a:r>
-            <a:r>
-              <a:rPr sz="1600" b="0">
-                <a:solidFill>
-                  <a:srgbClr val="1E2024"/>
-                </a:solidFill>
-                <a:latin typeface="Calibri"/>
-              </a:rPr>
-              <a:t>一律回 UNSUPPORTED_VERSION</a:t>
+            <a:off x="640080" y="2148840"/>
+            <a:ext cx="10972800" cy="822959"/>
+          </a:xfrm>
+          <a:prstGeom prst="rect">
+            <a:avLst/>
+          </a:prstGeom>
+          <a:solidFill>
+            <a:srgbClr val="F3F1EC"/>
+          </a:solidFill>
+          <a:ln w="6350">
+            <a:solidFill>
+              <a:srgbClr val="E3E0D8"/>
+            </a:solidFill>
+          </a:ln>
+        </p:spPr>
+        <p:txBody>
+          <a:bodyPr wrap="square" lIns="146304" tIns="91440" bIns="91440">
+            <a:noAutofit/>
+          </a:bodyPr>
+          <a:lstStyle/>
+          <a:p>
+            <a:r>
+              <a:rPr sz="1350" b="0">
+                <a:solidFill>
+                  <a:srgbClr val="2C2C2A"/>
+                </a:solidFill>
+                <a:latin typeface="Calibri"/>
+              </a:rPr>
+              <a:t>舊 wire API version 被整個移除，min 可 &gt; 0</a:t>
+            </a:r>
+          </a:p>
+          <a:p>
+            <a:r>
+              <a:rPr sz="1350" b="0">
+                <a:solidFill>
+                  <a:srgbClr val="2C2C2A"/>
+                </a:solidFill>
+                <a:latin typeface="Calibri"/>
+              </a:rPr>
+              <a:t>  Fetch：4–18（v0–3 在 4.0 移除）</a:t>
             </a:r>
           </a:p>
         </p:txBody>
@@ -4350,37 +4378,33 @@
         </p:nvSpPr>
         <p:spPr>
           <a:xfrm>
-            <a:off x="822960" y="2953512"/>
-            <a:ext cx="10515600" cy="493776"/>
-          </a:xfrm>
-          <a:prstGeom prst="rect">
-            <a:avLst/>
-          </a:prstGeom>
-          <a:noFill/>
-        </p:spPr>
-        <p:txBody>
-          <a:bodyPr wrap="square">
-            <a:noAutofit/>
-          </a:bodyPr>
-          <a:lstStyle/>
-          <a:p>
-            <a:r>
-              <a:rPr sz="1600" b="0">
-                <a:solidFill>
-                  <a:srgbClr val="1E2024"/>
-                </a:solidFill>
-                <a:latin typeface="Calibri"/>
-              </a:rPr>
-              <a:t>B.  </a:t>
-            </a:r>
-            <a:r>
-              <a:rPr sz="1600" b="0">
-                <a:solidFill>
-                  <a:srgbClr val="1E2024"/>
-                </a:solidFill>
-                <a:latin typeface="Calibri"/>
-              </a:rPr>
-              <a:t>只有 ApiVersions 例外回錯誤+範圍；其他 API 關線</a:t>
+            <a:off x="640080" y="3172968"/>
+            <a:ext cx="10972800" cy="566928"/>
+          </a:xfrm>
+          <a:prstGeom prst="rect">
+            <a:avLst/>
+          </a:prstGeom>
+          <a:solidFill>
+            <a:srgbClr val="E9F3DE"/>
+          </a:solidFill>
+          <a:ln>
+            <a:noFill/>
+          </a:ln>
+        </p:spPr>
+        <p:txBody>
+          <a:bodyPr wrap="square" lIns="146304" tIns="82296">
+            <a:noAutofit/>
+          </a:bodyPr>
+          <a:lstStyle/>
+          <a:p>
+            <a:r>
+              <a:rPr sz="1500" b="0">
+                <a:solidFill>
+                  <a:srgbClr val="27500A"/>
+                </a:solidFill>
+                <a:latin typeface="Calibri"/>
+              </a:rPr>
+              <a:t>解法：升級前確認兩端都跨過版本下限（升 4.0 需至少 2.1），否則協商結果沒有可用版本</a:t>
             </a:r>
           </a:p>
         </p:txBody>
@@ -4393,37 +4417,28 @@
         </p:nvSpPr>
         <p:spPr>
           <a:xfrm>
-            <a:off x="822960" y="3575304"/>
-            <a:ext cx="10515600" cy="493776"/>
-          </a:xfrm>
-          <a:prstGeom prst="rect">
-            <a:avLst/>
-          </a:prstGeom>
-          <a:noFill/>
-        </p:spPr>
-        <p:txBody>
-          <a:bodyPr wrap="square">
-            <a:noAutofit/>
-          </a:bodyPr>
-          <a:lstStyle/>
-          <a:p>
-            <a:r>
-              <a:rPr sz="1600" b="0">
-                <a:solidFill>
-                  <a:srgbClr val="1E2024"/>
-                </a:solidFill>
-                <a:latin typeface="Calibri"/>
-              </a:rPr>
-              <a:t>C.  </a:t>
-            </a:r>
-            <a:r>
-              <a:rPr sz="1600" b="0">
-                <a:solidFill>
-                  <a:srgbClr val="1E2024"/>
-                </a:solidFill>
-                <a:latin typeface="Calibri"/>
-              </a:rPr>
-              <a:t>broker 自動降版</a:t>
+            <a:off x="640080" y="3922776"/>
+            <a:ext cx="10972800" cy="731520"/>
+          </a:xfrm>
+          <a:prstGeom prst="rect">
+            <a:avLst/>
+          </a:prstGeom>
+          <a:noFill/>
+        </p:spPr>
+        <p:txBody>
+          <a:bodyPr wrap="square">
+            <a:noAutofit/>
+          </a:bodyPr>
+          <a:lstStyle/>
+          <a:p>
+            <a:r>
+              <a:rPr sz="1500" b="0">
+                <a:solidFill>
+                  <a:srgbClr val="5F5E5A"/>
+                </a:solidFill>
+                <a:latin typeface="Calibri"/>
+              </a:rPr>
+              <a:t>銜接（非本場）：finalize / 升降當下的錯誤（INVALID_UPDATE_VERSION 等）屬「運行時的版本升降」那場，本場不展開。</a:t>
             </a:r>
           </a:p>
         </p:txBody>
@@ -4436,71 +4451,57 @@
         </p:nvSpPr>
         <p:spPr>
           <a:xfrm>
-            <a:off x="822960" y="4197096"/>
-            <a:ext cx="10515600" cy="493776"/>
-          </a:xfrm>
-          <a:prstGeom prst="rect">
-            <a:avLst/>
-          </a:prstGeom>
-          <a:noFill/>
-        </p:spPr>
-        <p:txBody>
-          <a:bodyPr wrap="square">
-            <a:noAutofit/>
-          </a:bodyPr>
-          <a:lstStyle/>
-          <a:p>
-            <a:r>
-              <a:rPr sz="1600" b="0">
-                <a:solidFill>
-                  <a:srgbClr val="1E2024"/>
-                </a:solidFill>
-                <a:latin typeface="Calibri"/>
-              </a:rPr>
-              <a:t>D.  </a:t>
-            </a:r>
-            <a:r>
-              <a:rPr sz="1600" b="0">
-                <a:solidFill>
-                  <a:srgbClr val="1E2024"/>
-                </a:solidFill>
-                <a:latin typeface="Calibri"/>
-              </a:rPr>
-              <a:t>忽略版本照跑</a:t>
-            </a:r>
-          </a:p>
-        </p:txBody>
-      </p:sp>
-      <p:sp>
-        <p:nvSpPr>
-          <p:cNvPr id="8" name="TextBox 7"/>
-          <p:cNvSpPr txBox="1"/>
-          <p:nvPr/>
-        </p:nvSpPr>
-        <p:spPr>
-          <a:xfrm>
-            <a:off x="640080" y="4910327"/>
-            <a:ext cx="10972800" cy="914400"/>
-          </a:xfrm>
-          <a:prstGeom prst="rect">
-            <a:avLst/>
-          </a:prstGeom>
-          <a:noFill/>
-        </p:spPr>
-        <p:txBody>
-          <a:bodyPr wrap="square">
-            <a:noAutofit/>
-          </a:bodyPr>
-          <a:lstStyle/>
-          <a:p>
-            <a:r>
-              <a:rPr sz="1400" b="0">
+            <a:off x="640080" y="6400800"/>
+            <a:ext cx="10972800" cy="384048"/>
+          </a:xfrm>
+          <a:prstGeom prst="rect">
+            <a:avLst/>
+          </a:prstGeom>
+          <a:noFill/>
+        </p:spPr>
+        <p:txBody>
+          <a:bodyPr wrap="square">
+            <a:noAutofit/>
+          </a:bodyPr>
+          <a:lstStyle/>
+          <a:p>
+            <a:r>
+              <a:rPr sz="1200" b="1">
                 <a:solidFill>
                   <a:srgbClr val="8A8A8A"/>
                 </a:solidFill>
                 <a:latin typeface="Calibri"/>
               </a:rPr>
-              <a:t>想一想 —— 下一頁公布答案</a:t>
+              <a:t>REF   </a:t>
+            </a:r>
+            <a:r>
+              <a:rPr sz="1200" b="0" u="sng">
+                <a:solidFill>
+                  <a:srgbClr val="185FA5"/>
+                </a:solidFill>
+                <a:latin typeface="Courier New"/>
+                <a:hlinkClick r:id="rId2"/>
+              </a:rPr>
+              <a:t>upgrade.md:229</a:t>
+            </a:r>
+            <a:r>
+              <a:rPr sz="1200" b="0">
+                <a:solidFill>
+                  <a:srgbClr val="8A8A8A"/>
+                </a:solidFill>
+                <a:latin typeface="Calibri"/>
+              </a:rPr>
+              <a:t>   ·   </a:t>
+            </a:r>
+            <a:r>
+              <a:rPr sz="1200" b="0" u="sng">
+                <a:solidFill>
+                  <a:srgbClr val="185FA5"/>
+                </a:solidFill>
+                <a:latin typeface="Courier New"/>
+                <a:hlinkClick r:id="rId3"/>
+              </a:rPr>
+              <a:t>FetchRequest.json validVersions</a:t>
             </a:r>
           </a:p>
         </p:txBody>
@@ -4552,7 +4553,7 @@
                 </a:solidFill>
                 <a:latin typeface="Calibri"/>
               </a:rPr>
-              <a:t>隨堂考 · 核心　（正解）</a:t>
+              <a:t>隨堂考 · 核心</a:t>
             </a:r>
           </a:p>
         </p:txBody>
@@ -4648,36 +4649,31 @@
           <a:prstGeom prst="rect">
             <a:avLst/>
           </a:prstGeom>
-          <a:solidFill>
-            <a:srgbClr val="E9F3DE"/>
-          </a:solidFill>
-          <a:ln>
-            <a:noFill/>
-          </a:ln>
-        </p:spPr>
-        <p:txBody>
-          <a:bodyPr wrap="square" lIns="128016" tIns="54864">
-            <a:noAutofit/>
-          </a:bodyPr>
-          <a:lstStyle/>
-          <a:p>
-            <a:r>
-              <a:rPr sz="1600" b="1">
-                <a:solidFill>
-                  <a:srgbClr val="27500A"/>
+          <a:noFill/>
+        </p:spPr>
+        <p:txBody>
+          <a:bodyPr wrap="square">
+            <a:noAutofit/>
+          </a:bodyPr>
+          <a:lstStyle/>
+          <a:p>
+            <a:r>
+              <a:rPr sz="1600" b="0">
+                <a:solidFill>
+                  <a:srgbClr val="1E2024"/>
                 </a:solidFill>
                 <a:latin typeface="Calibri"/>
               </a:rPr>
               <a:t>B.  </a:t>
             </a:r>
             <a:r>
-              <a:rPr sz="1600" b="1">
-                <a:solidFill>
-                  <a:srgbClr val="27500A"/>
-                </a:solidFill>
-                <a:latin typeface="Calibri"/>
-              </a:rPr>
-              <a:t>只有 ApiVersions 例外回錯誤+範圍；其他 API 關線   ✓</a:t>
+              <a:rPr sz="1600" b="0">
+                <a:solidFill>
+                  <a:srgbClr val="1E2024"/>
+                </a:solidFill>
+                <a:latin typeface="Calibri"/>
+              </a:rPr>
+              <a:t>只有 ApiVersions 例外回錯誤+範圍；其他 API 關線</a:t>
             </a:r>
           </a:p>
         </p:txBody>
@@ -4791,66 +4787,13 @@
           <a:lstStyle/>
           <a:p>
             <a:r>
-              <a:rPr sz="1400" b="1">
-                <a:solidFill>
-                  <a:srgbClr val="27500A"/>
-                </a:solidFill>
-                <a:latin typeface="Calibri"/>
-              </a:rPr>
-              <a:t>正解 B — </a:t>
-            </a:r>
-            <a:r>
               <a:rPr sz="1400" b="0">
                 <a:solidFill>
-                  <a:srgbClr val="1E2024"/>
-                </a:solidFill>
-                <a:latin typeface="Calibri"/>
-              </a:rPr>
-              <a:t>ApiVersions 是 bootstrap 逃生口；其他 API → broker 丟 UnsupportedVersionException → 斷線。</a:t>
-            </a:r>
-          </a:p>
-        </p:txBody>
-      </p:sp>
-      <p:sp>
-        <p:nvSpPr>
-          <p:cNvPr id="9" name="TextBox 8"/>
-          <p:cNvSpPr txBox="1"/>
-          <p:nvPr/>
-        </p:nvSpPr>
-        <p:spPr>
-          <a:xfrm>
-            <a:off x="640080" y="6400800"/>
-            <a:ext cx="10972800" cy="384048"/>
-          </a:xfrm>
-          <a:prstGeom prst="rect">
-            <a:avLst/>
-          </a:prstGeom>
-          <a:noFill/>
-        </p:spPr>
-        <p:txBody>
-          <a:bodyPr wrap="square">
-            <a:noAutofit/>
-          </a:bodyPr>
-          <a:lstStyle/>
-          <a:p>
-            <a:r>
-              <a:rPr sz="1200" b="1">
-                <a:solidFill>
                   <a:srgbClr val="8A8A8A"/>
                 </a:solidFill>
                 <a:latin typeface="Calibri"/>
               </a:rPr>
-              <a:t>REF   </a:t>
-            </a:r>
-            <a:r>
-              <a:rPr sz="1200" b="0" u="sng">
-                <a:solidFill>
-                  <a:srgbClr val="185FA5"/>
-                </a:solidFill>
-                <a:latin typeface="Courier New"/>
-                <a:hlinkClick r:id="rId2"/>
-              </a:rPr>
-              <a:t>RequestContext.java:112</a:t>
+              <a:t>想一想 —— 下一頁公布答案</a:t>
             </a:r>
           </a:p>
         </p:txBody>
@@ -4902,7 +4845,357 @@
                 </a:solidFill>
                 <a:latin typeface="Calibri"/>
               </a:rPr>
-              <a:t>Takeaways</a:t>
+              <a:t>隨堂考 · 核心　（正解）</a:t>
+            </a:r>
+          </a:p>
+        </p:txBody>
+      </p:sp>
+      <p:sp>
+        <p:nvSpPr>
+          <p:cNvPr id="3" name="TextBox 2"/>
+          <p:cNvSpPr txBox="1"/>
+          <p:nvPr/>
+        </p:nvSpPr>
+        <p:spPr>
+          <a:xfrm>
+            <a:off x="640080" y="841248"/>
+            <a:ext cx="10972800" cy="1188720"/>
+          </a:xfrm>
+          <a:prstGeom prst="rect">
+            <a:avLst/>
+          </a:prstGeom>
+          <a:noFill/>
+        </p:spPr>
+        <p:txBody>
+          <a:bodyPr wrap="square">
+            <a:noAutofit/>
+          </a:bodyPr>
+          <a:lstStyle/>
+          <a:p>
+            <a:r>
+              <a:rPr sz="2600" b="1">
+                <a:solidFill>
+                  <a:srgbClr val="1E2024"/>
+                </a:solidFill>
+                <a:latin typeface="Calibri"/>
+              </a:rPr>
+              <a:t>自刻 client 送了不支援的 API version，會怎樣？</a:t>
+            </a:r>
+          </a:p>
+        </p:txBody>
+      </p:sp>
+      <p:sp>
+        <p:nvSpPr>
+          <p:cNvPr id="4" name="TextBox 3"/>
+          <p:cNvSpPr txBox="1"/>
+          <p:nvPr/>
+        </p:nvSpPr>
+        <p:spPr>
+          <a:xfrm>
+            <a:off x="822960" y="2331720"/>
+            <a:ext cx="10515600" cy="493776"/>
+          </a:xfrm>
+          <a:prstGeom prst="rect">
+            <a:avLst/>
+          </a:prstGeom>
+          <a:noFill/>
+        </p:spPr>
+        <p:txBody>
+          <a:bodyPr wrap="square">
+            <a:noAutofit/>
+          </a:bodyPr>
+          <a:lstStyle/>
+          <a:p>
+            <a:r>
+              <a:rPr sz="1600" b="0">
+                <a:solidFill>
+                  <a:srgbClr val="1E2024"/>
+                </a:solidFill>
+                <a:latin typeface="Calibri"/>
+              </a:rPr>
+              <a:t>A.  </a:t>
+            </a:r>
+            <a:r>
+              <a:rPr sz="1600" b="0">
+                <a:solidFill>
+                  <a:srgbClr val="1E2024"/>
+                </a:solidFill>
+                <a:latin typeface="Calibri"/>
+              </a:rPr>
+              <a:t>一律回 UNSUPPORTED_VERSION</a:t>
+            </a:r>
+          </a:p>
+        </p:txBody>
+      </p:sp>
+      <p:sp>
+        <p:nvSpPr>
+          <p:cNvPr id="5" name="TextBox 4"/>
+          <p:cNvSpPr txBox="1"/>
+          <p:nvPr/>
+        </p:nvSpPr>
+        <p:spPr>
+          <a:xfrm>
+            <a:off x="822960" y="2953512"/>
+            <a:ext cx="10515600" cy="493776"/>
+          </a:xfrm>
+          <a:prstGeom prst="rect">
+            <a:avLst/>
+          </a:prstGeom>
+          <a:solidFill>
+            <a:srgbClr val="E9F3DE"/>
+          </a:solidFill>
+          <a:ln>
+            <a:noFill/>
+          </a:ln>
+        </p:spPr>
+        <p:txBody>
+          <a:bodyPr wrap="square" lIns="128016" tIns="54864">
+            <a:noAutofit/>
+          </a:bodyPr>
+          <a:lstStyle/>
+          <a:p>
+            <a:r>
+              <a:rPr sz="1600" b="1">
+                <a:solidFill>
+                  <a:srgbClr val="27500A"/>
+                </a:solidFill>
+                <a:latin typeface="Calibri"/>
+              </a:rPr>
+              <a:t>B.  </a:t>
+            </a:r>
+            <a:r>
+              <a:rPr sz="1600" b="1">
+                <a:solidFill>
+                  <a:srgbClr val="27500A"/>
+                </a:solidFill>
+                <a:latin typeface="Calibri"/>
+              </a:rPr>
+              <a:t>只有 ApiVersions 例外回錯誤+範圍；其他 API 關線   ✓</a:t>
+            </a:r>
+          </a:p>
+        </p:txBody>
+      </p:sp>
+      <p:sp>
+        <p:nvSpPr>
+          <p:cNvPr id="6" name="TextBox 5"/>
+          <p:cNvSpPr txBox="1"/>
+          <p:nvPr/>
+        </p:nvSpPr>
+        <p:spPr>
+          <a:xfrm>
+            <a:off x="822960" y="3575304"/>
+            <a:ext cx="10515600" cy="493776"/>
+          </a:xfrm>
+          <a:prstGeom prst="rect">
+            <a:avLst/>
+          </a:prstGeom>
+          <a:noFill/>
+        </p:spPr>
+        <p:txBody>
+          <a:bodyPr wrap="square">
+            <a:noAutofit/>
+          </a:bodyPr>
+          <a:lstStyle/>
+          <a:p>
+            <a:r>
+              <a:rPr sz="1600" b="0">
+                <a:solidFill>
+                  <a:srgbClr val="1E2024"/>
+                </a:solidFill>
+                <a:latin typeface="Calibri"/>
+              </a:rPr>
+              <a:t>C.  </a:t>
+            </a:r>
+            <a:r>
+              <a:rPr sz="1600" b="0">
+                <a:solidFill>
+                  <a:srgbClr val="1E2024"/>
+                </a:solidFill>
+                <a:latin typeface="Calibri"/>
+              </a:rPr>
+              <a:t>broker 自動降版</a:t>
+            </a:r>
+          </a:p>
+        </p:txBody>
+      </p:sp>
+      <p:sp>
+        <p:nvSpPr>
+          <p:cNvPr id="7" name="TextBox 6"/>
+          <p:cNvSpPr txBox="1"/>
+          <p:nvPr/>
+        </p:nvSpPr>
+        <p:spPr>
+          <a:xfrm>
+            <a:off x="822960" y="4197096"/>
+            <a:ext cx="10515600" cy="493776"/>
+          </a:xfrm>
+          <a:prstGeom prst="rect">
+            <a:avLst/>
+          </a:prstGeom>
+          <a:noFill/>
+        </p:spPr>
+        <p:txBody>
+          <a:bodyPr wrap="square">
+            <a:noAutofit/>
+          </a:bodyPr>
+          <a:lstStyle/>
+          <a:p>
+            <a:r>
+              <a:rPr sz="1600" b="0">
+                <a:solidFill>
+                  <a:srgbClr val="1E2024"/>
+                </a:solidFill>
+                <a:latin typeface="Calibri"/>
+              </a:rPr>
+              <a:t>D.  </a:t>
+            </a:r>
+            <a:r>
+              <a:rPr sz="1600" b="0">
+                <a:solidFill>
+                  <a:srgbClr val="1E2024"/>
+                </a:solidFill>
+                <a:latin typeface="Calibri"/>
+              </a:rPr>
+              <a:t>忽略版本照跑</a:t>
+            </a:r>
+          </a:p>
+        </p:txBody>
+      </p:sp>
+      <p:sp>
+        <p:nvSpPr>
+          <p:cNvPr id="8" name="TextBox 7"/>
+          <p:cNvSpPr txBox="1"/>
+          <p:nvPr/>
+        </p:nvSpPr>
+        <p:spPr>
+          <a:xfrm>
+            <a:off x="640080" y="4910327"/>
+            <a:ext cx="10972800" cy="914400"/>
+          </a:xfrm>
+          <a:prstGeom prst="rect">
+            <a:avLst/>
+          </a:prstGeom>
+          <a:noFill/>
+        </p:spPr>
+        <p:txBody>
+          <a:bodyPr wrap="square">
+            <a:noAutofit/>
+          </a:bodyPr>
+          <a:lstStyle/>
+          <a:p>
+            <a:r>
+              <a:rPr sz="1400" b="1">
+                <a:solidFill>
+                  <a:srgbClr val="27500A"/>
+                </a:solidFill>
+                <a:latin typeface="Calibri"/>
+              </a:rPr>
+              <a:t>正解 B — </a:t>
+            </a:r>
+            <a:r>
+              <a:rPr sz="1400" b="0">
+                <a:solidFill>
+                  <a:srgbClr val="1E2024"/>
+                </a:solidFill>
+                <a:latin typeface="Calibri"/>
+              </a:rPr>
+              <a:t>ApiVersions 是 bootstrap 逃生口；其他 API → broker 丟 UnsupportedVersionException → 斷線。</a:t>
+            </a:r>
+          </a:p>
+        </p:txBody>
+      </p:sp>
+      <p:sp>
+        <p:nvSpPr>
+          <p:cNvPr id="9" name="TextBox 8"/>
+          <p:cNvSpPr txBox="1"/>
+          <p:nvPr/>
+        </p:nvSpPr>
+        <p:spPr>
+          <a:xfrm>
+            <a:off x="640080" y="6400800"/>
+            <a:ext cx="10972800" cy="384048"/>
+          </a:xfrm>
+          <a:prstGeom prst="rect">
+            <a:avLst/>
+          </a:prstGeom>
+          <a:noFill/>
+        </p:spPr>
+        <p:txBody>
+          <a:bodyPr wrap="square">
+            <a:noAutofit/>
+          </a:bodyPr>
+          <a:lstStyle/>
+          <a:p>
+            <a:r>
+              <a:rPr sz="1200" b="1">
+                <a:solidFill>
+                  <a:srgbClr val="8A8A8A"/>
+                </a:solidFill>
+                <a:latin typeface="Calibri"/>
+              </a:rPr>
+              <a:t>REF   </a:t>
+            </a:r>
+            <a:r>
+              <a:rPr sz="1200" b="0" u="sng">
+                <a:solidFill>
+                  <a:srgbClr val="185FA5"/>
+                </a:solidFill>
+                <a:latin typeface="Courier New"/>
+                <a:hlinkClick r:id="rId2"/>
+              </a:rPr>
+              <a:t>RequestContext.java:112</a:t>
+            </a:r>
+          </a:p>
+        </p:txBody>
+      </p:sp>
+    </p:spTree>
+  </p:cSld>
+  <p:clrMapOvr>
+    <a:masterClrMapping/>
+  </p:clrMapOvr>
+</p:sld>
+</file>
+
+<file path=ppt/slides/slide16.xml><?xml version="1.0" encoding="utf-8"?>
+<p:sld xmlns:a="http://schemas.openxmlformats.org/drawingml/2006/main" xmlns:p="http://schemas.openxmlformats.org/presentationml/2006/main" xmlns:r="http://schemas.openxmlformats.org/officeDocument/2006/relationships">
+  <p:cSld>
+    <p:spTree>
+      <p:nvGrpSpPr>
+        <p:cNvPr id="1" name=""/>
+        <p:cNvGrpSpPr/>
+        <p:nvPr/>
+      </p:nvGrpSpPr>
+      <p:grpSpPr/>
+      <p:sp>
+        <p:nvSpPr>
+          <p:cNvPr id="2" name="TextBox 1"/>
+          <p:cNvSpPr txBox="1"/>
+          <p:nvPr/>
+        </p:nvSpPr>
+        <p:spPr>
+          <a:xfrm>
+            <a:off x="640080" y="457200"/>
+            <a:ext cx="10972800" cy="365760"/>
+          </a:xfrm>
+          <a:prstGeom prst="rect">
+            <a:avLst/>
+          </a:prstGeom>
+          <a:noFill/>
+        </p:spPr>
+        <p:txBody>
+          <a:bodyPr wrap="square">
+            <a:noAutofit/>
+          </a:bodyPr>
+          <a:lstStyle/>
+          <a:p>
+            <a:r>
+              <a:rPr sz="1300" b="1">
+                <a:solidFill>
+                  <a:srgbClr val="185FA5"/>
+                </a:solidFill>
+                <a:latin typeface="Calibri"/>
+              </a:rPr>
+              <a:t>Recap</a:t>
             </a:r>
           </a:p>
         </p:txBody>
@@ -4994,7 +5287,7 @@
                 </a:solidFill>
                 <a:latin typeface="Calibri"/>
               </a:rPr>
-              <a:t>叢集三種通訊：client↔broker、broker↔controller、broker↔broker——版本機制都掛在這三條線</a:t>
+              <a:t>三種通訊：client↔broker、broker↔controller、broker↔broker——版本機制都掛在這三條線</a:t>
             </a:r>
           </a:p>
         </p:txBody>
@@ -5032,7 +5325,7 @@
         <p:spPr>
           <a:xfrm>
             <a:off x="1078992" y="3136392"/>
-            <a:ext cx="10515600" cy="493776"/>
+            <a:ext cx="10515600" cy="841248"/>
           </a:xfrm>
           <a:prstGeom prst="rect">
             <a:avLst/>
@@ -5052,7 +5345,7 @@
                 </a:solidFill>
                 <a:latin typeface="Calibri"/>
               </a:rPr>
-              <a:t>無法「一個版本打天下」：client 長壽、broker 滾動升級，只能連線當下協商</a:t>
+              <a:t>Part 1：不能「一個版本打天下」（client 長壽、broker 滾動升級）；多數路徑靠協商，只有複製面由 finalized MV 決定</a:t>
             </a:r>
           </a:p>
         </p:txBody>
@@ -5073,7 +5366,7 @@
         </p:blipFill>
         <p:spPr>
           <a:xfrm>
-            <a:off x="658368" y="3803904"/>
+            <a:off x="658368" y="4151376"/>
             <a:ext cx="274320" cy="274320"/>
           </a:xfrm>
           <a:prstGeom prst="rect">
@@ -5089,7 +5382,7 @@
         </p:nvSpPr>
         <p:spPr>
           <a:xfrm>
-            <a:off x="1078992" y="3776472"/>
+            <a:off x="1078992" y="4123944"/>
             <a:ext cx="10515600" cy="841248"/>
           </a:xfrm>
           <a:prstGeom prst="rect">
@@ -5110,65 +5403,7 @@
                 </a:solidFill>
                 <a:latin typeface="Calibri"/>
               </a:rPr>
-              <a:t>多數路徑靠 ApiVersions 協商；只有複製面由 finalized MV 決定</a:t>
-            </a:r>
-          </a:p>
-        </p:txBody>
-      </p:sp>
-      <p:pic>
-        <p:nvPicPr>
-          <p:cNvPr id="10" name="Picture 9" descr="point.png"/>
-          <p:cNvPicPr>
-            <a:picLocks noChangeAspect="1"/>
-          </p:cNvPicPr>
-          <p:nvPr/>
-        </p:nvPicPr>
-        <p:blipFill>
-          <a:blip r:embed="rId2"/>
-          <a:stretch>
-            <a:fillRect/>
-          </a:stretch>
-        </p:blipFill>
-        <p:spPr>
-          <a:xfrm>
-            <a:off x="658368" y="4791456"/>
-            <a:ext cx="274320" cy="274320"/>
-          </a:xfrm>
-          <a:prstGeom prst="rect">
-            <a:avLst/>
-          </a:prstGeom>
-        </p:spPr>
-      </p:pic>
-      <p:sp>
-        <p:nvSpPr>
-          <p:cNvPr id="11" name="TextBox 10"/>
-          <p:cNvSpPr txBox="1"/>
-          <p:nvPr/>
-        </p:nvSpPr>
-        <p:spPr>
-          <a:xfrm>
-            <a:off x="1078992" y="4764024"/>
-            <a:ext cx="10515600" cy="841248"/>
-          </a:xfrm>
-          <a:prstGeom prst="rect">
-            <a:avLst/>
-          </a:prstGeom>
-          <a:noFill/>
-        </p:spPr>
-        <p:txBody>
-          <a:bodyPr wrap="square">
-            <a:noAutofit/>
-          </a:bodyPr>
-          <a:lstStyle/>
-          <a:p>
-            <a:r>
-              <a:rPr sz="1650" b="0">
-                <a:solidFill>
-                  <a:srgbClr val="1E2024"/>
-                </a:solidFill>
-                <a:latin typeface="Calibri"/>
-              </a:rPr>
-              <a:t>協商不出版本 → UnsupportedVersionException（多在送出前中止）；升降錯誤交給運行時那場</a:t>
+              <a:t>Part 2：協商不出版本 → UnsupportedVersionException（多在送出前中止）；finalize／升降的錯誤交給運行時那場</a:t>
             </a:r>
           </a:p>
         </p:txBody>
@@ -5220,7 +5455,7 @@
                 </a:solidFill>
                 <a:latin typeface="Calibri"/>
               </a:rPr>
-              <a:t>點題</a:t>
+              <a:t>本場大綱</a:t>
             </a:r>
           </a:p>
         </p:txBody>
@@ -5254,14 +5489,14 @@
                 </a:solidFill>
                 <a:latin typeface="Calibri"/>
               </a:rPr>
-              <a:t>為什麼不「一個版本打天下」？</a:t>
+              <a:t>兩段，加 3 題隨堂考穿插</a:t>
             </a:r>
           </a:p>
         </p:txBody>
       </p:sp>
       <p:pic>
         <p:nvPicPr>
-          <p:cNvPr id="4" name="Picture 3" descr="bulb.png"/>
+          <p:cNvPr id="4" name="Picture 3" descr="point.png"/>
           <p:cNvPicPr>
             <a:picLocks noChangeAspect="1"/>
           </p:cNvPicPr>
@@ -5312,69 +5547,28 @@
                 </a:solidFill>
                 <a:latin typeface="Calibri"/>
               </a:rPr>
-              <a:t>初學者常有的直覺：client 與 broker 使用同一個版本，升級時一併更新</a:t>
-            </a:r>
-          </a:p>
-        </p:txBody>
-      </p:sp>
-      <p:sp>
-        <p:nvSpPr>
-          <p:cNvPr id="6" name="TextBox 5"/>
-          <p:cNvSpPr txBox="1"/>
-          <p:nvPr/>
-        </p:nvSpPr>
-        <p:spPr>
-          <a:xfrm>
-            <a:off x="640080" y="2788920"/>
-            <a:ext cx="10972800" cy="548640"/>
-          </a:xfrm>
-          <a:prstGeom prst="rect">
-            <a:avLst/>
-          </a:prstGeom>
-          <a:solidFill>
-            <a:srgbClr val="F3F1EC"/>
-          </a:solidFill>
-          <a:ln w="6350">
-            <a:solidFill>
-              <a:srgbClr val="E3E0D8"/>
-            </a:solidFill>
-          </a:ln>
-        </p:spPr>
-        <p:txBody>
-          <a:bodyPr wrap="square" lIns="146304" tIns="91440" bIns="91440">
-            <a:noAutofit/>
-          </a:bodyPr>
-          <a:lstStyle/>
-          <a:p>
-            <a:r>
-              <a:rPr sz="1350" b="0">
-                <a:solidFill>
-                  <a:srgbClr val="2C2C2A"/>
-                </a:solidFill>
-                <a:latin typeface="Calibri"/>
-              </a:rPr>
-              <a:t>想像中：  client v4.1 ─────── broker v4.1</a:t>
+              <a:t>Part 1 — 版本為何要在連線當下協商、又是怎麼選的</a:t>
             </a:r>
           </a:p>
         </p:txBody>
       </p:sp>
       <p:pic>
         <p:nvPicPr>
-          <p:cNvPr id="7" name="Picture 6" descr="help-circle.png"/>
+          <p:cNvPr id="6" name="Picture 5" descr="point.png"/>
           <p:cNvPicPr>
             <a:picLocks noChangeAspect="1"/>
           </p:cNvPicPr>
           <p:nvPr/>
         </p:nvPicPr>
         <p:blipFill>
-          <a:blip r:embed="rId3"/>
+          <a:blip r:embed="rId2"/>
           <a:stretch>
             <a:fillRect/>
           </a:stretch>
         </p:blipFill>
         <p:spPr>
           <a:xfrm>
-            <a:off x="658368" y="3566160"/>
+            <a:off x="658368" y="2816352"/>
             <a:ext cx="274320" cy="274320"/>
           </a:xfrm>
           <a:prstGeom prst="rect">
@@ -5384,78 +5578,68 @@
       </p:pic>
       <p:sp>
         <p:nvSpPr>
+          <p:cNvPr id="7" name="TextBox 6"/>
+          <p:cNvSpPr txBox="1"/>
+          <p:nvPr/>
+        </p:nvSpPr>
+        <p:spPr>
+          <a:xfrm>
+            <a:off x="1078992" y="2788920"/>
+            <a:ext cx="10515600" cy="493776"/>
+          </a:xfrm>
+          <a:prstGeom prst="rect">
+            <a:avLst/>
+          </a:prstGeom>
+          <a:noFill/>
+        </p:spPr>
+        <p:txBody>
+          <a:bodyPr wrap="square">
+            <a:noAutofit/>
+          </a:bodyPr>
+          <a:lstStyle/>
+          <a:p>
+            <a:r>
+              <a:rPr sz="1650" b="0">
+                <a:solidFill>
+                  <a:srgbClr val="1E2024"/>
+                </a:solidFill>
+                <a:latin typeface="Calibri"/>
+              </a:rPr>
+              <a:t>Part 2 — 協商失敗時，會看到什麼訊息</a:t>
+            </a:r>
+          </a:p>
+        </p:txBody>
+      </p:sp>
+      <p:sp>
+        <p:nvSpPr>
           <p:cNvPr id="8" name="TextBox 7"/>
           <p:cNvSpPr txBox="1"/>
           <p:nvPr/>
         </p:nvSpPr>
         <p:spPr>
           <a:xfrm>
-            <a:off x="1078992" y="3538728"/>
-            <a:ext cx="10515600" cy="493776"/>
-          </a:xfrm>
-          <a:prstGeom prst="rect">
-            <a:avLst/>
-          </a:prstGeom>
-          <a:noFill/>
-        </p:spPr>
-        <p:txBody>
-          <a:bodyPr wrap="square">
-            <a:noAutofit/>
-          </a:bodyPr>
-          <a:lstStyle/>
-          <a:p>
-            <a:r>
-              <a:rPr sz="1650" b="0">
-                <a:solidFill>
-                  <a:srgbClr val="1E2024"/>
-                </a:solidFill>
-                <a:latin typeface="Calibri"/>
-              </a:rPr>
-              <a:t>但只要叢集達到一定規模，這個假設就不再成立</a:t>
-            </a:r>
-          </a:p>
-        </p:txBody>
-      </p:sp>
-      <p:sp>
-        <p:nvSpPr>
-          <p:cNvPr id="9" name="TextBox 8"/>
-          <p:cNvSpPr txBox="1"/>
-          <p:nvPr/>
-        </p:nvSpPr>
-        <p:spPr>
-          <a:xfrm>
-            <a:off x="640080" y="6400800"/>
-            <a:ext cx="10972800" cy="384048"/>
-          </a:xfrm>
-          <a:prstGeom prst="rect">
-            <a:avLst/>
-          </a:prstGeom>
-          <a:noFill/>
-        </p:spPr>
-        <p:txBody>
-          <a:bodyPr wrap="square">
-            <a:noAutofit/>
-          </a:bodyPr>
-          <a:lstStyle/>
-          <a:p>
-            <a:r>
-              <a:rPr sz="1200" b="1">
-                <a:solidFill>
-                  <a:srgbClr val="8A8A8A"/>
-                </a:solidFill>
-                <a:latin typeface="Calibri"/>
-              </a:rPr>
-              <a:t>REF   </a:t>
-            </a:r>
-            <a:r>
-              <a:rPr sz="1200" b="0" u="sng">
-                <a:solidFill>
-                  <a:srgbClr val="185FA5"/>
-                </a:solidFill>
-                <a:latin typeface="Courier New"/>
-                <a:hlinkClick r:id="rId4"/>
-              </a:rPr>
-              <a:t>protocol.md:94</a:t>
+            <a:off x="640080" y="3429000"/>
+            <a:ext cx="10972800" cy="438912"/>
+          </a:xfrm>
+          <a:prstGeom prst="rect">
+            <a:avLst/>
+          </a:prstGeom>
+          <a:noFill/>
+        </p:spPr>
+        <p:txBody>
+          <a:bodyPr wrap="square">
+            <a:noAutofit/>
+          </a:bodyPr>
+          <a:lstStyle/>
+          <a:p>
+            <a:r>
+              <a:rPr sz="1500" b="0">
+                <a:solidFill>
+                  <a:srgbClr val="5F5E5A"/>
+                </a:solidFill>
+                <a:latin typeface="Calibri"/>
+              </a:rPr>
+              <a:t>結尾會用一頁 Recap 把兩段串回開場那個問題。</a:t>
             </a:r>
           </a:p>
         </p:txBody>
@@ -5507,7 +5691,7 @@
                 </a:solidFill>
                 <a:latin typeface="Calibri"/>
               </a:rPr>
-              <a:t>Part 1 · 地圖</a:t>
+              <a:t>點題</a:t>
             </a:r>
           </a:p>
         </p:txBody>
@@ -5541,21 +5725,79 @@
                 </a:solidFill>
                 <a:latin typeface="Calibri"/>
               </a:rPr>
-              <a:t>叢集裡有三種通訊，而且版本天生對不齊</a:t>
-            </a:r>
-          </a:p>
-        </p:txBody>
-      </p:sp>
-      <p:sp>
-        <p:nvSpPr>
-          <p:cNvPr id="4" name="TextBox 3"/>
-          <p:cNvSpPr txBox="1"/>
-          <p:nvPr/>
-        </p:nvSpPr>
-        <p:spPr>
-          <a:xfrm>
-            <a:off x="640080" y="2148840"/>
-            <a:ext cx="10972800" cy="1097280"/>
+              <a:t>為什麼不「一個版本打天下」？</a:t>
+            </a:r>
+          </a:p>
+        </p:txBody>
+      </p:sp>
+      <p:pic>
+        <p:nvPicPr>
+          <p:cNvPr id="4" name="Picture 3" descr="bulb.png"/>
+          <p:cNvPicPr>
+            <a:picLocks noChangeAspect="1"/>
+          </p:cNvPicPr>
+          <p:nvPr/>
+        </p:nvPicPr>
+        <p:blipFill>
+          <a:blip r:embed="rId2"/>
+          <a:stretch>
+            <a:fillRect/>
+          </a:stretch>
+        </p:blipFill>
+        <p:spPr>
+          <a:xfrm>
+            <a:off x="658368" y="2176272"/>
+            <a:ext cx="274320" cy="274320"/>
+          </a:xfrm>
+          <a:prstGeom prst="rect">
+            <a:avLst/>
+          </a:prstGeom>
+        </p:spPr>
+      </p:pic>
+      <p:sp>
+        <p:nvSpPr>
+          <p:cNvPr id="5" name="TextBox 4"/>
+          <p:cNvSpPr txBox="1"/>
+          <p:nvPr/>
+        </p:nvSpPr>
+        <p:spPr>
+          <a:xfrm>
+            <a:off x="1078992" y="2148840"/>
+            <a:ext cx="10515600" cy="493776"/>
+          </a:xfrm>
+          <a:prstGeom prst="rect">
+            <a:avLst/>
+          </a:prstGeom>
+          <a:noFill/>
+        </p:spPr>
+        <p:txBody>
+          <a:bodyPr wrap="square">
+            <a:noAutofit/>
+          </a:bodyPr>
+          <a:lstStyle/>
+          <a:p>
+            <a:r>
+              <a:rPr sz="1650" b="0">
+                <a:solidFill>
+                  <a:srgbClr val="1E2024"/>
+                </a:solidFill>
+                <a:latin typeface="Calibri"/>
+              </a:rPr>
+              <a:t>初學者常有的直覺：client 與 broker 使用同一個版本，升級時一併更新</a:t>
+            </a:r>
+          </a:p>
+        </p:txBody>
+      </p:sp>
+      <p:sp>
+        <p:nvSpPr>
+          <p:cNvPr id="6" name="TextBox 5"/>
+          <p:cNvSpPr txBox="1"/>
+          <p:nvPr/>
+        </p:nvSpPr>
+        <p:spPr>
+          <a:xfrm>
+            <a:off x="640080" y="2788920"/>
+            <a:ext cx="10972800" cy="548640"/>
           </a:xfrm>
           <a:prstGeom prst="rect">
             <a:avLst/>
@@ -5582,94 +5824,14 @@
                 </a:solidFill>
                 <a:latin typeface="Calibri"/>
               </a:rPr>
-              <a:t>client ─▶ broker        讀寫資料</a:t>
-            </a:r>
-          </a:p>
-          <a:p>
-            <a:r>
-              <a:rPr sz="1350" b="0">
-                <a:solidFill>
-                  <a:srgbClr val="2C2C2A"/>
-                </a:solidFill>
-                <a:latin typeface="Calibri"/>
-              </a:rPr>
-              <a:t>broker ─▶ controller    心跳 / 註冊</a:t>
-            </a:r>
-          </a:p>
-          <a:p>
-            <a:r>
-              <a:rPr sz="1350" b="0">
-                <a:solidFill>
-                  <a:srgbClr val="2C2C2A"/>
-                </a:solidFill>
-                <a:latin typeface="Calibri"/>
-              </a:rPr>
-              <a:t>broker ◀▶ broker        複製</a:t>
+              <a:t>想像中：  client v4.1 ─────── broker v4.1</a:t>
             </a:r>
           </a:p>
         </p:txBody>
       </p:sp>
       <p:pic>
         <p:nvPicPr>
-          <p:cNvPr id="5" name="Picture 4" descr="clock-hour-4.png"/>
-          <p:cNvPicPr>
-            <a:picLocks noChangeAspect="1"/>
-          </p:cNvPicPr>
-          <p:nvPr/>
-        </p:nvPicPr>
-        <p:blipFill>
-          <a:blip r:embed="rId2"/>
-          <a:stretch>
-            <a:fillRect/>
-          </a:stretch>
-        </p:blipFill>
-        <p:spPr>
-          <a:xfrm>
-            <a:off x="658368" y="3474720"/>
-            <a:ext cx="274320" cy="274320"/>
-          </a:xfrm>
-          <a:prstGeom prst="rect">
-            <a:avLst/>
-          </a:prstGeom>
-        </p:spPr>
-      </p:pic>
-      <p:sp>
-        <p:nvSpPr>
-          <p:cNvPr id="6" name="TextBox 5"/>
-          <p:cNvSpPr txBox="1"/>
-          <p:nvPr/>
-        </p:nvSpPr>
-        <p:spPr>
-          <a:xfrm>
-            <a:off x="1078992" y="3447288"/>
-            <a:ext cx="10515600" cy="841248"/>
-          </a:xfrm>
-          <a:prstGeom prst="rect">
-            <a:avLst/>
-          </a:prstGeom>
-          <a:noFill/>
-        </p:spPr>
-        <p:txBody>
-          <a:bodyPr wrap="square">
-            <a:noAutofit/>
-          </a:bodyPr>
-          <a:lstStyle/>
-          <a:p>
-            <a:r>
-              <a:rPr sz="1650" b="0">
-                <a:solidFill>
-                  <a:srgbClr val="1E2024"/>
-                </a:solidFill>
-                <a:latin typeface="Calibri"/>
-              </a:rPr>
-              <a:t>client 內嵌在各 app、長期不更新（Kafka 曾為舊 client 保留每個 protocol 版本近九年，4.0／KIP-896 才把下限提到 2.1）</a:t>
-            </a:r>
-          </a:p>
-        </p:txBody>
-      </p:sp>
-      <p:pic>
-        <p:nvPicPr>
-          <p:cNvPr id="7" name="Picture 6" descr="server-2.png"/>
+          <p:cNvPr id="7" name="Picture 6" descr="help-circle.png"/>
           <p:cNvPicPr>
             <a:picLocks noChangeAspect="1"/>
           </p:cNvPicPr>
@@ -5683,7 +5845,7 @@
         </p:blipFill>
         <p:spPr>
           <a:xfrm>
-            <a:off x="658368" y="4462272"/>
+            <a:off x="658368" y="3566160"/>
             <a:ext cx="274320" cy="274320"/>
           </a:xfrm>
           <a:prstGeom prst="rect">
@@ -5699,7 +5861,7 @@
         </p:nvSpPr>
         <p:spPr>
           <a:xfrm>
-            <a:off x="1078992" y="4434840"/>
+            <a:off x="1078992" y="3538728"/>
             <a:ext cx="10515600" cy="493776"/>
           </a:xfrm>
           <a:prstGeom prst="rect">
@@ -5720,7 +5882,7 @@
                 </a:solidFill>
                 <a:latin typeface="Calibri"/>
               </a:rPr>
-              <a:t>broker 逐台滾動升級，過程必然新舊並存；要不停機就不能要求全叢集同版</a:t>
+              <a:t>但只要叢集達到一定規模，這個假設就不再成立</a:t>
             </a:r>
           </a:p>
         </p:txBody>
@@ -5728,45 +5890,6 @@
       <p:sp>
         <p:nvSpPr>
           <p:cNvPr id="9" name="TextBox 8"/>
-          <p:cNvSpPr txBox="1"/>
-          <p:nvPr/>
-        </p:nvSpPr>
-        <p:spPr>
-          <a:xfrm>
-            <a:off x="640080" y="5074920"/>
-            <a:ext cx="10972800" cy="566928"/>
-          </a:xfrm>
-          <a:prstGeom prst="rect">
-            <a:avLst/>
-          </a:prstGeom>
-          <a:solidFill>
-            <a:srgbClr val="E9F3DE"/>
-          </a:solidFill>
-          <a:ln>
-            <a:noFill/>
-          </a:ln>
-        </p:spPr>
-        <p:txBody>
-          <a:bodyPr wrap="square" lIns="146304" tIns="82296">
-            <a:noAutofit/>
-          </a:bodyPr>
-          <a:lstStyle/>
-          <a:p>
-            <a:r>
-              <a:rPr sz="1500" b="0">
-                <a:solidFill>
-                  <a:srgbClr val="27500A"/>
-                </a:solidFill>
-                <a:latin typeface="Calibri"/>
-              </a:rPr>
-              <a:t>所以版本只能在連線當下協商——後面每個機制都掛在上面這三條線</a:t>
-            </a:r>
-          </a:p>
-        </p:txBody>
-      </p:sp>
-      <p:sp>
-        <p:nvSpPr>
-          <p:cNvPr id="10" name="TextBox 9"/>
           <p:cNvSpPr txBox="1"/>
           <p:nvPr/>
         </p:nvSpPr>
@@ -5800,48 +5923,10 @@
                 <a:solidFill>
                   <a:srgbClr val="185FA5"/>
                 </a:solidFill>
-                <a:latin typeface="Calibri"/>
+                <a:latin typeface="Courier New"/>
                 <a:hlinkClick r:id="rId4"/>
               </a:rPr>
-              <a:t>KIP-896</a:t>
-            </a:r>
-            <a:r>
-              <a:rPr sz="1200" b="0">
-                <a:solidFill>
-                  <a:srgbClr val="8A8A8A"/>
-                </a:solidFill>
-                <a:latin typeface="Calibri"/>
-              </a:rPr>
-              <a:t>   ·   </a:t>
-            </a:r>
-            <a:r>
-              <a:rPr sz="1200" b="0" u="sng">
-                <a:solidFill>
-                  <a:srgbClr val="185FA5"/>
-                </a:solidFill>
-                <a:latin typeface="Courier New"/>
-                <a:hlinkClick r:id="rId5"/>
-              </a:rPr>
               <a:t>protocol.md:94</a:t>
-            </a:r>
-            <a:r>
-              <a:rPr sz="1200" b="0">
-                <a:solidFill>
-                  <a:srgbClr val="8A8A8A"/>
-                </a:solidFill>
-                <a:latin typeface="Calibri"/>
-              </a:rPr>
-              <a:t>   ·   </a:t>
-            </a:r>
-            <a:r>
-              <a:rPr sz="1200" b="0" u="sng">
-                <a:solidFill>
-                  <a:srgbClr val="185FA5"/>
-                </a:solidFill>
-                <a:latin typeface="Calibri"/>
-                <a:hlinkClick r:id="rId6"/>
-              </a:rPr>
-              <a:t>KIP-35</a:t>
             </a:r>
           </a:p>
         </p:txBody>
@@ -5893,7 +5978,7 @@
                 </a:solidFill>
                 <a:latin typeface="Calibri"/>
               </a:rPr>
-              <a:t>Part 1 · 三層 scope</a:t>
+              <a:t>Part 1 · 地圖</a:t>
             </a:r>
           </a:p>
         </p:txBody>
@@ -5927,7 +6012,7 @@
                 </a:solidFill>
                 <a:latin typeface="Calibri"/>
               </a:rPr>
-              <a:t>一個版本號不夠：三種 scope 互斥</a:t>
+              <a:t>叢集裡有三種通訊，而且版本天生對不齊</a:t>
             </a:r>
           </a:p>
         </p:txBody>
@@ -5968,7 +6053,7 @@
                 </a:solidFill>
                 <a:latin typeface="Calibri"/>
               </a:rPr>
-              <a:t>release version   = 我裝了哪版 binary   (per-node)</a:t>
+              <a:t>client ─▶ broker        讀寫資料、查 metadata…</a:t>
             </a:r>
           </a:p>
           <a:p>
@@ -5979,7 +6064,7 @@
                 </a:solidFill>
                 <a:latin typeface="Calibri"/>
               </a:rPr>
-              <a:t>metadata.version  = 叢集一致的能力世代   (cluster-wide, finalize)</a:t>
+              <a:t>broker ─▶ controller    註冊、心跳、AlterPartition、轉發 admin…</a:t>
             </a:r>
           </a:p>
           <a:p>
@@ -5990,14 +6075,48 @@
                 </a:solidFill>
                 <a:latin typeface="Calibri"/>
               </a:rPr>
-              <a:t>wire API version  = 這條連線講第幾版     (per-connection)</a:t>
+              <a:t>broker ◀▶ broker        複製（follower 抓 leader）</a:t>
+            </a:r>
+          </a:p>
+        </p:txBody>
+      </p:sp>
+      <p:sp>
+        <p:nvSpPr>
+          <p:cNvPr id="5" name="TextBox 4"/>
+          <p:cNvSpPr txBox="1"/>
+          <p:nvPr/>
+        </p:nvSpPr>
+        <p:spPr>
+          <a:xfrm>
+            <a:off x="640080" y="3447288"/>
+            <a:ext cx="10972800" cy="438912"/>
+          </a:xfrm>
+          <a:prstGeom prst="rect">
+            <a:avLst/>
+          </a:prstGeom>
+          <a:noFill/>
+        </p:spPr>
+        <p:txBody>
+          <a:bodyPr wrap="square">
+            <a:noAutofit/>
+          </a:bodyPr>
+          <a:lstStyle/>
+          <a:p>
+            <a:r>
+              <a:rPr sz="1500" b="0">
+                <a:solidFill>
+                  <a:srgbClr val="5F5E5A"/>
+                </a:solidFill>
+                <a:latin typeface="Calibri"/>
+              </a:rPr>
+              <a:t>每列只列代表性的幾種、非窮舉；重點是「就這三條線」。</a:t>
             </a:r>
           </a:p>
         </p:txBody>
       </p:sp>
       <p:pic>
         <p:nvPicPr>
-          <p:cNvPr id="5" name="Picture 4" descr="arrows-split.png"/>
+          <p:cNvPr id="6" name="Picture 5" descr="clock-hour-4.png"/>
           <p:cNvPicPr>
             <a:picLocks noChangeAspect="1"/>
           </p:cNvPicPr>
@@ -6011,7 +6130,7 @@
         </p:blipFill>
         <p:spPr>
           <a:xfrm>
-            <a:off x="658368" y="3474720"/>
+            <a:off x="658368" y="4041648"/>
             <a:ext cx="274320" cy="274320"/>
           </a:xfrm>
           <a:prstGeom prst="rect">
@@ -6021,13 +6140,71 @@
       </p:pic>
       <p:sp>
         <p:nvSpPr>
-          <p:cNvPr id="6" name="TextBox 5"/>
-          <p:cNvSpPr txBox="1"/>
-          <p:nvPr/>
-        </p:nvSpPr>
-        <p:spPr>
-          <a:xfrm>
-            <a:off x="1078992" y="3447288"/>
+          <p:cNvPr id="7" name="TextBox 6"/>
+          <p:cNvSpPr txBox="1"/>
+          <p:nvPr/>
+        </p:nvSpPr>
+        <p:spPr>
+          <a:xfrm>
+            <a:off x="1078992" y="4014215"/>
+            <a:ext cx="10515600" cy="841248"/>
+          </a:xfrm>
+          <a:prstGeom prst="rect">
+            <a:avLst/>
+          </a:prstGeom>
+          <a:noFill/>
+        </p:spPr>
+        <p:txBody>
+          <a:bodyPr wrap="square">
+            <a:noAutofit/>
+          </a:bodyPr>
+          <a:lstStyle/>
+          <a:p>
+            <a:r>
+              <a:rPr sz="1650" b="0">
+                <a:solidFill>
+                  <a:srgbClr val="1E2024"/>
+                </a:solidFill>
+                <a:latin typeface="Calibri"/>
+              </a:rPr>
+              <a:t>client 內嵌在各 app、長期不更新（Kafka 曾為舊 client 保留每個 protocol 版本近九年，4.0／KIP-896 才把下限提到 2.1）</a:t>
+            </a:r>
+          </a:p>
+        </p:txBody>
+      </p:sp>
+      <p:pic>
+        <p:nvPicPr>
+          <p:cNvPr id="8" name="Picture 7" descr="server-2.png"/>
+          <p:cNvPicPr>
+            <a:picLocks noChangeAspect="1"/>
+          </p:cNvPicPr>
+          <p:nvPr/>
+        </p:nvPicPr>
+        <p:blipFill>
+          <a:blip r:embed="rId3"/>
+          <a:stretch>
+            <a:fillRect/>
+          </a:stretch>
+        </p:blipFill>
+        <p:spPr>
+          <a:xfrm>
+            <a:off x="658368" y="5029200"/>
+            <a:ext cx="274320" cy="274320"/>
+          </a:xfrm>
+          <a:prstGeom prst="rect">
+            <a:avLst/>
+          </a:prstGeom>
+        </p:spPr>
+      </p:pic>
+      <p:sp>
+        <p:nvSpPr>
+          <p:cNvPr id="9" name="TextBox 8"/>
+          <p:cNvSpPr txBox="1"/>
+          <p:nvPr/>
+        </p:nvSpPr>
+        <p:spPr>
+          <a:xfrm>
+            <a:off x="1078992" y="5001768"/>
             <a:ext cx="10515600" cy="493776"/>
           </a:xfrm>
           <a:prstGeom prst="rect">
@@ -6048,20 +6225,20 @@
                 </a:solidFill>
                 <a:latin typeface="Calibri"/>
               </a:rPr>
-              <a:t>三層不會同步變動、scope 也不同，多數版本問題的根源都在於此</a:t>
-            </a:r>
-          </a:p>
-        </p:txBody>
-      </p:sp>
-      <p:sp>
-        <p:nvSpPr>
-          <p:cNvPr id="7" name="TextBox 6"/>
-          <p:cNvSpPr txBox="1"/>
-          <p:nvPr/>
-        </p:nvSpPr>
-        <p:spPr>
-          <a:xfrm>
-            <a:off x="640080" y="4087368"/>
+              <a:t>broker 逐台滾動升級，過程必然新舊並存；要不停機就不能要求全叢集同版</a:t>
+            </a:r>
+          </a:p>
+        </p:txBody>
+      </p:sp>
+      <p:sp>
+        <p:nvSpPr>
+          <p:cNvPr id="10" name="TextBox 9"/>
+          <p:cNvSpPr txBox="1"/>
+          <p:nvPr/>
+        </p:nvSpPr>
+        <p:spPr>
+          <a:xfrm>
+            <a:off x="640080" y="5641848"/>
             <a:ext cx="10972800" cy="566928"/>
           </a:xfrm>
           <a:prstGeom prst="rect">
@@ -6087,14 +6264,14 @@
                 </a:solidFill>
                 <a:latin typeface="Calibri"/>
               </a:rPr>
-              <a:t>單一版本號無法同時表達三種 scope，只能拆成三層各自管</a:t>
-            </a:r>
-          </a:p>
-        </p:txBody>
-      </p:sp>
-      <p:sp>
-        <p:nvSpPr>
-          <p:cNvPr id="8" name="TextBox 7"/>
+              <a:t>所以版本只能在連線當下協商——後面每個機制都掛在上面這三條線</a:t>
+            </a:r>
+          </a:p>
+        </p:txBody>
+      </p:sp>
+      <p:sp>
+        <p:nvSpPr>
+          <p:cNvPr id="11" name="TextBox 10"/>
           <p:cNvSpPr txBox="1"/>
           <p:nvPr/>
         </p:nvSpPr>
@@ -6124,13 +6301,33 @@
               <a:t>REF   </a:t>
             </a:r>
             <a:r>
+              <a:rPr sz="1200" b="0" u="sng">
+                <a:solidFill>
+                  <a:srgbClr val="185FA5"/>
+                </a:solidFill>
+                <a:latin typeface="Calibri"/>
+                <a:hlinkClick r:id="rId4"/>
+              </a:rPr>
+              <a:t>KIP-896</a:t>
+            </a:r>
+            <a:r>
               <a:rPr sz="1200" b="0">
                 <a:solidFill>
                   <a:srgbClr val="8A8A8A"/>
                 </a:solidFill>
                 <a:latin typeface="Calibri"/>
               </a:rPr>
-              <a:t>kafka-features describe</a:t>
+              <a:t>   ·   </a:t>
+            </a:r>
+            <a:r>
+              <a:rPr sz="1200" b="0" u="sng">
+                <a:solidFill>
+                  <a:srgbClr val="185FA5"/>
+                </a:solidFill>
+                <a:latin typeface="Courier New"/>
+                <a:hlinkClick r:id="rId5"/>
+              </a:rPr>
+              <a:t>protocol.md:94</a:t>
             </a:r>
             <a:r>
               <a:rPr sz="1200" b="0">
@@ -6146,10 +6343,10 @@
                 <a:solidFill>
                   <a:srgbClr val="185FA5"/>
                 </a:solidFill>
-                <a:latin typeface="Courier New"/>
-                <a:hlinkClick r:id="rId3"/>
-              </a:rPr>
-              <a:t>zk2kraft.md:71</a:t>
+                <a:latin typeface="Calibri"/>
+                <a:hlinkClick r:id="rId6"/>
+              </a:rPr>
+              <a:t>KIP-35</a:t>
             </a:r>
           </a:p>
         </p:txBody>
@@ -6201,7 +6398,7 @@
                 </a:solidFill>
                 <a:latin typeface="Calibri"/>
               </a:rPr>
-              <a:t>Part 1 · 選版機制</a:t>
+              <a:t>Part 1 · 三層 scope</a:t>
             </a:r>
           </a:p>
         </p:txBody>
@@ -6235,79 +6432,21 @@
                 </a:solidFill>
                 <a:latin typeface="Calibri"/>
               </a:rPr>
-              <a:t>回到三個角色：各自怎麼選版</a:t>
-            </a:r>
-          </a:p>
-        </p:txBody>
-      </p:sp>
-      <p:pic>
-        <p:nvPicPr>
-          <p:cNvPr id="4" name="Picture 3" descr="arrows-split.png"/>
-          <p:cNvPicPr>
-            <a:picLocks noChangeAspect="1"/>
-          </p:cNvPicPr>
-          <p:nvPr/>
-        </p:nvPicPr>
-        <p:blipFill>
-          <a:blip r:embed="rId2"/>
-          <a:stretch>
-            <a:fillRect/>
-          </a:stretch>
-        </p:blipFill>
-        <p:spPr>
-          <a:xfrm>
-            <a:off x="658368" y="2176272"/>
-            <a:ext cx="274320" cy="274320"/>
-          </a:xfrm>
-          <a:prstGeom prst="rect">
-            <a:avLst/>
-          </a:prstGeom>
-        </p:spPr>
-      </p:pic>
-      <p:sp>
-        <p:nvSpPr>
-          <p:cNvPr id="5" name="TextBox 4"/>
-          <p:cNvSpPr txBox="1"/>
-          <p:nvPr/>
-        </p:nvSpPr>
-        <p:spPr>
-          <a:xfrm>
-            <a:off x="1078992" y="2148840"/>
-            <a:ext cx="10515600" cy="841248"/>
-          </a:xfrm>
-          <a:prstGeom prst="rect">
-            <a:avLst/>
-          </a:prstGeom>
-          <a:noFill/>
-        </p:spPr>
-        <p:txBody>
-          <a:bodyPr wrap="square">
-            <a:noAutofit/>
-          </a:bodyPr>
-          <a:lstStyle/>
-          <a:p>
-            <a:r>
-              <a:rPr sz="1650" b="0">
-                <a:solidFill>
-                  <a:srgbClr val="1E2024"/>
-                </a:solidFill>
-                <a:latin typeface="Calibri"/>
-              </a:rPr>
-              <a:t>底層都先做 ApiVersions 握手（共用同一顆 NetworkClient）；決定版本的是 request Builder 留多少空間</a:t>
-            </a:r>
-          </a:p>
-        </p:txBody>
-      </p:sp>
-      <p:sp>
-        <p:nvSpPr>
-          <p:cNvPr id="6" name="TextBox 5"/>
-          <p:cNvSpPr txBox="1"/>
-          <p:nvPr/>
-        </p:nvSpPr>
-        <p:spPr>
-          <a:xfrm>
-            <a:off x="640080" y="3136392"/>
-            <a:ext cx="10972800" cy="1371600"/>
+              <a:t>一個版本號不夠：三種 scope 互斥</a:t>
+            </a:r>
+          </a:p>
+        </p:txBody>
+      </p:sp>
+      <p:sp>
+        <p:nvSpPr>
+          <p:cNvPr id="4" name="TextBox 3"/>
+          <p:cNvSpPr txBox="1"/>
+          <p:nvPr/>
+        </p:nvSpPr>
+        <p:spPr>
+          <a:xfrm>
+            <a:off x="640080" y="2148840"/>
+            <a:ext cx="10972800" cy="1097280"/>
           </a:xfrm>
           <a:prstGeom prst="rect">
             <a:avLst/>
@@ -6334,7 +6473,7 @@
                 </a:solidFill>
                 <a:latin typeface="Calibri"/>
               </a:rPr>
-              <a:t>client ↔ broker       協商，取交集最高</a:t>
+              <a:t>release version   = 我裝了哪版 binary   (per-node)</a:t>
             </a:r>
           </a:p>
           <a:p>
@@ -6345,7 +6484,7 @@
                 </a:solidFill>
                 <a:latin typeface="Calibri"/>
               </a:rPr>
-              <a:t>broker ↔ controller   也協商（broker 當 client：heartbeat / registration）</a:t>
+              <a:t>metadata.version  = 叢集一致的能力世代   (cluster-wide, finalize)</a:t>
             </a:r>
           </a:p>
           <a:p>
@@ -6356,7 +6495,65 @@
                 </a:solidFill>
                 <a:latin typeface="Calibri"/>
               </a:rPr>
-              <a:t>broker ↔ broker 複製   Fetch 由 MV 決定、ListOffsets 以 MV 為上限</a:t>
+              <a:t>wire API version  = 這條連線講第幾版     (per-connection)</a:t>
+            </a:r>
+          </a:p>
+        </p:txBody>
+      </p:sp>
+      <p:pic>
+        <p:nvPicPr>
+          <p:cNvPr id="5" name="Picture 4" descr="arrows-split.png"/>
+          <p:cNvPicPr>
+            <a:picLocks noChangeAspect="1"/>
+          </p:cNvPicPr>
+          <p:nvPr/>
+        </p:nvPicPr>
+        <p:blipFill>
+          <a:blip r:embed="rId2"/>
+          <a:stretch>
+            <a:fillRect/>
+          </a:stretch>
+        </p:blipFill>
+        <p:spPr>
+          <a:xfrm>
+            <a:off x="658368" y="3474720"/>
+            <a:ext cx="274320" cy="274320"/>
+          </a:xfrm>
+          <a:prstGeom prst="rect">
+            <a:avLst/>
+          </a:prstGeom>
+        </p:spPr>
+      </p:pic>
+      <p:sp>
+        <p:nvSpPr>
+          <p:cNvPr id="6" name="TextBox 5"/>
+          <p:cNvSpPr txBox="1"/>
+          <p:nvPr/>
+        </p:nvSpPr>
+        <p:spPr>
+          <a:xfrm>
+            <a:off x="1078992" y="3447288"/>
+            <a:ext cx="10515600" cy="493776"/>
+          </a:xfrm>
+          <a:prstGeom prst="rect">
+            <a:avLst/>
+          </a:prstGeom>
+          <a:noFill/>
+        </p:spPr>
+        <p:txBody>
+          <a:bodyPr wrap="square">
+            <a:noAutofit/>
+          </a:bodyPr>
+          <a:lstStyle/>
+          <a:p>
+            <a:r>
+              <a:rPr sz="1650" b="0">
+                <a:solidFill>
+                  <a:srgbClr val="1E2024"/>
+                </a:solidFill>
+                <a:latin typeface="Calibri"/>
+              </a:rPr>
+              <a:t>三層不會同步變動、scope 也不同，多數版本問題的根源都在於此</a:t>
             </a:r>
           </a:p>
         </p:txBody>
@@ -6369,8 +6566,8 @@
         </p:nvSpPr>
         <p:spPr>
           <a:xfrm>
-            <a:off x="640080" y="4709160"/>
-            <a:ext cx="10972800" cy="877824"/>
+            <a:off x="640080" y="4087368"/>
+            <a:ext cx="10972800" cy="566928"/>
           </a:xfrm>
           <a:prstGeom prst="rect">
             <a:avLst/>
@@ -6395,7 +6592,7 @@
                 </a:solidFill>
                 <a:latin typeface="Calibri"/>
               </a:rPr>
-              <a:t>MV 只影響複製用的 Fetch / ListOffsets；client、controller 那兩條都是協商</a:t>
+              <a:t>單一版本號無法同時表達三種 scope，只能拆成三層各自管</a:t>
             </a:r>
           </a:p>
         </p:txBody>
@@ -6432,6 +6629,24 @@
               <a:t>REF   </a:t>
             </a:r>
             <a:r>
+              <a:rPr sz="1200" b="0">
+                <a:solidFill>
+                  <a:srgbClr val="8A8A8A"/>
+                </a:solidFill>
+                <a:latin typeface="Calibri"/>
+              </a:rPr>
+              <a:t>kafka-features describe</a:t>
+            </a:r>
+            <a:r>
+              <a:rPr sz="1200" b="0">
+                <a:solidFill>
+                  <a:srgbClr val="8A8A8A"/>
+                </a:solidFill>
+                <a:latin typeface="Calibri"/>
+              </a:rPr>
+              <a:t>   ·   </a:t>
+            </a:r>
+            <a:r>
               <a:rPr sz="1200" b="0" u="sng">
                 <a:solidFill>
                   <a:srgbClr val="185FA5"/>
@@ -6439,45 +6654,7 @@
                 <a:latin typeface="Courier New"/>
                 <a:hlinkClick r:id="rId3"/>
               </a:rPr>
-              <a:t>latestUsableVersion</a:t>
-            </a:r>
-            <a:r>
-              <a:rPr sz="1200" b="0">
-                <a:solidFill>
-                  <a:srgbClr val="8A8A8A"/>
-                </a:solidFill>
-                <a:latin typeface="Calibri"/>
-              </a:rPr>
-              <a:t>   ·   </a:t>
-            </a:r>
-            <a:r>
-              <a:rPr sz="1200" b="0" u="sng">
-                <a:solidFill>
-                  <a:srgbClr val="185FA5"/>
-                </a:solidFill>
-                <a:latin typeface="Courier New"/>
-                <a:hlinkClick r:id="rId4"/>
-              </a:rPr>
-              <a:t>fetchRequestVersion</a:t>
-            </a:r>
-            <a:r>
-              <a:rPr sz="1200" b="0">
-                <a:solidFill>
-                  <a:srgbClr val="8A8A8A"/>
-                </a:solidFill>
-                <a:latin typeface="Calibri"/>
-              </a:rPr>
-              <a:t>   ·   </a:t>
-            </a:r>
-            <a:r>
-              <a:rPr sz="1200" b="0" u="sng">
-                <a:solidFill>
-                  <a:srgbClr val="185FA5"/>
-                </a:solidFill>
-                <a:latin typeface="Courier New"/>
-                <a:hlinkClick r:id="rId5"/>
-              </a:rPr>
-              <a:t>javadoc</a:t>
+              <a:t>zk2kraft.md:71</a:t>
             </a:r>
           </a:p>
         </p:txBody>
@@ -6529,7 +6706,7 @@
                 </a:solidFill>
                 <a:latin typeface="Calibri"/>
               </a:rPr>
-              <a:t>Part 1 · 舉例</a:t>
+              <a:t>Part 1 · 選版機制</a:t>
             </a:r>
           </a:p>
         </p:txBody>
@@ -6542,69 +6719,35 @@
         </p:nvSpPr>
         <p:spPr>
           <a:xfrm>
-            <a:off x="640080" y="822960"/>
-            <a:ext cx="10972800" cy="640080"/>
-          </a:xfrm>
-          <a:prstGeom prst="rect">
-            <a:avLst/>
-          </a:prstGeom>
-          <a:noFill/>
-        </p:spPr>
-        <p:txBody>
-          <a:bodyPr wrap="square">
-            <a:noAutofit/>
-          </a:bodyPr>
-          <a:lstStyle/>
-          <a:p>
-            <a:r>
-              <a:rPr sz="3000" b="1">
+            <a:off x="640080" y="841248"/>
+            <a:ext cx="10972800" cy="1005840"/>
+          </a:xfrm>
+          <a:prstGeom prst="rect">
+            <a:avLst/>
+          </a:prstGeom>
+          <a:noFill/>
+        </p:spPr>
+        <p:txBody>
+          <a:bodyPr wrap="square">
+            <a:noAutofit/>
+          </a:bodyPr>
+          <a:lstStyle/>
+          <a:p>
+            <a:r>
+              <a:rPr sz="3200" b="1">
                 <a:solidFill>
                   <a:srgbClr val="1E2024"/>
                 </a:solidFill>
                 <a:latin typeface="Calibri"/>
               </a:rPr>
-              <a:t>以一支 Fetch 為例：cb 協商、bb 由 MV</a:t>
-            </a:r>
-          </a:p>
-        </p:txBody>
-      </p:sp>
-      <p:sp>
-        <p:nvSpPr>
-          <p:cNvPr id="4" name="TextBox 3"/>
-          <p:cNvSpPr txBox="1"/>
-          <p:nvPr/>
-        </p:nvSpPr>
-        <p:spPr>
-          <a:xfrm>
-            <a:off x="640080" y="1481328"/>
-            <a:ext cx="10972800" cy="365760"/>
-          </a:xfrm>
-          <a:prstGeom prst="rect">
-            <a:avLst/>
-          </a:prstGeom>
-          <a:noFill/>
-        </p:spPr>
-        <p:txBody>
-          <a:bodyPr wrap="square">
-            <a:noAutofit/>
-          </a:bodyPr>
-          <a:lstStyle/>
-          <a:p>
-            <a:r>
-              <a:rPr sz="1400" b="0">
-                <a:solidFill>
-                  <a:srgbClr val="5F5E5A"/>
-                </a:solidFill>
-                <a:latin typeface="Calibri"/>
-              </a:rPr>
-              <a:t>同一支 Fetch 兩條線都會走：consumer fetch 是 cb、replica fetch 是 bb</a:t>
+              <a:t>回到三個角色：各自怎麼選版</a:t>
             </a:r>
           </a:p>
         </p:txBody>
       </p:sp>
       <p:pic>
         <p:nvPicPr>
-          <p:cNvPr id="5" name="Picture 4" descr="s2a-rangeline.png"/>
+          <p:cNvPr id="4" name="Picture 3" descr="arrows-split.png"/>
           <p:cNvPicPr>
             <a:picLocks noChangeAspect="1"/>
           </p:cNvPicPr>
@@ -6618,8 +6761,8 @@
         </p:blipFill>
         <p:spPr>
           <a:xfrm>
-            <a:off x="1664208" y="1965960"/>
-            <a:ext cx="8869680" cy="4093698"/>
+            <a:off x="658368" y="2176272"/>
+            <a:ext cx="274320" cy="274320"/>
           </a:xfrm>
           <a:prstGeom prst="rect">
             <a:avLst/>
@@ -6628,7 +6771,143 @@
       </p:pic>
       <p:sp>
         <p:nvSpPr>
+          <p:cNvPr id="5" name="TextBox 4"/>
+          <p:cNvSpPr txBox="1"/>
+          <p:nvPr/>
+        </p:nvSpPr>
+        <p:spPr>
+          <a:xfrm>
+            <a:off x="1078992" y="2148840"/>
+            <a:ext cx="10515600" cy="841248"/>
+          </a:xfrm>
+          <a:prstGeom prst="rect">
+            <a:avLst/>
+          </a:prstGeom>
+          <a:noFill/>
+        </p:spPr>
+        <p:txBody>
+          <a:bodyPr wrap="square">
+            <a:noAutofit/>
+          </a:bodyPr>
+          <a:lstStyle/>
+          <a:p>
+            <a:r>
+              <a:rPr sz="1650" b="0">
+                <a:solidFill>
+                  <a:srgbClr val="1E2024"/>
+                </a:solidFill>
+                <a:latin typeface="Calibri"/>
+              </a:rPr>
+              <a:t>底層都先做 ApiVersions 握手（共用同一顆 NetworkClient）；決定版本的是 request Builder 留多少空間</a:t>
+            </a:r>
+          </a:p>
+        </p:txBody>
+      </p:sp>
+      <p:sp>
+        <p:nvSpPr>
           <p:cNvPr id="6" name="TextBox 5"/>
+          <p:cNvSpPr txBox="1"/>
+          <p:nvPr/>
+        </p:nvSpPr>
+        <p:spPr>
+          <a:xfrm>
+            <a:off x="640080" y="3136392"/>
+            <a:ext cx="10972800" cy="1371600"/>
+          </a:xfrm>
+          <a:prstGeom prst="rect">
+            <a:avLst/>
+          </a:prstGeom>
+          <a:solidFill>
+            <a:srgbClr val="F3F1EC"/>
+          </a:solidFill>
+          <a:ln w="6350">
+            <a:solidFill>
+              <a:srgbClr val="E3E0D8"/>
+            </a:solidFill>
+          </a:ln>
+        </p:spPr>
+        <p:txBody>
+          <a:bodyPr wrap="square" lIns="146304" tIns="91440" bIns="91440">
+            <a:noAutofit/>
+          </a:bodyPr>
+          <a:lstStyle/>
+          <a:p>
+            <a:r>
+              <a:rPr sz="1350" b="0">
+                <a:solidFill>
+                  <a:srgbClr val="2C2C2A"/>
+                </a:solidFill>
+                <a:latin typeface="Calibri"/>
+              </a:rPr>
+              <a:t>client ↔ broker       協商，取交集最高</a:t>
+            </a:r>
+          </a:p>
+          <a:p>
+            <a:r>
+              <a:rPr sz="1350" b="0">
+                <a:solidFill>
+                  <a:srgbClr val="2C2C2A"/>
+                </a:solidFill>
+                <a:latin typeface="Calibri"/>
+              </a:rPr>
+              <a:t>broker ↔ controller   也協商（broker 當 client：heartbeat / registration）</a:t>
+            </a:r>
+          </a:p>
+          <a:p>
+            <a:r>
+              <a:rPr sz="1350" b="0">
+                <a:solidFill>
+                  <a:srgbClr val="2C2C2A"/>
+                </a:solidFill>
+                <a:latin typeface="Calibri"/>
+              </a:rPr>
+              <a:t>broker ↔ broker 複製   Fetch 由 MV 決定、ListOffsets 以 MV 為上限</a:t>
+            </a:r>
+          </a:p>
+        </p:txBody>
+      </p:sp>
+      <p:sp>
+        <p:nvSpPr>
+          <p:cNvPr id="7" name="TextBox 6"/>
+          <p:cNvSpPr txBox="1"/>
+          <p:nvPr/>
+        </p:nvSpPr>
+        <p:spPr>
+          <a:xfrm>
+            <a:off x="640080" y="4709160"/>
+            <a:ext cx="10972800" cy="877824"/>
+          </a:xfrm>
+          <a:prstGeom prst="rect">
+            <a:avLst/>
+          </a:prstGeom>
+          <a:solidFill>
+            <a:srgbClr val="E9F3DE"/>
+          </a:solidFill>
+          <a:ln>
+            <a:noFill/>
+          </a:ln>
+        </p:spPr>
+        <p:txBody>
+          <a:bodyPr wrap="square" lIns="146304" tIns="82296">
+            <a:noAutofit/>
+          </a:bodyPr>
+          <a:lstStyle/>
+          <a:p>
+            <a:r>
+              <a:rPr sz="1500" b="0">
+                <a:solidFill>
+                  <a:srgbClr val="27500A"/>
+                </a:solidFill>
+                <a:latin typeface="Calibri"/>
+              </a:rPr>
+              <a:t>MV 只影響複製用的 Fetch / ListOffsets；client、controller 那兩條都是協商</a:t>
+            </a:r>
+          </a:p>
+        </p:txBody>
+      </p:sp>
+      <p:sp>
+        <p:nvSpPr>
+          <p:cNvPr id="8" name="TextBox 7"/>
           <p:cNvSpPr txBox="1"/>
           <p:nvPr/>
         </p:nvSpPr>
@@ -6665,7 +6944,7 @@
                 <a:latin typeface="Courier New"/>
                 <a:hlinkClick r:id="rId3"/>
               </a:rPr>
-              <a:t>forConsumer/forReplica</a:t>
+              <a:t>latestUsableVersion</a:t>
             </a:r>
             <a:r>
               <a:rPr sz="1200" b="0">
@@ -6703,7 +6982,7 @@
                 <a:latin typeface="Courier New"/>
                 <a:hlinkClick r:id="rId5"/>
               </a:rPr>
-              <a:t>validVersions</a:t>
+              <a:t>javadoc</a:t>
             </a:r>
           </a:p>
         </p:txBody>
@@ -6755,7 +7034,7 @@
                 </a:solidFill>
                 <a:latin typeface="Calibri"/>
               </a:rPr>
-              <a:t>隨堂考 · 暖身</a:t>
+              <a:t>Part 1 · 舉例</a:t>
             </a:r>
           </a:p>
         </p:txBody>
@@ -6768,28 +7047,28 @@
         </p:nvSpPr>
         <p:spPr>
           <a:xfrm>
-            <a:off x="640080" y="841248"/>
-            <a:ext cx="10972800" cy="1188720"/>
-          </a:xfrm>
-          <a:prstGeom prst="rect">
-            <a:avLst/>
-          </a:prstGeom>
-          <a:noFill/>
-        </p:spPr>
-        <p:txBody>
-          <a:bodyPr wrap="square">
-            <a:noAutofit/>
-          </a:bodyPr>
-          <a:lstStyle/>
-          <a:p>
-            <a:r>
-              <a:rPr sz="2600" b="1">
+            <a:off x="640080" y="822960"/>
+            <a:ext cx="10972800" cy="640080"/>
+          </a:xfrm>
+          <a:prstGeom prst="rect">
+            <a:avLst/>
+          </a:prstGeom>
+          <a:noFill/>
+        </p:spPr>
+        <p:txBody>
+          <a:bodyPr wrap="square">
+            <a:noAutofit/>
+          </a:bodyPr>
+          <a:lstStyle/>
+          <a:p>
+            <a:r>
+              <a:rPr sz="2900" b="1">
                 <a:solidFill>
                   <a:srgbClr val="1E2024"/>
                 </a:solidFill>
                 <a:latin typeface="Calibri"/>
               </a:rPr>
-              <a:t>可以「一個版本打天下」嗎？</a:t>
+              <a:t>以一支 Fetch 為例：consumer 協商、replica 由 MV</a:t>
             </a:r>
           </a:p>
         </p:txBody>
@@ -6802,84 +7081,56 @@
         </p:nvSpPr>
         <p:spPr>
           <a:xfrm>
-            <a:off x="822960" y="2331720"/>
-            <a:ext cx="10515600" cy="493776"/>
-          </a:xfrm>
-          <a:prstGeom prst="rect">
-            <a:avLst/>
-          </a:prstGeom>
-          <a:noFill/>
-        </p:spPr>
-        <p:txBody>
-          <a:bodyPr wrap="square">
-            <a:noAutofit/>
-          </a:bodyPr>
-          <a:lstStyle/>
-          <a:p>
-            <a:r>
-              <a:rPr sz="1600" b="0">
-                <a:solidFill>
-                  <a:srgbClr val="1E2024"/>
-                </a:solidFill>
-                <a:latin typeface="Calibri"/>
-              </a:rPr>
-              <a:t>A.  </a:t>
-            </a:r>
-            <a:r>
-              <a:rPr sz="1600" b="0">
-                <a:solidFill>
-                  <a:srgbClr val="1E2024"/>
-                </a:solidFill>
-                <a:latin typeface="Calibri"/>
-              </a:rPr>
-              <a:t>可以，大家同一版一起升</a:t>
-            </a:r>
-          </a:p>
-        </p:txBody>
-      </p:sp>
-      <p:sp>
-        <p:nvSpPr>
-          <p:cNvPr id="5" name="TextBox 4"/>
-          <p:cNvSpPr txBox="1"/>
-          <p:nvPr/>
-        </p:nvSpPr>
-        <p:spPr>
-          <a:xfrm>
-            <a:off x="822960" y="2953512"/>
-            <a:ext cx="10515600" cy="493776"/>
-          </a:xfrm>
-          <a:prstGeom prst="rect">
-            <a:avLst/>
-          </a:prstGeom>
-          <a:noFill/>
-        </p:spPr>
-        <p:txBody>
-          <a:bodyPr wrap="square">
-            <a:noAutofit/>
-          </a:bodyPr>
-          <a:lstStyle/>
-          <a:p>
-            <a:r>
-              <a:rPr sz="1600" b="0">
-                <a:solidFill>
-                  <a:srgbClr val="1E2024"/>
-                </a:solidFill>
-                <a:latin typeface="Calibri"/>
-              </a:rPr>
-              <a:t>B.  </a:t>
-            </a:r>
-            <a:r>
-              <a:rPr sz="1600" b="0">
-                <a:solidFill>
-                  <a:srgbClr val="1E2024"/>
-                </a:solidFill>
-                <a:latin typeface="Calibri"/>
-              </a:rPr>
-              <a:t>不行——client 長壽 + 要不停機，得溝通當下協商</a:t>
-            </a:r>
-          </a:p>
-        </p:txBody>
-      </p:sp>
+            <a:off x="640080" y="1481328"/>
+            <a:ext cx="10972800" cy="365760"/>
+          </a:xfrm>
+          <a:prstGeom prst="rect">
+            <a:avLst/>
+          </a:prstGeom>
+          <a:noFill/>
+        </p:spPr>
+        <p:txBody>
+          <a:bodyPr wrap="square">
+            <a:noAutofit/>
+          </a:bodyPr>
+          <a:lstStyle/>
+          <a:p>
+            <a:r>
+              <a:rPr sz="1400" b="0">
+                <a:solidFill>
+                  <a:srgbClr val="5F5E5A"/>
+                </a:solidFill>
+                <a:latin typeface="Calibri"/>
+              </a:rPr>
+              <a:t>同一支 Fetch 兩種身分：consumer fetch 走 client↔broker、replica fetch 走 broker↔broker</a:t>
+            </a:r>
+          </a:p>
+        </p:txBody>
+      </p:sp>
+      <p:pic>
+        <p:nvPicPr>
+          <p:cNvPr id="5" name="Picture 4" descr="s2a-rangeline.png"/>
+          <p:cNvPicPr>
+            <a:picLocks noChangeAspect="1"/>
+          </p:cNvPicPr>
+          <p:nvPr/>
+        </p:nvPicPr>
+        <p:blipFill>
+          <a:blip r:embed="rId2"/>
+          <a:stretch>
+            <a:fillRect/>
+          </a:stretch>
+        </p:blipFill>
+        <p:spPr>
+          <a:xfrm>
+            <a:off x="1664208" y="1965960"/>
+            <a:ext cx="8869680" cy="4093698"/>
+          </a:xfrm>
+          <a:prstGeom prst="rect">
+            <a:avLst/>
+          </a:prstGeom>
+        </p:spPr>
+      </p:pic>
       <p:sp>
         <p:nvSpPr>
           <p:cNvPr id="6" name="TextBox 5"/>
@@ -6888,114 +7139,76 @@
         </p:nvSpPr>
         <p:spPr>
           <a:xfrm>
-            <a:off x="822960" y="3575304"/>
-            <a:ext cx="10515600" cy="493776"/>
-          </a:xfrm>
-          <a:prstGeom prst="rect">
-            <a:avLst/>
-          </a:prstGeom>
-          <a:noFill/>
-        </p:spPr>
-        <p:txBody>
-          <a:bodyPr wrap="square">
-            <a:noAutofit/>
-          </a:bodyPr>
-          <a:lstStyle/>
-          <a:p>
-            <a:r>
-              <a:rPr sz="1600" b="0">
-                <a:solidFill>
-                  <a:srgbClr val="1E2024"/>
-                </a:solidFill>
-                <a:latin typeface="Calibri"/>
-              </a:rPr>
-              <a:t>C.  </a:t>
-            </a:r>
-            <a:r>
-              <a:rPr sz="1600" b="0">
-                <a:solidFill>
-                  <a:srgbClr val="1E2024"/>
-                </a:solidFill>
-                <a:latin typeface="Calibri"/>
-              </a:rPr>
-              <a:t>可以，只要都 4.x</a:t>
-            </a:r>
-          </a:p>
-        </p:txBody>
-      </p:sp>
-      <p:sp>
-        <p:nvSpPr>
-          <p:cNvPr id="7" name="TextBox 6"/>
-          <p:cNvSpPr txBox="1"/>
-          <p:nvPr/>
-        </p:nvSpPr>
-        <p:spPr>
-          <a:xfrm>
-            <a:off x="822960" y="4197096"/>
-            <a:ext cx="10515600" cy="493776"/>
-          </a:xfrm>
-          <a:prstGeom prst="rect">
-            <a:avLst/>
-          </a:prstGeom>
-          <a:noFill/>
-        </p:spPr>
-        <p:txBody>
-          <a:bodyPr wrap="square">
-            <a:noAutofit/>
-          </a:bodyPr>
-          <a:lstStyle/>
-          <a:p>
-            <a:r>
-              <a:rPr sz="1600" b="0">
-                <a:solidFill>
-                  <a:srgbClr val="1E2024"/>
-                </a:solidFill>
-                <a:latin typeface="Calibri"/>
-              </a:rPr>
-              <a:t>D.  </a:t>
-            </a:r>
-            <a:r>
-              <a:rPr sz="1600" b="0">
-                <a:solidFill>
-                  <a:srgbClr val="1E2024"/>
-                </a:solidFill>
-                <a:latin typeface="Calibri"/>
-              </a:rPr>
-              <a:t>看 broker 數量</a:t>
-            </a:r>
-          </a:p>
-        </p:txBody>
-      </p:sp>
-      <p:sp>
-        <p:nvSpPr>
-          <p:cNvPr id="8" name="TextBox 7"/>
-          <p:cNvSpPr txBox="1"/>
-          <p:nvPr/>
-        </p:nvSpPr>
-        <p:spPr>
-          <a:xfrm>
-            <a:off x="640080" y="4910327"/>
-            <a:ext cx="10972800" cy="914400"/>
-          </a:xfrm>
-          <a:prstGeom prst="rect">
-            <a:avLst/>
-          </a:prstGeom>
-          <a:noFill/>
-        </p:spPr>
-        <p:txBody>
-          <a:bodyPr wrap="square">
-            <a:noAutofit/>
-          </a:bodyPr>
-          <a:lstStyle/>
-          <a:p>
-            <a:r>
-              <a:rPr sz="1400" b="0">
+            <a:off x="640080" y="6400800"/>
+            <a:ext cx="10972800" cy="384048"/>
+          </a:xfrm>
+          <a:prstGeom prst="rect">
+            <a:avLst/>
+          </a:prstGeom>
+          <a:noFill/>
+        </p:spPr>
+        <p:txBody>
+          <a:bodyPr wrap="square">
+            <a:noAutofit/>
+          </a:bodyPr>
+          <a:lstStyle/>
+          <a:p>
+            <a:r>
+              <a:rPr sz="1200" b="1">
                 <a:solidFill>
                   <a:srgbClr val="8A8A8A"/>
                 </a:solidFill>
                 <a:latin typeface="Calibri"/>
               </a:rPr>
-              <a:t>想一想 —— 下一頁公布答案</a:t>
+              <a:t>REF   </a:t>
+            </a:r>
+            <a:r>
+              <a:rPr sz="1200" b="0" u="sng">
+                <a:solidFill>
+                  <a:srgbClr val="185FA5"/>
+                </a:solidFill>
+                <a:latin typeface="Courier New"/>
+                <a:hlinkClick r:id="rId3"/>
+              </a:rPr>
+              <a:t>forConsumer/forReplica</a:t>
+            </a:r>
+            <a:r>
+              <a:rPr sz="1200" b="0">
+                <a:solidFill>
+                  <a:srgbClr val="8A8A8A"/>
+                </a:solidFill>
+                <a:latin typeface="Calibri"/>
+              </a:rPr>
+              <a:t>   ·   </a:t>
+            </a:r>
+            <a:r>
+              <a:rPr sz="1200" b="0" u="sng">
+                <a:solidFill>
+                  <a:srgbClr val="185FA5"/>
+                </a:solidFill>
+                <a:latin typeface="Courier New"/>
+                <a:hlinkClick r:id="rId4"/>
+              </a:rPr>
+              <a:t>fetchRequestVersion</a:t>
+            </a:r>
+            <a:r>
+              <a:rPr sz="1200" b="0">
+                <a:solidFill>
+                  <a:srgbClr val="8A8A8A"/>
+                </a:solidFill>
+                <a:latin typeface="Calibri"/>
+              </a:rPr>
+              <a:t>   ·   </a:t>
+            </a:r>
+            <a:r>
+              <a:rPr sz="1200" b="0" u="sng">
+                <a:solidFill>
+                  <a:srgbClr val="185FA5"/>
+                </a:solidFill>
+                <a:latin typeface="Courier New"/>
+                <a:hlinkClick r:id="rId5"/>
+              </a:rPr>
+              <a:t>validVersions</a:t>
             </a:r>
           </a:p>
         </p:txBody>
@@ -7047,7 +7260,7 @@
                 </a:solidFill>
                 <a:latin typeface="Calibri"/>
               </a:rPr>
-              <a:t>隨堂考 · 暖身　（正解）</a:t>
+              <a:t>隨堂考 · 暖身</a:t>
             </a:r>
           </a:p>
         </p:txBody>
@@ -7143,36 +7356,31 @@
           <a:prstGeom prst="rect">
             <a:avLst/>
           </a:prstGeom>
-          <a:solidFill>
-            <a:srgbClr val="E9F3DE"/>
-          </a:solidFill>
-          <a:ln>
-            <a:noFill/>
-          </a:ln>
-        </p:spPr>
-        <p:txBody>
-          <a:bodyPr wrap="square" lIns="128016" tIns="54864">
-            <a:noAutofit/>
-          </a:bodyPr>
-          <a:lstStyle/>
-          <a:p>
-            <a:r>
-              <a:rPr sz="1600" b="1">
-                <a:solidFill>
-                  <a:srgbClr val="27500A"/>
+          <a:noFill/>
+        </p:spPr>
+        <p:txBody>
+          <a:bodyPr wrap="square">
+            <a:noAutofit/>
+          </a:bodyPr>
+          <a:lstStyle/>
+          <a:p>
+            <a:r>
+              <a:rPr sz="1600" b="0">
+                <a:solidFill>
+                  <a:srgbClr val="1E2024"/>
                 </a:solidFill>
                 <a:latin typeface="Calibri"/>
               </a:rPr>
               <a:t>B.  </a:t>
             </a:r>
             <a:r>
-              <a:rPr sz="1600" b="1">
-                <a:solidFill>
-                  <a:srgbClr val="27500A"/>
-                </a:solidFill>
-                <a:latin typeface="Calibri"/>
-              </a:rPr>
-              <a:t>不行——client 長壽 + 要不停機，得溝通當下協商   ✓</a:t>
+              <a:rPr sz="1600" b="0">
+                <a:solidFill>
+                  <a:srgbClr val="1E2024"/>
+                </a:solidFill>
+                <a:latin typeface="Calibri"/>
+              </a:rPr>
+              <a:t>不行——client 長壽 + 要不停機，得溝通當下協商</a:t>
             </a:r>
           </a:p>
         </p:txBody>
@@ -7286,85 +7494,13 @@
           <a:lstStyle/>
           <a:p>
             <a:r>
-              <a:rPr sz="1400" b="1">
-                <a:solidFill>
-                  <a:srgbClr val="27500A"/>
-                </a:solidFill>
-                <a:latin typeface="Calibri"/>
-              </a:rPr>
-              <a:t>正解 B — </a:t>
-            </a:r>
-            <a:r>
               <a:rPr sz="1400" b="0">
                 <a:solidFill>
-                  <a:srgbClr val="1E2024"/>
-                </a:solidFill>
-                <a:latin typeface="Calibri"/>
-              </a:rPr>
-              <a:t>client 嵌在各 app、超長壽，混版是常態；要不停機升級就得每條連線各自選版本。</a:t>
-            </a:r>
-          </a:p>
-        </p:txBody>
-      </p:sp>
-      <p:sp>
-        <p:nvSpPr>
-          <p:cNvPr id="9" name="TextBox 8"/>
-          <p:cNvSpPr txBox="1"/>
-          <p:nvPr/>
-        </p:nvSpPr>
-        <p:spPr>
-          <a:xfrm>
-            <a:off x="640080" y="6400800"/>
-            <a:ext cx="10972800" cy="384048"/>
-          </a:xfrm>
-          <a:prstGeom prst="rect">
-            <a:avLst/>
-          </a:prstGeom>
-          <a:noFill/>
-        </p:spPr>
-        <p:txBody>
-          <a:bodyPr wrap="square">
-            <a:noAutofit/>
-          </a:bodyPr>
-          <a:lstStyle/>
-          <a:p>
-            <a:r>
-              <a:rPr sz="1200" b="1">
-                <a:solidFill>
                   <a:srgbClr val="8A8A8A"/>
                 </a:solidFill>
                 <a:latin typeface="Calibri"/>
               </a:rPr>
-              <a:t>REF   </a:t>
-            </a:r>
-            <a:r>
-              <a:rPr sz="1200" b="0" u="sng">
-                <a:solidFill>
-                  <a:srgbClr val="185FA5"/>
-                </a:solidFill>
-                <a:latin typeface="Courier New"/>
-                <a:hlinkClick r:id="rId2"/>
-              </a:rPr>
-              <a:t>protocol.md:94</a:t>
-            </a:r>
-            <a:r>
-              <a:rPr sz="1200" b="0">
-                <a:solidFill>
-                  <a:srgbClr val="8A8A8A"/>
-                </a:solidFill>
-                <a:latin typeface="Calibri"/>
-              </a:rPr>
-              <a:t>   ·   </a:t>
-            </a:r>
-            <a:r>
-              <a:rPr sz="1200" b="0" u="sng">
-                <a:solidFill>
-                  <a:srgbClr val="185FA5"/>
-                </a:solidFill>
-                <a:latin typeface="Calibri"/>
-                <a:hlinkClick r:id="rId3"/>
-              </a:rPr>
-              <a:t>KIP-896</a:t>
+              <a:t>想一想 —— 下一頁公布答案</a:t>
             </a:r>
           </a:p>
         </p:txBody>
@@ -7416,7 +7552,7 @@
                 </a:solidFill>
                 <a:latin typeface="Calibri"/>
               </a:rPr>
-              <a:t>隨堂考 · 核心</a:t>
+              <a:t>隨堂考 · 暖身　（正解）</a:t>
             </a:r>
           </a:p>
         </p:txBody>
@@ -7450,7 +7586,7 @@
                 </a:solidFill>
                 <a:latin typeface="Calibri"/>
               </a:rPr>
-              <a:t>replica fetch（broker↔broker）的 Fetch 版本怎麼決定？</a:t>
+              <a:t>可以「一個版本打天下」嗎？</a:t>
             </a:r>
           </a:p>
         </p:txBody>
@@ -7493,7 +7629,7 @@
                 </a:solidFill>
                 <a:latin typeface="Calibri"/>
               </a:rPr>
-              <a:t>兩 broker ApiVersions 協商取交集</a:t>
+              <a:t>可以，大家同一版一起升</a:t>
             </a:r>
           </a:p>
         </p:txBody>
@@ -7512,31 +7648,36 @@
           <a:prstGeom prst="rect">
             <a:avLst/>
           </a:prstGeom>
-          <a:noFill/>
-        </p:spPr>
-        <p:txBody>
-          <a:bodyPr wrap="square">
-            <a:noAutofit/>
-          </a:bodyPr>
-          <a:lstStyle/>
-          <a:p>
-            <a:r>
-              <a:rPr sz="1600" b="0">
-                <a:solidFill>
-                  <a:srgbClr val="1E2024"/>
+          <a:solidFill>
+            <a:srgbClr val="E9F3DE"/>
+          </a:solidFill>
+          <a:ln>
+            <a:noFill/>
+          </a:ln>
+        </p:spPr>
+        <p:txBody>
+          <a:bodyPr wrap="square" lIns="128016" tIns="54864">
+            <a:noAutofit/>
+          </a:bodyPr>
+          <a:lstStyle/>
+          <a:p>
+            <a:r>
+              <a:rPr sz="1600" b="1">
+                <a:solidFill>
+                  <a:srgbClr val="27500A"/>
                 </a:solidFill>
                 <a:latin typeface="Calibri"/>
               </a:rPr>
               <a:t>B.  </a:t>
             </a:r>
             <a:r>
-              <a:rPr sz="1600" b="0">
-                <a:solidFill>
-                  <a:srgbClr val="1E2024"/>
-                </a:solidFill>
-                <a:latin typeface="Calibri"/>
-              </a:rPr>
-              <a:t>由 finalized metadata.version 決定</a:t>
+              <a:rPr sz="1600" b="1">
+                <a:solidFill>
+                  <a:srgbClr val="27500A"/>
+                </a:solidFill>
+                <a:latin typeface="Calibri"/>
+              </a:rPr>
+              <a:t>不行——client 長壽 + 要不停機，得溝通當下協商   ✓</a:t>
             </a:r>
           </a:p>
         </p:txBody>
@@ -7579,7 +7720,7 @@
                 </a:solidFill>
                 <a:latin typeface="Calibri"/>
               </a:rPr>
-              <a:t>永遠用最新版</a:t>
+              <a:t>可以，只要都 4.x</a:t>
             </a:r>
           </a:p>
         </p:txBody>
@@ -7622,7 +7763,7 @@
                 </a:solidFill>
                 <a:latin typeface="Calibri"/>
               </a:rPr>
-              <a:t>controller 每次指定</a:t>
+              <a:t>看 broker 數量</a:t>
             </a:r>
           </a:p>
         </p:txBody>
@@ -7650,13 +7791,85 @@
           <a:lstStyle/>
           <a:p>
             <a:r>
+              <a:rPr sz="1400" b="1">
+                <a:solidFill>
+                  <a:srgbClr val="27500A"/>
+                </a:solidFill>
+                <a:latin typeface="Calibri"/>
+              </a:rPr>
+              <a:t>正解 B — </a:t>
+            </a:r>
+            <a:r>
               <a:rPr sz="1400" b="0">
                 <a:solidFill>
+                  <a:srgbClr val="1E2024"/>
+                </a:solidFill>
+                <a:latin typeface="Calibri"/>
+              </a:rPr>
+              <a:t>client 嵌在各 app、超長壽，混版是常態；要不停機升級就得每條連線各自選版本。</a:t>
+            </a:r>
+          </a:p>
+        </p:txBody>
+      </p:sp>
+      <p:sp>
+        <p:nvSpPr>
+          <p:cNvPr id="9" name="TextBox 8"/>
+          <p:cNvSpPr txBox="1"/>
+          <p:nvPr/>
+        </p:nvSpPr>
+        <p:spPr>
+          <a:xfrm>
+            <a:off x="640080" y="6400800"/>
+            <a:ext cx="10972800" cy="384048"/>
+          </a:xfrm>
+          <a:prstGeom prst="rect">
+            <a:avLst/>
+          </a:prstGeom>
+          <a:noFill/>
+        </p:spPr>
+        <p:txBody>
+          <a:bodyPr wrap="square">
+            <a:noAutofit/>
+          </a:bodyPr>
+          <a:lstStyle/>
+          <a:p>
+            <a:r>
+              <a:rPr sz="1200" b="1">
+                <a:solidFill>
                   <a:srgbClr val="8A8A8A"/>
                 </a:solidFill>
                 <a:latin typeface="Calibri"/>
               </a:rPr>
-              <a:t>想一想 —— 下一頁公布答案</a:t>
+              <a:t>REF   </a:t>
+            </a:r>
+            <a:r>
+              <a:rPr sz="1200" b="0" u="sng">
+                <a:solidFill>
+                  <a:srgbClr val="185FA5"/>
+                </a:solidFill>
+                <a:latin typeface="Courier New"/>
+                <a:hlinkClick r:id="rId2"/>
+              </a:rPr>
+              <a:t>protocol.md:94</a:t>
+            </a:r>
+            <a:r>
+              <a:rPr sz="1200" b="0">
+                <a:solidFill>
+                  <a:srgbClr val="8A8A8A"/>
+                </a:solidFill>
+                <a:latin typeface="Calibri"/>
+              </a:rPr>
+              <a:t>   ·   </a:t>
+            </a:r>
+            <a:r>
+              <a:rPr sz="1200" b="0" u="sng">
+                <a:solidFill>
+                  <a:srgbClr val="185FA5"/>
+                </a:solidFill>
+                <a:latin typeface="Calibri"/>
+                <a:hlinkClick r:id="rId3"/>
+              </a:rPr>
+              <a:t>KIP-896</a:t>
             </a:r>
           </a:p>
         </p:txBody>

</xml_diff>

<commit_message>
study(version-control): Part 1 因果拆乾淨、隨堂考砍到 2 題
- 拆成 動機(為何對不齊→協商) / 術語(版本是哪一層) / 架構(三種連線各自怎麼選)，三個不同問題，不再重複「一個版本不夠」
- 三角色地圖併進「架構」那張、controller 一次登場；移除易誤導的「三種通訊 而且 對不齊」因果綁定
- 隨堂考 3→2（移除過於簡單的「一個版本打天下」）；14 張
- talk-outline.md 同步
</commit_message>
<xml_diff>
--- a/study/version-control/kafka-version-negotiation.pptx
+++ b/study/version-control/kafka-version-negotiation.pptx
@@ -19,8 +19,6 @@
     <p:sldId id="267" r:id="rId18"/>
     <p:sldId id="268" r:id="rId19"/>
     <p:sldId id="269" r:id="rId20"/>
-    <p:sldId id="270" r:id="rId21"/>
-    <p:sldId id="271" r:id="rId22"/>
   </p:sldIdLst>
   <p:sldSz cx="12191695" cy="6858000" type="screen4x3"/>
   <p:notesSz cx="6858000" cy="9144000"/>
@@ -3329,7 +3327,7 @@
                 </a:solidFill>
                 <a:latin typeface="Calibri"/>
               </a:rPr>
-              <a:t>隨堂考 · 核心</a:t>
+              <a:t>Part 2 · 失敗訊息</a:t>
             </a:r>
           </a:p>
         </p:txBody>
@@ -3343,7 +3341,7 @@
         <p:spPr>
           <a:xfrm>
             <a:off x="640080" y="841248"/>
-            <a:ext cx="10972800" cy="1188720"/>
+            <a:ext cx="10972800" cy="1005840"/>
           </a:xfrm>
           <a:prstGeom prst="rect">
             <a:avLst/>
@@ -3357,13 +3355,13 @@
           <a:lstStyle/>
           <a:p>
             <a:r>
-              <a:rPr sz="2600" b="1">
+              <a:rPr sz="3200" b="1">
                 <a:solidFill>
                   <a:srgbClr val="1E2024"/>
                 </a:solidFill>
                 <a:latin typeface="Calibri"/>
               </a:rPr>
-              <a:t>replica fetch（broker↔broker）的 Fetch 版本怎麼決定？</a:t>
+              <a:t>通訊當下協商不出版本，會看到什麼</a:t>
             </a:r>
           </a:p>
         </p:txBody>
@@ -3376,7 +3374,94 @@
         </p:nvSpPr>
         <p:spPr>
           <a:xfrm>
-            <a:off x="822960" y="2331720"/>
+            <a:off x="640080" y="2148840"/>
+            <a:ext cx="10972800" cy="1371600"/>
+          </a:xfrm>
+          <a:prstGeom prst="rect">
+            <a:avLst/>
+          </a:prstGeom>
+          <a:solidFill>
+            <a:srgbClr val="F3F1EC"/>
+          </a:solidFill>
+          <a:ln w="6350">
+            <a:solidFill>
+              <a:srgbClr val="E3E0D8"/>
+            </a:solidFill>
+          </a:ln>
+        </p:spPr>
+        <p:txBody>
+          <a:bodyPr wrap="square" lIns="146304" tIns="91440" bIns="91440">
+            <a:noAutofit/>
+          </a:bodyPr>
+          <a:lstStyle/>
+          <a:p>
+            <a:r>
+              <a:rPr sz="1350" b="0">
+                <a:solidFill>
+                  <a:srgbClr val="2C2C2A"/>
+                </a:solidFill>
+                <a:latin typeface="Calibri"/>
+              </a:rPr>
+              <a:t>交集空        → client 端 UnsupportedVersionException（送出前 abort）</a:t>
+            </a:r>
+          </a:p>
+          <a:p>
+            <a:r>
+              <a:rPr sz="1350" b="0">
+                <a:solidFill>
+                  <a:srgbClr val="2C2C2A"/>
+                </a:solidFill>
+                <a:latin typeface="Calibri"/>
+              </a:rPr>
+              <a:t>繞過協商自刻  → broker 丟 UnsupportedVersionException + 關線</a:t>
+            </a:r>
+          </a:p>
+          <a:p>
+            <a:r>
+              <a:rPr sz="1350" b="0">
+                <a:solidFill>
+                  <a:srgbClr val="2C2C2A"/>
+                </a:solidFill>
+                <a:latin typeface="Calibri"/>
+              </a:rPr>
+              <a:t>（ApiVersions 例外：回 v0 + UNSUPPORTED_VERSION 錯誤碼）</a:t>
+            </a:r>
+          </a:p>
+        </p:txBody>
+      </p:sp>
+      <p:pic>
+        <p:nvPicPr>
+          <p:cNvPr id="5" name="Picture 4" descr="ban.png"/>
+          <p:cNvPicPr>
+            <a:picLocks noChangeAspect="1"/>
+          </p:cNvPicPr>
+          <p:nvPr/>
+        </p:nvPicPr>
+        <p:blipFill>
+          <a:blip r:embed="rId2"/>
+          <a:stretch>
+            <a:fillRect/>
+          </a:stretch>
+        </p:blipFill>
+        <p:spPr>
+          <a:xfrm>
+            <a:off x="658368" y="3749040"/>
+            <a:ext cx="274320" cy="274320"/>
+          </a:xfrm>
+          <a:prstGeom prst="rect">
+            <a:avLst/>
+          </a:prstGeom>
+        </p:spPr>
+      </p:pic>
+      <p:sp>
+        <p:nvSpPr>
+          <p:cNvPr id="6" name="TextBox 5"/>
+          <p:cNvSpPr txBox="1"/>
+          <p:nvPr/>
+        </p:nvSpPr>
+        <p:spPr>
+          <a:xfrm>
+            <a:off x="1078992" y="3721608"/>
             <a:ext cx="10515600" cy="493776"/>
           </a:xfrm>
           <a:prstGeom prst="rect">
@@ -3391,36 +3476,27 @@
           <a:lstStyle/>
           <a:p>
             <a:r>
-              <a:rPr sz="1600" b="0">
+              <a:rPr sz="1650" b="0">
                 <a:solidFill>
                   <a:srgbClr val="1E2024"/>
                 </a:solidFill>
                 <a:latin typeface="Calibri"/>
               </a:rPr>
-              <a:t>A.  </a:t>
-            </a:r>
-            <a:r>
-              <a:rPr sz="1600" b="0">
-                <a:solidFill>
-                  <a:srgbClr val="1E2024"/>
-                </a:solidFill>
-                <a:latin typeface="Calibri"/>
-              </a:rPr>
-              <a:t>兩 broker ApiVersions 協商取交集</a:t>
-            </a:r>
-          </a:p>
-        </p:txBody>
-      </p:sp>
-      <p:sp>
-        <p:nvSpPr>
-          <p:cNvPr id="5" name="TextBox 4"/>
-          <p:cNvSpPr txBox="1"/>
-          <p:nvPr/>
-        </p:nvSpPr>
-        <p:spPr>
-          <a:xfrm>
-            <a:off x="822960" y="2953512"/>
-            <a:ext cx="10515600" cy="493776"/>
+              <a:t>多數情況 client 在送出前就本地中止，根本沒上網路</a:t>
+            </a:r>
+          </a:p>
+        </p:txBody>
+      </p:sp>
+      <p:sp>
+        <p:nvSpPr>
+          <p:cNvPr id="7" name="TextBox 6"/>
+          <p:cNvSpPr txBox="1"/>
+          <p:nvPr/>
+        </p:nvSpPr>
+        <p:spPr>
+          <a:xfrm>
+            <a:off x="640080" y="6400800"/>
+            <a:ext cx="10972800" cy="384048"/>
           </a:xfrm>
           <a:prstGeom prst="rect">
             <a:avLst/>
@@ -3434,142 +3510,61 @@
           <a:lstStyle/>
           <a:p>
             <a:r>
-              <a:rPr sz="1600" b="0">
-                <a:solidFill>
-                  <a:srgbClr val="1E2024"/>
-                </a:solidFill>
-                <a:latin typeface="Calibri"/>
-              </a:rPr>
-              <a:t>B.  </a:t>
-            </a:r>
-            <a:r>
-              <a:rPr sz="1600" b="0">
-                <a:solidFill>
-                  <a:srgbClr val="1E2024"/>
-                </a:solidFill>
-                <a:latin typeface="Calibri"/>
-              </a:rPr>
-              <a:t>由 finalized metadata.version 決定</a:t>
-            </a:r>
-          </a:p>
-        </p:txBody>
-      </p:sp>
-      <p:sp>
-        <p:nvSpPr>
-          <p:cNvPr id="6" name="TextBox 5"/>
-          <p:cNvSpPr txBox="1"/>
-          <p:nvPr/>
-        </p:nvSpPr>
-        <p:spPr>
-          <a:xfrm>
-            <a:off x="822960" y="3575304"/>
-            <a:ext cx="10515600" cy="493776"/>
-          </a:xfrm>
-          <a:prstGeom prst="rect">
-            <a:avLst/>
-          </a:prstGeom>
-          <a:noFill/>
-        </p:spPr>
-        <p:txBody>
-          <a:bodyPr wrap="square">
-            <a:noAutofit/>
-          </a:bodyPr>
-          <a:lstStyle/>
-          <a:p>
-            <a:r>
-              <a:rPr sz="1600" b="0">
-                <a:solidFill>
-                  <a:srgbClr val="1E2024"/>
-                </a:solidFill>
-                <a:latin typeface="Calibri"/>
-              </a:rPr>
-              <a:t>C.  </a:t>
-            </a:r>
-            <a:r>
-              <a:rPr sz="1600" b="0">
-                <a:solidFill>
-                  <a:srgbClr val="1E2024"/>
-                </a:solidFill>
-                <a:latin typeface="Calibri"/>
-              </a:rPr>
-              <a:t>永遠用最新版</a:t>
-            </a:r>
-          </a:p>
-        </p:txBody>
-      </p:sp>
-      <p:sp>
-        <p:nvSpPr>
-          <p:cNvPr id="7" name="TextBox 6"/>
-          <p:cNvSpPr txBox="1"/>
-          <p:nvPr/>
-        </p:nvSpPr>
-        <p:spPr>
-          <a:xfrm>
-            <a:off x="822960" y="4197096"/>
-            <a:ext cx="10515600" cy="493776"/>
-          </a:xfrm>
-          <a:prstGeom prst="rect">
-            <a:avLst/>
-          </a:prstGeom>
-          <a:noFill/>
-        </p:spPr>
-        <p:txBody>
-          <a:bodyPr wrap="square">
-            <a:noAutofit/>
-          </a:bodyPr>
-          <a:lstStyle/>
-          <a:p>
-            <a:r>
-              <a:rPr sz="1600" b="0">
-                <a:solidFill>
-                  <a:srgbClr val="1E2024"/>
-                </a:solidFill>
-                <a:latin typeface="Calibri"/>
-              </a:rPr>
-              <a:t>D.  </a:t>
-            </a:r>
-            <a:r>
-              <a:rPr sz="1600" b="0">
-                <a:solidFill>
-                  <a:srgbClr val="1E2024"/>
-                </a:solidFill>
-                <a:latin typeface="Calibri"/>
-              </a:rPr>
-              <a:t>controller 每次指定</a:t>
-            </a:r>
-          </a:p>
-        </p:txBody>
-      </p:sp>
-      <p:sp>
-        <p:nvSpPr>
-          <p:cNvPr id="8" name="TextBox 7"/>
-          <p:cNvSpPr txBox="1"/>
-          <p:nvPr/>
-        </p:nvSpPr>
-        <p:spPr>
-          <a:xfrm>
-            <a:off x="640080" y="4910327"/>
-            <a:ext cx="10972800" cy="914400"/>
-          </a:xfrm>
-          <a:prstGeom prst="rect">
-            <a:avLst/>
-          </a:prstGeom>
-          <a:noFill/>
-        </p:spPr>
-        <p:txBody>
-          <a:bodyPr wrap="square">
-            <a:noAutofit/>
-          </a:bodyPr>
-          <a:lstStyle/>
-          <a:p>
-            <a:r>
-              <a:rPr sz="1400" b="0">
+              <a:rPr sz="1200" b="1">
                 <a:solidFill>
                   <a:srgbClr val="8A8A8A"/>
                 </a:solidFill>
                 <a:latin typeface="Calibri"/>
               </a:rPr>
-              <a:t>想一想 —— 下一頁公布答案</a:t>
+              <a:t>REF   </a:t>
+            </a:r>
+            <a:r>
+              <a:rPr sz="1200" b="0" u="sng">
+                <a:solidFill>
+                  <a:srgbClr val="185FA5"/>
+                </a:solidFill>
+                <a:latin typeface="Courier New"/>
+                <a:hlinkClick r:id="rId3"/>
+              </a:rPr>
+              <a:t>latestUsableVersion</a:t>
+            </a:r>
+            <a:r>
+              <a:rPr sz="1200" b="0">
+                <a:solidFill>
+                  <a:srgbClr val="8A8A8A"/>
+                </a:solidFill>
+                <a:latin typeface="Calibri"/>
+              </a:rPr>
+              <a:t>   ·   </a:t>
+            </a:r>
+            <a:r>
+              <a:rPr sz="1200" b="0" u="sng">
+                <a:solidFill>
+                  <a:srgbClr val="185FA5"/>
+                </a:solidFill>
+                <a:latin typeface="Courier New"/>
+                <a:hlinkClick r:id="rId4"/>
+              </a:rPr>
+              <a:t>NetworkClient</a:t>
+            </a:r>
+            <a:r>
+              <a:rPr sz="1200" b="0">
+                <a:solidFill>
+                  <a:srgbClr val="8A8A8A"/>
+                </a:solidFill>
+                <a:latin typeface="Calibri"/>
+              </a:rPr>
+              <a:t>   ·   </a:t>
+            </a:r>
+            <a:r>
+              <a:rPr sz="1200" b="0" u="sng">
+                <a:solidFill>
+                  <a:srgbClr val="185FA5"/>
+                </a:solidFill>
+                <a:latin typeface="Courier New"/>
+                <a:hlinkClick r:id="rId5"/>
+              </a:rPr>
+              <a:t>RequestContext</a:t>
             </a:r>
           </a:p>
         </p:txBody>
@@ -3621,7 +3616,7 @@
                 </a:solidFill>
                 <a:latin typeface="Calibri"/>
               </a:rPr>
-              <a:t>隨堂考 · 核心　（正解）</a:t>
+              <a:t>Part 2 · 失敗訊息</a:t>
             </a:r>
           </a:p>
         </p:txBody>
@@ -3635,7 +3630,7 @@
         <p:spPr>
           <a:xfrm>
             <a:off x="640080" y="841248"/>
-            <a:ext cx="10972800" cy="1188720"/>
+            <a:ext cx="10972800" cy="1005840"/>
           </a:xfrm>
           <a:prstGeom prst="rect">
             <a:avLst/>
@@ -3649,13 +3644,13 @@
           <a:lstStyle/>
           <a:p>
             <a:r>
-              <a:rPr sz="2600" b="1">
+              <a:rPr sz="3200" b="1">
                 <a:solidFill>
                   <a:srgbClr val="1E2024"/>
                 </a:solidFill>
                 <a:latin typeface="Calibri"/>
               </a:rPr>
-              <a:t>replica fetch（broker↔broker）的 Fetch 版本怎麼決定？</a:t>
+              <a:t>版本截斷：為什麼「升一點點」不夠</a:t>
             </a:r>
           </a:p>
         </p:txBody>
@@ -3668,37 +3663,46 @@
         </p:nvSpPr>
         <p:spPr>
           <a:xfrm>
-            <a:off x="822960" y="2331720"/>
-            <a:ext cx="10515600" cy="493776"/>
-          </a:xfrm>
-          <a:prstGeom prst="rect">
-            <a:avLst/>
-          </a:prstGeom>
-          <a:noFill/>
-        </p:spPr>
-        <p:txBody>
-          <a:bodyPr wrap="square">
-            <a:noAutofit/>
-          </a:bodyPr>
-          <a:lstStyle/>
-          <a:p>
-            <a:r>
-              <a:rPr sz="1600" b="0">
-                <a:solidFill>
-                  <a:srgbClr val="1E2024"/>
-                </a:solidFill>
-                <a:latin typeface="Calibri"/>
-              </a:rPr>
-              <a:t>A.  </a:t>
-            </a:r>
-            <a:r>
-              <a:rPr sz="1600" b="0">
-                <a:solidFill>
-                  <a:srgbClr val="1E2024"/>
-                </a:solidFill>
-                <a:latin typeface="Calibri"/>
-              </a:rPr>
-              <a:t>兩 broker ApiVersions 協商取交集</a:t>
+            <a:off x="640080" y="2148840"/>
+            <a:ext cx="10972800" cy="822959"/>
+          </a:xfrm>
+          <a:prstGeom prst="rect">
+            <a:avLst/>
+          </a:prstGeom>
+          <a:solidFill>
+            <a:srgbClr val="F3F1EC"/>
+          </a:solidFill>
+          <a:ln w="6350">
+            <a:solidFill>
+              <a:srgbClr val="E3E0D8"/>
+            </a:solidFill>
+          </a:ln>
+        </p:spPr>
+        <p:txBody>
+          <a:bodyPr wrap="square" lIns="146304" tIns="91440" bIns="91440">
+            <a:noAutofit/>
+          </a:bodyPr>
+          <a:lstStyle/>
+          <a:p>
+            <a:r>
+              <a:rPr sz="1350" b="0">
+                <a:solidFill>
+                  <a:srgbClr val="2C2C2A"/>
+                </a:solidFill>
+                <a:latin typeface="Calibri"/>
+              </a:rPr>
+              <a:t>舊 wire API version 被整個移除，min 可 &gt; 0</a:t>
+            </a:r>
+          </a:p>
+          <a:p>
+            <a:r>
+              <a:rPr sz="1350" b="0">
+                <a:solidFill>
+                  <a:srgbClr val="2C2C2A"/>
+                </a:solidFill>
+                <a:latin typeface="Calibri"/>
+              </a:rPr>
+              <a:t>  Fetch：4–18（v0–3 在 4.0 移除）</a:t>
             </a:r>
           </a:p>
         </p:txBody>
@@ -3711,8 +3715,8 @@
         </p:nvSpPr>
         <p:spPr>
           <a:xfrm>
-            <a:off x="822960" y="2953512"/>
-            <a:ext cx="10515600" cy="493776"/>
+            <a:off x="640080" y="3172968"/>
+            <a:ext cx="10972800" cy="566928"/>
           </a:xfrm>
           <a:prstGeom prst="rect">
             <a:avLst/>
@@ -3725,28 +3729,19 @@
           </a:ln>
         </p:spPr>
         <p:txBody>
-          <a:bodyPr wrap="square" lIns="128016" tIns="54864">
-            <a:noAutofit/>
-          </a:bodyPr>
-          <a:lstStyle/>
-          <a:p>
-            <a:r>
-              <a:rPr sz="1600" b="1">
+          <a:bodyPr wrap="square" lIns="146304" tIns="82296">
+            <a:noAutofit/>
+          </a:bodyPr>
+          <a:lstStyle/>
+          <a:p>
+            <a:r>
+              <a:rPr sz="1500" b="0">
                 <a:solidFill>
                   <a:srgbClr val="27500A"/>
                 </a:solidFill>
                 <a:latin typeface="Calibri"/>
               </a:rPr>
-              <a:t>B.  </a:t>
-            </a:r>
-            <a:r>
-              <a:rPr sz="1600" b="1">
-                <a:solidFill>
-                  <a:srgbClr val="27500A"/>
-                </a:solidFill>
-                <a:latin typeface="Calibri"/>
-              </a:rPr>
-              <a:t>由 finalized metadata.version 決定   ✓</a:t>
+              <a:t>解法：升級前確認兩端都跨過版本下限（升 4.0 需至少 2.1），否則協商結果沒有可用版本</a:t>
             </a:r>
           </a:p>
         </p:txBody>
@@ -3759,8 +3754,8 @@
         </p:nvSpPr>
         <p:spPr>
           <a:xfrm>
-            <a:off x="822960" y="3575304"/>
-            <a:ext cx="10515600" cy="493776"/>
+            <a:off x="640080" y="3922776"/>
+            <a:ext cx="10972800" cy="731520"/>
           </a:xfrm>
           <a:prstGeom prst="rect">
             <a:avLst/>
@@ -3774,22 +3769,13 @@
           <a:lstStyle/>
           <a:p>
             <a:r>
-              <a:rPr sz="1600" b="0">
-                <a:solidFill>
-                  <a:srgbClr val="1E2024"/>
-                </a:solidFill>
-                <a:latin typeface="Calibri"/>
-              </a:rPr>
-              <a:t>C.  </a:t>
-            </a:r>
-            <a:r>
-              <a:rPr sz="1600" b="0">
-                <a:solidFill>
-                  <a:srgbClr val="1E2024"/>
-                </a:solidFill>
-                <a:latin typeface="Calibri"/>
-              </a:rPr>
-              <a:t>永遠用最新版</a:t>
+              <a:rPr sz="1500" b="0">
+                <a:solidFill>
+                  <a:srgbClr val="5F5E5A"/>
+                </a:solidFill>
+                <a:latin typeface="Calibri"/>
+              </a:rPr>
+              <a:t>銜接（非本場）：finalize / 升降當下的錯誤（INVALID_UPDATE_VERSION 等）屬「運行時的版本升降」那場，本場不展開。</a:t>
             </a:r>
           </a:p>
         </p:txBody>
@@ -3797,92 +3783,6 @@
       <p:sp>
         <p:nvSpPr>
           <p:cNvPr id="7" name="TextBox 6"/>
-          <p:cNvSpPr txBox="1"/>
-          <p:nvPr/>
-        </p:nvSpPr>
-        <p:spPr>
-          <a:xfrm>
-            <a:off x="822960" y="4197096"/>
-            <a:ext cx="10515600" cy="493776"/>
-          </a:xfrm>
-          <a:prstGeom prst="rect">
-            <a:avLst/>
-          </a:prstGeom>
-          <a:noFill/>
-        </p:spPr>
-        <p:txBody>
-          <a:bodyPr wrap="square">
-            <a:noAutofit/>
-          </a:bodyPr>
-          <a:lstStyle/>
-          <a:p>
-            <a:r>
-              <a:rPr sz="1600" b="0">
-                <a:solidFill>
-                  <a:srgbClr val="1E2024"/>
-                </a:solidFill>
-                <a:latin typeface="Calibri"/>
-              </a:rPr>
-              <a:t>D.  </a:t>
-            </a:r>
-            <a:r>
-              <a:rPr sz="1600" b="0">
-                <a:solidFill>
-                  <a:srgbClr val="1E2024"/>
-                </a:solidFill>
-                <a:latin typeface="Calibri"/>
-              </a:rPr>
-              <a:t>controller 每次指定</a:t>
-            </a:r>
-          </a:p>
-        </p:txBody>
-      </p:sp>
-      <p:sp>
-        <p:nvSpPr>
-          <p:cNvPr id="8" name="TextBox 7"/>
-          <p:cNvSpPr txBox="1"/>
-          <p:nvPr/>
-        </p:nvSpPr>
-        <p:spPr>
-          <a:xfrm>
-            <a:off x="640080" y="4910327"/>
-            <a:ext cx="10972800" cy="914400"/>
-          </a:xfrm>
-          <a:prstGeom prst="rect">
-            <a:avLst/>
-          </a:prstGeom>
-          <a:noFill/>
-        </p:spPr>
-        <p:txBody>
-          <a:bodyPr wrap="square">
-            <a:noAutofit/>
-          </a:bodyPr>
-          <a:lstStyle/>
-          <a:p>
-            <a:r>
-              <a:rPr sz="1400" b="1">
-                <a:solidFill>
-                  <a:srgbClr val="27500A"/>
-                </a:solidFill>
-                <a:latin typeface="Calibri"/>
-              </a:rPr>
-              <a:t>正解 B — </a:t>
-            </a:r>
-            <a:r>
-              <a:rPr sz="1400" b="0">
-                <a:solidFill>
-                  <a:srgbClr val="1E2024"/>
-                </a:solidFill>
-                <a:latin typeface="Calibri"/>
-              </a:rPr>
-              <a:t>fetchRequestVersion(MV)：MV 是集中共識，不做 per-connection 協商。</a:t>
-            </a:r>
-          </a:p>
-        </p:txBody>
-      </p:sp>
-      <p:sp>
-        <p:nvSpPr>
-          <p:cNvPr id="9" name="TextBox 8"/>
           <p:cNvSpPr txBox="1"/>
           <p:nvPr/>
         </p:nvSpPr>
@@ -3919,7 +3819,7 @@
                 <a:latin typeface="Courier New"/>
                 <a:hlinkClick r:id="rId2"/>
               </a:rPr>
-              <a:t>RemoteLeaderEndPoint.scala:215</a:t>
+              <a:t>upgrade.md:229</a:t>
             </a:r>
             <a:r>
               <a:rPr sz="1200" b="0">
@@ -3938,7 +3838,7 @@
                 <a:latin typeface="Courier New"/>
                 <a:hlinkClick r:id="rId3"/>
               </a:rPr>
-              <a:t>MetadataVersion.java:273</a:t>
+              <a:t>FetchRequest.json validVersions</a:t>
             </a:r>
           </a:p>
         </p:txBody>
@@ -3990,7 +3890,7 @@
                 </a:solidFill>
                 <a:latin typeface="Calibri"/>
               </a:rPr>
-              <a:t>Part 2 · 失敗訊息</a:t>
+              <a:t>隨堂考 · 核心</a:t>
             </a:r>
           </a:p>
         </p:txBody>
@@ -4004,7 +3904,7 @@
         <p:spPr>
           <a:xfrm>
             <a:off x="640080" y="841248"/>
-            <a:ext cx="10972800" cy="1005840"/>
+            <a:ext cx="10972800" cy="1188720"/>
           </a:xfrm>
           <a:prstGeom prst="rect">
             <a:avLst/>
@@ -4018,13 +3918,13 @@
           <a:lstStyle/>
           <a:p>
             <a:r>
-              <a:rPr sz="3200" b="1">
+              <a:rPr sz="2600" b="1">
                 <a:solidFill>
                   <a:srgbClr val="1E2024"/>
                 </a:solidFill>
                 <a:latin typeface="Calibri"/>
               </a:rPr>
-              <a:t>通訊當下協商不出版本，會看到什麼</a:t>
+              <a:t>自刻 client 送了不支援的 API version，會怎樣？</a:t>
             </a:r>
           </a:p>
         </p:txBody>
@@ -4037,85 +3937,84 @@
         </p:nvSpPr>
         <p:spPr>
           <a:xfrm>
-            <a:off x="640080" y="2148840"/>
-            <a:ext cx="10972800" cy="1371600"/>
-          </a:xfrm>
-          <a:prstGeom prst="rect">
-            <a:avLst/>
-          </a:prstGeom>
-          <a:solidFill>
-            <a:srgbClr val="F3F1EC"/>
-          </a:solidFill>
-          <a:ln w="6350">
-            <a:solidFill>
-              <a:srgbClr val="E3E0D8"/>
-            </a:solidFill>
-          </a:ln>
-        </p:spPr>
-        <p:txBody>
-          <a:bodyPr wrap="square" lIns="146304" tIns="91440" bIns="91440">
-            <a:noAutofit/>
-          </a:bodyPr>
-          <a:lstStyle/>
-          <a:p>
-            <a:r>
-              <a:rPr sz="1350" b="0">
-                <a:solidFill>
-                  <a:srgbClr val="2C2C2A"/>
-                </a:solidFill>
-                <a:latin typeface="Calibri"/>
-              </a:rPr>
-              <a:t>交集空        → client 端 UnsupportedVersionException（送出前 abort）</a:t>
-            </a:r>
-          </a:p>
-          <a:p>
-            <a:r>
-              <a:rPr sz="1350" b="0">
-                <a:solidFill>
-                  <a:srgbClr val="2C2C2A"/>
-                </a:solidFill>
-                <a:latin typeface="Calibri"/>
-              </a:rPr>
-              <a:t>繞過協商自刻  → broker 丟 UnsupportedVersionException + 關線</a:t>
-            </a:r>
-          </a:p>
-          <a:p>
-            <a:r>
-              <a:rPr sz="1350" b="0">
-                <a:solidFill>
-                  <a:srgbClr val="2C2C2A"/>
-                </a:solidFill>
-                <a:latin typeface="Calibri"/>
-              </a:rPr>
-              <a:t>（ApiVersions 例外：回 v0 + UNSUPPORTED_VERSION 錯誤碼）</a:t>
-            </a:r>
-          </a:p>
-        </p:txBody>
-      </p:sp>
-      <p:pic>
-        <p:nvPicPr>
-          <p:cNvPr id="5" name="Picture 4" descr="ban.png"/>
-          <p:cNvPicPr>
-            <a:picLocks noChangeAspect="1"/>
-          </p:cNvPicPr>
-          <p:nvPr/>
-        </p:nvPicPr>
-        <p:blipFill>
-          <a:blip r:embed="rId2"/>
-          <a:stretch>
-            <a:fillRect/>
-          </a:stretch>
-        </p:blipFill>
-        <p:spPr>
-          <a:xfrm>
-            <a:off x="658368" y="3749040"/>
-            <a:ext cx="274320" cy="274320"/>
-          </a:xfrm>
-          <a:prstGeom prst="rect">
-            <a:avLst/>
-          </a:prstGeom>
-        </p:spPr>
-      </p:pic>
+            <a:off x="822960" y="2331720"/>
+            <a:ext cx="10515600" cy="493776"/>
+          </a:xfrm>
+          <a:prstGeom prst="rect">
+            <a:avLst/>
+          </a:prstGeom>
+          <a:noFill/>
+        </p:spPr>
+        <p:txBody>
+          <a:bodyPr wrap="square">
+            <a:noAutofit/>
+          </a:bodyPr>
+          <a:lstStyle/>
+          <a:p>
+            <a:r>
+              <a:rPr sz="1600" b="0">
+                <a:solidFill>
+                  <a:srgbClr val="1E2024"/>
+                </a:solidFill>
+                <a:latin typeface="Calibri"/>
+              </a:rPr>
+              <a:t>A.  </a:t>
+            </a:r>
+            <a:r>
+              <a:rPr sz="1600" b="0">
+                <a:solidFill>
+                  <a:srgbClr val="1E2024"/>
+                </a:solidFill>
+                <a:latin typeface="Calibri"/>
+              </a:rPr>
+              <a:t>一律回 UNSUPPORTED_VERSION</a:t>
+            </a:r>
+          </a:p>
+        </p:txBody>
+      </p:sp>
+      <p:sp>
+        <p:nvSpPr>
+          <p:cNvPr id="5" name="TextBox 4"/>
+          <p:cNvSpPr txBox="1"/>
+          <p:nvPr/>
+        </p:nvSpPr>
+        <p:spPr>
+          <a:xfrm>
+            <a:off x="822960" y="2953512"/>
+            <a:ext cx="10515600" cy="493776"/>
+          </a:xfrm>
+          <a:prstGeom prst="rect">
+            <a:avLst/>
+          </a:prstGeom>
+          <a:noFill/>
+        </p:spPr>
+        <p:txBody>
+          <a:bodyPr wrap="square">
+            <a:noAutofit/>
+          </a:bodyPr>
+          <a:lstStyle/>
+          <a:p>
+            <a:r>
+              <a:rPr sz="1600" b="0">
+                <a:solidFill>
+                  <a:srgbClr val="1E2024"/>
+                </a:solidFill>
+                <a:latin typeface="Calibri"/>
+              </a:rPr>
+              <a:t>B.  </a:t>
+            </a:r>
+            <a:r>
+              <a:rPr sz="1600" b="0">
+                <a:solidFill>
+                  <a:srgbClr val="1E2024"/>
+                </a:solidFill>
+                <a:latin typeface="Calibri"/>
+              </a:rPr>
+              <a:t>只有 ApiVersions 例外回錯誤+範圍；其他 API 關線</a:t>
+            </a:r>
+          </a:p>
+        </p:txBody>
+      </p:sp>
       <p:sp>
         <p:nvSpPr>
           <p:cNvPr id="6" name="TextBox 5"/>
@@ -4124,7 +4023,7 @@
         </p:nvSpPr>
         <p:spPr>
           <a:xfrm>
-            <a:off x="1078992" y="3721608"/>
+            <a:off x="822960" y="3575304"/>
             <a:ext cx="10515600" cy="493776"/>
           </a:xfrm>
           <a:prstGeom prst="rect">
@@ -4139,13 +4038,22 @@
           <a:lstStyle/>
           <a:p>
             <a:r>
-              <a:rPr sz="1650" b="0">
+              <a:rPr sz="1600" b="0">
                 <a:solidFill>
                   <a:srgbClr val="1E2024"/>
                 </a:solidFill>
                 <a:latin typeface="Calibri"/>
               </a:rPr>
-              <a:t>多數情況 client 在送出前就本地中止，根本沒上網路</a:t>
+              <a:t>C.  </a:t>
+            </a:r>
+            <a:r>
+              <a:rPr sz="1600" b="0">
+                <a:solidFill>
+                  <a:srgbClr val="1E2024"/>
+                </a:solidFill>
+                <a:latin typeface="Calibri"/>
+              </a:rPr>
+              <a:t>broker 自動降版</a:t>
             </a:r>
           </a:p>
         </p:txBody>
@@ -4158,8 +4066,8 @@
         </p:nvSpPr>
         <p:spPr>
           <a:xfrm>
-            <a:off x="640080" y="6400800"/>
-            <a:ext cx="10972800" cy="384048"/>
+            <a:off x="822960" y="4197096"/>
+            <a:ext cx="10515600" cy="493776"/>
           </a:xfrm>
           <a:prstGeom prst="rect">
             <a:avLst/>
@@ -4173,61 +4081,56 @@
           <a:lstStyle/>
           <a:p>
             <a:r>
-              <a:rPr sz="1200" b="1">
+              <a:rPr sz="1600" b="0">
+                <a:solidFill>
+                  <a:srgbClr val="1E2024"/>
+                </a:solidFill>
+                <a:latin typeface="Calibri"/>
+              </a:rPr>
+              <a:t>D.  </a:t>
+            </a:r>
+            <a:r>
+              <a:rPr sz="1600" b="0">
+                <a:solidFill>
+                  <a:srgbClr val="1E2024"/>
+                </a:solidFill>
+                <a:latin typeface="Calibri"/>
+              </a:rPr>
+              <a:t>忽略版本照跑</a:t>
+            </a:r>
+          </a:p>
+        </p:txBody>
+      </p:sp>
+      <p:sp>
+        <p:nvSpPr>
+          <p:cNvPr id="8" name="TextBox 7"/>
+          <p:cNvSpPr txBox="1"/>
+          <p:nvPr/>
+        </p:nvSpPr>
+        <p:spPr>
+          <a:xfrm>
+            <a:off x="640080" y="4910327"/>
+            <a:ext cx="10972800" cy="914400"/>
+          </a:xfrm>
+          <a:prstGeom prst="rect">
+            <a:avLst/>
+          </a:prstGeom>
+          <a:noFill/>
+        </p:spPr>
+        <p:txBody>
+          <a:bodyPr wrap="square">
+            <a:noAutofit/>
+          </a:bodyPr>
+          <a:lstStyle/>
+          <a:p>
+            <a:r>
+              <a:rPr sz="1400" b="0">
                 <a:solidFill>
                   <a:srgbClr val="8A8A8A"/>
                 </a:solidFill>
                 <a:latin typeface="Calibri"/>
               </a:rPr>
-              <a:t>REF   </a:t>
-            </a:r>
-            <a:r>
-              <a:rPr sz="1200" b="0" u="sng">
-                <a:solidFill>
-                  <a:srgbClr val="185FA5"/>
-                </a:solidFill>
-                <a:latin typeface="Courier New"/>
-                <a:hlinkClick r:id="rId3"/>
-              </a:rPr>
-              <a:t>latestUsableVersion</a:t>
-            </a:r>
-            <a:r>
-              <a:rPr sz="1200" b="0">
-                <a:solidFill>
-                  <a:srgbClr val="8A8A8A"/>
-                </a:solidFill>
-                <a:latin typeface="Calibri"/>
-              </a:rPr>
-              <a:t>   ·   </a:t>
-            </a:r>
-            <a:r>
-              <a:rPr sz="1200" b="0" u="sng">
-                <a:solidFill>
-                  <a:srgbClr val="185FA5"/>
-                </a:solidFill>
-                <a:latin typeface="Courier New"/>
-                <a:hlinkClick r:id="rId4"/>
-              </a:rPr>
-              <a:t>NetworkClient</a:t>
-            </a:r>
-            <a:r>
-              <a:rPr sz="1200" b="0">
-                <a:solidFill>
-                  <a:srgbClr val="8A8A8A"/>
-                </a:solidFill>
-                <a:latin typeface="Calibri"/>
-              </a:rPr>
-              <a:t>   ·   </a:t>
-            </a:r>
-            <a:r>
-              <a:rPr sz="1200" b="0" u="sng">
-                <a:solidFill>
-                  <a:srgbClr val="185FA5"/>
-                </a:solidFill>
-                <a:latin typeface="Courier New"/>
-                <a:hlinkClick r:id="rId5"/>
-              </a:rPr>
-              <a:t>RequestContext</a:t>
+              <a:t>想一想 —— 下一頁公布答案</a:t>
             </a:r>
           </a:p>
         </p:txBody>
@@ -4279,7 +4182,7 @@
                 </a:solidFill>
                 <a:latin typeface="Calibri"/>
               </a:rPr>
-              <a:t>Part 2 · 失敗訊息</a:t>
+              <a:t>隨堂考 · 核心　（正解）</a:t>
             </a:r>
           </a:p>
         </p:txBody>
@@ -4293,7 +4196,7 @@
         <p:spPr>
           <a:xfrm>
             <a:off x="640080" y="841248"/>
-            <a:ext cx="10972800" cy="1005840"/>
+            <a:ext cx="10972800" cy="1188720"/>
           </a:xfrm>
           <a:prstGeom prst="rect">
             <a:avLst/>
@@ -4307,13 +4210,13 @@
           <a:lstStyle/>
           <a:p>
             <a:r>
-              <a:rPr sz="3200" b="1">
+              <a:rPr sz="2600" b="1">
                 <a:solidFill>
                   <a:srgbClr val="1E2024"/>
                 </a:solidFill>
                 <a:latin typeface="Calibri"/>
               </a:rPr>
-              <a:t>版本截斷：為什麼「升一點點」不夠</a:t>
+              <a:t>自刻 client 送了不支援的 API version，會怎樣？</a:t>
             </a:r>
           </a:p>
         </p:txBody>
@@ -4326,46 +4229,37 @@
         </p:nvSpPr>
         <p:spPr>
           <a:xfrm>
-            <a:off x="640080" y="2148840"/>
-            <a:ext cx="10972800" cy="822959"/>
-          </a:xfrm>
-          <a:prstGeom prst="rect">
-            <a:avLst/>
-          </a:prstGeom>
-          <a:solidFill>
-            <a:srgbClr val="F3F1EC"/>
-          </a:solidFill>
-          <a:ln w="6350">
-            <a:solidFill>
-              <a:srgbClr val="E3E0D8"/>
-            </a:solidFill>
-          </a:ln>
-        </p:spPr>
-        <p:txBody>
-          <a:bodyPr wrap="square" lIns="146304" tIns="91440" bIns="91440">
-            <a:noAutofit/>
-          </a:bodyPr>
-          <a:lstStyle/>
-          <a:p>
-            <a:r>
-              <a:rPr sz="1350" b="0">
-                <a:solidFill>
-                  <a:srgbClr val="2C2C2A"/>
-                </a:solidFill>
-                <a:latin typeface="Calibri"/>
-              </a:rPr>
-              <a:t>舊 wire API version 被整個移除，min 可 &gt; 0</a:t>
-            </a:r>
-          </a:p>
-          <a:p>
-            <a:r>
-              <a:rPr sz="1350" b="0">
-                <a:solidFill>
-                  <a:srgbClr val="2C2C2A"/>
-                </a:solidFill>
-                <a:latin typeface="Calibri"/>
-              </a:rPr>
-              <a:t>  Fetch：4–18（v0–3 在 4.0 移除）</a:t>
+            <a:off x="822960" y="2331720"/>
+            <a:ext cx="10515600" cy="493776"/>
+          </a:xfrm>
+          <a:prstGeom prst="rect">
+            <a:avLst/>
+          </a:prstGeom>
+          <a:noFill/>
+        </p:spPr>
+        <p:txBody>
+          <a:bodyPr wrap="square">
+            <a:noAutofit/>
+          </a:bodyPr>
+          <a:lstStyle/>
+          <a:p>
+            <a:r>
+              <a:rPr sz="1600" b="0">
+                <a:solidFill>
+                  <a:srgbClr val="1E2024"/>
+                </a:solidFill>
+                <a:latin typeface="Calibri"/>
+              </a:rPr>
+              <a:t>A.  </a:t>
+            </a:r>
+            <a:r>
+              <a:rPr sz="1600" b="0">
+                <a:solidFill>
+                  <a:srgbClr val="1E2024"/>
+                </a:solidFill>
+                <a:latin typeface="Calibri"/>
+              </a:rPr>
+              <a:t>一律回 UNSUPPORTED_VERSION</a:t>
             </a:r>
           </a:p>
         </p:txBody>
@@ -4378,8 +4272,8 @@
         </p:nvSpPr>
         <p:spPr>
           <a:xfrm>
-            <a:off x="640080" y="3172968"/>
-            <a:ext cx="10972800" cy="566928"/>
+            <a:off x="822960" y="2953512"/>
+            <a:ext cx="10515600" cy="493776"/>
           </a:xfrm>
           <a:prstGeom prst="rect">
             <a:avLst/>
@@ -4392,19 +4286,28 @@
           </a:ln>
         </p:spPr>
         <p:txBody>
-          <a:bodyPr wrap="square" lIns="146304" tIns="82296">
-            <a:noAutofit/>
-          </a:bodyPr>
-          <a:lstStyle/>
-          <a:p>
-            <a:r>
-              <a:rPr sz="1500" b="0">
+          <a:bodyPr wrap="square" lIns="128016" tIns="54864">
+            <a:noAutofit/>
+          </a:bodyPr>
+          <a:lstStyle/>
+          <a:p>
+            <a:r>
+              <a:rPr sz="1600" b="1">
                 <a:solidFill>
                   <a:srgbClr val="27500A"/>
                 </a:solidFill>
                 <a:latin typeface="Calibri"/>
               </a:rPr>
-              <a:t>解法：升級前確認兩端都跨過版本下限（升 4.0 需至少 2.1），否則協商結果沒有可用版本</a:t>
+              <a:t>B.  </a:t>
+            </a:r>
+            <a:r>
+              <a:rPr sz="1600" b="1">
+                <a:solidFill>
+                  <a:srgbClr val="27500A"/>
+                </a:solidFill>
+                <a:latin typeface="Calibri"/>
+              </a:rPr>
+              <a:t>只有 ApiVersions 例外回錯誤+範圍；其他 API 關線   ✓</a:t>
             </a:r>
           </a:p>
         </p:txBody>
@@ -4417,8 +4320,8 @@
         </p:nvSpPr>
         <p:spPr>
           <a:xfrm>
-            <a:off x="640080" y="3922776"/>
-            <a:ext cx="10972800" cy="731520"/>
+            <a:off x="822960" y="3575304"/>
+            <a:ext cx="10515600" cy="493776"/>
           </a:xfrm>
           <a:prstGeom prst="rect">
             <a:avLst/>
@@ -4432,13 +4335,22 @@
           <a:lstStyle/>
           <a:p>
             <a:r>
-              <a:rPr sz="1500" b="0">
-                <a:solidFill>
-                  <a:srgbClr val="5F5E5A"/>
-                </a:solidFill>
-                <a:latin typeface="Calibri"/>
-              </a:rPr>
-              <a:t>銜接（非本場）：finalize / 升降當下的錯誤（INVALID_UPDATE_VERSION 等）屬「運行時的版本升降」那場，本場不展開。</a:t>
+              <a:rPr sz="1600" b="0">
+                <a:solidFill>
+                  <a:srgbClr val="1E2024"/>
+                </a:solidFill>
+                <a:latin typeface="Calibri"/>
+              </a:rPr>
+              <a:t>C.  </a:t>
+            </a:r>
+            <a:r>
+              <a:rPr sz="1600" b="0">
+                <a:solidFill>
+                  <a:srgbClr val="1E2024"/>
+                </a:solidFill>
+                <a:latin typeface="Calibri"/>
+              </a:rPr>
+              <a:t>broker 自動降版</a:t>
             </a:r>
           </a:p>
         </p:txBody>
@@ -4446,6 +4358,92 @@
       <p:sp>
         <p:nvSpPr>
           <p:cNvPr id="7" name="TextBox 6"/>
+          <p:cNvSpPr txBox="1"/>
+          <p:nvPr/>
+        </p:nvSpPr>
+        <p:spPr>
+          <a:xfrm>
+            <a:off x="822960" y="4197096"/>
+            <a:ext cx="10515600" cy="493776"/>
+          </a:xfrm>
+          <a:prstGeom prst="rect">
+            <a:avLst/>
+          </a:prstGeom>
+          <a:noFill/>
+        </p:spPr>
+        <p:txBody>
+          <a:bodyPr wrap="square">
+            <a:noAutofit/>
+          </a:bodyPr>
+          <a:lstStyle/>
+          <a:p>
+            <a:r>
+              <a:rPr sz="1600" b="0">
+                <a:solidFill>
+                  <a:srgbClr val="1E2024"/>
+                </a:solidFill>
+                <a:latin typeface="Calibri"/>
+              </a:rPr>
+              <a:t>D.  </a:t>
+            </a:r>
+            <a:r>
+              <a:rPr sz="1600" b="0">
+                <a:solidFill>
+                  <a:srgbClr val="1E2024"/>
+                </a:solidFill>
+                <a:latin typeface="Calibri"/>
+              </a:rPr>
+              <a:t>忽略版本照跑</a:t>
+            </a:r>
+          </a:p>
+        </p:txBody>
+      </p:sp>
+      <p:sp>
+        <p:nvSpPr>
+          <p:cNvPr id="8" name="TextBox 7"/>
+          <p:cNvSpPr txBox="1"/>
+          <p:nvPr/>
+        </p:nvSpPr>
+        <p:spPr>
+          <a:xfrm>
+            <a:off x="640080" y="4910327"/>
+            <a:ext cx="10972800" cy="914400"/>
+          </a:xfrm>
+          <a:prstGeom prst="rect">
+            <a:avLst/>
+          </a:prstGeom>
+          <a:noFill/>
+        </p:spPr>
+        <p:txBody>
+          <a:bodyPr wrap="square">
+            <a:noAutofit/>
+          </a:bodyPr>
+          <a:lstStyle/>
+          <a:p>
+            <a:r>
+              <a:rPr sz="1400" b="1">
+                <a:solidFill>
+                  <a:srgbClr val="27500A"/>
+                </a:solidFill>
+                <a:latin typeface="Calibri"/>
+              </a:rPr>
+              <a:t>正解 B — </a:t>
+            </a:r>
+            <a:r>
+              <a:rPr sz="1400" b="0">
+                <a:solidFill>
+                  <a:srgbClr val="1E2024"/>
+                </a:solidFill>
+                <a:latin typeface="Calibri"/>
+              </a:rPr>
+              <a:t>ApiVersions 是 bootstrap 逃生口；其他 API → broker 丟 UnsupportedVersionException → 斷線。</a:t>
+            </a:r>
+          </a:p>
+        </p:txBody>
+      </p:sp>
+      <p:sp>
+        <p:nvSpPr>
+          <p:cNvPr id="9" name="TextBox 8"/>
           <p:cNvSpPr txBox="1"/>
           <p:nvPr/>
         </p:nvSpPr>
@@ -4482,26 +4480,7 @@
                 <a:latin typeface="Courier New"/>
                 <a:hlinkClick r:id="rId2"/>
               </a:rPr>
-              <a:t>upgrade.md:229</a:t>
-            </a:r>
-            <a:r>
-              <a:rPr sz="1200" b="0">
-                <a:solidFill>
-                  <a:srgbClr val="8A8A8A"/>
-                </a:solidFill>
-                <a:latin typeface="Calibri"/>
-              </a:rPr>
-              <a:t>   ·   </a:t>
-            </a:r>
-            <a:r>
-              <a:rPr sz="1200" b="0" u="sng">
-                <a:solidFill>
-                  <a:srgbClr val="185FA5"/>
-                </a:solidFill>
-                <a:latin typeface="Courier New"/>
-                <a:hlinkClick r:id="rId3"/>
-              </a:rPr>
-              <a:t>FetchRequest.json validVersions</a:t>
+              <a:t>RequestContext.java:112</a:t>
             </a:r>
           </a:p>
         </p:txBody>
@@ -4553,648 +4532,6 @@
                 </a:solidFill>
                 <a:latin typeface="Calibri"/>
               </a:rPr>
-              <a:t>隨堂考 · 核心</a:t>
-            </a:r>
-          </a:p>
-        </p:txBody>
-      </p:sp>
-      <p:sp>
-        <p:nvSpPr>
-          <p:cNvPr id="3" name="TextBox 2"/>
-          <p:cNvSpPr txBox="1"/>
-          <p:nvPr/>
-        </p:nvSpPr>
-        <p:spPr>
-          <a:xfrm>
-            <a:off x="640080" y="841248"/>
-            <a:ext cx="10972800" cy="1188720"/>
-          </a:xfrm>
-          <a:prstGeom prst="rect">
-            <a:avLst/>
-          </a:prstGeom>
-          <a:noFill/>
-        </p:spPr>
-        <p:txBody>
-          <a:bodyPr wrap="square">
-            <a:noAutofit/>
-          </a:bodyPr>
-          <a:lstStyle/>
-          <a:p>
-            <a:r>
-              <a:rPr sz="2600" b="1">
-                <a:solidFill>
-                  <a:srgbClr val="1E2024"/>
-                </a:solidFill>
-                <a:latin typeface="Calibri"/>
-              </a:rPr>
-              <a:t>自刻 client 送了不支援的 API version，會怎樣？</a:t>
-            </a:r>
-          </a:p>
-        </p:txBody>
-      </p:sp>
-      <p:sp>
-        <p:nvSpPr>
-          <p:cNvPr id="4" name="TextBox 3"/>
-          <p:cNvSpPr txBox="1"/>
-          <p:nvPr/>
-        </p:nvSpPr>
-        <p:spPr>
-          <a:xfrm>
-            <a:off x="822960" y="2331720"/>
-            <a:ext cx="10515600" cy="493776"/>
-          </a:xfrm>
-          <a:prstGeom prst="rect">
-            <a:avLst/>
-          </a:prstGeom>
-          <a:noFill/>
-        </p:spPr>
-        <p:txBody>
-          <a:bodyPr wrap="square">
-            <a:noAutofit/>
-          </a:bodyPr>
-          <a:lstStyle/>
-          <a:p>
-            <a:r>
-              <a:rPr sz="1600" b="0">
-                <a:solidFill>
-                  <a:srgbClr val="1E2024"/>
-                </a:solidFill>
-                <a:latin typeface="Calibri"/>
-              </a:rPr>
-              <a:t>A.  </a:t>
-            </a:r>
-            <a:r>
-              <a:rPr sz="1600" b="0">
-                <a:solidFill>
-                  <a:srgbClr val="1E2024"/>
-                </a:solidFill>
-                <a:latin typeface="Calibri"/>
-              </a:rPr>
-              <a:t>一律回 UNSUPPORTED_VERSION</a:t>
-            </a:r>
-          </a:p>
-        </p:txBody>
-      </p:sp>
-      <p:sp>
-        <p:nvSpPr>
-          <p:cNvPr id="5" name="TextBox 4"/>
-          <p:cNvSpPr txBox="1"/>
-          <p:nvPr/>
-        </p:nvSpPr>
-        <p:spPr>
-          <a:xfrm>
-            <a:off x="822960" y="2953512"/>
-            <a:ext cx="10515600" cy="493776"/>
-          </a:xfrm>
-          <a:prstGeom prst="rect">
-            <a:avLst/>
-          </a:prstGeom>
-          <a:noFill/>
-        </p:spPr>
-        <p:txBody>
-          <a:bodyPr wrap="square">
-            <a:noAutofit/>
-          </a:bodyPr>
-          <a:lstStyle/>
-          <a:p>
-            <a:r>
-              <a:rPr sz="1600" b="0">
-                <a:solidFill>
-                  <a:srgbClr val="1E2024"/>
-                </a:solidFill>
-                <a:latin typeface="Calibri"/>
-              </a:rPr>
-              <a:t>B.  </a:t>
-            </a:r>
-            <a:r>
-              <a:rPr sz="1600" b="0">
-                <a:solidFill>
-                  <a:srgbClr val="1E2024"/>
-                </a:solidFill>
-                <a:latin typeface="Calibri"/>
-              </a:rPr>
-              <a:t>只有 ApiVersions 例外回錯誤+範圍；其他 API 關線</a:t>
-            </a:r>
-          </a:p>
-        </p:txBody>
-      </p:sp>
-      <p:sp>
-        <p:nvSpPr>
-          <p:cNvPr id="6" name="TextBox 5"/>
-          <p:cNvSpPr txBox="1"/>
-          <p:nvPr/>
-        </p:nvSpPr>
-        <p:spPr>
-          <a:xfrm>
-            <a:off x="822960" y="3575304"/>
-            <a:ext cx="10515600" cy="493776"/>
-          </a:xfrm>
-          <a:prstGeom prst="rect">
-            <a:avLst/>
-          </a:prstGeom>
-          <a:noFill/>
-        </p:spPr>
-        <p:txBody>
-          <a:bodyPr wrap="square">
-            <a:noAutofit/>
-          </a:bodyPr>
-          <a:lstStyle/>
-          <a:p>
-            <a:r>
-              <a:rPr sz="1600" b="0">
-                <a:solidFill>
-                  <a:srgbClr val="1E2024"/>
-                </a:solidFill>
-                <a:latin typeface="Calibri"/>
-              </a:rPr>
-              <a:t>C.  </a:t>
-            </a:r>
-            <a:r>
-              <a:rPr sz="1600" b="0">
-                <a:solidFill>
-                  <a:srgbClr val="1E2024"/>
-                </a:solidFill>
-                <a:latin typeface="Calibri"/>
-              </a:rPr>
-              <a:t>broker 自動降版</a:t>
-            </a:r>
-          </a:p>
-        </p:txBody>
-      </p:sp>
-      <p:sp>
-        <p:nvSpPr>
-          <p:cNvPr id="7" name="TextBox 6"/>
-          <p:cNvSpPr txBox="1"/>
-          <p:nvPr/>
-        </p:nvSpPr>
-        <p:spPr>
-          <a:xfrm>
-            <a:off x="822960" y="4197096"/>
-            <a:ext cx="10515600" cy="493776"/>
-          </a:xfrm>
-          <a:prstGeom prst="rect">
-            <a:avLst/>
-          </a:prstGeom>
-          <a:noFill/>
-        </p:spPr>
-        <p:txBody>
-          <a:bodyPr wrap="square">
-            <a:noAutofit/>
-          </a:bodyPr>
-          <a:lstStyle/>
-          <a:p>
-            <a:r>
-              <a:rPr sz="1600" b="0">
-                <a:solidFill>
-                  <a:srgbClr val="1E2024"/>
-                </a:solidFill>
-                <a:latin typeface="Calibri"/>
-              </a:rPr>
-              <a:t>D.  </a:t>
-            </a:r>
-            <a:r>
-              <a:rPr sz="1600" b="0">
-                <a:solidFill>
-                  <a:srgbClr val="1E2024"/>
-                </a:solidFill>
-                <a:latin typeface="Calibri"/>
-              </a:rPr>
-              <a:t>忽略版本照跑</a:t>
-            </a:r>
-          </a:p>
-        </p:txBody>
-      </p:sp>
-      <p:sp>
-        <p:nvSpPr>
-          <p:cNvPr id="8" name="TextBox 7"/>
-          <p:cNvSpPr txBox="1"/>
-          <p:nvPr/>
-        </p:nvSpPr>
-        <p:spPr>
-          <a:xfrm>
-            <a:off x="640080" y="4910327"/>
-            <a:ext cx="10972800" cy="914400"/>
-          </a:xfrm>
-          <a:prstGeom prst="rect">
-            <a:avLst/>
-          </a:prstGeom>
-          <a:noFill/>
-        </p:spPr>
-        <p:txBody>
-          <a:bodyPr wrap="square">
-            <a:noAutofit/>
-          </a:bodyPr>
-          <a:lstStyle/>
-          <a:p>
-            <a:r>
-              <a:rPr sz="1400" b="0">
-                <a:solidFill>
-                  <a:srgbClr val="8A8A8A"/>
-                </a:solidFill>
-                <a:latin typeface="Calibri"/>
-              </a:rPr>
-              <a:t>想一想 —— 下一頁公布答案</a:t>
-            </a:r>
-          </a:p>
-        </p:txBody>
-      </p:sp>
-    </p:spTree>
-  </p:cSld>
-  <p:clrMapOvr>
-    <a:masterClrMapping/>
-  </p:clrMapOvr>
-</p:sld>
-</file>
-
-<file path=ppt/slides/slide15.xml><?xml version="1.0" encoding="utf-8"?>
-<p:sld xmlns:a="http://schemas.openxmlformats.org/drawingml/2006/main" xmlns:p="http://schemas.openxmlformats.org/presentationml/2006/main" xmlns:r="http://schemas.openxmlformats.org/officeDocument/2006/relationships">
-  <p:cSld>
-    <p:spTree>
-      <p:nvGrpSpPr>
-        <p:cNvPr id="1" name=""/>
-        <p:cNvGrpSpPr/>
-        <p:nvPr/>
-      </p:nvGrpSpPr>
-      <p:grpSpPr/>
-      <p:sp>
-        <p:nvSpPr>
-          <p:cNvPr id="2" name="TextBox 1"/>
-          <p:cNvSpPr txBox="1"/>
-          <p:nvPr/>
-        </p:nvSpPr>
-        <p:spPr>
-          <a:xfrm>
-            <a:off x="640080" y="457200"/>
-            <a:ext cx="10972800" cy="365760"/>
-          </a:xfrm>
-          <a:prstGeom prst="rect">
-            <a:avLst/>
-          </a:prstGeom>
-          <a:noFill/>
-        </p:spPr>
-        <p:txBody>
-          <a:bodyPr wrap="square">
-            <a:noAutofit/>
-          </a:bodyPr>
-          <a:lstStyle/>
-          <a:p>
-            <a:r>
-              <a:rPr sz="1300" b="1">
-                <a:solidFill>
-                  <a:srgbClr val="185FA5"/>
-                </a:solidFill>
-                <a:latin typeface="Calibri"/>
-              </a:rPr>
-              <a:t>隨堂考 · 核心　（正解）</a:t>
-            </a:r>
-          </a:p>
-        </p:txBody>
-      </p:sp>
-      <p:sp>
-        <p:nvSpPr>
-          <p:cNvPr id="3" name="TextBox 2"/>
-          <p:cNvSpPr txBox="1"/>
-          <p:nvPr/>
-        </p:nvSpPr>
-        <p:spPr>
-          <a:xfrm>
-            <a:off x="640080" y="841248"/>
-            <a:ext cx="10972800" cy="1188720"/>
-          </a:xfrm>
-          <a:prstGeom prst="rect">
-            <a:avLst/>
-          </a:prstGeom>
-          <a:noFill/>
-        </p:spPr>
-        <p:txBody>
-          <a:bodyPr wrap="square">
-            <a:noAutofit/>
-          </a:bodyPr>
-          <a:lstStyle/>
-          <a:p>
-            <a:r>
-              <a:rPr sz="2600" b="1">
-                <a:solidFill>
-                  <a:srgbClr val="1E2024"/>
-                </a:solidFill>
-                <a:latin typeface="Calibri"/>
-              </a:rPr>
-              <a:t>自刻 client 送了不支援的 API version，會怎樣？</a:t>
-            </a:r>
-          </a:p>
-        </p:txBody>
-      </p:sp>
-      <p:sp>
-        <p:nvSpPr>
-          <p:cNvPr id="4" name="TextBox 3"/>
-          <p:cNvSpPr txBox="1"/>
-          <p:nvPr/>
-        </p:nvSpPr>
-        <p:spPr>
-          <a:xfrm>
-            <a:off x="822960" y="2331720"/>
-            <a:ext cx="10515600" cy="493776"/>
-          </a:xfrm>
-          <a:prstGeom prst="rect">
-            <a:avLst/>
-          </a:prstGeom>
-          <a:noFill/>
-        </p:spPr>
-        <p:txBody>
-          <a:bodyPr wrap="square">
-            <a:noAutofit/>
-          </a:bodyPr>
-          <a:lstStyle/>
-          <a:p>
-            <a:r>
-              <a:rPr sz="1600" b="0">
-                <a:solidFill>
-                  <a:srgbClr val="1E2024"/>
-                </a:solidFill>
-                <a:latin typeface="Calibri"/>
-              </a:rPr>
-              <a:t>A.  </a:t>
-            </a:r>
-            <a:r>
-              <a:rPr sz="1600" b="0">
-                <a:solidFill>
-                  <a:srgbClr val="1E2024"/>
-                </a:solidFill>
-                <a:latin typeface="Calibri"/>
-              </a:rPr>
-              <a:t>一律回 UNSUPPORTED_VERSION</a:t>
-            </a:r>
-          </a:p>
-        </p:txBody>
-      </p:sp>
-      <p:sp>
-        <p:nvSpPr>
-          <p:cNvPr id="5" name="TextBox 4"/>
-          <p:cNvSpPr txBox="1"/>
-          <p:nvPr/>
-        </p:nvSpPr>
-        <p:spPr>
-          <a:xfrm>
-            <a:off x="822960" y="2953512"/>
-            <a:ext cx="10515600" cy="493776"/>
-          </a:xfrm>
-          <a:prstGeom prst="rect">
-            <a:avLst/>
-          </a:prstGeom>
-          <a:solidFill>
-            <a:srgbClr val="E9F3DE"/>
-          </a:solidFill>
-          <a:ln>
-            <a:noFill/>
-          </a:ln>
-        </p:spPr>
-        <p:txBody>
-          <a:bodyPr wrap="square" lIns="128016" tIns="54864">
-            <a:noAutofit/>
-          </a:bodyPr>
-          <a:lstStyle/>
-          <a:p>
-            <a:r>
-              <a:rPr sz="1600" b="1">
-                <a:solidFill>
-                  <a:srgbClr val="27500A"/>
-                </a:solidFill>
-                <a:latin typeface="Calibri"/>
-              </a:rPr>
-              <a:t>B.  </a:t>
-            </a:r>
-            <a:r>
-              <a:rPr sz="1600" b="1">
-                <a:solidFill>
-                  <a:srgbClr val="27500A"/>
-                </a:solidFill>
-                <a:latin typeface="Calibri"/>
-              </a:rPr>
-              <a:t>只有 ApiVersions 例外回錯誤+範圍；其他 API 關線   ✓</a:t>
-            </a:r>
-          </a:p>
-        </p:txBody>
-      </p:sp>
-      <p:sp>
-        <p:nvSpPr>
-          <p:cNvPr id="6" name="TextBox 5"/>
-          <p:cNvSpPr txBox="1"/>
-          <p:nvPr/>
-        </p:nvSpPr>
-        <p:spPr>
-          <a:xfrm>
-            <a:off x="822960" y="3575304"/>
-            <a:ext cx="10515600" cy="493776"/>
-          </a:xfrm>
-          <a:prstGeom prst="rect">
-            <a:avLst/>
-          </a:prstGeom>
-          <a:noFill/>
-        </p:spPr>
-        <p:txBody>
-          <a:bodyPr wrap="square">
-            <a:noAutofit/>
-          </a:bodyPr>
-          <a:lstStyle/>
-          <a:p>
-            <a:r>
-              <a:rPr sz="1600" b="0">
-                <a:solidFill>
-                  <a:srgbClr val="1E2024"/>
-                </a:solidFill>
-                <a:latin typeface="Calibri"/>
-              </a:rPr>
-              <a:t>C.  </a:t>
-            </a:r>
-            <a:r>
-              <a:rPr sz="1600" b="0">
-                <a:solidFill>
-                  <a:srgbClr val="1E2024"/>
-                </a:solidFill>
-                <a:latin typeface="Calibri"/>
-              </a:rPr>
-              <a:t>broker 自動降版</a:t>
-            </a:r>
-          </a:p>
-        </p:txBody>
-      </p:sp>
-      <p:sp>
-        <p:nvSpPr>
-          <p:cNvPr id="7" name="TextBox 6"/>
-          <p:cNvSpPr txBox="1"/>
-          <p:nvPr/>
-        </p:nvSpPr>
-        <p:spPr>
-          <a:xfrm>
-            <a:off x="822960" y="4197096"/>
-            <a:ext cx="10515600" cy="493776"/>
-          </a:xfrm>
-          <a:prstGeom prst="rect">
-            <a:avLst/>
-          </a:prstGeom>
-          <a:noFill/>
-        </p:spPr>
-        <p:txBody>
-          <a:bodyPr wrap="square">
-            <a:noAutofit/>
-          </a:bodyPr>
-          <a:lstStyle/>
-          <a:p>
-            <a:r>
-              <a:rPr sz="1600" b="0">
-                <a:solidFill>
-                  <a:srgbClr val="1E2024"/>
-                </a:solidFill>
-                <a:latin typeface="Calibri"/>
-              </a:rPr>
-              <a:t>D.  </a:t>
-            </a:r>
-            <a:r>
-              <a:rPr sz="1600" b="0">
-                <a:solidFill>
-                  <a:srgbClr val="1E2024"/>
-                </a:solidFill>
-                <a:latin typeface="Calibri"/>
-              </a:rPr>
-              <a:t>忽略版本照跑</a:t>
-            </a:r>
-          </a:p>
-        </p:txBody>
-      </p:sp>
-      <p:sp>
-        <p:nvSpPr>
-          <p:cNvPr id="8" name="TextBox 7"/>
-          <p:cNvSpPr txBox="1"/>
-          <p:nvPr/>
-        </p:nvSpPr>
-        <p:spPr>
-          <a:xfrm>
-            <a:off x="640080" y="4910327"/>
-            <a:ext cx="10972800" cy="914400"/>
-          </a:xfrm>
-          <a:prstGeom prst="rect">
-            <a:avLst/>
-          </a:prstGeom>
-          <a:noFill/>
-        </p:spPr>
-        <p:txBody>
-          <a:bodyPr wrap="square">
-            <a:noAutofit/>
-          </a:bodyPr>
-          <a:lstStyle/>
-          <a:p>
-            <a:r>
-              <a:rPr sz="1400" b="1">
-                <a:solidFill>
-                  <a:srgbClr val="27500A"/>
-                </a:solidFill>
-                <a:latin typeface="Calibri"/>
-              </a:rPr>
-              <a:t>正解 B — </a:t>
-            </a:r>
-            <a:r>
-              <a:rPr sz="1400" b="0">
-                <a:solidFill>
-                  <a:srgbClr val="1E2024"/>
-                </a:solidFill>
-                <a:latin typeface="Calibri"/>
-              </a:rPr>
-              <a:t>ApiVersions 是 bootstrap 逃生口；其他 API → broker 丟 UnsupportedVersionException → 斷線。</a:t>
-            </a:r>
-          </a:p>
-        </p:txBody>
-      </p:sp>
-      <p:sp>
-        <p:nvSpPr>
-          <p:cNvPr id="9" name="TextBox 8"/>
-          <p:cNvSpPr txBox="1"/>
-          <p:nvPr/>
-        </p:nvSpPr>
-        <p:spPr>
-          <a:xfrm>
-            <a:off x="640080" y="6400800"/>
-            <a:ext cx="10972800" cy="384048"/>
-          </a:xfrm>
-          <a:prstGeom prst="rect">
-            <a:avLst/>
-          </a:prstGeom>
-          <a:noFill/>
-        </p:spPr>
-        <p:txBody>
-          <a:bodyPr wrap="square">
-            <a:noAutofit/>
-          </a:bodyPr>
-          <a:lstStyle/>
-          <a:p>
-            <a:r>
-              <a:rPr sz="1200" b="1">
-                <a:solidFill>
-                  <a:srgbClr val="8A8A8A"/>
-                </a:solidFill>
-                <a:latin typeface="Calibri"/>
-              </a:rPr>
-              <a:t>REF   </a:t>
-            </a:r>
-            <a:r>
-              <a:rPr sz="1200" b="0" u="sng">
-                <a:solidFill>
-                  <a:srgbClr val="185FA5"/>
-                </a:solidFill>
-                <a:latin typeface="Courier New"/>
-                <a:hlinkClick r:id="rId2"/>
-              </a:rPr>
-              <a:t>RequestContext.java:112</a:t>
-            </a:r>
-          </a:p>
-        </p:txBody>
-      </p:sp>
-    </p:spTree>
-  </p:cSld>
-  <p:clrMapOvr>
-    <a:masterClrMapping/>
-  </p:clrMapOvr>
-</p:sld>
-</file>
-
-<file path=ppt/slides/slide16.xml><?xml version="1.0" encoding="utf-8"?>
-<p:sld xmlns:a="http://schemas.openxmlformats.org/drawingml/2006/main" xmlns:p="http://schemas.openxmlformats.org/presentationml/2006/main" xmlns:r="http://schemas.openxmlformats.org/officeDocument/2006/relationships">
-  <p:cSld>
-    <p:spTree>
-      <p:nvGrpSpPr>
-        <p:cNvPr id="1" name=""/>
-        <p:cNvGrpSpPr/>
-        <p:nvPr/>
-      </p:nvGrpSpPr>
-      <p:grpSpPr/>
-      <p:sp>
-        <p:nvSpPr>
-          <p:cNvPr id="2" name="TextBox 1"/>
-          <p:cNvSpPr txBox="1"/>
-          <p:nvPr/>
-        </p:nvSpPr>
-        <p:spPr>
-          <a:xfrm>
-            <a:off x="640080" y="457200"/>
-            <a:ext cx="10972800" cy="365760"/>
-          </a:xfrm>
-          <a:prstGeom prst="rect">
-            <a:avLst/>
-          </a:prstGeom>
-          <a:noFill/>
-        </p:spPr>
-        <p:txBody>
-          <a:bodyPr wrap="square">
-            <a:noAutofit/>
-          </a:bodyPr>
-          <a:lstStyle/>
-          <a:p>
-            <a:r>
-              <a:rPr sz="1300" b="1">
-                <a:solidFill>
-                  <a:srgbClr val="185FA5"/>
-                </a:solidFill>
-                <a:latin typeface="Calibri"/>
-              </a:rPr>
               <a:t>Recap</a:t>
             </a:r>
           </a:p>
@@ -5489,7 +4826,7 @@
                 </a:solidFill>
                 <a:latin typeface="Calibri"/>
               </a:rPr>
-              <a:t>兩段，加 3 題隨堂考穿插</a:t>
+              <a:t>兩段，加 2 題隨堂考穿插</a:t>
             </a:r>
           </a:p>
         </p:txBody>
@@ -5978,7 +5315,7 @@
                 </a:solidFill>
                 <a:latin typeface="Calibri"/>
               </a:rPr>
-              <a:t>Part 1 · 地圖</a:t>
+              <a:t>Part 1 · 動機</a:t>
             </a:r>
           </a:p>
         </p:txBody>
@@ -6012,20 +5349,136 @@
                 </a:solidFill>
                 <a:latin typeface="Calibri"/>
               </a:rPr>
-              <a:t>叢集裡有三種通訊，而且版本天生對不齊</a:t>
-            </a:r>
-          </a:p>
-        </p:txBody>
-      </p:sp>
-      <p:sp>
-        <p:nvSpPr>
-          <p:cNvPr id="4" name="TextBox 3"/>
-          <p:cNvSpPr txBox="1"/>
-          <p:nvPr/>
-        </p:nvSpPr>
-        <p:spPr>
-          <a:xfrm>
-            <a:off x="640080" y="2148840"/>
+              <a:t>為什麼版本天生對不齊，只能連線當下協商</a:t>
+            </a:r>
+          </a:p>
+        </p:txBody>
+      </p:sp>
+      <p:pic>
+        <p:nvPicPr>
+          <p:cNvPr id="4" name="Picture 3" descr="clock-hour-4.png"/>
+          <p:cNvPicPr>
+            <a:picLocks noChangeAspect="1"/>
+          </p:cNvPicPr>
+          <p:nvPr/>
+        </p:nvPicPr>
+        <p:blipFill>
+          <a:blip r:embed="rId2"/>
+          <a:stretch>
+            <a:fillRect/>
+          </a:stretch>
+        </p:blipFill>
+        <p:spPr>
+          <a:xfrm>
+            <a:off x="658368" y="2176272"/>
+            <a:ext cx="274320" cy="274320"/>
+          </a:xfrm>
+          <a:prstGeom prst="rect">
+            <a:avLst/>
+          </a:prstGeom>
+        </p:spPr>
+      </p:pic>
+      <p:sp>
+        <p:nvSpPr>
+          <p:cNvPr id="5" name="TextBox 4"/>
+          <p:cNvSpPr txBox="1"/>
+          <p:nvPr/>
+        </p:nvSpPr>
+        <p:spPr>
+          <a:xfrm>
+            <a:off x="1078992" y="2148840"/>
+            <a:ext cx="10515600" cy="841248"/>
+          </a:xfrm>
+          <a:prstGeom prst="rect">
+            <a:avLst/>
+          </a:prstGeom>
+          <a:noFill/>
+        </p:spPr>
+        <p:txBody>
+          <a:bodyPr wrap="square">
+            <a:noAutofit/>
+          </a:bodyPr>
+          <a:lstStyle/>
+          <a:p>
+            <a:r>
+              <a:rPr sz="1650" b="0">
+                <a:solidFill>
+                  <a:srgbClr val="1E2024"/>
+                </a:solidFill>
+                <a:latin typeface="Calibri"/>
+              </a:rPr>
+              <a:t>client 內嵌在各 app、長期不更新（Kafka 曾為舊 client 保留每個 protocol 版本近九年，4.0／KIP-896 才把下限提到 2.1）</a:t>
+            </a:r>
+          </a:p>
+        </p:txBody>
+      </p:sp>
+      <p:pic>
+        <p:nvPicPr>
+          <p:cNvPr id="6" name="Picture 5" descr="server-2.png"/>
+          <p:cNvPicPr>
+            <a:picLocks noChangeAspect="1"/>
+          </p:cNvPicPr>
+          <p:nvPr/>
+        </p:nvPicPr>
+        <p:blipFill>
+          <a:blip r:embed="rId3"/>
+          <a:stretch>
+            <a:fillRect/>
+          </a:stretch>
+        </p:blipFill>
+        <p:spPr>
+          <a:xfrm>
+            <a:off x="658368" y="3163824"/>
+            <a:ext cx="274320" cy="274320"/>
+          </a:xfrm>
+          <a:prstGeom prst="rect">
+            <a:avLst/>
+          </a:prstGeom>
+        </p:spPr>
+      </p:pic>
+      <p:sp>
+        <p:nvSpPr>
+          <p:cNvPr id="7" name="TextBox 6"/>
+          <p:cNvSpPr txBox="1"/>
+          <p:nvPr/>
+        </p:nvSpPr>
+        <p:spPr>
+          <a:xfrm>
+            <a:off x="1078992" y="3136392"/>
+            <a:ext cx="10515600" cy="493776"/>
+          </a:xfrm>
+          <a:prstGeom prst="rect">
+            <a:avLst/>
+          </a:prstGeom>
+          <a:noFill/>
+        </p:spPr>
+        <p:txBody>
+          <a:bodyPr wrap="square">
+            <a:noAutofit/>
+          </a:bodyPr>
+          <a:lstStyle/>
+          <a:p>
+            <a:r>
+              <a:rPr sz="1650" b="0">
+                <a:solidFill>
+                  <a:srgbClr val="1E2024"/>
+                </a:solidFill>
+                <a:latin typeface="Calibri"/>
+              </a:rPr>
+              <a:t>broker 逐台滾動升級，過程必然新舊並存</a:t>
+            </a:r>
+          </a:p>
+        </p:txBody>
+      </p:sp>
+      <p:sp>
+        <p:nvSpPr>
+          <p:cNvPr id="8" name="TextBox 7"/>
+          <p:cNvSpPr txBox="1"/>
+          <p:nvPr/>
+        </p:nvSpPr>
+        <p:spPr>
+          <a:xfrm>
+            <a:off x="640080" y="3776472"/>
             <a:ext cx="10972800" cy="1097280"/>
           </a:xfrm>
           <a:prstGeom prst="rect">
@@ -6053,7 +5506,7 @@
                 </a:solidFill>
                 <a:latin typeface="Calibri"/>
               </a:rPr>
-              <a:t>client ─▶ broker        讀寫資料、查 metadata…</a:t>
+              <a:t>任一時刻：不同節點能力／版本不同</a:t>
             </a:r>
           </a:p>
           <a:p>
@@ -6064,7 +5517,7 @@
                 </a:solidFill>
                 <a:latin typeface="Calibri"/>
               </a:rPr>
-              <a:t>broker ─▶ controller    註冊、心跳、AlterPartition、轉發 admin…</a:t>
+              <a:t>        → 不能鎖全叢集同一版（又要不停機）</a:t>
             </a:r>
           </a:p>
           <a:p>
@@ -6075,127 +5528,11 @@
                 </a:solidFill>
                 <a:latin typeface="Calibri"/>
               </a:rPr>
-              <a:t>broker ◀▶ broker        複製（follower 抓 leader）</a:t>
-            </a:r>
-          </a:p>
-        </p:txBody>
-      </p:sp>
-      <p:sp>
-        <p:nvSpPr>
-          <p:cNvPr id="5" name="TextBox 4"/>
-          <p:cNvSpPr txBox="1"/>
-          <p:nvPr/>
-        </p:nvSpPr>
-        <p:spPr>
-          <a:xfrm>
-            <a:off x="640080" y="3447288"/>
-            <a:ext cx="10972800" cy="438912"/>
-          </a:xfrm>
-          <a:prstGeom prst="rect">
-            <a:avLst/>
-          </a:prstGeom>
-          <a:noFill/>
-        </p:spPr>
-        <p:txBody>
-          <a:bodyPr wrap="square">
-            <a:noAutofit/>
-          </a:bodyPr>
-          <a:lstStyle/>
-          <a:p>
-            <a:r>
-              <a:rPr sz="1500" b="0">
-                <a:solidFill>
-                  <a:srgbClr val="5F5E5A"/>
-                </a:solidFill>
-                <a:latin typeface="Calibri"/>
-              </a:rPr>
-              <a:t>每列只列代表性的幾種、非窮舉；重點是「就這三條線」。</a:t>
-            </a:r>
-          </a:p>
-        </p:txBody>
-      </p:sp>
-      <p:pic>
-        <p:nvPicPr>
-          <p:cNvPr id="6" name="Picture 5" descr="clock-hour-4.png"/>
-          <p:cNvPicPr>
-            <a:picLocks noChangeAspect="1"/>
-          </p:cNvPicPr>
-          <p:nvPr/>
-        </p:nvPicPr>
-        <p:blipFill>
-          <a:blip r:embed="rId2"/>
-          <a:stretch>
-            <a:fillRect/>
-          </a:stretch>
-        </p:blipFill>
-        <p:spPr>
-          <a:xfrm>
-            <a:off x="658368" y="4041648"/>
-            <a:ext cx="274320" cy="274320"/>
-          </a:xfrm>
-          <a:prstGeom prst="rect">
-            <a:avLst/>
-          </a:prstGeom>
-        </p:spPr>
-      </p:pic>
-      <p:sp>
-        <p:nvSpPr>
-          <p:cNvPr id="7" name="TextBox 6"/>
-          <p:cNvSpPr txBox="1"/>
-          <p:nvPr/>
-        </p:nvSpPr>
-        <p:spPr>
-          <a:xfrm>
-            <a:off x="1078992" y="4014215"/>
-            <a:ext cx="10515600" cy="841248"/>
-          </a:xfrm>
-          <a:prstGeom prst="rect">
-            <a:avLst/>
-          </a:prstGeom>
-          <a:noFill/>
-        </p:spPr>
-        <p:txBody>
-          <a:bodyPr wrap="square">
-            <a:noAutofit/>
-          </a:bodyPr>
-          <a:lstStyle/>
-          <a:p>
-            <a:r>
-              <a:rPr sz="1650" b="0">
-                <a:solidFill>
-                  <a:srgbClr val="1E2024"/>
-                </a:solidFill>
-                <a:latin typeface="Calibri"/>
-              </a:rPr>
-              <a:t>client 內嵌在各 app、長期不更新（Kafka 曾為舊 client 保留每個 protocol 版本近九年，4.0／KIP-896 才把下限提到 2.1）</a:t>
-            </a:r>
-          </a:p>
-        </p:txBody>
-      </p:sp>
-      <p:pic>
-        <p:nvPicPr>
-          <p:cNvPr id="8" name="Picture 7" descr="server-2.png"/>
-          <p:cNvPicPr>
-            <a:picLocks noChangeAspect="1"/>
-          </p:cNvPicPr>
-          <p:nvPr/>
-        </p:nvPicPr>
-        <p:blipFill>
-          <a:blip r:embed="rId3"/>
-          <a:stretch>
-            <a:fillRect/>
-          </a:stretch>
-        </p:blipFill>
-        <p:spPr>
-          <a:xfrm>
-            <a:off x="658368" y="5029200"/>
-            <a:ext cx="274320" cy="274320"/>
-          </a:xfrm>
-          <a:prstGeom prst="rect">
-            <a:avLst/>
-          </a:prstGeom>
-        </p:spPr>
-      </p:pic>
+              <a:t>        → 只能在「連線當下」協商</a:t>
+            </a:r>
+          </a:p>
+        </p:txBody>
+      </p:sp>
       <p:sp>
         <p:nvSpPr>
           <p:cNvPr id="9" name="TextBox 8"/>
@@ -6204,41 +5541,7 @@
         </p:nvSpPr>
         <p:spPr>
           <a:xfrm>
-            <a:off x="1078992" y="5001768"/>
-            <a:ext cx="10515600" cy="493776"/>
-          </a:xfrm>
-          <a:prstGeom prst="rect">
-            <a:avLst/>
-          </a:prstGeom>
-          <a:noFill/>
-        </p:spPr>
-        <p:txBody>
-          <a:bodyPr wrap="square">
-            <a:noAutofit/>
-          </a:bodyPr>
-          <a:lstStyle/>
-          <a:p>
-            <a:r>
-              <a:rPr sz="1650" b="0">
-                <a:solidFill>
-                  <a:srgbClr val="1E2024"/>
-                </a:solidFill>
-                <a:latin typeface="Calibri"/>
-              </a:rPr>
-              <a:t>broker 逐台滾動升級，過程必然新舊並存；要不停機就不能要求全叢集同版</a:t>
-            </a:r>
-          </a:p>
-        </p:txBody>
-      </p:sp>
-      <p:sp>
-        <p:nvSpPr>
-          <p:cNvPr id="10" name="TextBox 9"/>
-          <p:cNvSpPr txBox="1"/>
-          <p:nvPr/>
-        </p:nvSpPr>
-        <p:spPr>
-          <a:xfrm>
-            <a:off x="640080" y="5641848"/>
+            <a:off x="640080" y="5074920"/>
             <a:ext cx="10972800" cy="566928"/>
           </a:xfrm>
           <a:prstGeom prst="rect">
@@ -6264,14 +5567,14 @@
                 </a:solidFill>
                 <a:latin typeface="Calibri"/>
               </a:rPr>
-              <a:t>所以版本只能在連線當下協商——後面每個機制都掛在上面這三條線</a:t>
-            </a:r>
-          </a:p>
-        </p:txBody>
-      </p:sp>
-      <p:sp>
-        <p:nvSpPr>
-          <p:cNvPr id="11" name="TextBox 10"/>
+              <a:t>這就是本場主題「溝通當下的版本選擇」的由來</a:t>
+            </a:r>
+          </a:p>
+        </p:txBody>
+      </p:sp>
+      <p:sp>
+        <p:nvSpPr>
+          <p:cNvPr id="10" name="TextBox 9"/>
           <p:cNvSpPr txBox="1"/>
           <p:nvPr/>
         </p:nvSpPr>
@@ -6398,7 +5701,7 @@
                 </a:solidFill>
                 <a:latin typeface="Calibri"/>
               </a:rPr>
-              <a:t>Part 1 · 三層 scope</a:t>
+              <a:t>Part 1 · 術語</a:t>
             </a:r>
           </a:p>
         </p:txBody>
@@ -6432,7 +5735,7 @@
                 </a:solidFill>
                 <a:latin typeface="Calibri"/>
               </a:rPr>
-              <a:t>一個版本號不夠：三種 scope 互斥</a:t>
+              <a:t>講「版本」時，其實是指哪一個？分三層</a:t>
             </a:r>
           </a:p>
         </p:txBody>
@@ -6553,7 +5856,7 @@
                 </a:solidFill>
                 <a:latin typeface="Calibri"/>
               </a:rPr>
-              <a:t>三層不會同步變動、scope 也不同，多數版本問題的根源都在於此</a:t>
+              <a:t>三個獨立的軸、各自變動；後面提到「版本」都要先分清楚是哪一層</a:t>
             </a:r>
           </a:p>
         </p:txBody>
@@ -6567,20 +5870,15 @@
         <p:spPr>
           <a:xfrm>
             <a:off x="640080" y="4087368"/>
-            <a:ext cx="10972800" cy="566928"/>
-          </a:xfrm>
-          <a:prstGeom prst="rect">
-            <a:avLst/>
-          </a:prstGeom>
-          <a:solidFill>
-            <a:srgbClr val="E9F3DE"/>
-          </a:solidFill>
-          <a:ln>
-            <a:noFill/>
-          </a:ln>
-        </p:spPr>
-        <p:txBody>
-          <a:bodyPr wrap="square" lIns="146304" tIns="82296">
+            <a:ext cx="10972800" cy="438912"/>
+          </a:xfrm>
+          <a:prstGeom prst="rect">
+            <a:avLst/>
+          </a:prstGeom>
+          <a:noFill/>
+        </p:spPr>
+        <p:txBody>
+          <a:bodyPr wrap="square">
             <a:noAutofit/>
           </a:bodyPr>
           <a:lstStyle/>
@@ -6588,11 +5886,11 @@
             <a:r>
               <a:rPr sz="1500" b="0">
                 <a:solidFill>
-                  <a:srgbClr val="27500A"/>
-                </a:solidFill>
-                <a:latin typeface="Calibri"/>
-              </a:rPr>
-              <a:t>單一版本號無法同時表達三種 scope，只能拆成三層各自管</a:t>
+                  <a:srgbClr val="5F5E5A"/>
+                </a:solidFill>
+                <a:latin typeface="Calibri"/>
+              </a:rPr>
+              <a:t>本場主角是 wire 版本（連線當下選哪版）；MV 是叢集治理、release 是 binary。</a:t>
             </a:r>
           </a:p>
         </p:txBody>
@@ -6706,7 +6004,7 @@
                 </a:solidFill>
                 <a:latin typeface="Calibri"/>
               </a:rPr>
-              <a:t>Part 1 · 選版機制</a:t>
+              <a:t>Part 1 · 架構</a:t>
             </a:r>
           </a:p>
         </p:txBody>
@@ -6740,7 +6038,7 @@
                 </a:solidFill>
                 <a:latin typeface="Calibri"/>
               </a:rPr>
-              <a:t>回到三個角色：各自怎麼選版</a:t>
+              <a:t>三種連線，各自怎麼選版</a:t>
             </a:r>
           </a:p>
         </p:txBody>
@@ -6798,7 +6096,7 @@
                 </a:solidFill>
                 <a:latin typeface="Calibri"/>
               </a:rPr>
-              <a:t>底層都先做 ApiVersions 握手（共用同一顆 NetworkClient）；決定版本的是 request Builder 留多少空間</a:t>
+              <a:t>協商發生在三條線上，底層都先做 ApiVersions 握手（共用同一顆 NetworkClient）</a:t>
             </a:r>
           </a:p>
         </p:txBody>
@@ -6850,7 +6148,7 @@
                 </a:solidFill>
                 <a:latin typeface="Calibri"/>
               </a:rPr>
-              <a:t>broker ↔ controller   也協商（broker 當 client：heartbeat / registration）</a:t>
+              <a:t>broker ↔ controller   也協商（broker 當 client：註冊 / 心跳 / 轉發 admin）</a:t>
             </a:r>
           </a:p>
           <a:p>
@@ -6900,7 +6198,7 @@
                 </a:solidFill>
                 <a:latin typeface="Calibri"/>
               </a:rPr>
-              <a:t>MV 只影響複製用的 Fetch / ListOffsets；client、controller 那兩條都是協商</a:t>
+              <a:t>決定版本的是 request Builder 留多少空間；MV 只影響複製的 Fetch / ListOffsets，其餘都是協商</a:t>
             </a:r>
           </a:p>
         </p:txBody>
@@ -7260,7 +6558,7 @@
                 </a:solidFill>
                 <a:latin typeface="Calibri"/>
               </a:rPr>
-              <a:t>隨堂考 · 暖身</a:t>
+              <a:t>隨堂考 · 核心</a:t>
             </a:r>
           </a:p>
         </p:txBody>
@@ -7294,7 +6592,7 @@
                 </a:solidFill>
                 <a:latin typeface="Calibri"/>
               </a:rPr>
-              <a:t>可以「一個版本打天下」嗎？</a:t>
+              <a:t>replica fetch（broker↔broker）的 Fetch 版本怎麼決定？</a:t>
             </a:r>
           </a:p>
         </p:txBody>
@@ -7337,7 +6635,7 @@
                 </a:solidFill>
                 <a:latin typeface="Calibri"/>
               </a:rPr>
-              <a:t>可以，大家同一版一起升</a:t>
+              <a:t>兩 broker ApiVersions 協商取交集</a:t>
             </a:r>
           </a:p>
         </p:txBody>
@@ -7380,7 +6678,7 @@
                 </a:solidFill>
                 <a:latin typeface="Calibri"/>
               </a:rPr>
-              <a:t>不行——client 長壽 + 要不停機，得溝通當下協商</a:t>
+              <a:t>由 finalized metadata.version 決定</a:t>
             </a:r>
           </a:p>
         </p:txBody>
@@ -7423,7 +6721,7 @@
                 </a:solidFill>
                 <a:latin typeface="Calibri"/>
               </a:rPr>
-              <a:t>可以，只要都 4.x</a:t>
+              <a:t>永遠用最新版</a:t>
             </a:r>
           </a:p>
         </p:txBody>
@@ -7466,7 +6764,7 @@
                 </a:solidFill>
                 <a:latin typeface="Calibri"/>
               </a:rPr>
-              <a:t>看 broker 數量</a:t>
+              <a:t>controller 每次指定</a:t>
             </a:r>
           </a:p>
         </p:txBody>
@@ -7552,7 +6850,7 @@
                 </a:solidFill>
                 <a:latin typeface="Calibri"/>
               </a:rPr>
-              <a:t>隨堂考 · 暖身　（正解）</a:t>
+              <a:t>隨堂考 · 核心　（正解）</a:t>
             </a:r>
           </a:p>
         </p:txBody>
@@ -7586,7 +6884,7 @@
                 </a:solidFill>
                 <a:latin typeface="Calibri"/>
               </a:rPr>
-              <a:t>可以「一個版本打天下」嗎？</a:t>
+              <a:t>replica fetch（broker↔broker）的 Fetch 版本怎麼決定？</a:t>
             </a:r>
           </a:p>
         </p:txBody>
@@ -7629,7 +6927,7 @@
                 </a:solidFill>
                 <a:latin typeface="Calibri"/>
               </a:rPr>
-              <a:t>可以，大家同一版一起升</a:t>
+              <a:t>兩 broker ApiVersions 協商取交集</a:t>
             </a:r>
           </a:p>
         </p:txBody>
@@ -7677,7 +6975,7 @@
                 </a:solidFill>
                 <a:latin typeface="Calibri"/>
               </a:rPr>
-              <a:t>不行——client 長壽 + 要不停機，得溝通當下協商   ✓</a:t>
+              <a:t>由 finalized metadata.version 決定   ✓</a:t>
             </a:r>
           </a:p>
         </p:txBody>
@@ -7720,7 +7018,7 @@
                 </a:solidFill>
                 <a:latin typeface="Calibri"/>
               </a:rPr>
-              <a:t>可以，只要都 4.x</a:t>
+              <a:t>永遠用最新版</a:t>
             </a:r>
           </a:p>
         </p:txBody>
@@ -7763,7 +7061,7 @@
                 </a:solidFill>
                 <a:latin typeface="Calibri"/>
               </a:rPr>
-              <a:t>看 broker 數量</a:t>
+              <a:t>controller 每次指定</a:t>
             </a:r>
           </a:p>
         </p:txBody>
@@ -7806,7 +7104,7 @@
                 </a:solidFill>
                 <a:latin typeface="Calibri"/>
               </a:rPr>
-              <a:t>client 嵌在各 app、超長壽，混版是常態；要不停機升級就得每條連線各自選版本。</a:t>
+              <a:t>fetchRequestVersion(MV)：MV 是集中共識，不做 per-connection 協商。</a:t>
             </a:r>
           </a:p>
         </p:txBody>
@@ -7850,7 +7148,7 @@
                 <a:latin typeface="Courier New"/>
                 <a:hlinkClick r:id="rId2"/>
               </a:rPr>
-              <a:t>protocol.md:94</a:t>
+              <a:t>RemoteLeaderEndPoint.scala:215</a:t>
             </a:r>
             <a:r>
               <a:rPr sz="1200" b="0">
@@ -7866,10 +7164,10 @@
                 <a:solidFill>
                   <a:srgbClr val="185FA5"/>
                 </a:solidFill>
-                <a:latin typeface="Calibri"/>
+                <a:latin typeface="Courier New"/>
                 <a:hlinkClick r:id="rId3"/>
               </a:rPr>
-              <a:t>KIP-896</a:t>
+              <a:t>MetadataVersion.java:273</a:t>
             </a:r>
           </a:p>
         </p:txBody>

</xml_diff>

<commit_message>
study(version-control): 套用 Fable review Top 5（deck 部分）
- 補「為什麼複製面用 MV、其餘協商」rationale（架構(b) solve）
- 三術語首現定義：ApiVersions 握手(KIP-35 REF 歸位)、finalize note、Builder 白話；NetworkClient 降級
- 架構拆兩張（握手 / 誰說了算），ListOffsets 細節降 note；15 張
- 清理：QUIZ 只留本場 2 題（刪兄弟場 3 題）、自刻出處統一 RequestContext+SocketServer、Recap 加 v11/v17 回收句
- review 報告存 review-fable-deck-blog.md；talk-outline.md 同步
</commit_message>
<xml_diff>
--- a/study/version-control/kafka-version-negotiation.pptx
+++ b/study/version-control/kafka-version-negotiation.pptx
@@ -19,6 +19,7 @@
     <p:sldId id="267" r:id="rId18"/>
     <p:sldId id="268" r:id="rId19"/>
     <p:sldId id="269" r:id="rId20"/>
+    <p:sldId id="270" r:id="rId21"/>
   </p:sldIdLst>
   <p:sldSz cx="12191695" cy="6858000" type="screen4x3"/>
   <p:notesSz cx="6858000" cy="9144000"/>
@@ -3327,7 +3328,7 @@
                 </a:solidFill>
                 <a:latin typeface="Calibri"/>
               </a:rPr>
-              <a:t>Part 2 · 失敗訊息</a:t>
+              <a:t>隨堂考 · 核心　（正解）</a:t>
             </a:r>
           </a:p>
         </p:txBody>
@@ -3341,7 +3342,7 @@
         <p:spPr>
           <a:xfrm>
             <a:off x="640080" y="841248"/>
-            <a:ext cx="10972800" cy="1005840"/>
+            <a:ext cx="10972800" cy="1188720"/>
           </a:xfrm>
           <a:prstGeom prst="rect">
             <a:avLst/>
@@ -3355,13 +3356,13 @@
           <a:lstStyle/>
           <a:p>
             <a:r>
-              <a:rPr sz="3200" b="1">
+              <a:rPr sz="2600" b="1">
                 <a:solidFill>
                   <a:srgbClr val="1E2024"/>
                 </a:solidFill>
                 <a:latin typeface="Calibri"/>
               </a:rPr>
-              <a:t>通訊當下協商不出版本，會看到什麼</a:t>
+              <a:t>replica fetch（broker↔broker）的 Fetch 版本怎麼決定？</a:t>
             </a:r>
           </a:p>
         </p:txBody>
@@ -3374,85 +3375,89 @@
         </p:nvSpPr>
         <p:spPr>
           <a:xfrm>
-            <a:off x="640080" y="2148840"/>
-            <a:ext cx="10972800" cy="1371600"/>
+            <a:off x="822960" y="2331720"/>
+            <a:ext cx="10515600" cy="493776"/>
+          </a:xfrm>
+          <a:prstGeom prst="rect">
+            <a:avLst/>
+          </a:prstGeom>
+          <a:noFill/>
+        </p:spPr>
+        <p:txBody>
+          <a:bodyPr wrap="square">
+            <a:noAutofit/>
+          </a:bodyPr>
+          <a:lstStyle/>
+          <a:p>
+            <a:r>
+              <a:rPr sz="1600" b="0">
+                <a:solidFill>
+                  <a:srgbClr val="1E2024"/>
+                </a:solidFill>
+                <a:latin typeface="Calibri"/>
+              </a:rPr>
+              <a:t>A.  </a:t>
+            </a:r>
+            <a:r>
+              <a:rPr sz="1600" b="0">
+                <a:solidFill>
+                  <a:srgbClr val="1E2024"/>
+                </a:solidFill>
+                <a:latin typeface="Calibri"/>
+              </a:rPr>
+              <a:t>兩 broker ApiVersions 協商取交集</a:t>
+            </a:r>
+          </a:p>
+        </p:txBody>
+      </p:sp>
+      <p:sp>
+        <p:nvSpPr>
+          <p:cNvPr id="5" name="TextBox 4"/>
+          <p:cNvSpPr txBox="1"/>
+          <p:nvPr/>
+        </p:nvSpPr>
+        <p:spPr>
+          <a:xfrm>
+            <a:off x="822960" y="2953512"/>
+            <a:ext cx="10515600" cy="493776"/>
           </a:xfrm>
           <a:prstGeom prst="rect">
             <a:avLst/>
           </a:prstGeom>
           <a:solidFill>
-            <a:srgbClr val="F3F1EC"/>
+            <a:srgbClr val="E9F3DE"/>
           </a:solidFill>
-          <a:ln w="6350">
-            <a:solidFill>
-              <a:srgbClr val="E3E0D8"/>
-            </a:solidFill>
+          <a:ln>
+            <a:noFill/>
           </a:ln>
         </p:spPr>
         <p:txBody>
-          <a:bodyPr wrap="square" lIns="146304" tIns="91440" bIns="91440">
-            <a:noAutofit/>
-          </a:bodyPr>
-          <a:lstStyle/>
-          <a:p>
-            <a:r>
-              <a:rPr sz="1350" b="0">
-                <a:solidFill>
-                  <a:srgbClr val="2C2C2A"/>
-                </a:solidFill>
-                <a:latin typeface="Calibri"/>
-              </a:rPr>
-              <a:t>交集空        → client 端 UnsupportedVersionException（送出前 abort）</a:t>
-            </a:r>
-          </a:p>
-          <a:p>
-            <a:r>
-              <a:rPr sz="1350" b="0">
-                <a:solidFill>
-                  <a:srgbClr val="2C2C2A"/>
-                </a:solidFill>
-                <a:latin typeface="Calibri"/>
-              </a:rPr>
-              <a:t>繞過協商自刻  → broker 丟 UnsupportedVersionException + 關線</a:t>
-            </a:r>
-          </a:p>
-          <a:p>
-            <a:r>
-              <a:rPr sz="1350" b="0">
-                <a:solidFill>
-                  <a:srgbClr val="2C2C2A"/>
-                </a:solidFill>
-                <a:latin typeface="Calibri"/>
-              </a:rPr>
-              <a:t>（ApiVersions 例外：回 v0 + UNSUPPORTED_VERSION 錯誤碼）</a:t>
-            </a:r>
-          </a:p>
-        </p:txBody>
-      </p:sp>
-      <p:pic>
-        <p:nvPicPr>
-          <p:cNvPr id="5" name="Picture 4" descr="ban.png"/>
-          <p:cNvPicPr>
-            <a:picLocks noChangeAspect="1"/>
-          </p:cNvPicPr>
-          <p:nvPr/>
-        </p:nvPicPr>
-        <p:blipFill>
-          <a:blip r:embed="rId2"/>
-          <a:stretch>
-            <a:fillRect/>
-          </a:stretch>
-        </p:blipFill>
-        <p:spPr>
-          <a:xfrm>
-            <a:off x="658368" y="3749040"/>
-            <a:ext cx="274320" cy="274320"/>
-          </a:xfrm>
-          <a:prstGeom prst="rect">
-            <a:avLst/>
-          </a:prstGeom>
-        </p:spPr>
-      </p:pic>
+          <a:bodyPr wrap="square" lIns="128016" tIns="54864">
+            <a:noAutofit/>
+          </a:bodyPr>
+          <a:lstStyle/>
+          <a:p>
+            <a:r>
+              <a:rPr sz="1600" b="1">
+                <a:solidFill>
+                  <a:srgbClr val="27500A"/>
+                </a:solidFill>
+                <a:latin typeface="Calibri"/>
+              </a:rPr>
+              <a:t>B.  </a:t>
+            </a:r>
+            <a:r>
+              <a:rPr sz="1600" b="1">
+                <a:solidFill>
+                  <a:srgbClr val="27500A"/>
+                </a:solidFill>
+                <a:latin typeface="Calibri"/>
+              </a:rPr>
+              <a:t>由 finalized metadata.version 決定   ✓</a:t>
+            </a:r>
+          </a:p>
+        </p:txBody>
+      </p:sp>
       <p:sp>
         <p:nvSpPr>
           <p:cNvPr id="6" name="TextBox 5"/>
@@ -3461,7 +3466,7 @@
         </p:nvSpPr>
         <p:spPr>
           <a:xfrm>
-            <a:off x="1078992" y="3721608"/>
+            <a:off x="822960" y="3575304"/>
             <a:ext cx="10515600" cy="493776"/>
           </a:xfrm>
           <a:prstGeom prst="rect">
@@ -3476,13 +3481,22 @@
           <a:lstStyle/>
           <a:p>
             <a:r>
-              <a:rPr sz="1650" b="0">
+              <a:rPr sz="1600" b="0">
                 <a:solidFill>
                   <a:srgbClr val="1E2024"/>
                 </a:solidFill>
                 <a:latin typeface="Calibri"/>
               </a:rPr>
-              <a:t>多數情況 client 在送出前就本地中止，根本沒上網路</a:t>
+              <a:t>C.  </a:t>
+            </a:r>
+            <a:r>
+              <a:rPr sz="1600" b="0">
+                <a:solidFill>
+                  <a:srgbClr val="1E2024"/>
+                </a:solidFill>
+                <a:latin typeface="Calibri"/>
+              </a:rPr>
+              <a:t>永遠用最新版</a:t>
             </a:r>
           </a:p>
         </p:txBody>
@@ -3490,6 +3504,92 @@
       <p:sp>
         <p:nvSpPr>
           <p:cNvPr id="7" name="TextBox 6"/>
+          <p:cNvSpPr txBox="1"/>
+          <p:nvPr/>
+        </p:nvSpPr>
+        <p:spPr>
+          <a:xfrm>
+            <a:off x="822960" y="4197096"/>
+            <a:ext cx="10515600" cy="493776"/>
+          </a:xfrm>
+          <a:prstGeom prst="rect">
+            <a:avLst/>
+          </a:prstGeom>
+          <a:noFill/>
+        </p:spPr>
+        <p:txBody>
+          <a:bodyPr wrap="square">
+            <a:noAutofit/>
+          </a:bodyPr>
+          <a:lstStyle/>
+          <a:p>
+            <a:r>
+              <a:rPr sz="1600" b="0">
+                <a:solidFill>
+                  <a:srgbClr val="1E2024"/>
+                </a:solidFill>
+                <a:latin typeface="Calibri"/>
+              </a:rPr>
+              <a:t>D.  </a:t>
+            </a:r>
+            <a:r>
+              <a:rPr sz="1600" b="0">
+                <a:solidFill>
+                  <a:srgbClr val="1E2024"/>
+                </a:solidFill>
+                <a:latin typeface="Calibri"/>
+              </a:rPr>
+              <a:t>controller 每次指定</a:t>
+            </a:r>
+          </a:p>
+        </p:txBody>
+      </p:sp>
+      <p:sp>
+        <p:nvSpPr>
+          <p:cNvPr id="8" name="TextBox 7"/>
+          <p:cNvSpPr txBox="1"/>
+          <p:nvPr/>
+        </p:nvSpPr>
+        <p:spPr>
+          <a:xfrm>
+            <a:off x="640080" y="4910327"/>
+            <a:ext cx="10972800" cy="914400"/>
+          </a:xfrm>
+          <a:prstGeom prst="rect">
+            <a:avLst/>
+          </a:prstGeom>
+          <a:noFill/>
+        </p:spPr>
+        <p:txBody>
+          <a:bodyPr wrap="square">
+            <a:noAutofit/>
+          </a:bodyPr>
+          <a:lstStyle/>
+          <a:p>
+            <a:r>
+              <a:rPr sz="1400" b="1">
+                <a:solidFill>
+                  <a:srgbClr val="27500A"/>
+                </a:solidFill>
+                <a:latin typeface="Calibri"/>
+              </a:rPr>
+              <a:t>正解 B — </a:t>
+            </a:r>
+            <a:r>
+              <a:rPr sz="1400" b="0">
+                <a:solidFill>
+                  <a:srgbClr val="1E2024"/>
+                </a:solidFill>
+                <a:latin typeface="Calibri"/>
+              </a:rPr>
+              <a:t>fetchRequestVersion(MV)：MV 是集中共識，不做 per-connection 協商。</a:t>
+            </a:r>
+          </a:p>
+        </p:txBody>
+      </p:sp>
+      <p:sp>
+        <p:nvSpPr>
+          <p:cNvPr id="9" name="TextBox 8"/>
           <p:cNvSpPr txBox="1"/>
           <p:nvPr/>
         </p:nvSpPr>
@@ -3524,47 +3624,28 @@
                   <a:srgbClr val="185FA5"/>
                 </a:solidFill>
                 <a:latin typeface="Courier New"/>
+                <a:hlinkClick r:id="rId2"/>
+              </a:rPr>
+              <a:t>RemoteLeaderEndPoint.scala:215</a:t>
+            </a:r>
+            <a:r>
+              <a:rPr sz="1200" b="0">
+                <a:solidFill>
+                  <a:srgbClr val="8A8A8A"/>
+                </a:solidFill>
+                <a:latin typeface="Calibri"/>
+              </a:rPr>
+              <a:t>   ·   </a:t>
+            </a:r>
+            <a:r>
+              <a:rPr sz="1200" b="0" u="sng">
+                <a:solidFill>
+                  <a:srgbClr val="185FA5"/>
+                </a:solidFill>
+                <a:latin typeface="Courier New"/>
                 <a:hlinkClick r:id="rId3"/>
               </a:rPr>
-              <a:t>latestUsableVersion</a:t>
-            </a:r>
-            <a:r>
-              <a:rPr sz="1200" b="0">
-                <a:solidFill>
-                  <a:srgbClr val="8A8A8A"/>
-                </a:solidFill>
-                <a:latin typeface="Calibri"/>
-              </a:rPr>
-              <a:t>   ·   </a:t>
-            </a:r>
-            <a:r>
-              <a:rPr sz="1200" b="0" u="sng">
-                <a:solidFill>
-                  <a:srgbClr val="185FA5"/>
-                </a:solidFill>
-                <a:latin typeface="Courier New"/>
-                <a:hlinkClick r:id="rId4"/>
-              </a:rPr>
-              <a:t>NetworkClient</a:t>
-            </a:r>
-            <a:r>
-              <a:rPr sz="1200" b="0">
-                <a:solidFill>
-                  <a:srgbClr val="8A8A8A"/>
-                </a:solidFill>
-                <a:latin typeface="Calibri"/>
-              </a:rPr>
-              <a:t>   ·   </a:t>
-            </a:r>
-            <a:r>
-              <a:rPr sz="1200" b="0" u="sng">
-                <a:solidFill>
-                  <a:srgbClr val="185FA5"/>
-                </a:solidFill>
-                <a:latin typeface="Courier New"/>
-                <a:hlinkClick r:id="rId5"/>
-              </a:rPr>
-              <a:t>RequestContext</a:t>
+              <a:t>MetadataVersion.java:273</a:t>
             </a:r>
           </a:p>
         </p:txBody>
@@ -3650,7 +3731,7 @@
                 </a:solidFill>
                 <a:latin typeface="Calibri"/>
               </a:rPr>
-              <a:t>版本截斷：為什麼「升一點點」不夠</a:t>
+              <a:t>通訊當下協商不出版本，會看到什麼</a:t>
             </a:r>
           </a:p>
         </p:txBody>
@@ -3664,7 +3745,7 @@
         <p:spPr>
           <a:xfrm>
             <a:off x="640080" y="2148840"/>
-            <a:ext cx="10972800" cy="822959"/>
+            <a:ext cx="10972800" cy="1371600"/>
           </a:xfrm>
           <a:prstGeom prst="rect">
             <a:avLst/>
@@ -3691,7 +3772,7 @@
                 </a:solidFill>
                 <a:latin typeface="Calibri"/>
               </a:rPr>
-              <a:t>舊 wire API version 被整個移除，min 可 &gt; 0</a:t>
+              <a:t>交集空        → client 端 UnsupportedVersionException（送出前 abort）</a:t>
             </a:r>
           </a:p>
           <a:p>
@@ -3702,50 +3783,46 @@
                 </a:solidFill>
                 <a:latin typeface="Calibri"/>
               </a:rPr>
-              <a:t>  Fetch：4–18（v0–3 在 4.0 移除）</a:t>
-            </a:r>
-          </a:p>
-        </p:txBody>
-      </p:sp>
-      <p:sp>
-        <p:nvSpPr>
-          <p:cNvPr id="5" name="TextBox 4"/>
-          <p:cNvSpPr txBox="1"/>
-          <p:nvPr/>
-        </p:nvSpPr>
-        <p:spPr>
-          <a:xfrm>
-            <a:off x="640080" y="3172968"/>
-            <a:ext cx="10972800" cy="566928"/>
-          </a:xfrm>
-          <a:prstGeom prst="rect">
-            <a:avLst/>
-          </a:prstGeom>
-          <a:solidFill>
-            <a:srgbClr val="E9F3DE"/>
-          </a:solidFill>
-          <a:ln>
-            <a:noFill/>
-          </a:ln>
-        </p:spPr>
-        <p:txBody>
-          <a:bodyPr wrap="square" lIns="146304" tIns="82296">
-            <a:noAutofit/>
-          </a:bodyPr>
-          <a:lstStyle/>
-          <a:p>
-            <a:r>
-              <a:rPr sz="1500" b="0">
-                <a:solidFill>
-                  <a:srgbClr val="27500A"/>
-                </a:solidFill>
-                <a:latin typeface="Calibri"/>
-              </a:rPr>
-              <a:t>解法：升級前確認兩端都跨過版本下限（升 4.0 需至少 2.1），否則協商結果沒有可用版本</a:t>
-            </a:r>
-          </a:p>
-        </p:txBody>
-      </p:sp>
+              <a:t>繞過協商自刻  → broker 丟 UnsupportedVersionException + 關線</a:t>
+            </a:r>
+          </a:p>
+          <a:p>
+            <a:r>
+              <a:rPr sz="1350" b="0">
+                <a:solidFill>
+                  <a:srgbClr val="2C2C2A"/>
+                </a:solidFill>
+                <a:latin typeface="Calibri"/>
+              </a:rPr>
+              <a:t>（ApiVersions 例外：回 v0 + UNSUPPORTED_VERSION 錯誤碼）</a:t>
+            </a:r>
+          </a:p>
+        </p:txBody>
+      </p:sp>
+      <p:pic>
+        <p:nvPicPr>
+          <p:cNvPr id="5" name="Picture 4" descr="ban.png"/>
+          <p:cNvPicPr>
+            <a:picLocks noChangeAspect="1"/>
+          </p:cNvPicPr>
+          <p:nvPr/>
+        </p:nvPicPr>
+        <p:blipFill>
+          <a:blip r:embed="rId2"/>
+          <a:stretch>
+            <a:fillRect/>
+          </a:stretch>
+        </p:blipFill>
+        <p:spPr>
+          <a:xfrm>
+            <a:off x="658368" y="3749040"/>
+            <a:ext cx="274320" cy="274320"/>
+          </a:xfrm>
+          <a:prstGeom prst="rect">
+            <a:avLst/>
+          </a:prstGeom>
+        </p:spPr>
+      </p:pic>
       <p:sp>
         <p:nvSpPr>
           <p:cNvPr id="6" name="TextBox 5"/>
@@ -3754,8 +3831,8 @@
         </p:nvSpPr>
         <p:spPr>
           <a:xfrm>
-            <a:off x="640080" y="3922776"/>
-            <a:ext cx="10972800" cy="731520"/>
+            <a:off x="1078992" y="3721608"/>
+            <a:ext cx="10515600" cy="493776"/>
           </a:xfrm>
           <a:prstGeom prst="rect">
             <a:avLst/>
@@ -3769,13 +3846,13 @@
           <a:lstStyle/>
           <a:p>
             <a:r>
-              <a:rPr sz="1500" b="0">
-                <a:solidFill>
-                  <a:srgbClr val="5F5E5A"/>
-                </a:solidFill>
-                <a:latin typeface="Calibri"/>
-              </a:rPr>
-              <a:t>銜接（非本場）：finalize / 升降當下的錯誤（INVALID_UPDATE_VERSION 等）屬「運行時的版本升降」那場，本場不展開。</a:t>
+              <a:rPr sz="1650" b="0">
+                <a:solidFill>
+                  <a:srgbClr val="1E2024"/>
+                </a:solidFill>
+                <a:latin typeface="Calibri"/>
+              </a:rPr>
+              <a:t>多數情況 client 在送出前就本地中止，根本沒上網路</a:t>
             </a:r>
           </a:p>
         </p:txBody>
@@ -3817,9 +3894,9 @@
                   <a:srgbClr val="185FA5"/>
                 </a:solidFill>
                 <a:latin typeface="Courier New"/>
-                <a:hlinkClick r:id="rId2"/>
-              </a:rPr>
-              <a:t>upgrade.md:229</a:t>
+                <a:hlinkClick r:id="rId3"/>
+              </a:rPr>
+              <a:t>latestUsableVersion</a:t>
             </a:r>
             <a:r>
               <a:rPr sz="1200" b="0">
@@ -3836,9 +3913,28 @@
                   <a:srgbClr val="185FA5"/>
                 </a:solidFill>
                 <a:latin typeface="Courier New"/>
-                <a:hlinkClick r:id="rId3"/>
-              </a:rPr>
-              <a:t>FetchRequest.json validVersions</a:t>
+                <a:hlinkClick r:id="rId4"/>
+              </a:rPr>
+              <a:t>NetworkClient</a:t>
+            </a:r>
+            <a:r>
+              <a:rPr sz="1200" b="0">
+                <a:solidFill>
+                  <a:srgbClr val="8A8A8A"/>
+                </a:solidFill>
+                <a:latin typeface="Calibri"/>
+              </a:rPr>
+              <a:t>   ·   </a:t>
+            </a:r>
+            <a:r>
+              <a:rPr sz="1200" b="0" u="sng">
+                <a:solidFill>
+                  <a:srgbClr val="185FA5"/>
+                </a:solidFill>
+                <a:latin typeface="Courier New"/>
+                <a:hlinkClick r:id="rId5"/>
+              </a:rPr>
+              <a:t>RequestContext</a:t>
             </a:r>
           </a:p>
         </p:txBody>
@@ -3890,7 +3986,7 @@
                 </a:solidFill>
                 <a:latin typeface="Calibri"/>
               </a:rPr>
-              <a:t>隨堂考 · 核心</a:t>
+              <a:t>Part 2 · 失敗訊息</a:t>
             </a:r>
           </a:p>
         </p:txBody>
@@ -3904,7 +4000,7 @@
         <p:spPr>
           <a:xfrm>
             <a:off x="640080" y="841248"/>
-            <a:ext cx="10972800" cy="1188720"/>
+            <a:ext cx="10972800" cy="1005840"/>
           </a:xfrm>
           <a:prstGeom prst="rect">
             <a:avLst/>
@@ -3918,13 +4014,13 @@
           <a:lstStyle/>
           <a:p>
             <a:r>
-              <a:rPr sz="2600" b="1">
+              <a:rPr sz="3200" b="1">
                 <a:solidFill>
                   <a:srgbClr val="1E2024"/>
                 </a:solidFill>
                 <a:latin typeface="Calibri"/>
               </a:rPr>
-              <a:t>自刻 client 送了不支援的 API version，會怎樣？</a:t>
+              <a:t>版本截斷：為什麼「升一點點」不夠</a:t>
             </a:r>
           </a:p>
         </p:txBody>
@@ -3937,8 +4033,99 @@
         </p:nvSpPr>
         <p:spPr>
           <a:xfrm>
-            <a:off x="822960" y="2331720"/>
-            <a:ext cx="10515600" cy="493776"/>
+            <a:off x="640080" y="2148840"/>
+            <a:ext cx="10972800" cy="822959"/>
+          </a:xfrm>
+          <a:prstGeom prst="rect">
+            <a:avLst/>
+          </a:prstGeom>
+          <a:solidFill>
+            <a:srgbClr val="F3F1EC"/>
+          </a:solidFill>
+          <a:ln w="6350">
+            <a:solidFill>
+              <a:srgbClr val="E3E0D8"/>
+            </a:solidFill>
+          </a:ln>
+        </p:spPr>
+        <p:txBody>
+          <a:bodyPr wrap="square" lIns="146304" tIns="91440" bIns="91440">
+            <a:noAutofit/>
+          </a:bodyPr>
+          <a:lstStyle/>
+          <a:p>
+            <a:r>
+              <a:rPr sz="1350" b="0">
+                <a:solidFill>
+                  <a:srgbClr val="2C2C2A"/>
+                </a:solidFill>
+                <a:latin typeface="Calibri"/>
+              </a:rPr>
+              <a:t>舊 wire API version 被整個移除，min 可 &gt; 0</a:t>
+            </a:r>
+          </a:p>
+          <a:p>
+            <a:r>
+              <a:rPr sz="1350" b="0">
+                <a:solidFill>
+                  <a:srgbClr val="2C2C2A"/>
+                </a:solidFill>
+                <a:latin typeface="Calibri"/>
+              </a:rPr>
+              <a:t>  Fetch：4–18（v0–3 在 4.0 移除）</a:t>
+            </a:r>
+          </a:p>
+        </p:txBody>
+      </p:sp>
+      <p:sp>
+        <p:nvSpPr>
+          <p:cNvPr id="5" name="TextBox 4"/>
+          <p:cNvSpPr txBox="1"/>
+          <p:nvPr/>
+        </p:nvSpPr>
+        <p:spPr>
+          <a:xfrm>
+            <a:off x="640080" y="3172968"/>
+            <a:ext cx="10972800" cy="566928"/>
+          </a:xfrm>
+          <a:prstGeom prst="rect">
+            <a:avLst/>
+          </a:prstGeom>
+          <a:solidFill>
+            <a:srgbClr val="E9F3DE"/>
+          </a:solidFill>
+          <a:ln>
+            <a:noFill/>
+          </a:ln>
+        </p:spPr>
+        <p:txBody>
+          <a:bodyPr wrap="square" lIns="146304" tIns="82296">
+            <a:noAutofit/>
+          </a:bodyPr>
+          <a:lstStyle/>
+          <a:p>
+            <a:r>
+              <a:rPr sz="1500" b="0">
+                <a:solidFill>
+                  <a:srgbClr val="27500A"/>
+                </a:solidFill>
+                <a:latin typeface="Calibri"/>
+              </a:rPr>
+              <a:t>解法：升級前確認兩端都跨過版本下限（升 4.0 需至少 2.1），否則協商結果沒有可用版本</a:t>
+            </a:r>
+          </a:p>
+        </p:txBody>
+      </p:sp>
+      <p:sp>
+        <p:nvSpPr>
+          <p:cNvPr id="6" name="TextBox 5"/>
+          <p:cNvSpPr txBox="1"/>
+          <p:nvPr/>
+        </p:nvSpPr>
+        <p:spPr>
+          <a:xfrm>
+            <a:off x="640080" y="3922776"/>
+            <a:ext cx="10972800" cy="731520"/>
           </a:xfrm>
           <a:prstGeom prst="rect">
             <a:avLst/>
@@ -3952,36 +4139,27 @@
           <a:lstStyle/>
           <a:p>
             <a:r>
-              <a:rPr sz="1600" b="0">
-                <a:solidFill>
-                  <a:srgbClr val="1E2024"/>
-                </a:solidFill>
-                <a:latin typeface="Calibri"/>
-              </a:rPr>
-              <a:t>A.  </a:t>
-            </a:r>
-            <a:r>
-              <a:rPr sz="1600" b="0">
-                <a:solidFill>
-                  <a:srgbClr val="1E2024"/>
-                </a:solidFill>
-                <a:latin typeface="Calibri"/>
-              </a:rPr>
-              <a:t>一律回 UNSUPPORTED_VERSION</a:t>
-            </a:r>
-          </a:p>
-        </p:txBody>
-      </p:sp>
-      <p:sp>
-        <p:nvSpPr>
-          <p:cNvPr id="5" name="TextBox 4"/>
-          <p:cNvSpPr txBox="1"/>
-          <p:nvPr/>
-        </p:nvSpPr>
-        <p:spPr>
-          <a:xfrm>
-            <a:off x="822960" y="2953512"/>
-            <a:ext cx="10515600" cy="493776"/>
+              <a:rPr sz="1500" b="0">
+                <a:solidFill>
+                  <a:srgbClr val="5F5E5A"/>
+                </a:solidFill>
+                <a:latin typeface="Calibri"/>
+              </a:rPr>
+              <a:t>銜接（非本場）：finalize / 升降當下的錯誤（INVALID_UPDATE_VERSION 等）屬「運行時的版本升降」那場，本場不展開。</a:t>
+            </a:r>
+          </a:p>
+        </p:txBody>
+      </p:sp>
+      <p:sp>
+        <p:nvSpPr>
+          <p:cNvPr id="7" name="TextBox 6"/>
+          <p:cNvSpPr txBox="1"/>
+          <p:nvPr/>
+        </p:nvSpPr>
+        <p:spPr>
+          <a:xfrm>
+            <a:off x="640080" y="6400800"/>
+            <a:ext cx="10972800" cy="384048"/>
           </a:xfrm>
           <a:prstGeom prst="rect">
             <a:avLst/>
@@ -3995,142 +4173,42 @@
           <a:lstStyle/>
           <a:p>
             <a:r>
-              <a:rPr sz="1600" b="0">
-                <a:solidFill>
-                  <a:srgbClr val="1E2024"/>
-                </a:solidFill>
-                <a:latin typeface="Calibri"/>
-              </a:rPr>
-              <a:t>B.  </a:t>
-            </a:r>
-            <a:r>
-              <a:rPr sz="1600" b="0">
-                <a:solidFill>
-                  <a:srgbClr val="1E2024"/>
-                </a:solidFill>
-                <a:latin typeface="Calibri"/>
-              </a:rPr>
-              <a:t>只有 ApiVersions 例外回錯誤+範圍；其他 API 關線</a:t>
-            </a:r>
-          </a:p>
-        </p:txBody>
-      </p:sp>
-      <p:sp>
-        <p:nvSpPr>
-          <p:cNvPr id="6" name="TextBox 5"/>
-          <p:cNvSpPr txBox="1"/>
-          <p:nvPr/>
-        </p:nvSpPr>
-        <p:spPr>
-          <a:xfrm>
-            <a:off x="822960" y="3575304"/>
-            <a:ext cx="10515600" cy="493776"/>
-          </a:xfrm>
-          <a:prstGeom prst="rect">
-            <a:avLst/>
-          </a:prstGeom>
-          <a:noFill/>
-        </p:spPr>
-        <p:txBody>
-          <a:bodyPr wrap="square">
-            <a:noAutofit/>
-          </a:bodyPr>
-          <a:lstStyle/>
-          <a:p>
-            <a:r>
-              <a:rPr sz="1600" b="0">
-                <a:solidFill>
-                  <a:srgbClr val="1E2024"/>
-                </a:solidFill>
-                <a:latin typeface="Calibri"/>
-              </a:rPr>
-              <a:t>C.  </a:t>
-            </a:r>
-            <a:r>
-              <a:rPr sz="1600" b="0">
-                <a:solidFill>
-                  <a:srgbClr val="1E2024"/>
-                </a:solidFill>
-                <a:latin typeface="Calibri"/>
-              </a:rPr>
-              <a:t>broker 自動降版</a:t>
-            </a:r>
-          </a:p>
-        </p:txBody>
-      </p:sp>
-      <p:sp>
-        <p:nvSpPr>
-          <p:cNvPr id="7" name="TextBox 6"/>
-          <p:cNvSpPr txBox="1"/>
-          <p:nvPr/>
-        </p:nvSpPr>
-        <p:spPr>
-          <a:xfrm>
-            <a:off x="822960" y="4197096"/>
-            <a:ext cx="10515600" cy="493776"/>
-          </a:xfrm>
-          <a:prstGeom prst="rect">
-            <a:avLst/>
-          </a:prstGeom>
-          <a:noFill/>
-        </p:spPr>
-        <p:txBody>
-          <a:bodyPr wrap="square">
-            <a:noAutofit/>
-          </a:bodyPr>
-          <a:lstStyle/>
-          <a:p>
-            <a:r>
-              <a:rPr sz="1600" b="0">
-                <a:solidFill>
-                  <a:srgbClr val="1E2024"/>
-                </a:solidFill>
-                <a:latin typeface="Calibri"/>
-              </a:rPr>
-              <a:t>D.  </a:t>
-            </a:r>
-            <a:r>
-              <a:rPr sz="1600" b="0">
-                <a:solidFill>
-                  <a:srgbClr val="1E2024"/>
-                </a:solidFill>
-                <a:latin typeface="Calibri"/>
-              </a:rPr>
-              <a:t>忽略版本照跑</a:t>
-            </a:r>
-          </a:p>
-        </p:txBody>
-      </p:sp>
-      <p:sp>
-        <p:nvSpPr>
-          <p:cNvPr id="8" name="TextBox 7"/>
-          <p:cNvSpPr txBox="1"/>
-          <p:nvPr/>
-        </p:nvSpPr>
-        <p:spPr>
-          <a:xfrm>
-            <a:off x="640080" y="4910327"/>
-            <a:ext cx="10972800" cy="914400"/>
-          </a:xfrm>
-          <a:prstGeom prst="rect">
-            <a:avLst/>
-          </a:prstGeom>
-          <a:noFill/>
-        </p:spPr>
-        <p:txBody>
-          <a:bodyPr wrap="square">
-            <a:noAutofit/>
-          </a:bodyPr>
-          <a:lstStyle/>
-          <a:p>
-            <a:r>
-              <a:rPr sz="1400" b="0">
+              <a:rPr sz="1200" b="1">
                 <a:solidFill>
                   <a:srgbClr val="8A8A8A"/>
                 </a:solidFill>
                 <a:latin typeface="Calibri"/>
               </a:rPr>
-              <a:t>想一想 —— 下一頁公布答案</a:t>
+              <a:t>REF   </a:t>
+            </a:r>
+            <a:r>
+              <a:rPr sz="1200" b="0" u="sng">
+                <a:solidFill>
+                  <a:srgbClr val="185FA5"/>
+                </a:solidFill>
+                <a:latin typeface="Courier New"/>
+                <a:hlinkClick r:id="rId2"/>
+              </a:rPr>
+              <a:t>upgrade.md:229</a:t>
+            </a:r>
+            <a:r>
+              <a:rPr sz="1200" b="0">
+                <a:solidFill>
+                  <a:srgbClr val="8A8A8A"/>
+                </a:solidFill>
+                <a:latin typeface="Calibri"/>
+              </a:rPr>
+              <a:t>   ·   </a:t>
+            </a:r>
+            <a:r>
+              <a:rPr sz="1200" b="0" u="sng">
+                <a:solidFill>
+                  <a:srgbClr val="185FA5"/>
+                </a:solidFill>
+                <a:latin typeface="Courier New"/>
+                <a:hlinkClick r:id="rId3"/>
+              </a:rPr>
+              <a:t>FetchRequest.json validVersions</a:t>
             </a:r>
           </a:p>
         </p:txBody>
@@ -4182,7 +4260,7 @@
                 </a:solidFill>
                 <a:latin typeface="Calibri"/>
               </a:rPr>
-              <a:t>隨堂考 · 核心　（正解）</a:t>
+              <a:t>隨堂考 · 核心</a:t>
             </a:r>
           </a:p>
         </p:txBody>
@@ -4278,36 +4356,31 @@
           <a:prstGeom prst="rect">
             <a:avLst/>
           </a:prstGeom>
-          <a:solidFill>
-            <a:srgbClr val="E9F3DE"/>
-          </a:solidFill>
-          <a:ln>
-            <a:noFill/>
-          </a:ln>
-        </p:spPr>
-        <p:txBody>
-          <a:bodyPr wrap="square" lIns="128016" tIns="54864">
-            <a:noAutofit/>
-          </a:bodyPr>
-          <a:lstStyle/>
-          <a:p>
-            <a:r>
-              <a:rPr sz="1600" b="1">
-                <a:solidFill>
-                  <a:srgbClr val="27500A"/>
+          <a:noFill/>
+        </p:spPr>
+        <p:txBody>
+          <a:bodyPr wrap="square">
+            <a:noAutofit/>
+          </a:bodyPr>
+          <a:lstStyle/>
+          <a:p>
+            <a:r>
+              <a:rPr sz="1600" b="0">
+                <a:solidFill>
+                  <a:srgbClr val="1E2024"/>
                 </a:solidFill>
                 <a:latin typeface="Calibri"/>
               </a:rPr>
               <a:t>B.  </a:t>
             </a:r>
             <a:r>
-              <a:rPr sz="1600" b="1">
-                <a:solidFill>
-                  <a:srgbClr val="27500A"/>
-                </a:solidFill>
-                <a:latin typeface="Calibri"/>
-              </a:rPr>
-              <a:t>只有 ApiVersions 例外回錯誤+範圍；其他 API 關線   ✓</a:t>
+              <a:rPr sz="1600" b="0">
+                <a:solidFill>
+                  <a:srgbClr val="1E2024"/>
+                </a:solidFill>
+                <a:latin typeface="Calibri"/>
+              </a:rPr>
+              <a:t>只有 ApiVersions 例外回錯誤+範圍；其他 API 關線</a:t>
             </a:r>
           </a:p>
         </p:txBody>
@@ -4421,66 +4494,13 @@
           <a:lstStyle/>
           <a:p>
             <a:r>
-              <a:rPr sz="1400" b="1">
-                <a:solidFill>
-                  <a:srgbClr val="27500A"/>
-                </a:solidFill>
-                <a:latin typeface="Calibri"/>
-              </a:rPr>
-              <a:t>正解 B — </a:t>
-            </a:r>
-            <a:r>
               <a:rPr sz="1400" b="0">
                 <a:solidFill>
-                  <a:srgbClr val="1E2024"/>
-                </a:solidFill>
-                <a:latin typeface="Calibri"/>
-              </a:rPr>
-              <a:t>ApiVersions 是 bootstrap 逃生口；其他 API → broker 丟 UnsupportedVersionException → 斷線。</a:t>
-            </a:r>
-          </a:p>
-        </p:txBody>
-      </p:sp>
-      <p:sp>
-        <p:nvSpPr>
-          <p:cNvPr id="9" name="TextBox 8"/>
-          <p:cNvSpPr txBox="1"/>
-          <p:nvPr/>
-        </p:nvSpPr>
-        <p:spPr>
-          <a:xfrm>
-            <a:off x="640080" y="6400800"/>
-            <a:ext cx="10972800" cy="384048"/>
-          </a:xfrm>
-          <a:prstGeom prst="rect">
-            <a:avLst/>
-          </a:prstGeom>
-          <a:noFill/>
-        </p:spPr>
-        <p:txBody>
-          <a:bodyPr wrap="square">
-            <a:noAutofit/>
-          </a:bodyPr>
-          <a:lstStyle/>
-          <a:p>
-            <a:r>
-              <a:rPr sz="1200" b="1">
-                <a:solidFill>
                   <a:srgbClr val="8A8A8A"/>
                 </a:solidFill>
                 <a:latin typeface="Calibri"/>
               </a:rPr>
-              <a:t>REF   </a:t>
-            </a:r>
-            <a:r>
-              <a:rPr sz="1200" b="0" u="sng">
-                <a:solidFill>
-                  <a:srgbClr val="185FA5"/>
-                </a:solidFill>
-                <a:latin typeface="Courier New"/>
-                <a:hlinkClick r:id="rId2"/>
-              </a:rPr>
-              <a:t>RequestContext.java:112</a:t>
+              <a:t>想一想 —— 下一頁公布答案</a:t>
             </a:r>
           </a:p>
         </p:txBody>
@@ -4532,6 +4552,375 @@
                 </a:solidFill>
                 <a:latin typeface="Calibri"/>
               </a:rPr>
+              <a:t>隨堂考 · 核心　（正解）</a:t>
+            </a:r>
+          </a:p>
+        </p:txBody>
+      </p:sp>
+      <p:sp>
+        <p:nvSpPr>
+          <p:cNvPr id="3" name="TextBox 2"/>
+          <p:cNvSpPr txBox="1"/>
+          <p:nvPr/>
+        </p:nvSpPr>
+        <p:spPr>
+          <a:xfrm>
+            <a:off x="640080" y="841248"/>
+            <a:ext cx="10972800" cy="1188720"/>
+          </a:xfrm>
+          <a:prstGeom prst="rect">
+            <a:avLst/>
+          </a:prstGeom>
+          <a:noFill/>
+        </p:spPr>
+        <p:txBody>
+          <a:bodyPr wrap="square">
+            <a:noAutofit/>
+          </a:bodyPr>
+          <a:lstStyle/>
+          <a:p>
+            <a:r>
+              <a:rPr sz="2600" b="1">
+                <a:solidFill>
+                  <a:srgbClr val="1E2024"/>
+                </a:solidFill>
+                <a:latin typeface="Calibri"/>
+              </a:rPr>
+              <a:t>自刻 client 送了不支援的 API version，會怎樣？</a:t>
+            </a:r>
+          </a:p>
+        </p:txBody>
+      </p:sp>
+      <p:sp>
+        <p:nvSpPr>
+          <p:cNvPr id="4" name="TextBox 3"/>
+          <p:cNvSpPr txBox="1"/>
+          <p:nvPr/>
+        </p:nvSpPr>
+        <p:spPr>
+          <a:xfrm>
+            <a:off x="822960" y="2331720"/>
+            <a:ext cx="10515600" cy="493776"/>
+          </a:xfrm>
+          <a:prstGeom prst="rect">
+            <a:avLst/>
+          </a:prstGeom>
+          <a:noFill/>
+        </p:spPr>
+        <p:txBody>
+          <a:bodyPr wrap="square">
+            <a:noAutofit/>
+          </a:bodyPr>
+          <a:lstStyle/>
+          <a:p>
+            <a:r>
+              <a:rPr sz="1600" b="0">
+                <a:solidFill>
+                  <a:srgbClr val="1E2024"/>
+                </a:solidFill>
+                <a:latin typeface="Calibri"/>
+              </a:rPr>
+              <a:t>A.  </a:t>
+            </a:r>
+            <a:r>
+              <a:rPr sz="1600" b="0">
+                <a:solidFill>
+                  <a:srgbClr val="1E2024"/>
+                </a:solidFill>
+                <a:latin typeface="Calibri"/>
+              </a:rPr>
+              <a:t>一律回 UNSUPPORTED_VERSION</a:t>
+            </a:r>
+          </a:p>
+        </p:txBody>
+      </p:sp>
+      <p:sp>
+        <p:nvSpPr>
+          <p:cNvPr id="5" name="TextBox 4"/>
+          <p:cNvSpPr txBox="1"/>
+          <p:nvPr/>
+        </p:nvSpPr>
+        <p:spPr>
+          <a:xfrm>
+            <a:off x="822960" y="2953512"/>
+            <a:ext cx="10515600" cy="493776"/>
+          </a:xfrm>
+          <a:prstGeom prst="rect">
+            <a:avLst/>
+          </a:prstGeom>
+          <a:solidFill>
+            <a:srgbClr val="E9F3DE"/>
+          </a:solidFill>
+          <a:ln>
+            <a:noFill/>
+          </a:ln>
+        </p:spPr>
+        <p:txBody>
+          <a:bodyPr wrap="square" lIns="128016" tIns="54864">
+            <a:noAutofit/>
+          </a:bodyPr>
+          <a:lstStyle/>
+          <a:p>
+            <a:r>
+              <a:rPr sz="1600" b="1">
+                <a:solidFill>
+                  <a:srgbClr val="27500A"/>
+                </a:solidFill>
+                <a:latin typeface="Calibri"/>
+              </a:rPr>
+              <a:t>B.  </a:t>
+            </a:r>
+            <a:r>
+              <a:rPr sz="1600" b="1">
+                <a:solidFill>
+                  <a:srgbClr val="27500A"/>
+                </a:solidFill>
+                <a:latin typeface="Calibri"/>
+              </a:rPr>
+              <a:t>只有 ApiVersions 例外回錯誤+範圍；其他 API 關線   ✓</a:t>
+            </a:r>
+          </a:p>
+        </p:txBody>
+      </p:sp>
+      <p:sp>
+        <p:nvSpPr>
+          <p:cNvPr id="6" name="TextBox 5"/>
+          <p:cNvSpPr txBox="1"/>
+          <p:nvPr/>
+        </p:nvSpPr>
+        <p:spPr>
+          <a:xfrm>
+            <a:off x="822960" y="3575304"/>
+            <a:ext cx="10515600" cy="493776"/>
+          </a:xfrm>
+          <a:prstGeom prst="rect">
+            <a:avLst/>
+          </a:prstGeom>
+          <a:noFill/>
+        </p:spPr>
+        <p:txBody>
+          <a:bodyPr wrap="square">
+            <a:noAutofit/>
+          </a:bodyPr>
+          <a:lstStyle/>
+          <a:p>
+            <a:r>
+              <a:rPr sz="1600" b="0">
+                <a:solidFill>
+                  <a:srgbClr val="1E2024"/>
+                </a:solidFill>
+                <a:latin typeface="Calibri"/>
+              </a:rPr>
+              <a:t>C.  </a:t>
+            </a:r>
+            <a:r>
+              <a:rPr sz="1600" b="0">
+                <a:solidFill>
+                  <a:srgbClr val="1E2024"/>
+                </a:solidFill>
+                <a:latin typeface="Calibri"/>
+              </a:rPr>
+              <a:t>broker 自動降版</a:t>
+            </a:r>
+          </a:p>
+        </p:txBody>
+      </p:sp>
+      <p:sp>
+        <p:nvSpPr>
+          <p:cNvPr id="7" name="TextBox 6"/>
+          <p:cNvSpPr txBox="1"/>
+          <p:nvPr/>
+        </p:nvSpPr>
+        <p:spPr>
+          <a:xfrm>
+            <a:off x="822960" y="4197096"/>
+            <a:ext cx="10515600" cy="493776"/>
+          </a:xfrm>
+          <a:prstGeom prst="rect">
+            <a:avLst/>
+          </a:prstGeom>
+          <a:noFill/>
+        </p:spPr>
+        <p:txBody>
+          <a:bodyPr wrap="square">
+            <a:noAutofit/>
+          </a:bodyPr>
+          <a:lstStyle/>
+          <a:p>
+            <a:r>
+              <a:rPr sz="1600" b="0">
+                <a:solidFill>
+                  <a:srgbClr val="1E2024"/>
+                </a:solidFill>
+                <a:latin typeface="Calibri"/>
+              </a:rPr>
+              <a:t>D.  </a:t>
+            </a:r>
+            <a:r>
+              <a:rPr sz="1600" b="0">
+                <a:solidFill>
+                  <a:srgbClr val="1E2024"/>
+                </a:solidFill>
+                <a:latin typeface="Calibri"/>
+              </a:rPr>
+              <a:t>忽略版本照跑</a:t>
+            </a:r>
+          </a:p>
+        </p:txBody>
+      </p:sp>
+      <p:sp>
+        <p:nvSpPr>
+          <p:cNvPr id="8" name="TextBox 7"/>
+          <p:cNvSpPr txBox="1"/>
+          <p:nvPr/>
+        </p:nvSpPr>
+        <p:spPr>
+          <a:xfrm>
+            <a:off x="640080" y="4910327"/>
+            <a:ext cx="10972800" cy="914400"/>
+          </a:xfrm>
+          <a:prstGeom prst="rect">
+            <a:avLst/>
+          </a:prstGeom>
+          <a:noFill/>
+        </p:spPr>
+        <p:txBody>
+          <a:bodyPr wrap="square">
+            <a:noAutofit/>
+          </a:bodyPr>
+          <a:lstStyle/>
+          <a:p>
+            <a:r>
+              <a:rPr sz="1400" b="1">
+                <a:solidFill>
+                  <a:srgbClr val="27500A"/>
+                </a:solidFill>
+                <a:latin typeface="Calibri"/>
+              </a:rPr>
+              <a:t>正解 B — </a:t>
+            </a:r>
+            <a:r>
+              <a:rPr sz="1400" b="0">
+                <a:solidFill>
+                  <a:srgbClr val="1E2024"/>
+                </a:solidFill>
+                <a:latin typeface="Calibri"/>
+              </a:rPr>
+              <a:t>ApiVersions 是 bootstrap 逃生口；其他 API 在 RequestContext 解析失敗、broker 丟 UnsupportedVersionException，SocketServer 關閉連線。</a:t>
+            </a:r>
+          </a:p>
+        </p:txBody>
+      </p:sp>
+      <p:sp>
+        <p:nvSpPr>
+          <p:cNvPr id="9" name="TextBox 8"/>
+          <p:cNvSpPr txBox="1"/>
+          <p:nvPr/>
+        </p:nvSpPr>
+        <p:spPr>
+          <a:xfrm>
+            <a:off x="640080" y="6400800"/>
+            <a:ext cx="10972800" cy="384048"/>
+          </a:xfrm>
+          <a:prstGeom prst="rect">
+            <a:avLst/>
+          </a:prstGeom>
+          <a:noFill/>
+        </p:spPr>
+        <p:txBody>
+          <a:bodyPr wrap="square">
+            <a:noAutofit/>
+          </a:bodyPr>
+          <a:lstStyle/>
+          <a:p>
+            <a:r>
+              <a:rPr sz="1200" b="1">
+                <a:solidFill>
+                  <a:srgbClr val="8A8A8A"/>
+                </a:solidFill>
+                <a:latin typeface="Calibri"/>
+              </a:rPr>
+              <a:t>REF   </a:t>
+            </a:r>
+            <a:r>
+              <a:rPr sz="1200" b="0" u="sng">
+                <a:solidFill>
+                  <a:srgbClr val="185FA5"/>
+                </a:solidFill>
+                <a:latin typeface="Courier New"/>
+                <a:hlinkClick r:id="rId2"/>
+              </a:rPr>
+              <a:t>RequestContext.java:112</a:t>
+            </a:r>
+            <a:r>
+              <a:rPr sz="1200" b="0">
+                <a:solidFill>
+                  <a:srgbClr val="8A8A8A"/>
+                </a:solidFill>
+                <a:latin typeface="Calibri"/>
+              </a:rPr>
+              <a:t>   ·   </a:t>
+            </a:r>
+            <a:r>
+              <a:rPr sz="1200" b="0" u="sng">
+                <a:solidFill>
+                  <a:srgbClr val="185FA5"/>
+                </a:solidFill>
+                <a:latin typeface="Courier New"/>
+                <a:hlinkClick r:id="rId3"/>
+              </a:rPr>
+              <a:t>SocketServer.scala:781</a:t>
+            </a:r>
+          </a:p>
+        </p:txBody>
+      </p:sp>
+    </p:spTree>
+  </p:cSld>
+  <p:clrMapOvr>
+    <a:masterClrMapping/>
+  </p:clrMapOvr>
+</p:sld>
+</file>
+
+<file path=ppt/slides/slide15.xml><?xml version="1.0" encoding="utf-8"?>
+<p:sld xmlns:a="http://schemas.openxmlformats.org/drawingml/2006/main" xmlns:p="http://schemas.openxmlformats.org/presentationml/2006/main" xmlns:r="http://schemas.openxmlformats.org/officeDocument/2006/relationships">
+  <p:cSld>
+    <p:spTree>
+      <p:nvGrpSpPr>
+        <p:cNvPr id="1" name=""/>
+        <p:cNvGrpSpPr/>
+        <p:nvPr/>
+      </p:nvGrpSpPr>
+      <p:grpSpPr/>
+      <p:sp>
+        <p:nvSpPr>
+          <p:cNvPr id="2" name="TextBox 1"/>
+          <p:cNvSpPr txBox="1"/>
+          <p:nvPr/>
+        </p:nvSpPr>
+        <p:spPr>
+          <a:xfrm>
+            <a:off x="640080" y="457200"/>
+            <a:ext cx="10972800" cy="365760"/>
+          </a:xfrm>
+          <a:prstGeom prst="rect">
+            <a:avLst/>
+          </a:prstGeom>
+          <a:noFill/>
+        </p:spPr>
+        <p:txBody>
+          <a:bodyPr wrap="square">
+            <a:noAutofit/>
+          </a:bodyPr>
+          <a:lstStyle/>
+          <a:p>
+            <a:r>
+              <a:rPr sz="1300" b="1">
+                <a:solidFill>
+                  <a:srgbClr val="185FA5"/>
+                </a:solidFill>
+                <a:latin typeface="Calibri"/>
+              </a:rPr>
               <a:t>Recap</a:t>
             </a:r>
           </a:p>
@@ -4571,9 +4960,61 @@
           </a:p>
         </p:txBody>
       </p:sp>
+      <p:sp>
+        <p:nvSpPr>
+          <p:cNvPr id="4" name="TextBox 3"/>
+          <p:cNvSpPr txBox="1"/>
+          <p:nvPr/>
+        </p:nvSpPr>
+        <p:spPr>
+          <a:xfrm>
+            <a:off x="640080" y="2148840"/>
+            <a:ext cx="10972800" cy="1097280"/>
+          </a:xfrm>
+          <a:prstGeom prst="rect">
+            <a:avLst/>
+          </a:prstGeom>
+          <a:solidFill>
+            <a:srgbClr val="F3F1EC"/>
+          </a:solidFill>
+          <a:ln w="6350">
+            <a:solidFill>
+              <a:srgbClr val="E3E0D8"/>
+            </a:solidFill>
+          </a:ln>
+        </p:spPr>
+        <p:txBody>
+          <a:bodyPr wrap="square" lIns="146304" tIns="91440" bIns="91440">
+            <a:noAutofit/>
+          </a:bodyPr>
+          <a:lstStyle/>
+          <a:p>
+            <a:r>
+              <a:rPr sz="1350" b="0">
+                <a:solidFill>
+                  <a:srgbClr val="2C2C2A"/>
+                </a:solidFill>
+                <a:latin typeface="Calibri"/>
+              </a:rPr>
+              <a:t>想像中：client v4.1 ─── broker v4.1</a:t>
+            </a:r>
+          </a:p>
+          <a:p>
+            <a:r>
+              <a:rPr sz="1350" b="0">
+                <a:solidFill>
+                  <a:srgbClr val="2C2C2A"/>
+                </a:solidFill>
+                <a:latin typeface="Calibri"/>
+              </a:rPr>
+              <a:t>實際上：同一顆 4.1 broker，同時講 Fetch v11（對老 consumer）和 v17（對 replica）</a:t>
+            </a:r>
+          </a:p>
+        </p:txBody>
+      </p:sp>
       <p:pic>
         <p:nvPicPr>
-          <p:cNvPr id="4" name="Picture 3" descr="point.png"/>
+          <p:cNvPr id="5" name="Picture 4" descr="point.png"/>
           <p:cNvPicPr>
             <a:picLocks noChangeAspect="1"/>
           </p:cNvPicPr>
@@ -4587,7 +5028,7 @@
         </p:blipFill>
         <p:spPr>
           <a:xfrm>
-            <a:off x="658368" y="2176272"/>
+            <a:off x="658368" y="3474720"/>
             <a:ext cx="274320" cy="274320"/>
           </a:xfrm>
           <a:prstGeom prst="rect">
@@ -4597,13 +5038,13 @@
       </p:pic>
       <p:sp>
         <p:nvSpPr>
-          <p:cNvPr id="5" name="TextBox 4"/>
-          <p:cNvSpPr txBox="1"/>
-          <p:nvPr/>
-        </p:nvSpPr>
-        <p:spPr>
-          <a:xfrm>
-            <a:off x="1078992" y="2148840"/>
+          <p:cNvPr id="6" name="TextBox 5"/>
+          <p:cNvSpPr txBox="1"/>
+          <p:nvPr/>
+        </p:nvSpPr>
+        <p:spPr>
+          <a:xfrm>
+            <a:off x="1078992" y="3447288"/>
             <a:ext cx="10515600" cy="841248"/>
           </a:xfrm>
           <a:prstGeom prst="rect">
@@ -4624,14 +5065,14 @@
                 </a:solidFill>
                 <a:latin typeface="Calibri"/>
               </a:rPr>
-              <a:t>三種通訊：client↔broker、broker↔controller、broker↔broker——版本機制都掛在這三條線</a:t>
+              <a:t>Part 1：不能「一個版本打天下」（client 長壽、broker 滾動升級）；三條線多數靠協商，只有複製面由 finalized MV 決定</a:t>
             </a:r>
           </a:p>
         </p:txBody>
       </p:sp>
       <p:pic>
         <p:nvPicPr>
-          <p:cNvPr id="6" name="Picture 5" descr="point.png"/>
+          <p:cNvPr id="7" name="Picture 6" descr="point.png"/>
           <p:cNvPicPr>
             <a:picLocks noChangeAspect="1"/>
           </p:cNvPicPr>
@@ -4645,7 +5086,7 @@
         </p:blipFill>
         <p:spPr>
           <a:xfrm>
-            <a:off x="658368" y="3163824"/>
+            <a:off x="658368" y="4462272"/>
             <a:ext cx="274320" cy="274320"/>
           </a:xfrm>
           <a:prstGeom prst="rect">
@@ -4655,71 +5096,13 @@
       </p:pic>
       <p:sp>
         <p:nvSpPr>
-          <p:cNvPr id="7" name="TextBox 6"/>
-          <p:cNvSpPr txBox="1"/>
-          <p:nvPr/>
-        </p:nvSpPr>
-        <p:spPr>
-          <a:xfrm>
-            <a:off x="1078992" y="3136392"/>
-            <a:ext cx="10515600" cy="841248"/>
-          </a:xfrm>
-          <a:prstGeom prst="rect">
-            <a:avLst/>
-          </a:prstGeom>
-          <a:noFill/>
-        </p:spPr>
-        <p:txBody>
-          <a:bodyPr wrap="square">
-            <a:noAutofit/>
-          </a:bodyPr>
-          <a:lstStyle/>
-          <a:p>
-            <a:r>
-              <a:rPr sz="1650" b="0">
-                <a:solidFill>
-                  <a:srgbClr val="1E2024"/>
-                </a:solidFill>
-                <a:latin typeface="Calibri"/>
-              </a:rPr>
-              <a:t>Part 1：不能「一個版本打天下」（client 長壽、broker 滾動升級）；多數路徑靠協商，只有複製面由 finalized MV 決定</a:t>
-            </a:r>
-          </a:p>
-        </p:txBody>
-      </p:sp>
-      <p:pic>
-        <p:nvPicPr>
-          <p:cNvPr id="8" name="Picture 7" descr="point.png"/>
-          <p:cNvPicPr>
-            <a:picLocks noChangeAspect="1"/>
-          </p:cNvPicPr>
-          <p:nvPr/>
-        </p:nvPicPr>
-        <p:blipFill>
-          <a:blip r:embed="rId2"/>
-          <a:stretch>
-            <a:fillRect/>
-          </a:stretch>
-        </p:blipFill>
-        <p:spPr>
-          <a:xfrm>
-            <a:off x="658368" y="4151376"/>
-            <a:ext cx="274320" cy="274320"/>
-          </a:xfrm>
-          <a:prstGeom prst="rect">
-            <a:avLst/>
-          </a:prstGeom>
-        </p:spPr>
-      </p:pic>
-      <p:sp>
-        <p:nvSpPr>
-          <p:cNvPr id="9" name="TextBox 8"/>
-          <p:cNvSpPr txBox="1"/>
-          <p:nvPr/>
-        </p:nvSpPr>
-        <p:spPr>
-          <a:xfrm>
-            <a:off x="1078992" y="4123944"/>
+          <p:cNvPr id="8" name="TextBox 7"/>
+          <p:cNvSpPr txBox="1"/>
+          <p:nvPr/>
+        </p:nvSpPr>
+        <p:spPr>
+          <a:xfrm>
+            <a:off x="1078992" y="4434840"/>
             <a:ext cx="10515600" cy="841248"/>
           </a:xfrm>
           <a:prstGeom prst="rect">
@@ -5632,25 +6015,6 @@
               </a:rPr>
               <a:t>protocol.md:94</a:t>
             </a:r>
-            <a:r>
-              <a:rPr sz="1200" b="0">
-                <a:solidFill>
-                  <a:srgbClr val="8A8A8A"/>
-                </a:solidFill>
-                <a:latin typeface="Calibri"/>
-              </a:rPr>
-              <a:t>   ·   </a:t>
-            </a:r>
-            <a:r>
-              <a:rPr sz="1200" b="0" u="sng">
-                <a:solidFill>
-                  <a:srgbClr val="185FA5"/>
-                </a:solidFill>
-                <a:latin typeface="Calibri"/>
-                <a:hlinkClick r:id="rId6"/>
-              </a:rPr>
-              <a:t>KIP-35</a:t>
-            </a:r>
           </a:p>
         </p:txBody>
       </p:sp>
@@ -5787,7 +6151,7 @@
                 </a:solidFill>
                 <a:latin typeface="Calibri"/>
               </a:rPr>
-              <a:t>metadata.version  = 叢集一致的能力世代   (cluster-wide, finalize)</a:t>
+              <a:t>metadata.version  = 叢集一致的能力世代   (cluster-wide, finalized)</a:t>
             </a:r>
           </a:p>
           <a:p>
@@ -5870,7 +6234,7 @@
         <p:spPr>
           <a:xfrm>
             <a:off x="640080" y="4087368"/>
-            <a:ext cx="10972800" cy="438912"/>
+            <a:ext cx="10972800" cy="731520"/>
           </a:xfrm>
           <a:prstGeom prst="rect">
             <a:avLst/>
@@ -5890,7 +6254,7 @@
                 </a:solidFill>
                 <a:latin typeface="Calibri"/>
               </a:rPr>
-              <a:t>本場主角是 wire 版本（連線當下選哪版）；MV 是叢集治理、release 是 binary。</a:t>
+              <a:t>finalize＝管理員手動宣告「全叢集從此認定這個能力世代」；怎麼宣告是第一場《版本定義》的主題，本場只需知道它是叢集共識的一個值。本場主角是 wire 版本。</a:t>
             </a:r>
           </a:p>
         </p:txBody>
@@ -6004,7 +6368,7 @@
                 </a:solidFill>
                 <a:latin typeface="Calibri"/>
               </a:rPr>
-              <a:t>Part 1 · 架構</a:t>
+              <a:t>Part 1 · 架構 (a)</a:t>
             </a:r>
           </a:p>
         </p:txBody>
@@ -6038,7 +6402,7 @@
                 </a:solidFill>
                 <a:latin typeface="Calibri"/>
               </a:rPr>
-              <a:t>三種連線，各自怎麼選版</a:t>
+              <a:t>三種連線，都先做 ApiVersions 握手</a:t>
             </a:r>
           </a:p>
         </p:txBody>
@@ -6096,7 +6460,7 @@
                 </a:solidFill>
                 <a:latin typeface="Calibri"/>
               </a:rPr>
-              <a:t>協商發生在三條線上，底層都先做 ApiVersions 握手（共用同一顆 NetworkClient）</a:t>
+              <a:t>連線建立後，發起端先送一支 ApiVersions：問對方「你每支 API 支援哪個版本區間？」（KIP-35）</a:t>
             </a:r>
           </a:p>
         </p:txBody>
@@ -6110,7 +6474,7 @@
         <p:spPr>
           <a:xfrm>
             <a:off x="640080" y="3136392"/>
-            <a:ext cx="10972800" cy="1371600"/>
+            <a:ext cx="10972800" cy="1097280"/>
           </a:xfrm>
           <a:prstGeom prst="rect">
             <a:avLst/>
@@ -6137,7 +6501,7 @@
                 </a:solidFill>
                 <a:latin typeface="Calibri"/>
               </a:rPr>
-              <a:t>client ↔ broker       協商，取交集最高</a:t>
+              <a:t>client ─▶ broker        讀寫資料、查 metadata…</a:t>
             </a:r>
           </a:p>
           <a:p>
@@ -6148,7 +6512,7 @@
                 </a:solidFill>
                 <a:latin typeface="Calibri"/>
               </a:rPr>
-              <a:t>broker ↔ controller   也協商（broker 當 client：註冊 / 心跳 / 轉發 admin）</a:t>
+              <a:t>broker ─▶ controller    註冊、心跳、轉發 admin…</a:t>
             </a:r>
           </a:p>
           <a:p>
@@ -6159,7 +6523,7 @@
                 </a:solidFill>
                 <a:latin typeface="Calibri"/>
               </a:rPr>
-              <a:t>broker ↔ broker 複製   Fetch 由 MV 決定、ListOffsets 以 MV 為上限</a:t>
+              <a:t>broker ◀▶ broker        複製（follower 抓 leader）</a:t>
             </a:r>
           </a:p>
         </p:txBody>
@@ -6172,21 +6536,16 @@
         </p:nvSpPr>
         <p:spPr>
           <a:xfrm>
-            <a:off x="640080" y="4709160"/>
-            <a:ext cx="10972800" cy="877824"/>
-          </a:xfrm>
-          <a:prstGeom prst="rect">
-            <a:avLst/>
-          </a:prstGeom>
-          <a:solidFill>
-            <a:srgbClr val="E9F3DE"/>
-          </a:solidFill>
-          <a:ln>
-            <a:noFill/>
-          </a:ln>
-        </p:spPr>
-        <p:txBody>
-          <a:bodyPr wrap="square" lIns="146304" tIns="82296">
+            <a:off x="640080" y="4434840"/>
+            <a:ext cx="10972800" cy="438912"/>
+          </a:xfrm>
+          <a:prstGeom prst="rect">
+            <a:avLst/>
+          </a:prstGeom>
+          <a:noFill/>
+        </p:spPr>
+        <p:txBody>
+          <a:bodyPr wrap="square">
             <a:noAutofit/>
           </a:bodyPr>
           <a:lstStyle/>
@@ -6194,11 +6553,11 @@
             <a:r>
               <a:rPr sz="1500" b="0">
                 <a:solidFill>
-                  <a:srgbClr val="27500A"/>
-                </a:solidFill>
-                <a:latin typeface="Calibri"/>
-              </a:rPr>
-              <a:t>決定版本的是 request Builder 留多少空間；MV 只影響複製的 Fetch / ListOffsets，其餘都是協商</a:t>
+                  <a:srgbClr val="5F5E5A"/>
+                </a:solidFill>
+                <a:latin typeface="Calibri"/>
+              </a:rPr>
+              <a:t>每列只列代表性的幾種、非窮舉；重點是三條線都先做這個握手。</a:t>
             </a:r>
           </a:p>
         </p:txBody>
@@ -6239,10 +6598,10 @@
                 <a:solidFill>
                   <a:srgbClr val="185FA5"/>
                 </a:solidFill>
-                <a:latin typeface="Courier New"/>
+                <a:latin typeface="Calibri"/>
                 <a:hlinkClick r:id="rId3"/>
               </a:rPr>
-              <a:t>latestUsableVersion</a:t>
+              <a:t>KIP-35</a:t>
             </a:r>
             <a:r>
               <a:rPr sz="1200" b="0">
@@ -6261,26 +6620,7 @@
                 <a:latin typeface="Courier New"/>
                 <a:hlinkClick r:id="rId4"/>
               </a:rPr>
-              <a:t>fetchRequestVersion</a:t>
-            </a:r>
-            <a:r>
-              <a:rPr sz="1200" b="0">
-                <a:solidFill>
-                  <a:srgbClr val="8A8A8A"/>
-                </a:solidFill>
-                <a:latin typeface="Calibri"/>
-              </a:rPr>
-              <a:t>   ·   </a:t>
-            </a:r>
-            <a:r>
-              <a:rPr sz="1200" b="0" u="sng">
-                <a:solidFill>
-                  <a:srgbClr val="185FA5"/>
-                </a:solidFill>
-                <a:latin typeface="Courier New"/>
-                <a:hlinkClick r:id="rId5"/>
-              </a:rPr>
-              <a:t>javadoc</a:t>
+              <a:t>latestUsableVersion</a:t>
             </a:r>
           </a:p>
         </p:txBody>
@@ -6332,7 +6672,7 @@
                 </a:solidFill>
                 <a:latin typeface="Calibri"/>
               </a:rPr>
-              <a:t>Part 1 · 舉例</a:t>
+              <a:t>Part 1 · 架構 (b)</a:t>
             </a:r>
           </a:p>
         </p:txBody>
@@ -6345,8 +6685,8 @@
         </p:nvSpPr>
         <p:spPr>
           <a:xfrm>
-            <a:off x="640080" y="822960"/>
-            <a:ext cx="10972800" cy="640080"/>
+            <a:off x="640080" y="841248"/>
+            <a:ext cx="10972800" cy="1005840"/>
           </a:xfrm>
           <a:prstGeom prst="rect">
             <a:avLst/>
@@ -6360,13 +6700,13 @@
           <a:lstStyle/>
           <a:p>
             <a:r>
-              <a:rPr sz="2900" b="1">
+              <a:rPr sz="3200" b="1">
                 <a:solidFill>
                   <a:srgbClr val="1E2024"/>
                 </a:solidFill>
                 <a:latin typeface="Calibri"/>
               </a:rPr>
-              <a:t>以一支 Fetch 為例：consumer 協商、replica 由 MV</a:t>
+              <a:t>握手之後，最終版本誰說了算？</a:t>
             </a:r>
           </a:p>
         </p:txBody>
@@ -6379,35 +6719,64 @@
         </p:nvSpPr>
         <p:spPr>
           <a:xfrm>
-            <a:off x="640080" y="1481328"/>
-            <a:ext cx="10972800" cy="365760"/>
-          </a:xfrm>
-          <a:prstGeom prst="rect">
-            <a:avLst/>
-          </a:prstGeom>
-          <a:noFill/>
-        </p:spPr>
-        <p:txBody>
-          <a:bodyPr wrap="square">
-            <a:noAutofit/>
-          </a:bodyPr>
-          <a:lstStyle/>
-          <a:p>
-            <a:r>
-              <a:rPr sz="1400" b="0">
-                <a:solidFill>
-                  <a:srgbClr val="5F5E5A"/>
-                </a:solidFill>
-                <a:latin typeface="Calibri"/>
-              </a:rPr>
-              <a:t>同一支 Fetch 兩種身分：consumer fetch 走 client↔broker、replica fetch 走 broker↔broker</a:t>
+            <a:off x="640080" y="2148840"/>
+            <a:ext cx="10972800" cy="1097280"/>
+          </a:xfrm>
+          <a:prstGeom prst="rect">
+            <a:avLst/>
+          </a:prstGeom>
+          <a:solidFill>
+            <a:srgbClr val="F3F1EC"/>
+          </a:solidFill>
+          <a:ln w="6350">
+            <a:solidFill>
+              <a:srgbClr val="E3E0D8"/>
+            </a:solidFill>
+          </a:ln>
+        </p:spPr>
+        <p:txBody>
+          <a:bodyPr wrap="square" lIns="146304" tIns="91440" bIns="91440">
+            <a:noAutofit/>
+          </a:bodyPr>
+          <a:lstStyle/>
+          <a:p>
+            <a:r>
+              <a:rPr sz="1350" b="0">
+                <a:solidFill>
+                  <a:srgbClr val="2C2C2A"/>
+                </a:solidFill>
+                <a:latin typeface="Calibri"/>
+              </a:rPr>
+              <a:t>client ↔ broker       協商，取交集最高</a:t>
+            </a:r>
+          </a:p>
+          <a:p>
+            <a:r>
+              <a:rPr sz="1350" b="0">
+                <a:solidFill>
+                  <a:srgbClr val="2C2C2A"/>
+                </a:solidFill>
+                <a:latin typeface="Calibri"/>
+              </a:rPr>
+              <a:t>broker ↔ controller   也協商（broker 當 client）</a:t>
+            </a:r>
+          </a:p>
+          <a:p>
+            <a:r>
+              <a:rPr sz="1350" b="0">
+                <a:solidFill>
+                  <a:srgbClr val="2C2C2A"/>
+                </a:solidFill>
+                <a:latin typeface="Calibri"/>
+              </a:rPr>
+              <a:t>broker ↔ broker 複製   不協商——由 finalized MV 決定</a:t>
             </a:r>
           </a:p>
         </p:txBody>
       </p:sp>
       <p:pic>
         <p:nvPicPr>
-          <p:cNvPr id="5" name="Picture 4" descr="s2a-rangeline.png"/>
+          <p:cNvPr id="5" name="Picture 4" descr="point.png"/>
           <p:cNvPicPr>
             <a:picLocks noChangeAspect="1"/>
           </p:cNvPicPr>
@@ -6421,8 +6790,8 @@
         </p:blipFill>
         <p:spPr>
           <a:xfrm>
-            <a:off x="1664208" y="1965960"/>
-            <a:ext cx="8869680" cy="4093698"/>
+            <a:off x="658368" y="3474720"/>
+            <a:ext cx="274320" cy="274320"/>
           </a:xfrm>
           <a:prstGeom prst="rect">
             <a:avLst/>
@@ -6432,6 +6801,113 @@
       <p:sp>
         <p:nvSpPr>
           <p:cNvPr id="6" name="TextBox 5"/>
+          <p:cNvSpPr txBox="1"/>
+          <p:nvPr/>
+        </p:nvSpPr>
+        <p:spPr>
+          <a:xfrm>
+            <a:off x="1078992" y="3447288"/>
+            <a:ext cx="10515600" cy="841248"/>
+          </a:xfrm>
+          <a:prstGeom prst="rect">
+            <a:avLst/>
+          </a:prstGeom>
+          <a:noFill/>
+        </p:spPr>
+        <p:txBody>
+          <a:bodyPr wrap="square">
+            <a:noAutofit/>
+          </a:bodyPr>
+          <a:lstStyle/>
+          <a:p>
+            <a:r>
+              <a:rPr sz="1650" b="0">
+                <a:solidFill>
+                  <a:srgbClr val="1E2024"/>
+                </a:solidFill>
+                <a:latin typeface="Calibri"/>
+              </a:rPr>
+              <a:t>決定權在「組出這支 request 的程式碼」宣告的允許版本範圍：留全範圍就走協商、被指成 MV 對應的單一版本就不協商</a:t>
+            </a:r>
+          </a:p>
+        </p:txBody>
+      </p:sp>
+      <p:sp>
+        <p:nvSpPr>
+          <p:cNvPr id="7" name="TextBox 6"/>
+          <p:cNvSpPr txBox="1"/>
+          <p:nvPr/>
+        </p:nvSpPr>
+        <p:spPr>
+          <a:xfrm>
+            <a:off x="640080" y="4434840"/>
+            <a:ext cx="10972800" cy="877824"/>
+          </a:xfrm>
+          <a:prstGeom prst="rect">
+            <a:avLst/>
+          </a:prstGeom>
+          <a:solidFill>
+            <a:srgbClr val="E9F3DE"/>
+          </a:solidFill>
+          <a:ln>
+            <a:noFill/>
+          </a:ln>
+        </p:spPr>
+        <p:txBody>
+          <a:bodyPr wrap="square" lIns="146304" tIns="82296">
+            <a:noAutofit/>
+          </a:bodyPr>
+          <a:lstStyle/>
+          <a:p>
+            <a:r>
+              <a:rPr sz="1500" b="0">
+                <a:solidFill>
+                  <a:srgbClr val="27500A"/>
+                </a:solidFill>
+                <a:latin typeface="Calibri"/>
+              </a:rPr>
+              <a:t>為什麼複製面例外？複製要求所有 follower↔leader 講同一版，才交給 finalized MV 集中決定；其餘連線點對點，各自挑最好版即可</a:t>
+            </a:r>
+          </a:p>
+        </p:txBody>
+      </p:sp>
+      <p:sp>
+        <p:nvSpPr>
+          <p:cNvPr id="8" name="TextBox 7"/>
+          <p:cNvSpPr txBox="1"/>
+          <p:nvPr/>
+        </p:nvSpPr>
+        <p:spPr>
+          <a:xfrm>
+            <a:off x="640080" y="5495544"/>
+            <a:ext cx="10972800" cy="438912"/>
+          </a:xfrm>
+          <a:prstGeom prst="rect">
+            <a:avLst/>
+          </a:prstGeom>
+          <a:noFill/>
+        </p:spPr>
+        <p:txBody>
+          <a:bodyPr wrap="square">
+            <a:noAutofit/>
+          </a:bodyPr>
+          <a:lstStyle/>
+          <a:p>
+            <a:r>
+              <a:rPr sz="1500" b="0">
+                <a:solidFill>
+                  <a:srgbClr val="5F5E5A"/>
+                </a:solidFill>
+                <a:latin typeface="Calibri"/>
+              </a:rPr>
+              <a:t>更細的差異（ListOffsets 以 MV 為上限等）見 blog 附錄，此處不展開。</a:t>
+            </a:r>
+          </a:p>
+        </p:txBody>
+      </p:sp>
+      <p:sp>
+        <p:nvSpPr>
+          <p:cNvPr id="9" name="TextBox 8"/>
           <p:cNvSpPr txBox="1"/>
           <p:nvPr/>
         </p:nvSpPr>
@@ -6468,7 +6944,7 @@
                 <a:latin typeface="Courier New"/>
                 <a:hlinkClick r:id="rId3"/>
               </a:rPr>
-              <a:t>forConsumer/forReplica</a:t>
+              <a:t>fetchRequestVersion</a:t>
             </a:r>
             <a:r>
               <a:rPr sz="1200" b="0">
@@ -6487,7 +6963,7 @@
                 <a:latin typeface="Courier New"/>
                 <a:hlinkClick r:id="rId4"/>
               </a:rPr>
-              <a:t>fetchRequestVersion</a:t>
+              <a:t>javadoc</a:t>
             </a:r>
             <a:r>
               <a:rPr sz="1200" b="0">
@@ -6506,7 +6982,7 @@
                 <a:latin typeface="Courier New"/>
                 <a:hlinkClick r:id="rId5"/>
               </a:rPr>
-              <a:t>validVersions</a:t>
+              <a:t>RemoteLeaderEndPoint.scala:215</a:t>
             </a:r>
           </a:p>
         </p:txBody>
@@ -6558,7 +7034,7 @@
                 </a:solidFill>
                 <a:latin typeface="Calibri"/>
               </a:rPr>
-              <a:t>隨堂考 · 核心</a:t>
+              <a:t>Part 1 · 舉例</a:t>
             </a:r>
           </a:p>
         </p:txBody>
@@ -6571,8 +7047,8 @@
         </p:nvSpPr>
         <p:spPr>
           <a:xfrm>
-            <a:off x="640080" y="841248"/>
-            <a:ext cx="10972800" cy="1188720"/>
+            <a:off x="640080" y="822960"/>
+            <a:ext cx="10972800" cy="640080"/>
           </a:xfrm>
           <a:prstGeom prst="rect">
             <a:avLst/>
@@ -6586,13 +7062,13 @@
           <a:lstStyle/>
           <a:p>
             <a:r>
-              <a:rPr sz="2600" b="1">
+              <a:rPr sz="2900" b="1">
                 <a:solidFill>
                   <a:srgbClr val="1E2024"/>
                 </a:solidFill>
                 <a:latin typeface="Calibri"/>
               </a:rPr>
-              <a:t>replica fetch（broker↔broker）的 Fetch 版本怎麼決定？</a:t>
+              <a:t>以一支 Fetch 為例：consumer 協商、replica 由 MV</a:t>
             </a:r>
           </a:p>
         </p:txBody>
@@ -6605,8 +7081,8 @@
         </p:nvSpPr>
         <p:spPr>
           <a:xfrm>
-            <a:off x="822960" y="2331720"/>
-            <a:ext cx="10515600" cy="493776"/>
+            <a:off x="640080" y="1481328"/>
+            <a:ext cx="10972800" cy="365760"/>
           </a:xfrm>
           <a:prstGeom prst="rect">
             <a:avLst/>
@@ -6620,36 +7096,51 @@
           <a:lstStyle/>
           <a:p>
             <a:r>
-              <a:rPr sz="1600" b="0">
-                <a:solidFill>
-                  <a:srgbClr val="1E2024"/>
-                </a:solidFill>
-                <a:latin typeface="Calibri"/>
-              </a:rPr>
-              <a:t>A.  </a:t>
-            </a:r>
-            <a:r>
-              <a:rPr sz="1600" b="0">
-                <a:solidFill>
-                  <a:srgbClr val="1E2024"/>
-                </a:solidFill>
-                <a:latin typeface="Calibri"/>
-              </a:rPr>
-              <a:t>兩 broker ApiVersions 協商取交集</a:t>
-            </a:r>
-          </a:p>
-        </p:txBody>
-      </p:sp>
-      <p:sp>
-        <p:nvSpPr>
-          <p:cNvPr id="5" name="TextBox 4"/>
-          <p:cNvSpPr txBox="1"/>
-          <p:nvPr/>
-        </p:nvSpPr>
-        <p:spPr>
-          <a:xfrm>
-            <a:off x="822960" y="2953512"/>
-            <a:ext cx="10515600" cy="493776"/>
+              <a:rPr sz="1400" b="0">
+                <a:solidFill>
+                  <a:srgbClr val="5F5E5A"/>
+                </a:solidFill>
+                <a:latin typeface="Calibri"/>
+              </a:rPr>
+              <a:t>同一支 Fetch 兩種身分：consumer fetch 走 client↔broker、replica fetch 走 broker↔broker</a:t>
+            </a:r>
+          </a:p>
+        </p:txBody>
+      </p:sp>
+      <p:pic>
+        <p:nvPicPr>
+          <p:cNvPr id="5" name="Picture 4" descr="s2a-rangeline.png"/>
+          <p:cNvPicPr>
+            <a:picLocks noChangeAspect="1"/>
+          </p:cNvPicPr>
+          <p:nvPr/>
+        </p:nvPicPr>
+        <p:blipFill>
+          <a:blip r:embed="rId2"/>
+          <a:stretch>
+            <a:fillRect/>
+          </a:stretch>
+        </p:blipFill>
+        <p:spPr>
+          <a:xfrm>
+            <a:off x="1664208" y="1965960"/>
+            <a:ext cx="8869680" cy="4093698"/>
+          </a:xfrm>
+          <a:prstGeom prst="rect">
+            <a:avLst/>
+          </a:prstGeom>
+        </p:spPr>
+      </p:pic>
+      <p:sp>
+        <p:nvSpPr>
+          <p:cNvPr id="6" name="TextBox 5"/>
+          <p:cNvSpPr txBox="1"/>
+          <p:nvPr/>
+        </p:nvSpPr>
+        <p:spPr>
+          <a:xfrm>
+            <a:off x="640080" y="6400800"/>
+            <a:ext cx="10972800" cy="384048"/>
           </a:xfrm>
           <a:prstGeom prst="rect">
             <a:avLst/>
@@ -6663,142 +7154,61 @@
           <a:lstStyle/>
           <a:p>
             <a:r>
-              <a:rPr sz="1600" b="0">
-                <a:solidFill>
-                  <a:srgbClr val="1E2024"/>
-                </a:solidFill>
-                <a:latin typeface="Calibri"/>
-              </a:rPr>
-              <a:t>B.  </a:t>
-            </a:r>
-            <a:r>
-              <a:rPr sz="1600" b="0">
-                <a:solidFill>
-                  <a:srgbClr val="1E2024"/>
-                </a:solidFill>
-                <a:latin typeface="Calibri"/>
-              </a:rPr>
-              <a:t>由 finalized metadata.version 決定</a:t>
-            </a:r>
-          </a:p>
-        </p:txBody>
-      </p:sp>
-      <p:sp>
-        <p:nvSpPr>
-          <p:cNvPr id="6" name="TextBox 5"/>
-          <p:cNvSpPr txBox="1"/>
-          <p:nvPr/>
-        </p:nvSpPr>
-        <p:spPr>
-          <a:xfrm>
-            <a:off x="822960" y="3575304"/>
-            <a:ext cx="10515600" cy="493776"/>
-          </a:xfrm>
-          <a:prstGeom prst="rect">
-            <a:avLst/>
-          </a:prstGeom>
-          <a:noFill/>
-        </p:spPr>
-        <p:txBody>
-          <a:bodyPr wrap="square">
-            <a:noAutofit/>
-          </a:bodyPr>
-          <a:lstStyle/>
-          <a:p>
-            <a:r>
-              <a:rPr sz="1600" b="0">
-                <a:solidFill>
-                  <a:srgbClr val="1E2024"/>
-                </a:solidFill>
-                <a:latin typeface="Calibri"/>
-              </a:rPr>
-              <a:t>C.  </a:t>
-            </a:r>
-            <a:r>
-              <a:rPr sz="1600" b="0">
-                <a:solidFill>
-                  <a:srgbClr val="1E2024"/>
-                </a:solidFill>
-                <a:latin typeface="Calibri"/>
-              </a:rPr>
-              <a:t>永遠用最新版</a:t>
-            </a:r>
-          </a:p>
-        </p:txBody>
-      </p:sp>
-      <p:sp>
-        <p:nvSpPr>
-          <p:cNvPr id="7" name="TextBox 6"/>
-          <p:cNvSpPr txBox="1"/>
-          <p:nvPr/>
-        </p:nvSpPr>
-        <p:spPr>
-          <a:xfrm>
-            <a:off x="822960" y="4197096"/>
-            <a:ext cx="10515600" cy="493776"/>
-          </a:xfrm>
-          <a:prstGeom prst="rect">
-            <a:avLst/>
-          </a:prstGeom>
-          <a:noFill/>
-        </p:spPr>
-        <p:txBody>
-          <a:bodyPr wrap="square">
-            <a:noAutofit/>
-          </a:bodyPr>
-          <a:lstStyle/>
-          <a:p>
-            <a:r>
-              <a:rPr sz="1600" b="0">
-                <a:solidFill>
-                  <a:srgbClr val="1E2024"/>
-                </a:solidFill>
-                <a:latin typeface="Calibri"/>
-              </a:rPr>
-              <a:t>D.  </a:t>
-            </a:r>
-            <a:r>
-              <a:rPr sz="1600" b="0">
-                <a:solidFill>
-                  <a:srgbClr val="1E2024"/>
-                </a:solidFill>
-                <a:latin typeface="Calibri"/>
-              </a:rPr>
-              <a:t>controller 每次指定</a:t>
-            </a:r>
-          </a:p>
-        </p:txBody>
-      </p:sp>
-      <p:sp>
-        <p:nvSpPr>
-          <p:cNvPr id="8" name="TextBox 7"/>
-          <p:cNvSpPr txBox="1"/>
-          <p:nvPr/>
-        </p:nvSpPr>
-        <p:spPr>
-          <a:xfrm>
-            <a:off x="640080" y="4910327"/>
-            <a:ext cx="10972800" cy="914400"/>
-          </a:xfrm>
-          <a:prstGeom prst="rect">
-            <a:avLst/>
-          </a:prstGeom>
-          <a:noFill/>
-        </p:spPr>
-        <p:txBody>
-          <a:bodyPr wrap="square">
-            <a:noAutofit/>
-          </a:bodyPr>
-          <a:lstStyle/>
-          <a:p>
-            <a:r>
-              <a:rPr sz="1400" b="0">
+              <a:rPr sz="1200" b="1">
                 <a:solidFill>
                   <a:srgbClr val="8A8A8A"/>
                 </a:solidFill>
                 <a:latin typeface="Calibri"/>
               </a:rPr>
-              <a:t>想一想 —— 下一頁公布答案</a:t>
+              <a:t>REF   </a:t>
+            </a:r>
+            <a:r>
+              <a:rPr sz="1200" b="0" u="sng">
+                <a:solidFill>
+                  <a:srgbClr val="185FA5"/>
+                </a:solidFill>
+                <a:latin typeface="Courier New"/>
+                <a:hlinkClick r:id="rId3"/>
+              </a:rPr>
+              <a:t>forConsumer/forReplica</a:t>
+            </a:r>
+            <a:r>
+              <a:rPr sz="1200" b="0">
+                <a:solidFill>
+                  <a:srgbClr val="8A8A8A"/>
+                </a:solidFill>
+                <a:latin typeface="Calibri"/>
+              </a:rPr>
+              <a:t>   ·   </a:t>
+            </a:r>
+            <a:r>
+              <a:rPr sz="1200" b="0" u="sng">
+                <a:solidFill>
+                  <a:srgbClr val="185FA5"/>
+                </a:solidFill>
+                <a:latin typeface="Courier New"/>
+                <a:hlinkClick r:id="rId4"/>
+              </a:rPr>
+              <a:t>fetchRequestVersion</a:t>
+            </a:r>
+            <a:r>
+              <a:rPr sz="1200" b="0">
+                <a:solidFill>
+                  <a:srgbClr val="8A8A8A"/>
+                </a:solidFill>
+                <a:latin typeface="Calibri"/>
+              </a:rPr>
+              <a:t>   ·   </a:t>
+            </a:r>
+            <a:r>
+              <a:rPr sz="1200" b="0" u="sng">
+                <a:solidFill>
+                  <a:srgbClr val="185FA5"/>
+                </a:solidFill>
+                <a:latin typeface="Courier New"/>
+                <a:hlinkClick r:id="rId5"/>
+              </a:rPr>
+              <a:t>validVersions</a:t>
             </a:r>
           </a:p>
         </p:txBody>
@@ -6850,7 +7260,7 @@
                 </a:solidFill>
                 <a:latin typeface="Calibri"/>
               </a:rPr>
-              <a:t>隨堂考 · 核心　（正解）</a:t>
+              <a:t>隨堂考 · 核心</a:t>
             </a:r>
           </a:p>
         </p:txBody>
@@ -6946,36 +7356,31 @@
           <a:prstGeom prst="rect">
             <a:avLst/>
           </a:prstGeom>
-          <a:solidFill>
-            <a:srgbClr val="E9F3DE"/>
-          </a:solidFill>
-          <a:ln>
-            <a:noFill/>
-          </a:ln>
-        </p:spPr>
-        <p:txBody>
-          <a:bodyPr wrap="square" lIns="128016" tIns="54864">
-            <a:noAutofit/>
-          </a:bodyPr>
-          <a:lstStyle/>
-          <a:p>
-            <a:r>
-              <a:rPr sz="1600" b="1">
-                <a:solidFill>
-                  <a:srgbClr val="27500A"/>
+          <a:noFill/>
+        </p:spPr>
+        <p:txBody>
+          <a:bodyPr wrap="square">
+            <a:noAutofit/>
+          </a:bodyPr>
+          <a:lstStyle/>
+          <a:p>
+            <a:r>
+              <a:rPr sz="1600" b="0">
+                <a:solidFill>
+                  <a:srgbClr val="1E2024"/>
                 </a:solidFill>
                 <a:latin typeface="Calibri"/>
               </a:rPr>
               <a:t>B.  </a:t>
             </a:r>
             <a:r>
-              <a:rPr sz="1600" b="1">
-                <a:solidFill>
-                  <a:srgbClr val="27500A"/>
-                </a:solidFill>
-                <a:latin typeface="Calibri"/>
-              </a:rPr>
-              <a:t>由 finalized metadata.version 決定   ✓</a:t>
+              <a:rPr sz="1600" b="0">
+                <a:solidFill>
+                  <a:srgbClr val="1E2024"/>
+                </a:solidFill>
+                <a:latin typeface="Calibri"/>
+              </a:rPr>
+              <a:t>由 finalized metadata.version 決定</a:t>
             </a:r>
           </a:p>
         </p:txBody>
@@ -7089,85 +7494,13 @@
           <a:lstStyle/>
           <a:p>
             <a:r>
-              <a:rPr sz="1400" b="1">
-                <a:solidFill>
-                  <a:srgbClr val="27500A"/>
-                </a:solidFill>
-                <a:latin typeface="Calibri"/>
-              </a:rPr>
-              <a:t>正解 B — </a:t>
-            </a:r>
-            <a:r>
               <a:rPr sz="1400" b="0">
                 <a:solidFill>
-                  <a:srgbClr val="1E2024"/>
-                </a:solidFill>
-                <a:latin typeface="Calibri"/>
-              </a:rPr>
-              <a:t>fetchRequestVersion(MV)：MV 是集中共識，不做 per-connection 協商。</a:t>
-            </a:r>
-          </a:p>
-        </p:txBody>
-      </p:sp>
-      <p:sp>
-        <p:nvSpPr>
-          <p:cNvPr id="9" name="TextBox 8"/>
-          <p:cNvSpPr txBox="1"/>
-          <p:nvPr/>
-        </p:nvSpPr>
-        <p:spPr>
-          <a:xfrm>
-            <a:off x="640080" y="6400800"/>
-            <a:ext cx="10972800" cy="384048"/>
-          </a:xfrm>
-          <a:prstGeom prst="rect">
-            <a:avLst/>
-          </a:prstGeom>
-          <a:noFill/>
-        </p:spPr>
-        <p:txBody>
-          <a:bodyPr wrap="square">
-            <a:noAutofit/>
-          </a:bodyPr>
-          <a:lstStyle/>
-          <a:p>
-            <a:r>
-              <a:rPr sz="1200" b="1">
-                <a:solidFill>
                   <a:srgbClr val="8A8A8A"/>
                 </a:solidFill>
                 <a:latin typeface="Calibri"/>
               </a:rPr>
-              <a:t>REF   </a:t>
-            </a:r>
-            <a:r>
-              <a:rPr sz="1200" b="0" u="sng">
-                <a:solidFill>
-                  <a:srgbClr val="185FA5"/>
-                </a:solidFill>
-                <a:latin typeface="Courier New"/>
-                <a:hlinkClick r:id="rId2"/>
-              </a:rPr>
-              <a:t>RemoteLeaderEndPoint.scala:215</a:t>
-            </a:r>
-            <a:r>
-              <a:rPr sz="1200" b="0">
-                <a:solidFill>
-                  <a:srgbClr val="8A8A8A"/>
-                </a:solidFill>
-                <a:latin typeface="Calibri"/>
-              </a:rPr>
-              <a:t>   ·   </a:t>
-            </a:r>
-            <a:r>
-              <a:rPr sz="1200" b="0" u="sng">
-                <a:solidFill>
-                  <a:srgbClr val="185FA5"/>
-                </a:solidFill>
-                <a:latin typeface="Courier New"/>
-                <a:hlinkClick r:id="rId3"/>
-              </a:rPr>
-              <a:t>MetadataVersion.java:273</a:t>
+              <a:t>想一想 —— 下一頁公布答案</a:t>
             </a:r>
           </a:p>
         </p:txBody>

</xml_diff>

<commit_message>
study(version-control): deck 收尾兩條 review [低] 項
- 動機張：bullet 縮短，九年/KIP-896 細節降為 note
- 截斷張：開頭加焊接句「前一頁交集空最容易被忽略的根因」
</commit_message>
<xml_diff>
--- a/study/version-control/kafka-version-negotiation.pptx
+++ b/study/version-control/kafka-version-negotiation.pptx
@@ -4025,15 +4025,73 @@
           </a:p>
         </p:txBody>
       </p:sp>
-      <p:sp>
-        <p:nvSpPr>
-          <p:cNvPr id="4" name="TextBox 3"/>
-          <p:cNvSpPr txBox="1"/>
-          <p:nvPr/>
-        </p:nvSpPr>
-        <p:spPr>
-          <a:xfrm>
-            <a:off x="640080" y="2148840"/>
+      <p:pic>
+        <p:nvPicPr>
+          <p:cNvPr id="4" name="Picture 3" descr="alert-triangle.png"/>
+          <p:cNvPicPr>
+            <a:picLocks noChangeAspect="1"/>
+          </p:cNvPicPr>
+          <p:nvPr/>
+        </p:nvPicPr>
+        <p:blipFill>
+          <a:blip r:embed="rId2"/>
+          <a:stretch>
+            <a:fillRect/>
+          </a:stretch>
+        </p:blipFill>
+        <p:spPr>
+          <a:xfrm>
+            <a:off x="658368" y="2176272"/>
+            <a:ext cx="274320" cy="274320"/>
+          </a:xfrm>
+          <a:prstGeom prst="rect">
+            <a:avLst/>
+          </a:prstGeom>
+        </p:spPr>
+      </p:pic>
+      <p:sp>
+        <p:nvSpPr>
+          <p:cNvPr id="5" name="TextBox 4"/>
+          <p:cNvSpPr txBox="1"/>
+          <p:nvPr/>
+        </p:nvSpPr>
+        <p:spPr>
+          <a:xfrm>
+            <a:off x="1078992" y="2148840"/>
+            <a:ext cx="10515600" cy="493776"/>
+          </a:xfrm>
+          <a:prstGeom prst="rect">
+            <a:avLst/>
+          </a:prstGeom>
+          <a:noFill/>
+        </p:spPr>
+        <p:txBody>
+          <a:bodyPr wrap="square">
+            <a:noAutofit/>
+          </a:bodyPr>
+          <a:lstStyle/>
+          <a:p>
+            <a:r>
+              <a:rPr sz="1650" b="0">
+                <a:solidFill>
+                  <a:srgbClr val="1E2024"/>
+                </a:solidFill>
+                <a:latin typeface="Calibri"/>
+              </a:rPr>
+              <a:t>前一頁「交集空」最容易被忽略的根因——舊 wire 版本被整批移除</a:t>
+            </a:r>
+          </a:p>
+        </p:txBody>
+      </p:sp>
+      <p:sp>
+        <p:nvSpPr>
+          <p:cNvPr id="6" name="TextBox 5"/>
+          <p:cNvSpPr txBox="1"/>
+          <p:nvPr/>
+        </p:nvSpPr>
+        <p:spPr>
+          <a:xfrm>
+            <a:off x="640080" y="2788920"/>
             <a:ext cx="10972800" cy="822959"/>
           </a:xfrm>
           <a:prstGeom prst="rect">
@@ -4079,13 +4137,13 @@
       </p:sp>
       <p:sp>
         <p:nvSpPr>
-          <p:cNvPr id="5" name="TextBox 4"/>
-          <p:cNvSpPr txBox="1"/>
-          <p:nvPr/>
-        </p:nvSpPr>
-        <p:spPr>
-          <a:xfrm>
-            <a:off x="640080" y="3172968"/>
+          <p:cNvPr id="7" name="TextBox 6"/>
+          <p:cNvSpPr txBox="1"/>
+          <p:nvPr/>
+        </p:nvSpPr>
+        <p:spPr>
+          <a:xfrm>
+            <a:off x="640080" y="3813048"/>
             <a:ext cx="10972800" cy="566928"/>
           </a:xfrm>
           <a:prstGeom prst="rect">
@@ -4118,13 +4176,13 @@
       </p:sp>
       <p:sp>
         <p:nvSpPr>
-          <p:cNvPr id="6" name="TextBox 5"/>
-          <p:cNvSpPr txBox="1"/>
-          <p:nvPr/>
-        </p:nvSpPr>
-        <p:spPr>
-          <a:xfrm>
-            <a:off x="640080" y="3922776"/>
+          <p:cNvPr id="8" name="TextBox 7"/>
+          <p:cNvSpPr txBox="1"/>
+          <p:nvPr/>
+        </p:nvSpPr>
+        <p:spPr>
+          <a:xfrm>
+            <a:off x="640080" y="4562856"/>
             <a:ext cx="10972800" cy="731520"/>
           </a:xfrm>
           <a:prstGeom prst="rect">
@@ -4152,7 +4210,7 @@
       </p:sp>
       <p:sp>
         <p:nvSpPr>
-          <p:cNvPr id="7" name="TextBox 6"/>
+          <p:cNvPr id="9" name="TextBox 8"/>
           <p:cNvSpPr txBox="1"/>
           <p:nvPr/>
         </p:nvSpPr>
@@ -4187,7 +4245,7 @@
                   <a:srgbClr val="185FA5"/>
                 </a:solidFill>
                 <a:latin typeface="Courier New"/>
-                <a:hlinkClick r:id="rId2"/>
+                <a:hlinkClick r:id="rId3"/>
               </a:rPr>
               <a:t>upgrade.md:229</a:t>
             </a:r>
@@ -4206,7 +4264,7 @@
                   <a:srgbClr val="185FA5"/>
                 </a:solidFill>
                 <a:latin typeface="Courier New"/>
-                <a:hlinkClick r:id="rId3"/>
+                <a:hlinkClick r:id="rId4"/>
               </a:rPr>
               <a:t>FetchRequest.json validVersions</a:t>
             </a:r>
@@ -5770,7 +5828,7 @@
         <p:spPr>
           <a:xfrm>
             <a:off x="1078992" y="2148840"/>
-            <a:ext cx="10515600" cy="841248"/>
+            <a:ext cx="10515600" cy="493776"/>
           </a:xfrm>
           <a:prstGeom prst="rect">
             <a:avLst/>
@@ -5790,7 +5848,7 @@
                 </a:solidFill>
                 <a:latin typeface="Calibri"/>
               </a:rPr>
-              <a:t>client 內嵌在各 app、長期不更新（Kafka 曾為舊 client 保留每個 protocol 版本近九年，4.0／KIP-896 才把下限提到 2.1）</a:t>
+              <a:t>client 內嵌在各 app、長期不更新</a:t>
             </a:r>
           </a:p>
         </p:txBody>
@@ -5811,7 +5869,7 @@
         </p:blipFill>
         <p:spPr>
           <a:xfrm>
-            <a:off x="658368" y="3163824"/>
+            <a:off x="658368" y="2816352"/>
             <a:ext cx="274320" cy="274320"/>
           </a:xfrm>
           <a:prstGeom prst="rect">
@@ -5827,7 +5885,7 @@
         </p:nvSpPr>
         <p:spPr>
           <a:xfrm>
-            <a:off x="1078992" y="3136392"/>
+            <a:off x="1078992" y="2788920"/>
             <a:ext cx="10515600" cy="493776"/>
           </a:xfrm>
           <a:prstGeom prst="rect">
@@ -5861,7 +5919,41 @@
         </p:nvSpPr>
         <p:spPr>
           <a:xfrm>
-            <a:off x="640080" y="3776472"/>
+            <a:off x="640080" y="3429000"/>
+            <a:ext cx="10972800" cy="731520"/>
+          </a:xfrm>
+          <a:prstGeom prst="rect">
+            <a:avLst/>
+          </a:prstGeom>
+          <a:noFill/>
+        </p:spPr>
+        <p:txBody>
+          <a:bodyPr wrap="square">
+            <a:noAutofit/>
+          </a:bodyPr>
+          <a:lstStyle/>
+          <a:p>
+            <a:r>
+              <a:rPr sz="1500" b="0">
+                <a:solidFill>
+                  <a:srgbClr val="5F5E5A"/>
+                </a:solidFill>
+                <a:latin typeface="Calibri"/>
+              </a:rPr>
+              <a:t>有多長壽？Kafka 曾為舊 client 保留每個 protocol 版本近九年，直到 4.0（KIP-896）才把下限提到 2.1。</a:t>
+            </a:r>
+          </a:p>
+        </p:txBody>
+      </p:sp>
+      <p:sp>
+        <p:nvSpPr>
+          <p:cNvPr id="9" name="TextBox 8"/>
+          <p:cNvSpPr txBox="1"/>
+          <p:nvPr/>
+        </p:nvSpPr>
+        <p:spPr>
+          <a:xfrm>
+            <a:off x="640080" y="4288536"/>
             <a:ext cx="10972800" cy="1097280"/>
           </a:xfrm>
           <a:prstGeom prst="rect">
@@ -5918,13 +6010,13 @@
       </p:sp>
       <p:sp>
         <p:nvSpPr>
-          <p:cNvPr id="9" name="TextBox 8"/>
-          <p:cNvSpPr txBox="1"/>
-          <p:nvPr/>
-        </p:nvSpPr>
-        <p:spPr>
-          <a:xfrm>
-            <a:off x="640080" y="5074920"/>
+          <p:cNvPr id="10" name="TextBox 9"/>
+          <p:cNvSpPr txBox="1"/>
+          <p:nvPr/>
+        </p:nvSpPr>
+        <p:spPr>
+          <a:xfrm>
+            <a:off x="640080" y="5586984"/>
             <a:ext cx="10972800" cy="566928"/>
           </a:xfrm>
           <a:prstGeom prst="rect">
@@ -5957,7 +6049,7 @@
       </p:sp>
       <p:sp>
         <p:nvSpPr>
-          <p:cNvPr id="10" name="TextBox 9"/>
+          <p:cNvPr id="11" name="TextBox 10"/>
           <p:cNvSpPr txBox="1"/>
           <p:nvPr/>
         </p:nvSpPr>

</xml_diff>

<commit_message>
study(version-control): 套用 Eric round-2 review（10 條）＋修正一個事實錯誤
- 重大更正：replication 路徑不送 ApiVersionsRequest（BrokerBlockingSender discoverBrokerVersions=false）；
  broker→controller/KRaft 為 true——原「三條線都先握手」陳述有誤，deck/outline/rpc doc 同步更正
- 術語精確化：不用「握手」（非 Kafka 用語）改「送 ApiVersionsRequest 查詢」；「能力世代」→ finalized feature level；
  「能力」→ supported versions；「複製」→ partition replication；「自刻」→ 繞過協商直接送出；「關線」→ 關閉連線
- 點題改「生產環境資料主幹道不能停機」；動機 client 例子具體化（IoT/車載/batch job）
- 截斷 2.1 標明雙向要求；隨堂考正解補「ApiVersions 為何是例外」的解釋
- review 記錄存 review-eric-round2.md
</commit_message>
<xml_diff>
--- a/study/version-control/kafka-version-negotiation.pptx
+++ b/study/version-control/kafka-version-negotiation.pptx
@@ -3772,7 +3772,7 @@
                 </a:solidFill>
                 <a:latin typeface="Calibri"/>
               </a:rPr>
-              <a:t>交集空        → client 端 UnsupportedVersionException（送出前 abort）</a:t>
+              <a:t>交集空              → client 端 UnsupportedVersionException（送出前 abort）</a:t>
             </a:r>
           </a:p>
           <a:p>
@@ -3783,7 +3783,7 @@
                 </a:solidFill>
                 <a:latin typeface="Calibri"/>
               </a:rPr>
-              <a:t>繞過協商自刻  → broker 丟 UnsupportedVersionException + 關線</a:t>
+              <a:t>直送不支援的版本    → broker 丟 UnsupportedVersionException、關閉連線</a:t>
             </a:r>
           </a:p>
           <a:p>
@@ -4144,7 +4144,7 @@
         <p:spPr>
           <a:xfrm>
             <a:off x="640080" y="3813048"/>
-            <a:ext cx="10972800" cy="566928"/>
+            <a:ext cx="10972800" cy="877824"/>
           </a:xfrm>
           <a:prstGeom prst="rect">
             <a:avLst/>
@@ -4169,7 +4169,7 @@
                 </a:solidFill>
                 <a:latin typeface="Calibri"/>
               </a:rPr>
-              <a:t>解法：升級前確認兩端都跨過版本下限（升 4.0 需至少 2.1），否則協商結果沒有可用版本</a:t>
+              <a:t>解法：升任一端到 4.0 前，先確認另一端 ≥ 2.1（upgrade guide 明訂雙向要求），否則協商結果沒有可用版本</a:t>
             </a:r>
           </a:p>
         </p:txBody>
@@ -4182,7 +4182,7 @@
         </p:nvSpPr>
         <p:spPr>
           <a:xfrm>
-            <a:off x="640080" y="4562856"/>
+            <a:off x="640080" y="4873752"/>
             <a:ext cx="10972800" cy="731520"/>
           </a:xfrm>
           <a:prstGeom prst="rect">
@@ -4352,7 +4352,7 @@
                 </a:solidFill>
                 <a:latin typeface="Calibri"/>
               </a:rPr>
-              <a:t>自刻 client 送了不支援的 API version，會怎樣？</a:t>
+              <a:t>client 繞過協商、直接送出 broker 不支援的 API version，會怎樣？</a:t>
             </a:r>
           </a:p>
         </p:txBody>
@@ -4395,7 +4395,7 @@
                 </a:solidFill>
                 <a:latin typeface="Calibri"/>
               </a:rPr>
-              <a:t>一律回 UNSUPPORTED_VERSION</a:t>
+              <a:t>一律回 UNSUPPORTED_VERSION 錯誤碼</a:t>
             </a:r>
           </a:p>
         </p:txBody>
@@ -4438,7 +4438,7 @@
                 </a:solidFill>
                 <a:latin typeface="Calibri"/>
               </a:rPr>
-              <a:t>只有 ApiVersions 例外回錯誤+範圍；其他 API 關線</a:t>
+              <a:t>只有 ApiVersions 例外回錯誤碼+支援範圍；其他 API 直接關閉連線</a:t>
             </a:r>
           </a:p>
         </p:txBody>
@@ -4481,7 +4481,7 @@
                 </a:solidFill>
                 <a:latin typeface="Calibri"/>
               </a:rPr>
-              <a:t>broker 自動降版</a:t>
+              <a:t>broker 自動降版處理</a:t>
             </a:r>
           </a:p>
         </p:txBody>
@@ -4524,7 +4524,7 @@
                 </a:solidFill>
                 <a:latin typeface="Calibri"/>
               </a:rPr>
-              <a:t>忽略版本照跑</a:t>
+              <a:t>忽略版本照常處理</a:t>
             </a:r>
           </a:p>
         </p:txBody>
@@ -4644,7 +4644,7 @@
                 </a:solidFill>
                 <a:latin typeface="Calibri"/>
               </a:rPr>
-              <a:t>自刻 client 送了不支援的 API version，會怎樣？</a:t>
+              <a:t>client 繞過協商、直接送出 broker 不支援的 API version，會怎樣？</a:t>
             </a:r>
           </a:p>
         </p:txBody>
@@ -4687,7 +4687,7 @@
                 </a:solidFill>
                 <a:latin typeface="Calibri"/>
               </a:rPr>
-              <a:t>一律回 UNSUPPORTED_VERSION</a:t>
+              <a:t>一律回 UNSUPPORTED_VERSION 錯誤碼</a:t>
             </a:r>
           </a:p>
         </p:txBody>
@@ -4735,7 +4735,7 @@
                 </a:solidFill>
                 <a:latin typeface="Calibri"/>
               </a:rPr>
-              <a:t>只有 ApiVersions 例外回錯誤+範圍；其他 API 關線   ✓</a:t>
+              <a:t>只有 ApiVersions 例外回錯誤碼+支援範圍；其他 API 直接關閉連線   ✓</a:t>
             </a:r>
           </a:p>
         </p:txBody>
@@ -4778,7 +4778,7 @@
                 </a:solidFill>
                 <a:latin typeface="Calibri"/>
               </a:rPr>
-              <a:t>broker 自動降版</a:t>
+              <a:t>broker 自動降版處理</a:t>
             </a:r>
           </a:p>
         </p:txBody>
@@ -4821,7 +4821,7 @@
                 </a:solidFill>
                 <a:latin typeface="Calibri"/>
               </a:rPr>
-              <a:t>忽略版本照跑</a:t>
+              <a:t>忽略版本照常處理</a:t>
             </a:r>
           </a:p>
         </p:txBody>
@@ -4864,7 +4864,7 @@
                 </a:solidFill>
                 <a:latin typeface="Calibri"/>
               </a:rPr>
-              <a:t>ApiVersions 是 bootstrap 逃生口；其他 API 在 RequestContext 解析失敗、broker 丟 UnsupportedVersionException，SocketServer 關閉連線。</a:t>
+              <a:t>ApiVersions 是協商的第一支 request（此時雙方還不知道彼此版本），若它也關線，client 永遠問不到支援範圍，故回 v0+錯誤碼讓 client 重新協商；其他 API 在 RequestContext 解析失敗、SocketServer 關閉連線。</a:t>
             </a:r>
           </a:p>
         </p:txBody>
@@ -5103,7 +5103,7 @@
         <p:spPr>
           <a:xfrm>
             <a:off x="1078992" y="3447288"/>
-            <a:ext cx="10515600" cy="841248"/>
+            <a:ext cx="10515600" cy="1188720"/>
           </a:xfrm>
           <a:prstGeom prst="rect">
             <a:avLst/>
@@ -5123,7 +5123,7 @@
                 </a:solidFill>
                 <a:latin typeface="Calibri"/>
               </a:rPr>
-              <a:t>Part 1：不能「一個版本打天下」（client 長壽、broker 滾動升級）；三條線多數靠協商，只有複製面由 finalized MV 決定</a:t>
+              <a:t>Part 1：不能「一個版本打天下」（client 長壽、broker 滾動升級）；三條線多數靠協商，只有 partition replication 由 finalized MV 決定</a:t>
             </a:r>
           </a:p>
         </p:txBody>
@@ -5144,7 +5144,7 @@
         </p:blipFill>
         <p:spPr>
           <a:xfrm>
-            <a:off x="658368" y="4462272"/>
+            <a:off x="658368" y="4809744"/>
             <a:ext cx="274320" cy="274320"/>
           </a:xfrm>
           <a:prstGeom prst="rect">
@@ -5160,7 +5160,7 @@
         </p:nvSpPr>
         <p:spPr>
           <a:xfrm>
-            <a:off x="1078992" y="4434840"/>
+            <a:off x="1078992" y="4782312"/>
             <a:ext cx="10515600" cy="841248"/>
           </a:xfrm>
           <a:prstGeom prst="rect">
@@ -5233,7 +5233,7 @@
                 </a:solidFill>
                 <a:latin typeface="Calibri"/>
               </a:rPr>
-              <a:t>本場大綱</a:t>
+              <a:t>議程</a:t>
             </a:r>
           </a:p>
         </p:txBody>
@@ -5267,7 +5267,7 @@
                 </a:solidFill>
                 <a:latin typeface="Calibri"/>
               </a:rPr>
-              <a:t>兩段，加 2 題隨堂考穿插</a:t>
+              <a:t>本場範圍</a:t>
             </a:r>
           </a:p>
         </p:txBody>
@@ -5325,7 +5325,7 @@
                 </a:solidFill>
                 <a:latin typeface="Calibri"/>
               </a:rPr>
-              <a:t>Part 1 — 版本為何要在連線當下協商、又是怎麼選的</a:t>
+              <a:t>Part 1 — 版本為何要在連線當下決定、又是怎麼選的</a:t>
             </a:r>
           </a:p>
         </p:txBody>
@@ -5417,7 +5417,7 @@
                 </a:solidFill>
                 <a:latin typeface="Calibri"/>
               </a:rPr>
-              <a:t>結尾會用一頁 Recap 把兩段串回開場那個問題。</a:t>
+              <a:t>兩題隨堂考穿插於對應段落；結尾以 Recap 回收開場的問題。</a:t>
             </a:r>
           </a:p>
         </p:txBody>
@@ -5640,7 +5640,7 @@
         <p:spPr>
           <a:xfrm>
             <a:off x="1078992" y="3538728"/>
-            <a:ext cx="10515600" cy="493776"/>
+            <a:ext cx="10515600" cy="841248"/>
           </a:xfrm>
           <a:prstGeom prst="rect">
             <a:avLst/>
@@ -5660,7 +5660,7 @@
                 </a:solidFill>
                 <a:latin typeface="Calibri"/>
               </a:rPr>
-              <a:t>但只要叢集達到一定規模，這個假設就不再成立</a:t>
+              <a:t>但生產環境的 Kafka 通常是資料主幹道——訂單事件、log、metrics pipeline 都在上面，停機升級＝整條資料鏈路停擺，這個假設不成立</a:t>
             </a:r>
           </a:p>
         </p:txBody>
@@ -5828,7 +5828,7 @@
         <p:spPr>
           <a:xfrm>
             <a:off x="1078992" y="2148840"/>
-            <a:ext cx="10515600" cy="493776"/>
+            <a:ext cx="10515600" cy="841248"/>
           </a:xfrm>
           <a:prstGeom prst="rect">
             <a:avLst/>
@@ -5848,7 +5848,7 @@
                 </a:solidFill>
                 <a:latin typeface="Calibri"/>
               </a:rPr>
-              <a:t>client 內嵌在各 app、長期不更新</a:t>
+              <a:t>client 是內嵌在應用程式裡的函式庫：IoT 裝置、車載系統、多年前的 batch job——隨應用長期運行、難以更新</a:t>
             </a:r>
           </a:p>
         </p:txBody>
@@ -5869,7 +5869,7 @@
         </p:blipFill>
         <p:spPr>
           <a:xfrm>
-            <a:off x="658368" y="2816352"/>
+            <a:off x="658368" y="3163824"/>
             <a:ext cx="274320" cy="274320"/>
           </a:xfrm>
           <a:prstGeom prst="rect">
@@ -5885,7 +5885,7 @@
         </p:nvSpPr>
         <p:spPr>
           <a:xfrm>
-            <a:off x="1078992" y="2788920"/>
+            <a:off x="1078992" y="3136392"/>
             <a:ext cx="10515600" cy="493776"/>
           </a:xfrm>
           <a:prstGeom prst="rect">
@@ -5919,7 +5919,7 @@
         </p:nvSpPr>
         <p:spPr>
           <a:xfrm>
-            <a:off x="640080" y="3429000"/>
+            <a:off x="640080" y="3776472"/>
             <a:ext cx="10972800" cy="731520"/>
           </a:xfrm>
           <a:prstGeom prst="rect">
@@ -5953,7 +5953,7 @@
         </p:nvSpPr>
         <p:spPr>
           <a:xfrm>
-            <a:off x="640080" y="4288536"/>
+            <a:off x="640080" y="4636008"/>
             <a:ext cx="10972800" cy="1097280"/>
           </a:xfrm>
           <a:prstGeom prst="rect">
@@ -5981,7 +5981,7 @@
                 </a:solidFill>
                 <a:latin typeface="Calibri"/>
               </a:rPr>
-              <a:t>任一時刻：不同節點能力／版本不同</a:t>
+              <a:t>任一時刻：各節點支援的版本範圍（supported versions）不同</a:t>
             </a:r>
           </a:p>
           <a:p>
@@ -6003,7 +6003,7 @@
                 </a:solidFill>
                 <a:latin typeface="Calibri"/>
               </a:rPr>
-              <a:t>        → 只能在「連線當下」協商</a:t>
+              <a:t>        → 只能在「連線當下」決定</a:t>
             </a:r>
           </a:p>
         </p:txBody>
@@ -6016,7 +6016,7 @@
         </p:nvSpPr>
         <p:spPr>
           <a:xfrm>
-            <a:off x="640080" y="5586984"/>
+            <a:off x="640080" y="5934456"/>
             <a:ext cx="10972800" cy="566928"/>
           </a:xfrm>
           <a:prstGeom prst="rect">
@@ -6205,7 +6205,7 @@
         <p:spPr>
           <a:xfrm>
             <a:off x="640080" y="2148840"/>
-            <a:ext cx="10972800" cy="1097280"/>
+            <a:ext cx="10972800" cy="1645920"/>
           </a:xfrm>
           <a:prstGeom prst="rect">
             <a:avLst/>
@@ -6232,7 +6232,7 @@
                 </a:solidFill>
                 <a:latin typeface="Calibri"/>
               </a:rPr>
-              <a:t>release version   = 我裝了哪版 binary   (per-node)</a:t>
+              <a:t>release version   = 我裝了哪版 binary            (per-node)</a:t>
             </a:r>
           </a:p>
           <a:p>
@@ -6243,7 +6243,7 @@
                 </a:solidFill>
                 <a:latin typeface="Calibri"/>
               </a:rPr>
-              <a:t>metadata.version  = 叢集一致的能力世代   (cluster-wide, finalized)</a:t>
+              <a:t>metadata.version  = 叢集 finalized 的 feature level (cluster-wide)</a:t>
             </a:r>
           </a:p>
           <a:p>
@@ -6254,7 +6254,7 @@
                 </a:solidFill>
                 <a:latin typeface="Calibri"/>
               </a:rPr>
-              <a:t>wire API version  = 這條連線講第幾版     (per-connection)</a:t>
+              <a:t>wire API version  = 這條連線講第幾版               (per-connection)</a:t>
             </a:r>
           </a:p>
         </p:txBody>
@@ -6275,7 +6275,7 @@
         </p:blipFill>
         <p:spPr>
           <a:xfrm>
-            <a:off x="658368" y="3474720"/>
+            <a:off x="658368" y="4023360"/>
             <a:ext cx="274320" cy="274320"/>
           </a:xfrm>
           <a:prstGeom prst="rect">
@@ -6291,7 +6291,7 @@
         </p:nvSpPr>
         <p:spPr>
           <a:xfrm>
-            <a:off x="1078992" y="3447288"/>
+            <a:off x="1078992" y="3995928"/>
             <a:ext cx="10515600" cy="493776"/>
           </a:xfrm>
           <a:prstGeom prst="rect">
@@ -6325,7 +6325,7 @@
         </p:nvSpPr>
         <p:spPr>
           <a:xfrm>
-            <a:off x="640080" y="4087368"/>
+            <a:off x="640080" y="4636008"/>
             <a:ext cx="10972800" cy="731520"/>
           </a:xfrm>
           <a:prstGeom prst="rect">
@@ -6346,7 +6346,7 @@
                 </a:solidFill>
                 <a:latin typeface="Calibri"/>
               </a:rPr>
-              <a:t>finalize＝管理員手動宣告「全叢集從此認定這個能力世代」；怎麼宣告是第一場《版本定義》的主題，本場只需知道它是叢集共識的一個值。本場主角是 wire 版本。</a:t>
+              <a:t>finalize＝管理員手動宣告全叢集一致採用的 feature level；怎麼宣告是第一場《版本定義》的主題。本場主角是 wire 版本。</a:t>
             </a:r>
           </a:p>
         </p:txBody>
@@ -6494,7 +6494,7 @@
                 </a:solidFill>
                 <a:latin typeface="Calibri"/>
               </a:rPr>
-              <a:t>三種連線，都先做 ApiVersions 握手</a:t>
+              <a:t>三種連線；要協商，先送 ApiVersionsRequest</a:t>
             </a:r>
           </a:p>
         </p:txBody>
@@ -6552,7 +6552,7 @@
                 </a:solidFill>
                 <a:latin typeface="Calibri"/>
               </a:rPr>
-              <a:t>連線建立後，發起端先送一支 ApiVersions：問對方「你每支 API 支援哪個版本區間？」（KIP-35）</a:t>
+              <a:t>連線建立後，發起端先送一支 ApiVersionsRequest，查詢對方「每支 API 支援哪個版本區間？」（KIP-35）</a:t>
             </a:r>
           </a:p>
         </p:txBody>
@@ -6566,7 +6566,7 @@
         <p:spPr>
           <a:xfrm>
             <a:off x="640080" y="3136392"/>
-            <a:ext cx="10972800" cy="1097280"/>
+            <a:ext cx="10972800" cy="1371600"/>
           </a:xfrm>
           <a:prstGeom prst="rect">
             <a:avLst/>
@@ -6593,7 +6593,7 @@
                 </a:solidFill>
                 <a:latin typeface="Calibri"/>
               </a:rPr>
-              <a:t>client ─▶ broker        讀寫資料、查 metadata…</a:t>
+              <a:t>client ─▶ broker        讀寫資料、查 metadata…      連線後先查詢</a:t>
             </a:r>
           </a:p>
           <a:p>
@@ -6604,7 +6604,7 @@
                 </a:solidFill>
                 <a:latin typeface="Calibri"/>
               </a:rPr>
-              <a:t>broker ─▶ controller    註冊、心跳、轉發 admin…</a:t>
+              <a:t>broker ─▶ controller    註冊、心跳、轉發 admin…      連線後先查詢</a:t>
             </a:r>
           </a:p>
           <a:p>
@@ -6615,7 +6615,7 @@
                 </a:solidFill>
                 <a:latin typeface="Calibri"/>
               </a:rPr>
-              <a:t>broker ◀▶ broker        複製（follower 抓 leader）</a:t>
+              <a:t>broker ◀▶ broker        partition replication        不查詢（下一張）</a:t>
             </a:r>
           </a:p>
         </p:txBody>
@@ -6628,7 +6628,7 @@
         </p:nvSpPr>
         <p:spPr>
           <a:xfrm>
-            <a:off x="640080" y="4434840"/>
+            <a:off x="640080" y="4709160"/>
             <a:ext cx="10972800" cy="438912"/>
           </a:xfrm>
           <a:prstGeom prst="rect">
@@ -6649,7 +6649,7 @@
                 </a:solidFill>
                 <a:latin typeface="Calibri"/>
               </a:rPr>
-              <a:t>每列只列代表性的幾種、非窮舉；重點是三條線都先做這個握手。</a:t>
+              <a:t>每列的 RPC 只列代表性的幾種、非窮舉。</a:t>
             </a:r>
           </a:p>
         </p:txBody>
@@ -6798,7 +6798,7 @@
                 </a:solidFill>
                 <a:latin typeface="Calibri"/>
               </a:rPr>
-              <a:t>握手之後，最終版本誰說了算？</a:t>
+              <a:t>查詢之後，最終版本誰說了算？</a:t>
             </a:r>
           </a:p>
         </p:txBody>
@@ -6839,7 +6839,7 @@
                 </a:solidFill>
                 <a:latin typeface="Calibri"/>
               </a:rPr>
-              <a:t>client ↔ broker       協商，取交集最高</a:t>
+              <a:t>client ↔ broker              協商，取交集最高</a:t>
             </a:r>
           </a:p>
           <a:p>
@@ -6850,7 +6850,7 @@
                 </a:solidFill>
                 <a:latin typeface="Calibri"/>
               </a:rPr>
-              <a:t>broker ↔ controller   也協商（broker 當 client）</a:t>
+              <a:t>broker ↔ controller          也協商（broker 當 client）</a:t>
             </a:r>
           </a:p>
           <a:p>
@@ -6861,14 +6861,14 @@
                 </a:solidFill>
                 <a:latin typeface="Calibri"/>
               </a:rPr>
-              <a:t>broker ↔ broker 複製   不協商——由 finalized MV 決定</a:t>
+              <a:t>broker ↔ broker replication  不協商——由 finalized MV 決定</a:t>
             </a:r>
           </a:p>
         </p:txBody>
       </p:sp>
       <p:pic>
         <p:nvPicPr>
-          <p:cNvPr id="5" name="Picture 4" descr="point.png"/>
+          <p:cNvPr id="5" name="Picture 4" descr="ban.png"/>
           <p:cNvPicPr>
             <a:picLocks noChangeAspect="1"/>
           </p:cNvPicPr>
@@ -6899,7 +6899,7 @@
         <p:spPr>
           <a:xfrm>
             <a:off x="1078992" y="3447288"/>
-            <a:ext cx="10515600" cy="841248"/>
+            <a:ext cx="10515600" cy="1188720"/>
           </a:xfrm>
           <a:prstGeom prst="rect">
             <a:avLst/>
@@ -6919,7 +6919,7 @@
                 </a:solidFill>
                 <a:latin typeface="Calibri"/>
               </a:rPr>
-              <a:t>決定權在「組出這支 request 的程式碼」宣告的允許版本範圍：留全範圍就走協商、被指成 MV 對應的單一版本就不協商</a:t>
+              <a:t>replication 連 ApiVersionsRequest 都不送（discoverBrokerVersions=false）：版本已由 finalized MV 決定，直接照該版本送</a:t>
             </a:r>
           </a:p>
         </p:txBody>
@@ -6932,7 +6932,7 @@
         </p:nvSpPr>
         <p:spPr>
           <a:xfrm>
-            <a:off x="640080" y="4434840"/>
+            <a:off x="640080" y="4782312"/>
             <a:ext cx="10972800" cy="877824"/>
           </a:xfrm>
           <a:prstGeom prst="rect">
@@ -6958,7 +6958,7 @@
                 </a:solidFill>
                 <a:latin typeface="Calibri"/>
               </a:rPr>
-              <a:t>為什麼複製面例外？複製要求所有 follower↔leader 講同一版，才交給 finalized MV 集中決定；其餘連線點對點，各自挑最好版即可</a:t>
+              <a:t>為什麼 replication 例外？它要求所有 follower↔leader 講同一版，才交給 finalized MV 集中決定；其餘連線點對點，各自挑最好版即可</a:t>
             </a:r>
           </a:p>
         </p:txBody>
@@ -6971,7 +6971,7 @@
         </p:nvSpPr>
         <p:spPr>
           <a:xfrm>
-            <a:off x="640080" y="5495544"/>
+            <a:off x="640080" y="5843016"/>
             <a:ext cx="10972800" cy="438912"/>
           </a:xfrm>
           <a:prstGeom prst="rect">
@@ -6992,7 +6992,7 @@
                 </a:solidFill>
                 <a:latin typeface="Calibri"/>
               </a:rPr>
-              <a:t>更細的差異（ListOffsets 以 MV 為上限等）見 blog 附錄，此處不展開。</a:t>
+              <a:t>機制上，決定權在組出 request 的程式碼宣告的允許版本範圍；ListOffsets 等更細差異見 blog 附錄。</a:t>
             </a:r>
           </a:p>
         </p:txBody>
@@ -7055,7 +7055,7 @@
                 <a:latin typeface="Courier New"/>
                 <a:hlinkClick r:id="rId4"/>
               </a:rPr>
-              <a:t>javadoc</a:t>
+              <a:t>discoverBrokerVersions=false</a:t>
             </a:r>
             <a:r>
               <a:rPr sz="1200" b="0">

</xml_diff>

<commit_message>
study(version-control): 補「專家取捨」層（deck 5 處+1 張、blog 9 處，皆經 Codex fact-check）
- deck：點題預告帳單、架構(b)補 MV 兩階段代價、新增「同一道題別家怎麼答」對照張（回收
  MONGO/PGURL、刪 KIP482/PBUF dead constants）、截斷加九年窗結算 note、Recap 加立場句；16 張
- blog：§1 per-API 帳單（KIP-482 措辭修正：flexible version 後 tagged fields 才免升版）、
  §3 一次 RTT 代價、§4 MV 帳單+PostgreSQL 反事實小節、§5 dual-role 評價（KIP-903 broker epoch）、
  §7 為何關線（response 序列化依 request version）、§8 KIP-896 九年結算、Recap 立場句、
  附錄 A3 OffsetsForLeaderEpoch 解讀（KAFKA-18465 清理殘留、非文件化決策）、新增附錄 C 三家對照
- fact-check 修正三處原草稿：KIP-482 非「永不升版」、v4 pin 非「刻意低成本」、關線理由精確化
</commit_message>
<xml_diff>
--- a/study/version-control/kafka-version-negotiation.pptx
+++ b/study/version-control/kafka-version-negotiation.pptx
@@ -20,6 +20,7 @@
     <p:sldId id="268" r:id="rId19"/>
     <p:sldId id="269" r:id="rId20"/>
     <p:sldId id="270" r:id="rId21"/>
+    <p:sldId id="271" r:id="rId22"/>
   </p:sldIdLst>
   <p:sldSz cx="12191695" cy="6858000" type="screen4x3"/>
   <p:notesSz cx="6858000" cy="9144000"/>
@@ -3328,7 +3329,7 @@
                 </a:solidFill>
                 <a:latin typeface="Calibri"/>
               </a:rPr>
-              <a:t>隨堂考 · 核心　（正解）</a:t>
+              <a:t>隨堂考 · 核心</a:t>
             </a:r>
           </a:p>
         </p:txBody>
@@ -3424,36 +3425,31 @@
           <a:prstGeom prst="rect">
             <a:avLst/>
           </a:prstGeom>
-          <a:solidFill>
-            <a:srgbClr val="E9F3DE"/>
-          </a:solidFill>
-          <a:ln>
-            <a:noFill/>
-          </a:ln>
-        </p:spPr>
-        <p:txBody>
-          <a:bodyPr wrap="square" lIns="128016" tIns="54864">
-            <a:noAutofit/>
-          </a:bodyPr>
-          <a:lstStyle/>
-          <a:p>
-            <a:r>
-              <a:rPr sz="1600" b="1">
-                <a:solidFill>
-                  <a:srgbClr val="27500A"/>
+          <a:noFill/>
+        </p:spPr>
+        <p:txBody>
+          <a:bodyPr wrap="square">
+            <a:noAutofit/>
+          </a:bodyPr>
+          <a:lstStyle/>
+          <a:p>
+            <a:r>
+              <a:rPr sz="1600" b="0">
+                <a:solidFill>
+                  <a:srgbClr val="1E2024"/>
                 </a:solidFill>
                 <a:latin typeface="Calibri"/>
               </a:rPr>
               <a:t>B.  </a:t>
             </a:r>
             <a:r>
-              <a:rPr sz="1600" b="1">
-                <a:solidFill>
-                  <a:srgbClr val="27500A"/>
-                </a:solidFill>
-                <a:latin typeface="Calibri"/>
-              </a:rPr>
-              <a:t>由 finalized metadata.version 決定   ✓</a:t>
+              <a:rPr sz="1600" b="0">
+                <a:solidFill>
+                  <a:srgbClr val="1E2024"/>
+                </a:solidFill>
+                <a:latin typeface="Calibri"/>
+              </a:rPr>
+              <a:t>由 finalized metadata.version 決定</a:t>
             </a:r>
           </a:p>
         </p:txBody>
@@ -3567,85 +3563,13 @@
           <a:lstStyle/>
           <a:p>
             <a:r>
-              <a:rPr sz="1400" b="1">
-                <a:solidFill>
-                  <a:srgbClr val="27500A"/>
-                </a:solidFill>
-                <a:latin typeface="Calibri"/>
-              </a:rPr>
-              <a:t>正解 B — </a:t>
-            </a:r>
-            <a:r>
               <a:rPr sz="1400" b="0">
                 <a:solidFill>
-                  <a:srgbClr val="1E2024"/>
-                </a:solidFill>
-                <a:latin typeface="Calibri"/>
-              </a:rPr>
-              <a:t>fetchRequestVersion(MV)：MV 是集中共識，不做 per-connection 協商。</a:t>
-            </a:r>
-          </a:p>
-        </p:txBody>
-      </p:sp>
-      <p:sp>
-        <p:nvSpPr>
-          <p:cNvPr id="9" name="TextBox 8"/>
-          <p:cNvSpPr txBox="1"/>
-          <p:nvPr/>
-        </p:nvSpPr>
-        <p:spPr>
-          <a:xfrm>
-            <a:off x="640080" y="6400800"/>
-            <a:ext cx="10972800" cy="384048"/>
-          </a:xfrm>
-          <a:prstGeom prst="rect">
-            <a:avLst/>
-          </a:prstGeom>
-          <a:noFill/>
-        </p:spPr>
-        <p:txBody>
-          <a:bodyPr wrap="square">
-            <a:noAutofit/>
-          </a:bodyPr>
-          <a:lstStyle/>
-          <a:p>
-            <a:r>
-              <a:rPr sz="1200" b="1">
-                <a:solidFill>
                   <a:srgbClr val="8A8A8A"/>
                 </a:solidFill>
                 <a:latin typeface="Calibri"/>
               </a:rPr>
-              <a:t>REF   </a:t>
-            </a:r>
-            <a:r>
-              <a:rPr sz="1200" b="0" u="sng">
-                <a:solidFill>
-                  <a:srgbClr val="185FA5"/>
-                </a:solidFill>
-                <a:latin typeface="Courier New"/>
-                <a:hlinkClick r:id="rId2"/>
-              </a:rPr>
-              <a:t>RemoteLeaderEndPoint.scala:215</a:t>
-            </a:r>
-            <a:r>
-              <a:rPr sz="1200" b="0">
-                <a:solidFill>
-                  <a:srgbClr val="8A8A8A"/>
-                </a:solidFill>
-                <a:latin typeface="Calibri"/>
-              </a:rPr>
-              <a:t>   ·   </a:t>
-            </a:r>
-            <a:r>
-              <a:rPr sz="1200" b="0" u="sng">
-                <a:solidFill>
-                  <a:srgbClr val="185FA5"/>
-                </a:solidFill>
-                <a:latin typeface="Courier New"/>
-                <a:hlinkClick r:id="rId3"/>
-              </a:rPr>
-              <a:t>MetadataVersion.java:273</a:t>
+              <a:t>想一想 —— 下一頁公布答案</a:t>
             </a:r>
           </a:p>
         </p:txBody>
@@ -3697,7 +3621,7 @@
                 </a:solidFill>
                 <a:latin typeface="Calibri"/>
               </a:rPr>
-              <a:t>Part 2 · 失敗訊息</a:t>
+              <a:t>隨堂考 · 核心　（正解）</a:t>
             </a:r>
           </a:p>
         </p:txBody>
@@ -3711,27 +3635,27 @@
         <p:spPr>
           <a:xfrm>
             <a:off x="640080" y="841248"/>
-            <a:ext cx="10972800" cy="1005840"/>
-          </a:xfrm>
-          <a:prstGeom prst="rect">
-            <a:avLst/>
-          </a:prstGeom>
-          <a:noFill/>
-        </p:spPr>
-        <p:txBody>
-          <a:bodyPr wrap="square">
-            <a:noAutofit/>
-          </a:bodyPr>
-          <a:lstStyle/>
-          <a:p>
-            <a:r>
-              <a:rPr sz="3200" b="1">
+            <a:ext cx="10972800" cy="1188720"/>
+          </a:xfrm>
+          <a:prstGeom prst="rect">
+            <a:avLst/>
+          </a:prstGeom>
+          <a:noFill/>
+        </p:spPr>
+        <p:txBody>
+          <a:bodyPr wrap="square">
+            <a:noAutofit/>
+          </a:bodyPr>
+          <a:lstStyle/>
+          <a:p>
+            <a:r>
+              <a:rPr sz="2600" b="1">
                 <a:solidFill>
                   <a:srgbClr val="1E2024"/>
                 </a:solidFill>
                 <a:latin typeface="Calibri"/>
               </a:rPr>
-              <a:t>通訊當下協商不出版本，會看到什麼</a:t>
+              <a:t>replica fetch（broker↔broker）的 Fetch 版本怎麼決定？</a:t>
             </a:r>
           </a:p>
         </p:txBody>
@@ -3744,85 +3668,89 @@
         </p:nvSpPr>
         <p:spPr>
           <a:xfrm>
-            <a:off x="640080" y="2148840"/>
-            <a:ext cx="10972800" cy="1371600"/>
+            <a:off x="822960" y="2331720"/>
+            <a:ext cx="10515600" cy="493776"/>
+          </a:xfrm>
+          <a:prstGeom prst="rect">
+            <a:avLst/>
+          </a:prstGeom>
+          <a:noFill/>
+        </p:spPr>
+        <p:txBody>
+          <a:bodyPr wrap="square">
+            <a:noAutofit/>
+          </a:bodyPr>
+          <a:lstStyle/>
+          <a:p>
+            <a:r>
+              <a:rPr sz="1600" b="0">
+                <a:solidFill>
+                  <a:srgbClr val="1E2024"/>
+                </a:solidFill>
+                <a:latin typeface="Calibri"/>
+              </a:rPr>
+              <a:t>A.  </a:t>
+            </a:r>
+            <a:r>
+              <a:rPr sz="1600" b="0">
+                <a:solidFill>
+                  <a:srgbClr val="1E2024"/>
+                </a:solidFill>
+                <a:latin typeface="Calibri"/>
+              </a:rPr>
+              <a:t>兩 broker ApiVersions 協商取交集</a:t>
+            </a:r>
+          </a:p>
+        </p:txBody>
+      </p:sp>
+      <p:sp>
+        <p:nvSpPr>
+          <p:cNvPr id="5" name="TextBox 4"/>
+          <p:cNvSpPr txBox="1"/>
+          <p:nvPr/>
+        </p:nvSpPr>
+        <p:spPr>
+          <a:xfrm>
+            <a:off x="822960" y="2953512"/>
+            <a:ext cx="10515600" cy="493776"/>
           </a:xfrm>
           <a:prstGeom prst="rect">
             <a:avLst/>
           </a:prstGeom>
           <a:solidFill>
-            <a:srgbClr val="F3F1EC"/>
+            <a:srgbClr val="E9F3DE"/>
           </a:solidFill>
-          <a:ln w="6350">
-            <a:solidFill>
-              <a:srgbClr val="E3E0D8"/>
-            </a:solidFill>
+          <a:ln>
+            <a:noFill/>
           </a:ln>
         </p:spPr>
         <p:txBody>
-          <a:bodyPr wrap="square" lIns="146304" tIns="91440" bIns="91440">
-            <a:noAutofit/>
-          </a:bodyPr>
-          <a:lstStyle/>
-          <a:p>
-            <a:r>
-              <a:rPr sz="1350" b="0">
-                <a:solidFill>
-                  <a:srgbClr val="2C2C2A"/>
-                </a:solidFill>
-                <a:latin typeface="Calibri"/>
-              </a:rPr>
-              <a:t>交集空              → client 端 UnsupportedVersionException（送出前 abort）</a:t>
-            </a:r>
-          </a:p>
-          <a:p>
-            <a:r>
-              <a:rPr sz="1350" b="0">
-                <a:solidFill>
-                  <a:srgbClr val="2C2C2A"/>
-                </a:solidFill>
-                <a:latin typeface="Calibri"/>
-              </a:rPr>
-              <a:t>直送不支援的版本    → broker 丟 UnsupportedVersionException、關閉連線</a:t>
-            </a:r>
-          </a:p>
-          <a:p>
-            <a:r>
-              <a:rPr sz="1350" b="0">
-                <a:solidFill>
-                  <a:srgbClr val="2C2C2A"/>
-                </a:solidFill>
-                <a:latin typeface="Calibri"/>
-              </a:rPr>
-              <a:t>（ApiVersions 例外：回 v0 + UNSUPPORTED_VERSION 錯誤碼）</a:t>
-            </a:r>
-          </a:p>
-        </p:txBody>
-      </p:sp>
-      <p:pic>
-        <p:nvPicPr>
-          <p:cNvPr id="5" name="Picture 4" descr="ban.png"/>
-          <p:cNvPicPr>
-            <a:picLocks noChangeAspect="1"/>
-          </p:cNvPicPr>
-          <p:nvPr/>
-        </p:nvPicPr>
-        <p:blipFill>
-          <a:blip r:embed="rId2"/>
-          <a:stretch>
-            <a:fillRect/>
-          </a:stretch>
-        </p:blipFill>
-        <p:spPr>
-          <a:xfrm>
-            <a:off x="658368" y="3749040"/>
-            <a:ext cx="274320" cy="274320"/>
-          </a:xfrm>
-          <a:prstGeom prst="rect">
-            <a:avLst/>
-          </a:prstGeom>
-        </p:spPr>
-      </p:pic>
+          <a:bodyPr wrap="square" lIns="128016" tIns="54864">
+            <a:noAutofit/>
+          </a:bodyPr>
+          <a:lstStyle/>
+          <a:p>
+            <a:r>
+              <a:rPr sz="1600" b="1">
+                <a:solidFill>
+                  <a:srgbClr val="27500A"/>
+                </a:solidFill>
+                <a:latin typeface="Calibri"/>
+              </a:rPr>
+              <a:t>B.  </a:t>
+            </a:r>
+            <a:r>
+              <a:rPr sz="1600" b="1">
+                <a:solidFill>
+                  <a:srgbClr val="27500A"/>
+                </a:solidFill>
+                <a:latin typeface="Calibri"/>
+              </a:rPr>
+              <a:t>由 finalized metadata.version 決定   ✓</a:t>
+            </a:r>
+          </a:p>
+        </p:txBody>
+      </p:sp>
       <p:sp>
         <p:nvSpPr>
           <p:cNvPr id="6" name="TextBox 5"/>
@@ -3831,7 +3759,7 @@
         </p:nvSpPr>
         <p:spPr>
           <a:xfrm>
-            <a:off x="1078992" y="3721608"/>
+            <a:off x="822960" y="3575304"/>
             <a:ext cx="10515600" cy="493776"/>
           </a:xfrm>
           <a:prstGeom prst="rect">
@@ -3846,13 +3774,22 @@
           <a:lstStyle/>
           <a:p>
             <a:r>
-              <a:rPr sz="1650" b="0">
+              <a:rPr sz="1600" b="0">
                 <a:solidFill>
                   <a:srgbClr val="1E2024"/>
                 </a:solidFill>
                 <a:latin typeface="Calibri"/>
               </a:rPr>
-              <a:t>多數情況 client 在送出前就本地中止，根本沒上網路</a:t>
+              <a:t>C.  </a:t>
+            </a:r>
+            <a:r>
+              <a:rPr sz="1600" b="0">
+                <a:solidFill>
+                  <a:srgbClr val="1E2024"/>
+                </a:solidFill>
+                <a:latin typeface="Calibri"/>
+              </a:rPr>
+              <a:t>永遠用最新版</a:t>
             </a:r>
           </a:p>
         </p:txBody>
@@ -3860,6 +3797,92 @@
       <p:sp>
         <p:nvSpPr>
           <p:cNvPr id="7" name="TextBox 6"/>
+          <p:cNvSpPr txBox="1"/>
+          <p:nvPr/>
+        </p:nvSpPr>
+        <p:spPr>
+          <a:xfrm>
+            <a:off x="822960" y="4197096"/>
+            <a:ext cx="10515600" cy="493776"/>
+          </a:xfrm>
+          <a:prstGeom prst="rect">
+            <a:avLst/>
+          </a:prstGeom>
+          <a:noFill/>
+        </p:spPr>
+        <p:txBody>
+          <a:bodyPr wrap="square">
+            <a:noAutofit/>
+          </a:bodyPr>
+          <a:lstStyle/>
+          <a:p>
+            <a:r>
+              <a:rPr sz="1600" b="0">
+                <a:solidFill>
+                  <a:srgbClr val="1E2024"/>
+                </a:solidFill>
+                <a:latin typeface="Calibri"/>
+              </a:rPr>
+              <a:t>D.  </a:t>
+            </a:r>
+            <a:r>
+              <a:rPr sz="1600" b="0">
+                <a:solidFill>
+                  <a:srgbClr val="1E2024"/>
+                </a:solidFill>
+                <a:latin typeface="Calibri"/>
+              </a:rPr>
+              <a:t>controller 每次指定</a:t>
+            </a:r>
+          </a:p>
+        </p:txBody>
+      </p:sp>
+      <p:sp>
+        <p:nvSpPr>
+          <p:cNvPr id="8" name="TextBox 7"/>
+          <p:cNvSpPr txBox="1"/>
+          <p:nvPr/>
+        </p:nvSpPr>
+        <p:spPr>
+          <a:xfrm>
+            <a:off x="640080" y="4910327"/>
+            <a:ext cx="10972800" cy="914400"/>
+          </a:xfrm>
+          <a:prstGeom prst="rect">
+            <a:avLst/>
+          </a:prstGeom>
+          <a:noFill/>
+        </p:spPr>
+        <p:txBody>
+          <a:bodyPr wrap="square">
+            <a:noAutofit/>
+          </a:bodyPr>
+          <a:lstStyle/>
+          <a:p>
+            <a:r>
+              <a:rPr sz="1400" b="1">
+                <a:solidFill>
+                  <a:srgbClr val="27500A"/>
+                </a:solidFill>
+                <a:latin typeface="Calibri"/>
+              </a:rPr>
+              <a:t>正解 B — </a:t>
+            </a:r>
+            <a:r>
+              <a:rPr sz="1400" b="0">
+                <a:solidFill>
+                  <a:srgbClr val="1E2024"/>
+                </a:solidFill>
+                <a:latin typeface="Calibri"/>
+              </a:rPr>
+              <a:t>fetchRequestVersion(MV)：MV 是集中共識，不做 per-connection 協商。</a:t>
+            </a:r>
+          </a:p>
+        </p:txBody>
+      </p:sp>
+      <p:sp>
+        <p:nvSpPr>
+          <p:cNvPr id="9" name="TextBox 8"/>
           <p:cNvSpPr txBox="1"/>
           <p:nvPr/>
         </p:nvSpPr>
@@ -3894,47 +3917,28 @@
                   <a:srgbClr val="185FA5"/>
                 </a:solidFill>
                 <a:latin typeface="Courier New"/>
+                <a:hlinkClick r:id="rId2"/>
+              </a:rPr>
+              <a:t>RemoteLeaderEndPoint.scala:215</a:t>
+            </a:r>
+            <a:r>
+              <a:rPr sz="1200" b="0">
+                <a:solidFill>
+                  <a:srgbClr val="8A8A8A"/>
+                </a:solidFill>
+                <a:latin typeface="Calibri"/>
+              </a:rPr>
+              <a:t>   ·   </a:t>
+            </a:r>
+            <a:r>
+              <a:rPr sz="1200" b="0" u="sng">
+                <a:solidFill>
+                  <a:srgbClr val="185FA5"/>
+                </a:solidFill>
+                <a:latin typeface="Courier New"/>
                 <a:hlinkClick r:id="rId3"/>
               </a:rPr>
-              <a:t>latestUsableVersion</a:t>
-            </a:r>
-            <a:r>
-              <a:rPr sz="1200" b="0">
-                <a:solidFill>
-                  <a:srgbClr val="8A8A8A"/>
-                </a:solidFill>
-                <a:latin typeface="Calibri"/>
-              </a:rPr>
-              <a:t>   ·   </a:t>
-            </a:r>
-            <a:r>
-              <a:rPr sz="1200" b="0" u="sng">
-                <a:solidFill>
-                  <a:srgbClr val="185FA5"/>
-                </a:solidFill>
-                <a:latin typeface="Courier New"/>
-                <a:hlinkClick r:id="rId4"/>
-              </a:rPr>
-              <a:t>NetworkClient</a:t>
-            </a:r>
-            <a:r>
-              <a:rPr sz="1200" b="0">
-                <a:solidFill>
-                  <a:srgbClr val="8A8A8A"/>
-                </a:solidFill>
-                <a:latin typeface="Calibri"/>
-              </a:rPr>
-              <a:t>   ·   </a:t>
-            </a:r>
-            <a:r>
-              <a:rPr sz="1200" b="0" u="sng">
-                <a:solidFill>
-                  <a:srgbClr val="185FA5"/>
-                </a:solidFill>
-                <a:latin typeface="Courier New"/>
-                <a:hlinkClick r:id="rId5"/>
-              </a:rPr>
-              <a:t>RequestContext</a:t>
+              <a:t>MetadataVersion.java:273</a:t>
             </a:r>
           </a:p>
         </p:txBody>
@@ -4020,79 +4024,21 @@
                 </a:solidFill>
                 <a:latin typeface="Calibri"/>
               </a:rPr>
-              <a:t>版本截斷：為什麼「升一點點」不夠</a:t>
-            </a:r>
-          </a:p>
-        </p:txBody>
-      </p:sp>
-      <p:pic>
-        <p:nvPicPr>
-          <p:cNvPr id="4" name="Picture 3" descr="alert-triangle.png"/>
-          <p:cNvPicPr>
-            <a:picLocks noChangeAspect="1"/>
-          </p:cNvPicPr>
-          <p:nvPr/>
-        </p:nvPicPr>
-        <p:blipFill>
-          <a:blip r:embed="rId2"/>
-          <a:stretch>
-            <a:fillRect/>
-          </a:stretch>
-        </p:blipFill>
-        <p:spPr>
-          <a:xfrm>
-            <a:off x="658368" y="2176272"/>
-            <a:ext cx="274320" cy="274320"/>
-          </a:xfrm>
-          <a:prstGeom prst="rect">
-            <a:avLst/>
-          </a:prstGeom>
-        </p:spPr>
-      </p:pic>
-      <p:sp>
-        <p:nvSpPr>
-          <p:cNvPr id="5" name="TextBox 4"/>
-          <p:cNvSpPr txBox="1"/>
-          <p:nvPr/>
-        </p:nvSpPr>
-        <p:spPr>
-          <a:xfrm>
-            <a:off x="1078992" y="2148840"/>
-            <a:ext cx="10515600" cy="493776"/>
-          </a:xfrm>
-          <a:prstGeom prst="rect">
-            <a:avLst/>
-          </a:prstGeom>
-          <a:noFill/>
-        </p:spPr>
-        <p:txBody>
-          <a:bodyPr wrap="square">
-            <a:noAutofit/>
-          </a:bodyPr>
-          <a:lstStyle/>
-          <a:p>
-            <a:r>
-              <a:rPr sz="1650" b="0">
-                <a:solidFill>
-                  <a:srgbClr val="1E2024"/>
-                </a:solidFill>
-                <a:latin typeface="Calibri"/>
-              </a:rPr>
-              <a:t>前一頁「交集空」最容易被忽略的根因——舊 wire 版本被整批移除</a:t>
-            </a:r>
-          </a:p>
-        </p:txBody>
-      </p:sp>
-      <p:sp>
-        <p:nvSpPr>
-          <p:cNvPr id="6" name="TextBox 5"/>
-          <p:cNvSpPr txBox="1"/>
-          <p:nvPr/>
-        </p:nvSpPr>
-        <p:spPr>
-          <a:xfrm>
-            <a:off x="640080" y="2788920"/>
-            <a:ext cx="10972800" cy="822959"/>
+              <a:t>通訊當下協商不出版本，會看到什麼</a:t>
+            </a:r>
+          </a:p>
+        </p:txBody>
+      </p:sp>
+      <p:sp>
+        <p:nvSpPr>
+          <p:cNvPr id="4" name="TextBox 3"/>
+          <p:cNvSpPr txBox="1"/>
+          <p:nvPr/>
+        </p:nvSpPr>
+        <p:spPr>
+          <a:xfrm>
+            <a:off x="640080" y="2148840"/>
+            <a:ext cx="10972800" cy="1371600"/>
           </a:xfrm>
           <a:prstGeom prst="rect">
             <a:avLst/>
@@ -4119,7 +4065,7 @@
                 </a:solidFill>
                 <a:latin typeface="Calibri"/>
               </a:rPr>
-              <a:t>舊 wire API version 被整個移除，min 可 &gt; 0</a:t>
+              <a:t>交集空              → client 端 UnsupportedVersionException（送出前 abort）</a:t>
             </a:r>
           </a:p>
           <a:p>
@@ -4130,7 +4076,76 @@
                 </a:solidFill>
                 <a:latin typeface="Calibri"/>
               </a:rPr>
-              <a:t>  Fetch：4–18（v0–3 在 4.0 移除）</a:t>
+              <a:t>直送不支援的版本    → broker 丟 UnsupportedVersionException、關閉連線</a:t>
+            </a:r>
+          </a:p>
+          <a:p>
+            <a:r>
+              <a:rPr sz="1350" b="0">
+                <a:solidFill>
+                  <a:srgbClr val="2C2C2A"/>
+                </a:solidFill>
+                <a:latin typeface="Calibri"/>
+              </a:rPr>
+              <a:t>（ApiVersions 例外：回 v0 + UNSUPPORTED_VERSION 錯誤碼）</a:t>
+            </a:r>
+          </a:p>
+        </p:txBody>
+      </p:sp>
+      <p:pic>
+        <p:nvPicPr>
+          <p:cNvPr id="5" name="Picture 4" descr="ban.png"/>
+          <p:cNvPicPr>
+            <a:picLocks noChangeAspect="1"/>
+          </p:cNvPicPr>
+          <p:nvPr/>
+        </p:nvPicPr>
+        <p:blipFill>
+          <a:blip r:embed="rId2"/>
+          <a:stretch>
+            <a:fillRect/>
+          </a:stretch>
+        </p:blipFill>
+        <p:spPr>
+          <a:xfrm>
+            <a:off x="658368" y="3749040"/>
+            <a:ext cx="274320" cy="274320"/>
+          </a:xfrm>
+          <a:prstGeom prst="rect">
+            <a:avLst/>
+          </a:prstGeom>
+        </p:spPr>
+      </p:pic>
+      <p:sp>
+        <p:nvSpPr>
+          <p:cNvPr id="6" name="TextBox 5"/>
+          <p:cNvSpPr txBox="1"/>
+          <p:nvPr/>
+        </p:nvSpPr>
+        <p:spPr>
+          <a:xfrm>
+            <a:off x="1078992" y="3721608"/>
+            <a:ext cx="10515600" cy="493776"/>
+          </a:xfrm>
+          <a:prstGeom prst="rect">
+            <a:avLst/>
+          </a:prstGeom>
+          <a:noFill/>
+        </p:spPr>
+        <p:txBody>
+          <a:bodyPr wrap="square">
+            <a:noAutofit/>
+          </a:bodyPr>
+          <a:lstStyle/>
+          <a:p>
+            <a:r>
+              <a:rPr sz="1650" b="0">
+                <a:solidFill>
+                  <a:srgbClr val="1E2024"/>
+                </a:solidFill>
+                <a:latin typeface="Calibri"/>
+              </a:rPr>
+              <a:t>多數情況 client 在送出前就本地中止，根本沒上網路</a:t>
             </a:r>
           </a:p>
         </p:txBody>
@@ -4138,79 +4153,6 @@
       <p:sp>
         <p:nvSpPr>
           <p:cNvPr id="7" name="TextBox 6"/>
-          <p:cNvSpPr txBox="1"/>
-          <p:nvPr/>
-        </p:nvSpPr>
-        <p:spPr>
-          <a:xfrm>
-            <a:off x="640080" y="3813048"/>
-            <a:ext cx="10972800" cy="877824"/>
-          </a:xfrm>
-          <a:prstGeom prst="rect">
-            <a:avLst/>
-          </a:prstGeom>
-          <a:solidFill>
-            <a:srgbClr val="E9F3DE"/>
-          </a:solidFill>
-          <a:ln>
-            <a:noFill/>
-          </a:ln>
-        </p:spPr>
-        <p:txBody>
-          <a:bodyPr wrap="square" lIns="146304" tIns="82296">
-            <a:noAutofit/>
-          </a:bodyPr>
-          <a:lstStyle/>
-          <a:p>
-            <a:r>
-              <a:rPr sz="1500" b="0">
-                <a:solidFill>
-                  <a:srgbClr val="27500A"/>
-                </a:solidFill>
-                <a:latin typeface="Calibri"/>
-              </a:rPr>
-              <a:t>解法：升任一端到 4.0 前，先確認另一端 ≥ 2.1（upgrade guide 明訂雙向要求），否則協商結果沒有可用版本</a:t>
-            </a:r>
-          </a:p>
-        </p:txBody>
-      </p:sp>
-      <p:sp>
-        <p:nvSpPr>
-          <p:cNvPr id="8" name="TextBox 7"/>
-          <p:cNvSpPr txBox="1"/>
-          <p:nvPr/>
-        </p:nvSpPr>
-        <p:spPr>
-          <a:xfrm>
-            <a:off x="640080" y="4873752"/>
-            <a:ext cx="10972800" cy="731520"/>
-          </a:xfrm>
-          <a:prstGeom prst="rect">
-            <a:avLst/>
-          </a:prstGeom>
-          <a:noFill/>
-        </p:spPr>
-        <p:txBody>
-          <a:bodyPr wrap="square">
-            <a:noAutofit/>
-          </a:bodyPr>
-          <a:lstStyle/>
-          <a:p>
-            <a:r>
-              <a:rPr sz="1500" b="0">
-                <a:solidFill>
-                  <a:srgbClr val="5F5E5A"/>
-                </a:solidFill>
-                <a:latin typeface="Calibri"/>
-              </a:rPr>
-              <a:t>銜接（非本場）：finalize / 升降當下的錯誤（INVALID_UPDATE_VERSION 等）屬「運行時的版本升降」那場，本場不展開。</a:t>
-            </a:r>
-          </a:p>
-        </p:txBody>
-      </p:sp>
-      <p:sp>
-        <p:nvSpPr>
-          <p:cNvPr id="9" name="TextBox 8"/>
           <p:cNvSpPr txBox="1"/>
           <p:nvPr/>
         </p:nvSpPr>
@@ -4247,7 +4189,7 @@
                 <a:latin typeface="Courier New"/>
                 <a:hlinkClick r:id="rId3"/>
               </a:rPr>
-              <a:t>upgrade.md:229</a:t>
+              <a:t>latestUsableVersion</a:t>
             </a:r>
             <a:r>
               <a:rPr sz="1200" b="0">
@@ -4266,7 +4208,26 @@
                 <a:latin typeface="Courier New"/>
                 <a:hlinkClick r:id="rId4"/>
               </a:rPr>
-              <a:t>FetchRequest.json validVersions</a:t>
+              <a:t>NetworkClient</a:t>
+            </a:r>
+            <a:r>
+              <a:rPr sz="1200" b="0">
+                <a:solidFill>
+                  <a:srgbClr val="8A8A8A"/>
+                </a:solidFill>
+                <a:latin typeface="Calibri"/>
+              </a:rPr>
+              <a:t>   ·   </a:t>
+            </a:r>
+            <a:r>
+              <a:rPr sz="1200" b="0" u="sng">
+                <a:solidFill>
+                  <a:srgbClr val="185FA5"/>
+                </a:solidFill>
+                <a:latin typeface="Courier New"/>
+                <a:hlinkClick r:id="rId5"/>
+              </a:rPr>
+              <a:t>RequestContext</a:t>
             </a:r>
           </a:p>
         </p:txBody>
@@ -4318,7 +4279,7 @@
                 </a:solidFill>
                 <a:latin typeface="Calibri"/>
               </a:rPr>
-              <a:t>隨堂考 · 核心</a:t>
+              <a:t>Part 2 · 失敗訊息</a:t>
             </a:r>
           </a:p>
         </p:txBody>
@@ -4332,40 +4293,64 @@
         <p:spPr>
           <a:xfrm>
             <a:off x="640080" y="841248"/>
-            <a:ext cx="10972800" cy="1188720"/>
-          </a:xfrm>
-          <a:prstGeom prst="rect">
-            <a:avLst/>
-          </a:prstGeom>
-          <a:noFill/>
-        </p:spPr>
-        <p:txBody>
-          <a:bodyPr wrap="square">
-            <a:noAutofit/>
-          </a:bodyPr>
-          <a:lstStyle/>
-          <a:p>
-            <a:r>
-              <a:rPr sz="2600" b="1">
+            <a:ext cx="10972800" cy="1005840"/>
+          </a:xfrm>
+          <a:prstGeom prst="rect">
+            <a:avLst/>
+          </a:prstGeom>
+          <a:noFill/>
+        </p:spPr>
+        <p:txBody>
+          <a:bodyPr wrap="square">
+            <a:noAutofit/>
+          </a:bodyPr>
+          <a:lstStyle/>
+          <a:p>
+            <a:r>
+              <a:rPr sz="3200" b="1">
                 <a:solidFill>
                   <a:srgbClr val="1E2024"/>
                 </a:solidFill>
                 <a:latin typeface="Calibri"/>
               </a:rPr>
-              <a:t>client 繞過協商、直接送出 broker 不支援的 API version，會怎樣？</a:t>
-            </a:r>
-          </a:p>
-        </p:txBody>
-      </p:sp>
-      <p:sp>
-        <p:nvSpPr>
-          <p:cNvPr id="4" name="TextBox 3"/>
-          <p:cNvSpPr txBox="1"/>
-          <p:nvPr/>
-        </p:nvSpPr>
-        <p:spPr>
-          <a:xfrm>
-            <a:off x="822960" y="2331720"/>
+              <a:t>版本截斷：為什麼「升一點點」不夠</a:t>
+            </a:r>
+          </a:p>
+        </p:txBody>
+      </p:sp>
+      <p:pic>
+        <p:nvPicPr>
+          <p:cNvPr id="4" name="Picture 3" descr="alert-triangle.png"/>
+          <p:cNvPicPr>
+            <a:picLocks noChangeAspect="1"/>
+          </p:cNvPicPr>
+          <p:nvPr/>
+        </p:nvPicPr>
+        <p:blipFill>
+          <a:blip r:embed="rId2"/>
+          <a:stretch>
+            <a:fillRect/>
+          </a:stretch>
+        </p:blipFill>
+        <p:spPr>
+          <a:xfrm>
+            <a:off x="658368" y="2176272"/>
+            <a:ext cx="274320" cy="274320"/>
+          </a:xfrm>
+          <a:prstGeom prst="rect">
+            <a:avLst/>
+          </a:prstGeom>
+        </p:spPr>
+      </p:pic>
+      <p:sp>
+        <p:nvSpPr>
+          <p:cNvPr id="5" name="TextBox 4"/>
+          <p:cNvSpPr txBox="1"/>
+          <p:nvPr/>
+        </p:nvSpPr>
+        <p:spPr>
+          <a:xfrm>
+            <a:off x="1078992" y="2148840"/>
             <a:ext cx="10515600" cy="493776"/>
           </a:xfrm>
           <a:prstGeom prst="rect">
@@ -4380,65 +4365,13 @@
           <a:lstStyle/>
           <a:p>
             <a:r>
-              <a:rPr sz="1600" b="0">
+              <a:rPr sz="1650" b="0">
                 <a:solidFill>
                   <a:srgbClr val="1E2024"/>
                 </a:solidFill>
                 <a:latin typeface="Calibri"/>
               </a:rPr>
-              <a:t>A.  </a:t>
-            </a:r>
-            <a:r>
-              <a:rPr sz="1600" b="0">
-                <a:solidFill>
-                  <a:srgbClr val="1E2024"/>
-                </a:solidFill>
-                <a:latin typeface="Calibri"/>
-              </a:rPr>
-              <a:t>一律回 UNSUPPORTED_VERSION 錯誤碼</a:t>
-            </a:r>
-          </a:p>
-        </p:txBody>
-      </p:sp>
-      <p:sp>
-        <p:nvSpPr>
-          <p:cNvPr id="5" name="TextBox 4"/>
-          <p:cNvSpPr txBox="1"/>
-          <p:nvPr/>
-        </p:nvSpPr>
-        <p:spPr>
-          <a:xfrm>
-            <a:off x="822960" y="2953512"/>
-            <a:ext cx="10515600" cy="493776"/>
-          </a:xfrm>
-          <a:prstGeom prst="rect">
-            <a:avLst/>
-          </a:prstGeom>
-          <a:noFill/>
-        </p:spPr>
-        <p:txBody>
-          <a:bodyPr wrap="square">
-            <a:noAutofit/>
-          </a:bodyPr>
-          <a:lstStyle/>
-          <a:p>
-            <a:r>
-              <a:rPr sz="1600" b="0">
-                <a:solidFill>
-                  <a:srgbClr val="1E2024"/>
-                </a:solidFill>
-                <a:latin typeface="Calibri"/>
-              </a:rPr>
-              <a:t>B.  </a:t>
-            </a:r>
-            <a:r>
-              <a:rPr sz="1600" b="0">
-                <a:solidFill>
-                  <a:srgbClr val="1E2024"/>
-                </a:solidFill>
-                <a:latin typeface="Calibri"/>
-              </a:rPr>
-              <a:t>只有 ApiVersions 例外回錯誤碼+支援範圍；其他 API 直接關閉連線</a:t>
+              <a:t>前一頁「交集空」最容易被忽略的根因——舊 wire 版本被整批移除</a:t>
             </a:r>
           </a:p>
         </p:txBody>
@@ -4451,37 +4384,46 @@
         </p:nvSpPr>
         <p:spPr>
           <a:xfrm>
-            <a:off x="822960" y="3575304"/>
-            <a:ext cx="10515600" cy="493776"/>
-          </a:xfrm>
-          <a:prstGeom prst="rect">
-            <a:avLst/>
-          </a:prstGeom>
-          <a:noFill/>
-        </p:spPr>
-        <p:txBody>
-          <a:bodyPr wrap="square">
-            <a:noAutofit/>
-          </a:bodyPr>
-          <a:lstStyle/>
-          <a:p>
-            <a:r>
-              <a:rPr sz="1600" b="0">
-                <a:solidFill>
-                  <a:srgbClr val="1E2024"/>
-                </a:solidFill>
-                <a:latin typeface="Calibri"/>
-              </a:rPr>
-              <a:t>C.  </a:t>
-            </a:r>
-            <a:r>
-              <a:rPr sz="1600" b="0">
-                <a:solidFill>
-                  <a:srgbClr val="1E2024"/>
-                </a:solidFill>
-                <a:latin typeface="Calibri"/>
-              </a:rPr>
-              <a:t>broker 自動降版處理</a:t>
+            <a:off x="640080" y="2788920"/>
+            <a:ext cx="10972800" cy="822959"/>
+          </a:xfrm>
+          <a:prstGeom prst="rect">
+            <a:avLst/>
+          </a:prstGeom>
+          <a:solidFill>
+            <a:srgbClr val="F3F1EC"/>
+          </a:solidFill>
+          <a:ln w="6350">
+            <a:solidFill>
+              <a:srgbClr val="E3E0D8"/>
+            </a:solidFill>
+          </a:ln>
+        </p:spPr>
+        <p:txBody>
+          <a:bodyPr wrap="square" lIns="146304" tIns="91440" bIns="91440">
+            <a:noAutofit/>
+          </a:bodyPr>
+          <a:lstStyle/>
+          <a:p>
+            <a:r>
+              <a:rPr sz="1350" b="0">
+                <a:solidFill>
+                  <a:srgbClr val="2C2C2A"/>
+                </a:solidFill>
+                <a:latin typeface="Calibri"/>
+              </a:rPr>
+              <a:t>舊 wire API version 被整個移除，min 可 &gt; 0</a:t>
+            </a:r>
+          </a:p>
+          <a:p>
+            <a:r>
+              <a:rPr sz="1350" b="0">
+                <a:solidFill>
+                  <a:srgbClr val="2C2C2A"/>
+                </a:solidFill>
+                <a:latin typeface="Calibri"/>
+              </a:rPr>
+              <a:t>  Fetch：4–18（v0–3 在 4.0 移除）</a:t>
             </a:r>
           </a:p>
         </p:txBody>
@@ -4494,37 +4436,33 @@
         </p:nvSpPr>
         <p:spPr>
           <a:xfrm>
-            <a:off x="822960" y="4197096"/>
-            <a:ext cx="10515600" cy="493776"/>
-          </a:xfrm>
-          <a:prstGeom prst="rect">
-            <a:avLst/>
-          </a:prstGeom>
-          <a:noFill/>
-        </p:spPr>
-        <p:txBody>
-          <a:bodyPr wrap="square">
-            <a:noAutofit/>
-          </a:bodyPr>
-          <a:lstStyle/>
-          <a:p>
-            <a:r>
-              <a:rPr sz="1600" b="0">
-                <a:solidFill>
-                  <a:srgbClr val="1E2024"/>
-                </a:solidFill>
-                <a:latin typeface="Calibri"/>
-              </a:rPr>
-              <a:t>D.  </a:t>
-            </a:r>
-            <a:r>
-              <a:rPr sz="1600" b="0">
-                <a:solidFill>
-                  <a:srgbClr val="1E2024"/>
-                </a:solidFill>
-                <a:latin typeface="Calibri"/>
-              </a:rPr>
-              <a:t>忽略版本照常處理</a:t>
+            <a:off x="640080" y="3813048"/>
+            <a:ext cx="10972800" cy="877824"/>
+          </a:xfrm>
+          <a:prstGeom prst="rect">
+            <a:avLst/>
+          </a:prstGeom>
+          <a:solidFill>
+            <a:srgbClr val="E9F3DE"/>
+          </a:solidFill>
+          <a:ln>
+            <a:noFill/>
+          </a:ln>
+        </p:spPr>
+        <p:txBody>
+          <a:bodyPr wrap="square" lIns="146304" tIns="82296">
+            <a:noAutofit/>
+          </a:bodyPr>
+          <a:lstStyle/>
+          <a:p>
+            <a:r>
+              <a:rPr sz="1500" b="0">
+                <a:solidFill>
+                  <a:srgbClr val="27500A"/>
+                </a:solidFill>
+                <a:latin typeface="Calibri"/>
+              </a:rPr>
+              <a:t>解法：升任一端到 4.0 前，先確認另一端 ≥ 2.1（upgrade guide 明訂雙向要求），否則協商結果沒有可用版本</a:t>
             </a:r>
           </a:p>
         </p:txBody>
@@ -4537,28 +4475,125 @@
         </p:nvSpPr>
         <p:spPr>
           <a:xfrm>
-            <a:off x="640080" y="4910327"/>
-            <a:ext cx="10972800" cy="914400"/>
-          </a:xfrm>
-          <a:prstGeom prst="rect">
-            <a:avLst/>
-          </a:prstGeom>
-          <a:noFill/>
-        </p:spPr>
-        <p:txBody>
-          <a:bodyPr wrap="square">
-            <a:noAutofit/>
-          </a:bodyPr>
-          <a:lstStyle/>
-          <a:p>
-            <a:r>
-              <a:rPr sz="1400" b="0">
+            <a:off x="640080" y="4873752"/>
+            <a:ext cx="10972800" cy="731520"/>
+          </a:xfrm>
+          <a:prstGeom prst="rect">
+            <a:avLst/>
+          </a:prstGeom>
+          <a:noFill/>
+        </p:spPr>
+        <p:txBody>
+          <a:bodyPr wrap="square">
+            <a:noAutofit/>
+          </a:bodyPr>
+          <a:lstStyle/>
+          <a:p>
+            <a:r>
+              <a:rPr sz="1500" b="0">
+                <a:solidFill>
+                  <a:srgbClr val="5F5E5A"/>
+                </a:solidFill>
+                <a:latin typeface="Calibri"/>
+              </a:rPr>
+              <a:t>取捨：0.8.0（2013）起九年保留每個版本——每個舊版本都是活的程式碼與測試面；4.0 用「斷 2018 年前的 client」換「刪九年的碼」，只有 major 版本邊界付得起。</a:t>
+            </a:r>
+          </a:p>
+        </p:txBody>
+      </p:sp>
+      <p:sp>
+        <p:nvSpPr>
+          <p:cNvPr id="9" name="TextBox 8"/>
+          <p:cNvSpPr txBox="1"/>
+          <p:nvPr/>
+        </p:nvSpPr>
+        <p:spPr>
+          <a:xfrm>
+            <a:off x="640080" y="5733288"/>
+            <a:ext cx="10972800" cy="731520"/>
+          </a:xfrm>
+          <a:prstGeom prst="rect">
+            <a:avLst/>
+          </a:prstGeom>
+          <a:noFill/>
+        </p:spPr>
+        <p:txBody>
+          <a:bodyPr wrap="square">
+            <a:noAutofit/>
+          </a:bodyPr>
+          <a:lstStyle/>
+          <a:p>
+            <a:r>
+              <a:rPr sz="1500" b="0">
+                <a:solidFill>
+                  <a:srgbClr val="5F5E5A"/>
+                </a:solidFill>
+                <a:latin typeface="Calibri"/>
+              </a:rPr>
+              <a:t>銜接（非本場）：finalize / 升降當下的錯誤（INVALID_UPDATE_VERSION 等）屬「運行時的版本升降」那場，本場不展開。</a:t>
+            </a:r>
+          </a:p>
+        </p:txBody>
+      </p:sp>
+      <p:sp>
+        <p:nvSpPr>
+          <p:cNvPr id="10" name="TextBox 9"/>
+          <p:cNvSpPr txBox="1"/>
+          <p:nvPr/>
+        </p:nvSpPr>
+        <p:spPr>
+          <a:xfrm>
+            <a:off x="640080" y="6400800"/>
+            <a:ext cx="10972800" cy="384048"/>
+          </a:xfrm>
+          <a:prstGeom prst="rect">
+            <a:avLst/>
+          </a:prstGeom>
+          <a:noFill/>
+        </p:spPr>
+        <p:txBody>
+          <a:bodyPr wrap="square">
+            <a:noAutofit/>
+          </a:bodyPr>
+          <a:lstStyle/>
+          <a:p>
+            <a:r>
+              <a:rPr sz="1200" b="1">
                 <a:solidFill>
                   <a:srgbClr val="8A8A8A"/>
                 </a:solidFill>
                 <a:latin typeface="Calibri"/>
               </a:rPr>
-              <a:t>想一想 —— 下一頁公布答案</a:t>
+              <a:t>REF   </a:t>
+            </a:r>
+            <a:r>
+              <a:rPr sz="1200" b="0" u="sng">
+                <a:solidFill>
+                  <a:srgbClr val="185FA5"/>
+                </a:solidFill>
+                <a:latin typeface="Courier New"/>
+                <a:hlinkClick r:id="rId3"/>
+              </a:rPr>
+              <a:t>upgrade.md:229</a:t>
+            </a:r>
+            <a:r>
+              <a:rPr sz="1200" b="0">
+                <a:solidFill>
+                  <a:srgbClr val="8A8A8A"/>
+                </a:solidFill>
+                <a:latin typeface="Calibri"/>
+              </a:rPr>
+              <a:t>   ·   </a:t>
+            </a:r>
+            <a:r>
+              <a:rPr sz="1200" b="0" u="sng">
+                <a:solidFill>
+                  <a:srgbClr val="185FA5"/>
+                </a:solidFill>
+                <a:latin typeface="Courier New"/>
+                <a:hlinkClick r:id="rId4"/>
+              </a:rPr>
+              <a:t>FetchRequest.json validVersions</a:t>
             </a:r>
           </a:p>
         </p:txBody>
@@ -4610,7 +4645,7 @@
                 </a:solidFill>
                 <a:latin typeface="Calibri"/>
               </a:rPr>
-              <a:t>隨堂考 · 核心　（正解）</a:t>
+              <a:t>隨堂考 · 核心</a:t>
             </a:r>
           </a:p>
         </p:txBody>
@@ -4706,36 +4741,31 @@
           <a:prstGeom prst="rect">
             <a:avLst/>
           </a:prstGeom>
-          <a:solidFill>
-            <a:srgbClr val="E9F3DE"/>
-          </a:solidFill>
-          <a:ln>
-            <a:noFill/>
-          </a:ln>
-        </p:spPr>
-        <p:txBody>
-          <a:bodyPr wrap="square" lIns="128016" tIns="54864">
-            <a:noAutofit/>
-          </a:bodyPr>
-          <a:lstStyle/>
-          <a:p>
-            <a:r>
-              <a:rPr sz="1600" b="1">
-                <a:solidFill>
-                  <a:srgbClr val="27500A"/>
+          <a:noFill/>
+        </p:spPr>
+        <p:txBody>
+          <a:bodyPr wrap="square">
+            <a:noAutofit/>
+          </a:bodyPr>
+          <a:lstStyle/>
+          <a:p>
+            <a:r>
+              <a:rPr sz="1600" b="0">
+                <a:solidFill>
+                  <a:srgbClr val="1E2024"/>
                 </a:solidFill>
                 <a:latin typeface="Calibri"/>
               </a:rPr>
               <a:t>B.  </a:t>
             </a:r>
             <a:r>
-              <a:rPr sz="1600" b="1">
-                <a:solidFill>
-                  <a:srgbClr val="27500A"/>
-                </a:solidFill>
-                <a:latin typeface="Calibri"/>
-              </a:rPr>
-              <a:t>只有 ApiVersions 例外回錯誤碼+支援範圍；其他 API 直接關閉連線   ✓</a:t>
+              <a:rPr sz="1600" b="0">
+                <a:solidFill>
+                  <a:srgbClr val="1E2024"/>
+                </a:solidFill>
+                <a:latin typeface="Calibri"/>
+              </a:rPr>
+              <a:t>只有 ApiVersions 例外回錯誤碼+支援範圍；其他 API 直接關閉連線</a:t>
             </a:r>
           </a:p>
         </p:txBody>
@@ -4849,85 +4879,13 @@
           <a:lstStyle/>
           <a:p>
             <a:r>
-              <a:rPr sz="1400" b="1">
-                <a:solidFill>
-                  <a:srgbClr val="27500A"/>
-                </a:solidFill>
-                <a:latin typeface="Calibri"/>
-              </a:rPr>
-              <a:t>正解 B — </a:t>
-            </a:r>
-            <a:r>
               <a:rPr sz="1400" b="0">
                 <a:solidFill>
-                  <a:srgbClr val="1E2024"/>
-                </a:solidFill>
-                <a:latin typeface="Calibri"/>
-              </a:rPr>
-              <a:t>ApiVersions 是協商的第一支 request（此時雙方還不知道彼此版本），若它也關線，client 永遠問不到支援範圍，故回 v0+錯誤碼讓 client 重新協商；其他 API 在 RequestContext 解析失敗、SocketServer 關閉連線。</a:t>
-            </a:r>
-          </a:p>
-        </p:txBody>
-      </p:sp>
-      <p:sp>
-        <p:nvSpPr>
-          <p:cNvPr id="9" name="TextBox 8"/>
-          <p:cNvSpPr txBox="1"/>
-          <p:nvPr/>
-        </p:nvSpPr>
-        <p:spPr>
-          <a:xfrm>
-            <a:off x="640080" y="6400800"/>
-            <a:ext cx="10972800" cy="384048"/>
-          </a:xfrm>
-          <a:prstGeom prst="rect">
-            <a:avLst/>
-          </a:prstGeom>
-          <a:noFill/>
-        </p:spPr>
-        <p:txBody>
-          <a:bodyPr wrap="square">
-            <a:noAutofit/>
-          </a:bodyPr>
-          <a:lstStyle/>
-          <a:p>
-            <a:r>
-              <a:rPr sz="1200" b="1">
-                <a:solidFill>
                   <a:srgbClr val="8A8A8A"/>
                 </a:solidFill>
                 <a:latin typeface="Calibri"/>
               </a:rPr>
-              <a:t>REF   </a:t>
-            </a:r>
-            <a:r>
-              <a:rPr sz="1200" b="0" u="sng">
-                <a:solidFill>
-                  <a:srgbClr val="185FA5"/>
-                </a:solidFill>
-                <a:latin typeface="Courier New"/>
-                <a:hlinkClick r:id="rId2"/>
-              </a:rPr>
-              <a:t>RequestContext.java:112</a:t>
-            </a:r>
-            <a:r>
-              <a:rPr sz="1200" b="0">
-                <a:solidFill>
-                  <a:srgbClr val="8A8A8A"/>
-                </a:solidFill>
-                <a:latin typeface="Calibri"/>
-              </a:rPr>
-              <a:t>   ·   </a:t>
-            </a:r>
-            <a:r>
-              <a:rPr sz="1200" b="0" u="sng">
-                <a:solidFill>
-                  <a:srgbClr val="185FA5"/>
-                </a:solidFill>
-                <a:latin typeface="Courier New"/>
-                <a:hlinkClick r:id="rId3"/>
-              </a:rPr>
-              <a:t>SocketServer.scala:781</a:t>
+              <a:t>想一想 —— 下一頁公布答案</a:t>
             </a:r>
           </a:p>
         </p:txBody>
@@ -4979,6 +4937,375 @@
                 </a:solidFill>
                 <a:latin typeface="Calibri"/>
               </a:rPr>
+              <a:t>隨堂考 · 核心　（正解）</a:t>
+            </a:r>
+          </a:p>
+        </p:txBody>
+      </p:sp>
+      <p:sp>
+        <p:nvSpPr>
+          <p:cNvPr id="3" name="TextBox 2"/>
+          <p:cNvSpPr txBox="1"/>
+          <p:nvPr/>
+        </p:nvSpPr>
+        <p:spPr>
+          <a:xfrm>
+            <a:off x="640080" y="841248"/>
+            <a:ext cx="10972800" cy="1188720"/>
+          </a:xfrm>
+          <a:prstGeom prst="rect">
+            <a:avLst/>
+          </a:prstGeom>
+          <a:noFill/>
+        </p:spPr>
+        <p:txBody>
+          <a:bodyPr wrap="square">
+            <a:noAutofit/>
+          </a:bodyPr>
+          <a:lstStyle/>
+          <a:p>
+            <a:r>
+              <a:rPr sz="2600" b="1">
+                <a:solidFill>
+                  <a:srgbClr val="1E2024"/>
+                </a:solidFill>
+                <a:latin typeface="Calibri"/>
+              </a:rPr>
+              <a:t>client 繞過協商、直接送出 broker 不支援的 API version，會怎樣？</a:t>
+            </a:r>
+          </a:p>
+        </p:txBody>
+      </p:sp>
+      <p:sp>
+        <p:nvSpPr>
+          <p:cNvPr id="4" name="TextBox 3"/>
+          <p:cNvSpPr txBox="1"/>
+          <p:nvPr/>
+        </p:nvSpPr>
+        <p:spPr>
+          <a:xfrm>
+            <a:off x="822960" y="2331720"/>
+            <a:ext cx="10515600" cy="493776"/>
+          </a:xfrm>
+          <a:prstGeom prst="rect">
+            <a:avLst/>
+          </a:prstGeom>
+          <a:noFill/>
+        </p:spPr>
+        <p:txBody>
+          <a:bodyPr wrap="square">
+            <a:noAutofit/>
+          </a:bodyPr>
+          <a:lstStyle/>
+          <a:p>
+            <a:r>
+              <a:rPr sz="1600" b="0">
+                <a:solidFill>
+                  <a:srgbClr val="1E2024"/>
+                </a:solidFill>
+                <a:latin typeface="Calibri"/>
+              </a:rPr>
+              <a:t>A.  </a:t>
+            </a:r>
+            <a:r>
+              <a:rPr sz="1600" b="0">
+                <a:solidFill>
+                  <a:srgbClr val="1E2024"/>
+                </a:solidFill>
+                <a:latin typeface="Calibri"/>
+              </a:rPr>
+              <a:t>一律回 UNSUPPORTED_VERSION 錯誤碼</a:t>
+            </a:r>
+          </a:p>
+        </p:txBody>
+      </p:sp>
+      <p:sp>
+        <p:nvSpPr>
+          <p:cNvPr id="5" name="TextBox 4"/>
+          <p:cNvSpPr txBox="1"/>
+          <p:nvPr/>
+        </p:nvSpPr>
+        <p:spPr>
+          <a:xfrm>
+            <a:off x="822960" y="2953512"/>
+            <a:ext cx="10515600" cy="493776"/>
+          </a:xfrm>
+          <a:prstGeom prst="rect">
+            <a:avLst/>
+          </a:prstGeom>
+          <a:solidFill>
+            <a:srgbClr val="E9F3DE"/>
+          </a:solidFill>
+          <a:ln>
+            <a:noFill/>
+          </a:ln>
+        </p:spPr>
+        <p:txBody>
+          <a:bodyPr wrap="square" lIns="128016" tIns="54864">
+            <a:noAutofit/>
+          </a:bodyPr>
+          <a:lstStyle/>
+          <a:p>
+            <a:r>
+              <a:rPr sz="1600" b="1">
+                <a:solidFill>
+                  <a:srgbClr val="27500A"/>
+                </a:solidFill>
+                <a:latin typeface="Calibri"/>
+              </a:rPr>
+              <a:t>B.  </a:t>
+            </a:r>
+            <a:r>
+              <a:rPr sz="1600" b="1">
+                <a:solidFill>
+                  <a:srgbClr val="27500A"/>
+                </a:solidFill>
+                <a:latin typeface="Calibri"/>
+              </a:rPr>
+              <a:t>只有 ApiVersions 例外回錯誤碼+支援範圍；其他 API 直接關閉連線   ✓</a:t>
+            </a:r>
+          </a:p>
+        </p:txBody>
+      </p:sp>
+      <p:sp>
+        <p:nvSpPr>
+          <p:cNvPr id="6" name="TextBox 5"/>
+          <p:cNvSpPr txBox="1"/>
+          <p:nvPr/>
+        </p:nvSpPr>
+        <p:spPr>
+          <a:xfrm>
+            <a:off x="822960" y="3575304"/>
+            <a:ext cx="10515600" cy="493776"/>
+          </a:xfrm>
+          <a:prstGeom prst="rect">
+            <a:avLst/>
+          </a:prstGeom>
+          <a:noFill/>
+        </p:spPr>
+        <p:txBody>
+          <a:bodyPr wrap="square">
+            <a:noAutofit/>
+          </a:bodyPr>
+          <a:lstStyle/>
+          <a:p>
+            <a:r>
+              <a:rPr sz="1600" b="0">
+                <a:solidFill>
+                  <a:srgbClr val="1E2024"/>
+                </a:solidFill>
+                <a:latin typeface="Calibri"/>
+              </a:rPr>
+              <a:t>C.  </a:t>
+            </a:r>
+            <a:r>
+              <a:rPr sz="1600" b="0">
+                <a:solidFill>
+                  <a:srgbClr val="1E2024"/>
+                </a:solidFill>
+                <a:latin typeface="Calibri"/>
+              </a:rPr>
+              <a:t>broker 自動降版處理</a:t>
+            </a:r>
+          </a:p>
+        </p:txBody>
+      </p:sp>
+      <p:sp>
+        <p:nvSpPr>
+          <p:cNvPr id="7" name="TextBox 6"/>
+          <p:cNvSpPr txBox="1"/>
+          <p:nvPr/>
+        </p:nvSpPr>
+        <p:spPr>
+          <a:xfrm>
+            <a:off x="822960" y="4197096"/>
+            <a:ext cx="10515600" cy="493776"/>
+          </a:xfrm>
+          <a:prstGeom prst="rect">
+            <a:avLst/>
+          </a:prstGeom>
+          <a:noFill/>
+        </p:spPr>
+        <p:txBody>
+          <a:bodyPr wrap="square">
+            <a:noAutofit/>
+          </a:bodyPr>
+          <a:lstStyle/>
+          <a:p>
+            <a:r>
+              <a:rPr sz="1600" b="0">
+                <a:solidFill>
+                  <a:srgbClr val="1E2024"/>
+                </a:solidFill>
+                <a:latin typeface="Calibri"/>
+              </a:rPr>
+              <a:t>D.  </a:t>
+            </a:r>
+            <a:r>
+              <a:rPr sz="1600" b="0">
+                <a:solidFill>
+                  <a:srgbClr val="1E2024"/>
+                </a:solidFill>
+                <a:latin typeface="Calibri"/>
+              </a:rPr>
+              <a:t>忽略版本照常處理</a:t>
+            </a:r>
+          </a:p>
+        </p:txBody>
+      </p:sp>
+      <p:sp>
+        <p:nvSpPr>
+          <p:cNvPr id="8" name="TextBox 7"/>
+          <p:cNvSpPr txBox="1"/>
+          <p:nvPr/>
+        </p:nvSpPr>
+        <p:spPr>
+          <a:xfrm>
+            <a:off x="640080" y="4910327"/>
+            <a:ext cx="10972800" cy="914400"/>
+          </a:xfrm>
+          <a:prstGeom prst="rect">
+            <a:avLst/>
+          </a:prstGeom>
+          <a:noFill/>
+        </p:spPr>
+        <p:txBody>
+          <a:bodyPr wrap="square">
+            <a:noAutofit/>
+          </a:bodyPr>
+          <a:lstStyle/>
+          <a:p>
+            <a:r>
+              <a:rPr sz="1400" b="1">
+                <a:solidFill>
+                  <a:srgbClr val="27500A"/>
+                </a:solidFill>
+                <a:latin typeface="Calibri"/>
+              </a:rPr>
+              <a:t>正解 B — </a:t>
+            </a:r>
+            <a:r>
+              <a:rPr sz="1400" b="0">
+                <a:solidFill>
+                  <a:srgbClr val="1E2024"/>
+                </a:solidFill>
+                <a:latin typeface="Calibri"/>
+              </a:rPr>
+              <a:t>ApiVersions 是協商的第一支 request（此時雙方還不知道彼此版本），若它也關線，client 永遠問不到支援範圍，故回 v0+錯誤碼讓 client 重新協商；其他 API 在 RequestContext 解析失敗、SocketServer 關閉連線。</a:t>
+            </a:r>
+          </a:p>
+        </p:txBody>
+      </p:sp>
+      <p:sp>
+        <p:nvSpPr>
+          <p:cNvPr id="9" name="TextBox 8"/>
+          <p:cNvSpPr txBox="1"/>
+          <p:nvPr/>
+        </p:nvSpPr>
+        <p:spPr>
+          <a:xfrm>
+            <a:off x="640080" y="6400800"/>
+            <a:ext cx="10972800" cy="384048"/>
+          </a:xfrm>
+          <a:prstGeom prst="rect">
+            <a:avLst/>
+          </a:prstGeom>
+          <a:noFill/>
+        </p:spPr>
+        <p:txBody>
+          <a:bodyPr wrap="square">
+            <a:noAutofit/>
+          </a:bodyPr>
+          <a:lstStyle/>
+          <a:p>
+            <a:r>
+              <a:rPr sz="1200" b="1">
+                <a:solidFill>
+                  <a:srgbClr val="8A8A8A"/>
+                </a:solidFill>
+                <a:latin typeface="Calibri"/>
+              </a:rPr>
+              <a:t>REF   </a:t>
+            </a:r>
+            <a:r>
+              <a:rPr sz="1200" b="0" u="sng">
+                <a:solidFill>
+                  <a:srgbClr val="185FA5"/>
+                </a:solidFill>
+                <a:latin typeface="Courier New"/>
+                <a:hlinkClick r:id="rId2"/>
+              </a:rPr>
+              <a:t>RequestContext.java:112</a:t>
+            </a:r>
+            <a:r>
+              <a:rPr sz="1200" b="0">
+                <a:solidFill>
+                  <a:srgbClr val="8A8A8A"/>
+                </a:solidFill>
+                <a:latin typeface="Calibri"/>
+              </a:rPr>
+              <a:t>   ·   </a:t>
+            </a:r>
+            <a:r>
+              <a:rPr sz="1200" b="0" u="sng">
+                <a:solidFill>
+                  <a:srgbClr val="185FA5"/>
+                </a:solidFill>
+                <a:latin typeface="Courier New"/>
+                <a:hlinkClick r:id="rId3"/>
+              </a:rPr>
+              <a:t>SocketServer.scala:781</a:t>
+            </a:r>
+          </a:p>
+        </p:txBody>
+      </p:sp>
+    </p:spTree>
+  </p:cSld>
+  <p:clrMapOvr>
+    <a:masterClrMapping/>
+  </p:clrMapOvr>
+</p:sld>
+</file>
+
+<file path=ppt/slides/slide16.xml><?xml version="1.0" encoding="utf-8"?>
+<p:sld xmlns:a="http://schemas.openxmlformats.org/drawingml/2006/main" xmlns:p="http://schemas.openxmlformats.org/presentationml/2006/main" xmlns:r="http://schemas.openxmlformats.org/officeDocument/2006/relationships">
+  <p:cSld>
+    <p:spTree>
+      <p:nvGrpSpPr>
+        <p:cNvPr id="1" name=""/>
+        <p:cNvGrpSpPr/>
+        <p:nvPr/>
+      </p:nvGrpSpPr>
+      <p:grpSpPr/>
+      <p:sp>
+        <p:nvSpPr>
+          <p:cNvPr id="2" name="TextBox 1"/>
+          <p:cNvSpPr txBox="1"/>
+          <p:nvPr/>
+        </p:nvSpPr>
+        <p:spPr>
+          <a:xfrm>
+            <a:off x="640080" y="457200"/>
+            <a:ext cx="10972800" cy="365760"/>
+          </a:xfrm>
+          <a:prstGeom prst="rect">
+            <a:avLst/>
+          </a:prstGeom>
+          <a:noFill/>
+        </p:spPr>
+        <p:txBody>
+          <a:bodyPr wrap="square">
+            <a:noAutofit/>
+          </a:bodyPr>
+          <a:lstStyle/>
+          <a:p>
+            <a:r>
+              <a:rPr sz="1300" b="1">
+                <a:solidFill>
+                  <a:srgbClr val="185FA5"/>
+                </a:solidFill>
+                <a:latin typeface="Calibri"/>
+              </a:rPr>
               <a:t>Recap</a:t>
             </a:r>
           </a:p>
@@ -5182,6 +5509,45 @@
                 <a:latin typeface="Calibri"/>
               </a:rPr>
               <a:t>Part 2：協商不出版本 → UnsupportedVersionException（多在送出前中止）；finalize／升降的錯誤交給運行時那場</a:t>
+            </a:r>
+          </a:p>
+        </p:txBody>
+      </p:sp>
+      <p:sp>
+        <p:nvSpPr>
+          <p:cNvPr id="9" name="TextBox 8"/>
+          <p:cNvSpPr txBox="1"/>
+          <p:nvPr/>
+        </p:nvSpPr>
+        <p:spPr>
+          <a:xfrm>
+            <a:off x="640080" y="5769864"/>
+            <a:ext cx="10972800" cy="877824"/>
+          </a:xfrm>
+          <a:prstGeom prst="rect">
+            <a:avLst/>
+          </a:prstGeom>
+          <a:solidFill>
+            <a:srgbClr val="E9F3DE"/>
+          </a:solidFill>
+          <a:ln>
+            <a:noFill/>
+          </a:ln>
+        </p:spPr>
+        <p:txBody>
+          <a:bodyPr wrap="square" lIns="146304" tIns="82296">
+            <a:noAutofit/>
+          </a:bodyPr>
+          <a:lstStyle/>
+          <a:p>
+            <a:r>
+              <a:rPr sz="1500" b="0">
+                <a:solidFill>
+                  <a:srgbClr val="27500A"/>
+                </a:solidFill>
+                <a:latin typeface="Calibri"/>
+              </a:rPr>
+              <a:t>立場：per-API 細粒度協商＋replication 集中治理，是為「client 生態極度分散」量身的取捨——對 Kafka 划算，但不是通用解</a:t>
             </a:r>
           </a:p>
         </p:txBody>
@@ -5673,6 +6039,40 @@
         </p:nvSpPr>
         <p:spPr>
           <a:xfrm>
+            <a:off x="640080" y="4526280"/>
+            <a:ext cx="10972800" cy="731520"/>
+          </a:xfrm>
+          <a:prstGeom prst="rect">
+            <a:avLst/>
+          </a:prstGeom>
+          <a:noFill/>
+        </p:spPr>
+        <p:txBody>
+          <a:bodyPr wrap="square">
+            <a:noAutofit/>
+          </a:bodyPr>
+          <a:lstStyle/>
+          <a:p>
+            <a:r>
+              <a:rPr sz="1500" b="0">
+                <a:solidFill>
+                  <a:srgbClr val="5F5E5A"/>
+                </a:solidFill>
+                <a:latin typeface="Calibri"/>
+              </a:rPr>
+              <a:t>預告：拆開版本也不是免費的——Kafka 為此揹上每支 API 一組 [min,max] 版本矩陣；MongoDB／PostgreSQL 選擇只維護一個全域版本號。結尾會回來評這筆帳。</a:t>
+            </a:r>
+          </a:p>
+        </p:txBody>
+      </p:sp>
+      <p:sp>
+        <p:nvSpPr>
+          <p:cNvPr id="10" name="TextBox 9"/>
+          <p:cNvSpPr txBox="1"/>
+          <p:nvPr/>
+        </p:nvSpPr>
+        <p:spPr>
+          <a:xfrm>
             <a:off x="640080" y="6400800"/>
             <a:ext cx="10972800" cy="384048"/>
           </a:xfrm>
@@ -6933,7 +7333,7 @@
         <p:spPr>
           <a:xfrm>
             <a:off x="640080" y="4782312"/>
-            <a:ext cx="10972800" cy="877824"/>
+            <a:ext cx="10972800" cy="1188720"/>
           </a:xfrm>
           <a:prstGeom prst="rect">
             <a:avLst/>
@@ -6958,7 +7358,7 @@
                 </a:solidFill>
                 <a:latin typeface="Calibri"/>
               </a:rPr>
-              <a:t>為什麼 replication 例外？它要求所有 follower↔leader 講同一版，才交給 finalized MV 集中決定；其餘連線點對點，各自挑最好版即可</a:t>
+              <a:t>為什麼 replication 例外？它要求所有 follower↔leader 講同一版，才交給 finalized MV 集中決定；帳單是升級變兩階段（先滾 binary、再 finalize）——一致性拿彈性換</a:t>
             </a:r>
           </a:p>
         </p:txBody>
@@ -6971,7 +7371,7 @@
         </p:nvSpPr>
         <p:spPr>
           <a:xfrm>
-            <a:off x="640080" y="5843016"/>
+            <a:off x="640080" y="6153912"/>
             <a:ext cx="10972800" cy="438912"/>
           </a:xfrm>
           <a:prstGeom prst="rect">
@@ -7126,7 +7526,7 @@
                 </a:solidFill>
                 <a:latin typeface="Calibri"/>
               </a:rPr>
-              <a:t>Part 1 · 舉例</a:t>
+              <a:t>Part 1 · 對照</a:t>
             </a:r>
           </a:p>
         </p:txBody>
@@ -7139,28 +7539,28 @@
         </p:nvSpPr>
         <p:spPr>
           <a:xfrm>
-            <a:off x="640080" y="822960"/>
-            <a:ext cx="10972800" cy="640080"/>
-          </a:xfrm>
-          <a:prstGeom prst="rect">
-            <a:avLst/>
-          </a:prstGeom>
-          <a:noFill/>
-        </p:spPr>
-        <p:txBody>
-          <a:bodyPr wrap="square">
-            <a:noAutofit/>
-          </a:bodyPr>
-          <a:lstStyle/>
-          <a:p>
-            <a:r>
-              <a:rPr sz="2900" b="1">
+            <a:off x="640080" y="841248"/>
+            <a:ext cx="10972800" cy="1005840"/>
+          </a:xfrm>
+          <a:prstGeom prst="rect">
+            <a:avLst/>
+          </a:prstGeom>
+          <a:noFill/>
+        </p:spPr>
+        <p:txBody>
+          <a:bodyPr wrap="square">
+            <a:noAutofit/>
+          </a:bodyPr>
+          <a:lstStyle/>
+          <a:p>
+            <a:r>
+              <a:rPr sz="3200" b="1">
                 <a:solidFill>
                   <a:srgbClr val="1E2024"/>
                 </a:solidFill>
                 <a:latin typeface="Calibri"/>
               </a:rPr>
-              <a:t>以一支 Fetch 為例：consumer 協商、replica 由 MV</a:t>
+              <a:t>同一道題，別家怎麼答</a:t>
             </a:r>
           </a:p>
         </p:txBody>
@@ -7173,59 +7573,137 @@
         </p:nvSpPr>
         <p:spPr>
           <a:xfrm>
-            <a:off x="640080" y="1481328"/>
-            <a:ext cx="10972800" cy="365760"/>
-          </a:xfrm>
-          <a:prstGeom prst="rect">
-            <a:avLst/>
-          </a:prstGeom>
-          <a:noFill/>
-        </p:spPr>
-        <p:txBody>
-          <a:bodyPr wrap="square">
-            <a:noAutofit/>
-          </a:bodyPr>
-          <a:lstStyle/>
-          <a:p>
-            <a:r>
-              <a:rPr sz="1400" b="0">
+            <a:off x="640080" y="2148840"/>
+            <a:ext cx="10972800" cy="1645920"/>
+          </a:xfrm>
+          <a:prstGeom prst="rect">
+            <a:avLst/>
+          </a:prstGeom>
+          <a:solidFill>
+            <a:srgbClr val="F3F1EC"/>
+          </a:solidFill>
+          <a:ln w="6350">
+            <a:solidFill>
+              <a:srgbClr val="E3E0D8"/>
+            </a:solidFill>
+          </a:ln>
+        </p:spPr>
+        <p:txBody>
+          <a:bodyPr wrap="square" lIns="146304" tIns="91440" bIns="91440">
+            <a:noAutofit/>
+          </a:bodyPr>
+          <a:lstStyle/>
+          <a:p>
+            <a:r>
+              <a:rPr sz="1350" b="0">
+                <a:solidFill>
+                  <a:srgbClr val="2C2C2A"/>
+                </a:solidFill>
+                <a:latin typeface="Calibri"/>
+              </a:rPr>
+              <a:t>Kafka        per-API 協商 + MV 治理 replication      粒度最細、協定面積最大</a:t>
+            </a:r>
+          </a:p>
+          <a:p>
+            <a:r>
+              <a:rPr sz="1350" b="0">
+                <a:solidFill>
+                  <a:srgbClr val="2C2C2A"/>
+                </a:solidFill>
+                <a:latin typeface="Calibri"/>
+              </a:rPr>
+              <a:t>MongoDB      全域 wire version + FCV 治理叢集         FCV ≈ MV，同一套思路</a:t>
+            </a:r>
+          </a:p>
+          <a:p>
+            <a:r>
+              <a:rPr sz="1350" b="0">
+                <a:solidFill>
+                  <a:srgbClr val="2C2C2A"/>
+                </a:solidFill>
+                <a:latin typeface="Calibri"/>
+              </a:rPr>
+              <a:t>PostgreSQL   協定 v3 逾二十年；實體複製鎖 major 版本   複製層無法滾動升級</a:t>
+            </a:r>
+          </a:p>
+        </p:txBody>
+      </p:sp>
+      <p:sp>
+        <p:nvSpPr>
+          <p:cNvPr id="5" name="TextBox 4"/>
+          <p:cNvSpPr txBox="1"/>
+          <p:nvPr/>
+        </p:nvSpPr>
+        <p:spPr>
+          <a:xfrm>
+            <a:off x="640080" y="3995928"/>
+            <a:ext cx="10972800" cy="877824"/>
+          </a:xfrm>
+          <a:prstGeom prst="rect">
+            <a:avLst/>
+          </a:prstGeom>
+          <a:solidFill>
+            <a:srgbClr val="E9F3DE"/>
+          </a:solidFill>
+          <a:ln>
+            <a:noFill/>
+          </a:ln>
+        </p:spPr>
+        <p:txBody>
+          <a:bodyPr wrap="square" lIns="146304" tIns="82296">
+            <a:noAutofit/>
+          </a:bodyPr>
+          <a:lstStyle/>
+          <a:p>
+            <a:r>
+              <a:rPr sz="1500" b="0">
+                <a:solidFill>
+                  <a:srgbClr val="27500A"/>
+                </a:solidFill>
+                <a:latin typeface="Calibri"/>
+              </a:rPr>
+              <a:t>PostgreSQL 就是「複製層不做版本治理」的反事實——Kafka 的 MV 買到的，正是 PostgreSQL 買不到的線上滾動升級</a:t>
+            </a:r>
+          </a:p>
+        </p:txBody>
+      </p:sp>
+      <p:sp>
+        <p:nvSpPr>
+          <p:cNvPr id="6" name="TextBox 5"/>
+          <p:cNvSpPr txBox="1"/>
+          <p:nvPr/>
+        </p:nvSpPr>
+        <p:spPr>
+          <a:xfrm>
+            <a:off x="640080" y="5056632"/>
+            <a:ext cx="10972800" cy="438912"/>
+          </a:xfrm>
+          <a:prstGeom prst="rect">
+            <a:avLst/>
+          </a:prstGeom>
+          <a:noFill/>
+        </p:spPr>
+        <p:txBody>
+          <a:bodyPr wrap="square">
+            <a:noAutofit/>
+          </a:bodyPr>
+          <a:lstStyle/>
+          <a:p>
+            <a:r>
+              <a:rPr sz="1500" b="0">
                 <a:solidFill>
                   <a:srgbClr val="5F5E5A"/>
                 </a:solidFill>
                 <a:latin typeface="Calibri"/>
               </a:rPr>
-              <a:t>同一支 Fetch 兩種身分：consumer fetch 走 client↔broker、replica fetch 走 broker↔broker</a:t>
-            </a:r>
-          </a:p>
-        </p:txBody>
-      </p:sp>
-      <p:pic>
-        <p:nvPicPr>
-          <p:cNvPr id="5" name="Picture 4" descr="s2a-rangeline.png"/>
-          <p:cNvPicPr>
-            <a:picLocks noChangeAspect="1"/>
-          </p:cNvPicPr>
-          <p:nvPr/>
-        </p:nvPicPr>
-        <p:blipFill>
-          <a:blip r:embed="rId2"/>
-          <a:stretch>
-            <a:fillRect/>
-          </a:stretch>
-        </p:blipFill>
-        <p:spPr>
-          <a:xfrm>
-            <a:off x="1664208" y="1965960"/>
-            <a:ext cx="8869680" cy="4093698"/>
-          </a:xfrm>
-          <a:prstGeom prst="rect">
-            <a:avLst/>
-          </a:prstGeom>
-        </p:spPr>
-      </p:pic>
-      <p:sp>
-        <p:nvSpPr>
-          <p:cNvPr id="6" name="TextBox 5"/>
+              <a:t>細節與來源見 other-systems-comparison.md，本場不展開。</a:t>
+            </a:r>
+          </a:p>
+        </p:txBody>
+      </p:sp>
+      <p:sp>
+        <p:nvSpPr>
+          <p:cNvPr id="7" name="TextBox 6"/>
           <p:cNvSpPr txBox="1"/>
           <p:nvPr/>
         </p:nvSpPr>
@@ -7259,48 +7737,29 @@
                 <a:solidFill>
                   <a:srgbClr val="185FA5"/>
                 </a:solidFill>
-                <a:latin typeface="Courier New"/>
+                <a:latin typeface="Calibri"/>
+                <a:hlinkClick r:id="rId2"/>
+              </a:rPr>
+              <a:t>MongoDB hello / FCV</a:t>
+            </a:r>
+            <a:r>
+              <a:rPr sz="1200" b="0">
+                <a:solidFill>
+                  <a:srgbClr val="8A8A8A"/>
+                </a:solidFill>
+                <a:latin typeface="Calibri"/>
+              </a:rPr>
+              <a:t>   ·   </a:t>
+            </a:r>
+            <a:r>
+              <a:rPr sz="1200" b="0" u="sng">
+                <a:solidFill>
+                  <a:srgbClr val="185FA5"/>
+                </a:solidFill>
+                <a:latin typeface="Calibri"/>
                 <a:hlinkClick r:id="rId3"/>
               </a:rPr>
-              <a:t>forConsumer/forReplica</a:t>
-            </a:r>
-            <a:r>
-              <a:rPr sz="1200" b="0">
-                <a:solidFill>
-                  <a:srgbClr val="8A8A8A"/>
-                </a:solidFill>
-                <a:latin typeface="Calibri"/>
-              </a:rPr>
-              <a:t>   ·   </a:t>
-            </a:r>
-            <a:r>
-              <a:rPr sz="1200" b="0" u="sng">
-                <a:solidFill>
-                  <a:srgbClr val="185FA5"/>
-                </a:solidFill>
-                <a:latin typeface="Courier New"/>
-                <a:hlinkClick r:id="rId4"/>
-              </a:rPr>
-              <a:t>fetchRequestVersion</a:t>
-            </a:r>
-            <a:r>
-              <a:rPr sz="1200" b="0">
-                <a:solidFill>
-                  <a:srgbClr val="8A8A8A"/>
-                </a:solidFill>
-                <a:latin typeface="Calibri"/>
-              </a:rPr>
-              <a:t>   ·   </a:t>
-            </a:r>
-            <a:r>
-              <a:rPr sz="1200" b="0" u="sng">
-                <a:solidFill>
-                  <a:srgbClr val="185FA5"/>
-                </a:solidFill>
-                <a:latin typeface="Courier New"/>
-                <a:hlinkClick r:id="rId5"/>
-              </a:rPr>
-              <a:t>validVersions</a:t>
+              <a:t>PostgreSQL protocol</a:t>
             </a:r>
           </a:p>
         </p:txBody>
@@ -7352,7 +7811,7 @@
                 </a:solidFill>
                 <a:latin typeface="Calibri"/>
               </a:rPr>
-              <a:t>隨堂考 · 核心</a:t>
+              <a:t>Part 1 · 舉例</a:t>
             </a:r>
           </a:p>
         </p:txBody>
@@ -7365,28 +7824,28 @@
         </p:nvSpPr>
         <p:spPr>
           <a:xfrm>
-            <a:off x="640080" y="841248"/>
-            <a:ext cx="10972800" cy="1188720"/>
-          </a:xfrm>
-          <a:prstGeom prst="rect">
-            <a:avLst/>
-          </a:prstGeom>
-          <a:noFill/>
-        </p:spPr>
-        <p:txBody>
-          <a:bodyPr wrap="square">
-            <a:noAutofit/>
-          </a:bodyPr>
-          <a:lstStyle/>
-          <a:p>
-            <a:r>
-              <a:rPr sz="2600" b="1">
+            <a:off x="640080" y="822960"/>
+            <a:ext cx="10972800" cy="640080"/>
+          </a:xfrm>
+          <a:prstGeom prst="rect">
+            <a:avLst/>
+          </a:prstGeom>
+          <a:noFill/>
+        </p:spPr>
+        <p:txBody>
+          <a:bodyPr wrap="square">
+            <a:noAutofit/>
+          </a:bodyPr>
+          <a:lstStyle/>
+          <a:p>
+            <a:r>
+              <a:rPr sz="2900" b="1">
                 <a:solidFill>
                   <a:srgbClr val="1E2024"/>
                 </a:solidFill>
                 <a:latin typeface="Calibri"/>
               </a:rPr>
-              <a:t>replica fetch（broker↔broker）的 Fetch 版本怎麼決定？</a:t>
+              <a:t>以一支 Fetch 為例：consumer 協商、replica 由 MV</a:t>
             </a:r>
           </a:p>
         </p:txBody>
@@ -7399,84 +7858,56 @@
         </p:nvSpPr>
         <p:spPr>
           <a:xfrm>
-            <a:off x="822960" y="2331720"/>
-            <a:ext cx="10515600" cy="493776"/>
-          </a:xfrm>
-          <a:prstGeom prst="rect">
-            <a:avLst/>
-          </a:prstGeom>
-          <a:noFill/>
-        </p:spPr>
-        <p:txBody>
-          <a:bodyPr wrap="square">
-            <a:noAutofit/>
-          </a:bodyPr>
-          <a:lstStyle/>
-          <a:p>
-            <a:r>
-              <a:rPr sz="1600" b="0">
-                <a:solidFill>
-                  <a:srgbClr val="1E2024"/>
-                </a:solidFill>
-                <a:latin typeface="Calibri"/>
-              </a:rPr>
-              <a:t>A.  </a:t>
-            </a:r>
-            <a:r>
-              <a:rPr sz="1600" b="0">
-                <a:solidFill>
-                  <a:srgbClr val="1E2024"/>
-                </a:solidFill>
-                <a:latin typeface="Calibri"/>
-              </a:rPr>
-              <a:t>兩 broker ApiVersions 協商取交集</a:t>
-            </a:r>
-          </a:p>
-        </p:txBody>
-      </p:sp>
-      <p:sp>
-        <p:nvSpPr>
-          <p:cNvPr id="5" name="TextBox 4"/>
-          <p:cNvSpPr txBox="1"/>
-          <p:nvPr/>
-        </p:nvSpPr>
-        <p:spPr>
-          <a:xfrm>
-            <a:off x="822960" y="2953512"/>
-            <a:ext cx="10515600" cy="493776"/>
-          </a:xfrm>
-          <a:prstGeom prst="rect">
-            <a:avLst/>
-          </a:prstGeom>
-          <a:noFill/>
-        </p:spPr>
-        <p:txBody>
-          <a:bodyPr wrap="square">
-            <a:noAutofit/>
-          </a:bodyPr>
-          <a:lstStyle/>
-          <a:p>
-            <a:r>
-              <a:rPr sz="1600" b="0">
-                <a:solidFill>
-                  <a:srgbClr val="1E2024"/>
-                </a:solidFill>
-                <a:latin typeface="Calibri"/>
-              </a:rPr>
-              <a:t>B.  </a:t>
-            </a:r>
-            <a:r>
-              <a:rPr sz="1600" b="0">
-                <a:solidFill>
-                  <a:srgbClr val="1E2024"/>
-                </a:solidFill>
-                <a:latin typeface="Calibri"/>
-              </a:rPr>
-              <a:t>由 finalized metadata.version 決定</a:t>
-            </a:r>
-          </a:p>
-        </p:txBody>
-      </p:sp>
+            <a:off x="640080" y="1481328"/>
+            <a:ext cx="10972800" cy="365760"/>
+          </a:xfrm>
+          <a:prstGeom prst="rect">
+            <a:avLst/>
+          </a:prstGeom>
+          <a:noFill/>
+        </p:spPr>
+        <p:txBody>
+          <a:bodyPr wrap="square">
+            <a:noAutofit/>
+          </a:bodyPr>
+          <a:lstStyle/>
+          <a:p>
+            <a:r>
+              <a:rPr sz="1400" b="0">
+                <a:solidFill>
+                  <a:srgbClr val="5F5E5A"/>
+                </a:solidFill>
+                <a:latin typeface="Calibri"/>
+              </a:rPr>
+              <a:t>同一支 Fetch 兩種身分：consumer fetch 走 client↔broker、replica fetch 走 broker↔broker</a:t>
+            </a:r>
+          </a:p>
+        </p:txBody>
+      </p:sp>
+      <p:pic>
+        <p:nvPicPr>
+          <p:cNvPr id="5" name="Picture 4" descr="s2a-rangeline.png"/>
+          <p:cNvPicPr>
+            <a:picLocks noChangeAspect="1"/>
+          </p:cNvPicPr>
+          <p:nvPr/>
+        </p:nvPicPr>
+        <p:blipFill>
+          <a:blip r:embed="rId2"/>
+          <a:stretch>
+            <a:fillRect/>
+          </a:stretch>
+        </p:blipFill>
+        <p:spPr>
+          <a:xfrm>
+            <a:off x="1664208" y="1965960"/>
+            <a:ext cx="8869680" cy="4093698"/>
+          </a:xfrm>
+          <a:prstGeom prst="rect">
+            <a:avLst/>
+          </a:prstGeom>
+        </p:spPr>
+      </p:pic>
       <p:sp>
         <p:nvSpPr>
           <p:cNvPr id="6" name="TextBox 5"/>
@@ -7485,114 +7916,76 @@
         </p:nvSpPr>
         <p:spPr>
           <a:xfrm>
-            <a:off x="822960" y="3575304"/>
-            <a:ext cx="10515600" cy="493776"/>
-          </a:xfrm>
-          <a:prstGeom prst="rect">
-            <a:avLst/>
-          </a:prstGeom>
-          <a:noFill/>
-        </p:spPr>
-        <p:txBody>
-          <a:bodyPr wrap="square">
-            <a:noAutofit/>
-          </a:bodyPr>
-          <a:lstStyle/>
-          <a:p>
-            <a:r>
-              <a:rPr sz="1600" b="0">
-                <a:solidFill>
-                  <a:srgbClr val="1E2024"/>
-                </a:solidFill>
-                <a:latin typeface="Calibri"/>
-              </a:rPr>
-              <a:t>C.  </a:t>
-            </a:r>
-            <a:r>
-              <a:rPr sz="1600" b="0">
-                <a:solidFill>
-                  <a:srgbClr val="1E2024"/>
-                </a:solidFill>
-                <a:latin typeface="Calibri"/>
-              </a:rPr>
-              <a:t>永遠用最新版</a:t>
-            </a:r>
-          </a:p>
-        </p:txBody>
-      </p:sp>
-      <p:sp>
-        <p:nvSpPr>
-          <p:cNvPr id="7" name="TextBox 6"/>
-          <p:cNvSpPr txBox="1"/>
-          <p:nvPr/>
-        </p:nvSpPr>
-        <p:spPr>
-          <a:xfrm>
-            <a:off x="822960" y="4197096"/>
-            <a:ext cx="10515600" cy="493776"/>
-          </a:xfrm>
-          <a:prstGeom prst="rect">
-            <a:avLst/>
-          </a:prstGeom>
-          <a:noFill/>
-        </p:spPr>
-        <p:txBody>
-          <a:bodyPr wrap="square">
-            <a:noAutofit/>
-          </a:bodyPr>
-          <a:lstStyle/>
-          <a:p>
-            <a:r>
-              <a:rPr sz="1600" b="0">
-                <a:solidFill>
-                  <a:srgbClr val="1E2024"/>
-                </a:solidFill>
-                <a:latin typeface="Calibri"/>
-              </a:rPr>
-              <a:t>D.  </a:t>
-            </a:r>
-            <a:r>
-              <a:rPr sz="1600" b="0">
-                <a:solidFill>
-                  <a:srgbClr val="1E2024"/>
-                </a:solidFill>
-                <a:latin typeface="Calibri"/>
-              </a:rPr>
-              <a:t>controller 每次指定</a:t>
-            </a:r>
-          </a:p>
-        </p:txBody>
-      </p:sp>
-      <p:sp>
-        <p:nvSpPr>
-          <p:cNvPr id="8" name="TextBox 7"/>
-          <p:cNvSpPr txBox="1"/>
-          <p:nvPr/>
-        </p:nvSpPr>
-        <p:spPr>
-          <a:xfrm>
-            <a:off x="640080" y="4910327"/>
-            <a:ext cx="10972800" cy="914400"/>
-          </a:xfrm>
-          <a:prstGeom prst="rect">
-            <a:avLst/>
-          </a:prstGeom>
-          <a:noFill/>
-        </p:spPr>
-        <p:txBody>
-          <a:bodyPr wrap="square">
-            <a:noAutofit/>
-          </a:bodyPr>
-          <a:lstStyle/>
-          <a:p>
-            <a:r>
-              <a:rPr sz="1400" b="0">
+            <a:off x="640080" y="6400800"/>
+            <a:ext cx="10972800" cy="384048"/>
+          </a:xfrm>
+          <a:prstGeom prst="rect">
+            <a:avLst/>
+          </a:prstGeom>
+          <a:noFill/>
+        </p:spPr>
+        <p:txBody>
+          <a:bodyPr wrap="square">
+            <a:noAutofit/>
+          </a:bodyPr>
+          <a:lstStyle/>
+          <a:p>
+            <a:r>
+              <a:rPr sz="1200" b="1">
                 <a:solidFill>
                   <a:srgbClr val="8A8A8A"/>
                 </a:solidFill>
                 <a:latin typeface="Calibri"/>
               </a:rPr>
-              <a:t>想一想 —— 下一頁公布答案</a:t>
+              <a:t>REF   </a:t>
+            </a:r>
+            <a:r>
+              <a:rPr sz="1200" b="0" u="sng">
+                <a:solidFill>
+                  <a:srgbClr val="185FA5"/>
+                </a:solidFill>
+                <a:latin typeface="Courier New"/>
+                <a:hlinkClick r:id="rId3"/>
+              </a:rPr>
+              <a:t>forConsumer/forReplica</a:t>
+            </a:r>
+            <a:r>
+              <a:rPr sz="1200" b="0">
+                <a:solidFill>
+                  <a:srgbClr val="8A8A8A"/>
+                </a:solidFill>
+                <a:latin typeface="Calibri"/>
+              </a:rPr>
+              <a:t>   ·   </a:t>
+            </a:r>
+            <a:r>
+              <a:rPr sz="1200" b="0" u="sng">
+                <a:solidFill>
+                  <a:srgbClr val="185FA5"/>
+                </a:solidFill>
+                <a:latin typeface="Courier New"/>
+                <a:hlinkClick r:id="rId4"/>
+              </a:rPr>
+              <a:t>fetchRequestVersion</a:t>
+            </a:r>
+            <a:r>
+              <a:rPr sz="1200" b="0">
+                <a:solidFill>
+                  <a:srgbClr val="8A8A8A"/>
+                </a:solidFill>
+                <a:latin typeface="Calibri"/>
+              </a:rPr>
+              <a:t>   ·   </a:t>
+            </a:r>
+            <a:r>
+              <a:rPr sz="1200" b="0" u="sng">
+                <a:solidFill>
+                  <a:srgbClr val="185FA5"/>
+                </a:solidFill>
+                <a:latin typeface="Courier New"/>
+                <a:hlinkClick r:id="rId5"/>
+              </a:rPr>
+              <a:t>validVersions</a:t>
             </a:r>
           </a:p>
         </p:txBody>

</xml_diff>

<commit_message>
study(version-control): 套用 Eric 議程/點題/架構a/對照 review
- 議程 Part 1 改「版本為何對不齊，又是怎麼決定的」（broker↔broker 由 MV 事先決定、非連線當下）；移除隨堂考說明句
- 點題移除預告帳單 note；帳單集中到「對照」張講三家各付什麼代價（Kafka 協定面積／Mongo 粒度粗／PG 複製層無法線上升級）
- 架構(a) 標題改「先認識叢集裡的三種連線」，明說不是每條都協商
- 對照移除 other-systems-comparison.md 出處句（該檔不公開）
- blog Part 1 標題同步；talk-outline 同步
</commit_message>
<xml_diff>
--- a/study/version-control/kafka-version-negotiation.pptx
+++ b/study/version-control/kafka-version-negotiation.pptx
@@ -5691,7 +5691,7 @@
                 </a:solidFill>
                 <a:latin typeface="Calibri"/>
               </a:rPr>
-              <a:t>Part 1 — 版本為何要在連線當下決定、又是怎麼選的</a:t>
+              <a:t>Part 1 — 版本為何對不齊，又是怎麼決定的</a:t>
             </a:r>
           </a:p>
         </p:txBody>
@@ -5750,40 +5750,6 @@
                 <a:latin typeface="Calibri"/>
               </a:rPr>
               <a:t>Part 2 — 協商失敗時，會看到什麼訊息</a:t>
-            </a:r>
-          </a:p>
-        </p:txBody>
-      </p:sp>
-      <p:sp>
-        <p:nvSpPr>
-          <p:cNvPr id="8" name="TextBox 7"/>
-          <p:cNvSpPr txBox="1"/>
-          <p:nvPr/>
-        </p:nvSpPr>
-        <p:spPr>
-          <a:xfrm>
-            <a:off x="640080" y="3429000"/>
-            <a:ext cx="10972800" cy="438912"/>
-          </a:xfrm>
-          <a:prstGeom prst="rect">
-            <a:avLst/>
-          </a:prstGeom>
-          <a:noFill/>
-        </p:spPr>
-        <p:txBody>
-          <a:bodyPr wrap="square">
-            <a:noAutofit/>
-          </a:bodyPr>
-          <a:lstStyle/>
-          <a:p>
-            <a:r>
-              <a:rPr sz="1500" b="0">
-                <a:solidFill>
-                  <a:srgbClr val="5F5E5A"/>
-                </a:solidFill>
-                <a:latin typeface="Calibri"/>
-              </a:rPr>
-              <a:t>兩題隨堂考穿插於對應段落；結尾以 Recap 回收開場的問題。</a:t>
             </a:r>
           </a:p>
         </p:txBody>
@@ -6039,40 +6005,6 @@
         </p:nvSpPr>
         <p:spPr>
           <a:xfrm>
-            <a:off x="640080" y="4526280"/>
-            <a:ext cx="10972800" cy="731520"/>
-          </a:xfrm>
-          <a:prstGeom prst="rect">
-            <a:avLst/>
-          </a:prstGeom>
-          <a:noFill/>
-        </p:spPr>
-        <p:txBody>
-          <a:bodyPr wrap="square">
-            <a:noAutofit/>
-          </a:bodyPr>
-          <a:lstStyle/>
-          <a:p>
-            <a:r>
-              <a:rPr sz="1500" b="0">
-                <a:solidFill>
-                  <a:srgbClr val="5F5E5A"/>
-                </a:solidFill>
-                <a:latin typeface="Calibri"/>
-              </a:rPr>
-              <a:t>預告：拆開版本也不是免費的——Kafka 為此揹上每支 API 一組 [min,max] 版本矩陣；MongoDB／PostgreSQL 選擇只維護一個全域版本號。結尾會回來評這筆帳。</a:t>
-            </a:r>
-          </a:p>
-        </p:txBody>
-      </p:sp>
-      <p:sp>
-        <p:nvSpPr>
-          <p:cNvPr id="10" name="TextBox 9"/>
-          <p:cNvSpPr txBox="1"/>
-          <p:nvPr/>
-        </p:nvSpPr>
-        <p:spPr>
-          <a:xfrm>
             <a:off x="640080" y="6400800"/>
             <a:ext cx="10972800" cy="384048"/>
           </a:xfrm>
@@ -6894,7 +6826,7 @@
                 </a:solidFill>
                 <a:latin typeface="Calibri"/>
               </a:rPr>
-              <a:t>三種連線；要協商，先送 ApiVersionsRequest</a:t>
+              <a:t>先認識叢集裡的三種連線</a:t>
             </a:r>
           </a:p>
         </p:txBody>
@@ -6952,7 +6884,7 @@
                 </a:solidFill>
                 <a:latin typeface="Calibri"/>
               </a:rPr>
-              <a:t>連線建立後，發起端先送一支 ApiVersionsRequest，查詢對方「每支 API 支援哪個版本區間？」（KIP-35）</a:t>
+              <a:t>要協商的連線，會在建立後先送一支 ApiVersionsRequest 查詢對方「每支 API 支援哪個版本區間？」（KIP-35）——但不是每條都協商</a:t>
             </a:r>
           </a:p>
         </p:txBody>
@@ -7015,7 +6947,7 @@
                 </a:solidFill>
                 <a:latin typeface="Calibri"/>
               </a:rPr>
-              <a:t>broker ◀▶ broker        partition replication        不查詢（下一張）</a:t>
+              <a:t>broker ◀▶ broker        partition replication        不查詢（下一張說明）</a:t>
             </a:r>
           </a:p>
         </p:txBody>
@@ -7560,74 +7492,35 @@
                 </a:solidFill>
                 <a:latin typeface="Calibri"/>
               </a:rPr>
-              <a:t>同一道題，別家怎麼答</a:t>
-            </a:r>
-          </a:p>
-        </p:txBody>
-      </p:sp>
-      <p:sp>
-        <p:nvSpPr>
-          <p:cNvPr id="4" name="TextBox 3"/>
-          <p:cNvSpPr txBox="1"/>
-          <p:nvPr/>
-        </p:nvSpPr>
-        <p:spPr>
-          <a:xfrm>
-            <a:off x="640080" y="2148840"/>
-            <a:ext cx="10972800" cy="1645920"/>
-          </a:xfrm>
-          <a:prstGeom prst="rect">
-            <a:avLst/>
-          </a:prstGeom>
-          <a:solidFill>
-            <a:srgbClr val="F3F1EC"/>
-          </a:solidFill>
-          <a:ln w="6350">
-            <a:solidFill>
-              <a:srgbClr val="E3E0D8"/>
-            </a:solidFill>
-          </a:ln>
-        </p:spPr>
-        <p:txBody>
-          <a:bodyPr wrap="square" lIns="146304" tIns="91440" bIns="91440">
-            <a:noAutofit/>
-          </a:bodyPr>
-          <a:lstStyle/>
-          <a:p>
-            <a:r>
-              <a:rPr sz="1350" b="0">
-                <a:solidFill>
-                  <a:srgbClr val="2C2C2A"/>
-                </a:solidFill>
-                <a:latin typeface="Calibri"/>
-              </a:rPr>
-              <a:t>Kafka        per-API 協商 + MV 治理 replication      粒度最細、協定面積最大</a:t>
-            </a:r>
-          </a:p>
-          <a:p>
-            <a:r>
-              <a:rPr sz="1350" b="0">
-                <a:solidFill>
-                  <a:srgbClr val="2C2C2A"/>
-                </a:solidFill>
-                <a:latin typeface="Calibri"/>
-              </a:rPr>
-              <a:t>MongoDB      全域 wire version + FCV 治理叢集         FCV ≈ MV，同一套思路</a:t>
-            </a:r>
-          </a:p>
-          <a:p>
-            <a:r>
-              <a:rPr sz="1350" b="0">
-                <a:solidFill>
-                  <a:srgbClr val="2C2C2A"/>
-                </a:solidFill>
-                <a:latin typeface="Calibri"/>
-              </a:rPr>
-              <a:t>PostgreSQL   協定 v3 逾二十年；實體複製鎖 major 版本   複製層無法滾動升級</a:t>
-            </a:r>
-          </a:p>
-        </p:txBody>
-      </p:sp>
+              <a:t>同一道題，別家怎麼答——各付什麼代價</a:t>
+            </a:r>
+          </a:p>
+        </p:txBody>
+      </p:sp>
+      <p:pic>
+        <p:nvPicPr>
+          <p:cNvPr id="4" name="Picture 3" descr="arrows-split.png"/>
+          <p:cNvPicPr>
+            <a:picLocks noChangeAspect="1"/>
+          </p:cNvPicPr>
+          <p:nvPr/>
+        </p:nvPicPr>
+        <p:blipFill>
+          <a:blip r:embed="rId2"/>
+          <a:stretch>
+            <a:fillRect/>
+          </a:stretch>
+        </p:blipFill>
+        <p:spPr>
+          <a:xfrm>
+            <a:off x="658368" y="2176272"/>
+            <a:ext cx="274320" cy="274320"/>
+          </a:xfrm>
+          <a:prstGeom prst="rect">
+            <a:avLst/>
+          </a:prstGeom>
+        </p:spPr>
+      </p:pic>
       <p:sp>
         <p:nvSpPr>
           <p:cNvPr id="5" name="TextBox 4"/>
@@ -7636,7 +7529,157 @@
         </p:nvSpPr>
         <p:spPr>
           <a:xfrm>
-            <a:off x="640080" y="3995928"/>
+            <a:off x="1078992" y="2148840"/>
+            <a:ext cx="10515600" cy="841248"/>
+          </a:xfrm>
+          <a:prstGeom prst="rect">
+            <a:avLst/>
+          </a:prstGeom>
+          <a:noFill/>
+        </p:spPr>
+        <p:txBody>
+          <a:bodyPr wrap="square">
+            <a:noAutofit/>
+          </a:bodyPr>
+          <a:lstStyle/>
+          <a:p>
+            <a:r>
+              <a:rPr sz="1650" b="0">
+                <a:solidFill>
+                  <a:srgbClr val="1E2024"/>
+                </a:solidFill>
+                <a:latin typeface="Calibri"/>
+              </a:rPr>
+              <a:t>Kafka：per-API 協商＋MV 治理 replication。買到單支 API 獨立演進、複製層可線上滾動升級；代價＝協定面積最大、相容性測試按 API 數放大</a:t>
+            </a:r>
+          </a:p>
+        </p:txBody>
+      </p:sp>
+      <p:pic>
+        <p:nvPicPr>
+          <p:cNvPr id="6" name="Picture 5" descr="database.png"/>
+          <p:cNvPicPr>
+            <a:picLocks noChangeAspect="1"/>
+          </p:cNvPicPr>
+          <p:nvPr/>
+        </p:nvPicPr>
+        <p:blipFill>
+          <a:blip r:embed="rId3"/>
+          <a:stretch>
+            <a:fillRect/>
+          </a:stretch>
+        </p:blipFill>
+        <p:spPr>
+          <a:xfrm>
+            <a:off x="658368" y="3163824"/>
+            <a:ext cx="274320" cy="274320"/>
+          </a:xfrm>
+          <a:prstGeom prst="rect">
+            <a:avLst/>
+          </a:prstGeom>
+        </p:spPr>
+      </p:pic>
+      <p:sp>
+        <p:nvSpPr>
+          <p:cNvPr id="7" name="TextBox 6"/>
+          <p:cNvSpPr txBox="1"/>
+          <p:nvPr/>
+        </p:nvSpPr>
+        <p:spPr>
+          <a:xfrm>
+            <a:off x="1078992" y="3136392"/>
+            <a:ext cx="10515600" cy="841248"/>
+          </a:xfrm>
+          <a:prstGeom prst="rect">
+            <a:avLst/>
+          </a:prstGeom>
+          <a:noFill/>
+        </p:spPr>
+        <p:txBody>
+          <a:bodyPr wrap="square">
+            <a:noAutofit/>
+          </a:bodyPr>
+          <a:lstStyle/>
+          <a:p>
+            <a:r>
+              <a:rPr sz="1650" b="0">
+                <a:solidFill>
+                  <a:srgbClr val="1E2024"/>
+                </a:solidFill>
+                <a:latin typeface="Calibri"/>
+              </a:rPr>
+              <a:t>MongoDB：全域一個 wire version＋FCV 治理叢集。實作簡單；代價＝粒度粗、無法單支 API 獨立演進（FCV 與 MV 同一套思路）</a:t>
+            </a:r>
+          </a:p>
+        </p:txBody>
+      </p:sp>
+      <p:pic>
+        <p:nvPicPr>
+          <p:cNvPr id="8" name="Picture 7" descr="leaf.png"/>
+          <p:cNvPicPr>
+            <a:picLocks noChangeAspect="1"/>
+          </p:cNvPicPr>
+          <p:nvPr/>
+        </p:nvPicPr>
+        <p:blipFill>
+          <a:blip r:embed="rId4"/>
+          <a:stretch>
+            <a:fillRect/>
+          </a:stretch>
+        </p:blipFill>
+        <p:spPr>
+          <a:xfrm>
+            <a:off x="658368" y="4151376"/>
+            <a:ext cx="274320" cy="274320"/>
+          </a:xfrm>
+          <a:prstGeom prst="rect">
+            <a:avLst/>
+          </a:prstGeom>
+        </p:spPr>
+      </p:pic>
+      <p:sp>
+        <p:nvSpPr>
+          <p:cNvPr id="9" name="TextBox 8"/>
+          <p:cNvSpPr txBox="1"/>
+          <p:nvPr/>
+        </p:nvSpPr>
+        <p:spPr>
+          <a:xfrm>
+            <a:off x="1078992" y="4123944"/>
+            <a:ext cx="10515600" cy="841248"/>
+          </a:xfrm>
+          <a:prstGeom prst="rect">
+            <a:avLst/>
+          </a:prstGeom>
+          <a:noFill/>
+        </p:spPr>
+        <p:txBody>
+          <a:bodyPr wrap="square">
+            <a:noAutofit/>
+          </a:bodyPr>
+          <a:lstStyle/>
+          <a:p>
+            <a:r>
+              <a:rPr sz="1650" b="0">
+                <a:solidFill>
+                  <a:srgbClr val="1E2024"/>
+                </a:solidFill>
+                <a:latin typeface="Calibri"/>
+              </a:rPr>
+              <a:t>PostgreSQL：協定 v3 逾二十年極穩定；但實體複製鎖 major → 複製層無法線上滾動升級（得停機 pg_upgrade 或另建叢集）</a:t>
+            </a:r>
+          </a:p>
+        </p:txBody>
+      </p:sp>
+      <p:sp>
+        <p:nvSpPr>
+          <p:cNvPr id="10" name="TextBox 9"/>
+          <p:cNvSpPr txBox="1"/>
+          <p:nvPr/>
+        </p:nvSpPr>
+        <p:spPr>
+          <a:xfrm>
+            <a:off x="640080" y="5111496"/>
             <a:ext cx="10972800" cy="877824"/>
           </a:xfrm>
           <a:prstGeom prst="rect">
@@ -7662,48 +7705,14 @@
                 </a:solidFill>
                 <a:latin typeface="Calibri"/>
               </a:rPr>
-              <a:t>PostgreSQL 就是「複製層不做版本治理」的反事實——Kafka 的 MV 買到的，正是 PostgreSQL 買不到的線上滾動升級</a:t>
-            </a:r>
-          </a:p>
-        </p:txBody>
-      </p:sp>
-      <p:sp>
-        <p:nvSpPr>
-          <p:cNvPr id="6" name="TextBox 5"/>
-          <p:cNvSpPr txBox="1"/>
-          <p:nvPr/>
-        </p:nvSpPr>
-        <p:spPr>
-          <a:xfrm>
-            <a:off x="640080" y="5056632"/>
-            <a:ext cx="10972800" cy="438912"/>
-          </a:xfrm>
-          <a:prstGeom prst="rect">
-            <a:avLst/>
-          </a:prstGeom>
-          <a:noFill/>
-        </p:spPr>
-        <p:txBody>
-          <a:bodyPr wrap="square">
-            <a:noAutofit/>
-          </a:bodyPr>
-          <a:lstStyle/>
-          <a:p>
-            <a:r>
-              <a:rPr sz="1500" b="0">
-                <a:solidFill>
-                  <a:srgbClr val="5F5E5A"/>
-                </a:solidFill>
-                <a:latin typeface="Calibri"/>
-              </a:rPr>
-              <a:t>細節與來源見 other-systems-comparison.md，本場不展開。</a:t>
-            </a:r>
-          </a:p>
-        </p:txBody>
-      </p:sp>
-      <p:sp>
-        <p:nvSpPr>
-          <p:cNvPr id="7" name="TextBox 6"/>
+              <a:t>沒有免費的選擇：Kafka 拿協定複雜度換到細粒度演進＋複製層線上升級——後者正是 PostgreSQL 買不到的</a:t>
+            </a:r>
+          </a:p>
+        </p:txBody>
+      </p:sp>
+      <p:sp>
+        <p:nvSpPr>
+          <p:cNvPr id="11" name="TextBox 10"/>
           <p:cNvSpPr txBox="1"/>
           <p:nvPr/>
         </p:nvSpPr>
@@ -7738,7 +7747,7 @@
                   <a:srgbClr val="185FA5"/>
                 </a:solidFill>
                 <a:latin typeface="Calibri"/>
-                <a:hlinkClick r:id="rId2"/>
+                <a:hlinkClick r:id="rId5"/>
               </a:rPr>
               <a:t>MongoDB hello / FCV</a:t>
             </a:r>
@@ -7757,7 +7766,7 @@
                   <a:srgbClr val="185FA5"/>
                 </a:solidFill>
                 <a:latin typeface="Calibri"/>
-                <a:hlinkClick r:id="rId3"/>
+                <a:hlinkClick r:id="rId6"/>
               </a:rPr>
               <a:t>PostgreSQL protocol</a:t>
             </a:r>

</xml_diff>

<commit_message>
study(version-control): 新增 RPC version-range 代價專門頁 + deck「帳單」張
- rpc-range-cost.md：Kafka per-API range 協商的工程代價帳單（90 API×308 版本、~18× 生成碼、
  23 broker 版本相容測試、tagged fields 硬約束、KIP-896 自白），headline 數字皆親自 grep 驗過
- deck 新增「Part 1 · 帳單」張（放對照之後、Part 1 收尾）；16 張
- 數字實測：94 Request.json（4 除役→90 現役）、308 現役 wire 版本、生成碼約 18 萬行
</commit_message>
<xml_diff>
--- a/study/version-control/kafka-version-negotiation.pptx
+++ b/study/version-control/kafka-version-negotiation.pptx
@@ -20,6 +20,7 @@
     <p:sldId id="268" r:id="rId19"/>
     <p:sldId id="269" r:id="rId20"/>
     <p:sldId id="270" r:id="rId21"/>
+    <p:sldId id="271" r:id="rId22"/>
   </p:sldIdLst>
   <p:sldSz cx="12191695" cy="6858000" type="screen4x3"/>
   <p:notesSz cx="6858000" cy="9144000"/>
@@ -3328,7 +3329,7 @@
                 </a:solidFill>
                 <a:latin typeface="Calibri"/>
               </a:rPr>
-              <a:t>隨堂考 · 核心　（正解）</a:t>
+              <a:t>隨堂考 · 核心</a:t>
             </a:r>
           </a:p>
         </p:txBody>
@@ -3424,36 +3425,31 @@
           <a:prstGeom prst="rect">
             <a:avLst/>
           </a:prstGeom>
-          <a:solidFill>
-            <a:srgbClr val="E9F3DE"/>
-          </a:solidFill>
-          <a:ln>
-            <a:noFill/>
-          </a:ln>
-        </p:spPr>
-        <p:txBody>
-          <a:bodyPr wrap="square" lIns="128016" tIns="54864">
-            <a:noAutofit/>
-          </a:bodyPr>
-          <a:lstStyle/>
-          <a:p>
-            <a:r>
-              <a:rPr sz="1600" b="1">
-                <a:solidFill>
-                  <a:srgbClr val="27500A"/>
+          <a:noFill/>
+        </p:spPr>
+        <p:txBody>
+          <a:bodyPr wrap="square">
+            <a:noAutofit/>
+          </a:bodyPr>
+          <a:lstStyle/>
+          <a:p>
+            <a:r>
+              <a:rPr sz="1600" b="0">
+                <a:solidFill>
+                  <a:srgbClr val="1E2024"/>
                 </a:solidFill>
                 <a:latin typeface="Calibri"/>
               </a:rPr>
               <a:t>B.  </a:t>
             </a:r>
             <a:r>
-              <a:rPr sz="1600" b="1">
-                <a:solidFill>
-                  <a:srgbClr val="27500A"/>
-                </a:solidFill>
-                <a:latin typeface="Calibri"/>
-              </a:rPr>
-              <a:t>由 finalized metadata.version 決定   ✓</a:t>
+              <a:rPr sz="1600" b="0">
+                <a:solidFill>
+                  <a:srgbClr val="1E2024"/>
+                </a:solidFill>
+                <a:latin typeface="Calibri"/>
+              </a:rPr>
+              <a:t>由 finalized metadata.version 決定</a:t>
             </a:r>
           </a:p>
         </p:txBody>
@@ -3567,85 +3563,13 @@
           <a:lstStyle/>
           <a:p>
             <a:r>
-              <a:rPr sz="1400" b="1">
-                <a:solidFill>
-                  <a:srgbClr val="27500A"/>
-                </a:solidFill>
-                <a:latin typeface="Calibri"/>
-              </a:rPr>
-              <a:t>正解 B — </a:t>
-            </a:r>
-            <a:r>
               <a:rPr sz="1400" b="0">
                 <a:solidFill>
-                  <a:srgbClr val="1E2024"/>
-                </a:solidFill>
-                <a:latin typeface="Calibri"/>
-              </a:rPr>
-              <a:t>fetchRequestVersion(MV)：MV 是集中共識，不做 per-connection 協商。</a:t>
-            </a:r>
-          </a:p>
-        </p:txBody>
-      </p:sp>
-      <p:sp>
-        <p:nvSpPr>
-          <p:cNvPr id="9" name="TextBox 8"/>
-          <p:cNvSpPr txBox="1"/>
-          <p:nvPr/>
-        </p:nvSpPr>
-        <p:spPr>
-          <a:xfrm>
-            <a:off x="640080" y="6400800"/>
-            <a:ext cx="10972800" cy="384048"/>
-          </a:xfrm>
-          <a:prstGeom prst="rect">
-            <a:avLst/>
-          </a:prstGeom>
-          <a:noFill/>
-        </p:spPr>
-        <p:txBody>
-          <a:bodyPr wrap="square">
-            <a:noAutofit/>
-          </a:bodyPr>
-          <a:lstStyle/>
-          <a:p>
-            <a:r>
-              <a:rPr sz="1200" b="1">
-                <a:solidFill>
                   <a:srgbClr val="8A8A8A"/>
                 </a:solidFill>
                 <a:latin typeface="Calibri"/>
               </a:rPr>
-              <a:t>REF   </a:t>
-            </a:r>
-            <a:r>
-              <a:rPr sz="1200" b="0" u="sng">
-                <a:solidFill>
-                  <a:srgbClr val="185FA5"/>
-                </a:solidFill>
-                <a:latin typeface="Courier New"/>
-                <a:hlinkClick r:id="rId2"/>
-              </a:rPr>
-              <a:t>RemoteLeaderEndPoint.scala:215</a:t>
-            </a:r>
-            <a:r>
-              <a:rPr sz="1200" b="0">
-                <a:solidFill>
-                  <a:srgbClr val="8A8A8A"/>
-                </a:solidFill>
-                <a:latin typeface="Calibri"/>
-              </a:rPr>
-              <a:t>   ·   </a:t>
-            </a:r>
-            <a:r>
-              <a:rPr sz="1200" b="0" u="sng">
-                <a:solidFill>
-                  <a:srgbClr val="185FA5"/>
-                </a:solidFill>
-                <a:latin typeface="Courier New"/>
-                <a:hlinkClick r:id="rId3"/>
-              </a:rPr>
-              <a:t>MetadataVersion.java:273</a:t>
+              <a:t>想一想 —— 下一頁公布答案</a:t>
             </a:r>
           </a:p>
         </p:txBody>
@@ -3697,7 +3621,7 @@
                 </a:solidFill>
                 <a:latin typeface="Calibri"/>
               </a:rPr>
-              <a:t>Part 2 · 失敗訊息</a:t>
+              <a:t>隨堂考 · 核心　（正解）</a:t>
             </a:r>
           </a:p>
         </p:txBody>
@@ -3711,7 +3635,7 @@
         <p:spPr>
           <a:xfrm>
             <a:off x="640080" y="841248"/>
-            <a:ext cx="10972800" cy="1005840"/>
+            <a:ext cx="10972800" cy="1188720"/>
           </a:xfrm>
           <a:prstGeom prst="rect">
             <a:avLst/>
@@ -3725,13 +3649,13 @@
           <a:lstStyle/>
           <a:p>
             <a:r>
-              <a:rPr sz="3200" b="1">
+              <a:rPr sz="2600" b="1">
                 <a:solidFill>
                   <a:srgbClr val="1E2024"/>
                 </a:solidFill>
                 <a:latin typeface="Calibri"/>
               </a:rPr>
-              <a:t>通訊當下協商不出版本，會看到什麼</a:t>
+              <a:t>replica fetch（broker↔broker）的 Fetch 版本怎麼決定？</a:t>
             </a:r>
           </a:p>
         </p:txBody>
@@ -3744,85 +3668,89 @@
         </p:nvSpPr>
         <p:spPr>
           <a:xfrm>
-            <a:off x="640080" y="2148840"/>
-            <a:ext cx="10972800" cy="1371600"/>
+            <a:off x="822960" y="2331720"/>
+            <a:ext cx="10515600" cy="493776"/>
+          </a:xfrm>
+          <a:prstGeom prst="rect">
+            <a:avLst/>
+          </a:prstGeom>
+          <a:noFill/>
+        </p:spPr>
+        <p:txBody>
+          <a:bodyPr wrap="square">
+            <a:noAutofit/>
+          </a:bodyPr>
+          <a:lstStyle/>
+          <a:p>
+            <a:r>
+              <a:rPr sz="1600" b="0">
+                <a:solidFill>
+                  <a:srgbClr val="1E2024"/>
+                </a:solidFill>
+                <a:latin typeface="Calibri"/>
+              </a:rPr>
+              <a:t>A.  </a:t>
+            </a:r>
+            <a:r>
+              <a:rPr sz="1600" b="0">
+                <a:solidFill>
+                  <a:srgbClr val="1E2024"/>
+                </a:solidFill>
+                <a:latin typeface="Calibri"/>
+              </a:rPr>
+              <a:t>兩 broker ApiVersions 協商取交集</a:t>
+            </a:r>
+          </a:p>
+        </p:txBody>
+      </p:sp>
+      <p:sp>
+        <p:nvSpPr>
+          <p:cNvPr id="5" name="TextBox 4"/>
+          <p:cNvSpPr txBox="1"/>
+          <p:nvPr/>
+        </p:nvSpPr>
+        <p:spPr>
+          <a:xfrm>
+            <a:off x="822960" y="2953512"/>
+            <a:ext cx="10515600" cy="493776"/>
           </a:xfrm>
           <a:prstGeom prst="rect">
             <a:avLst/>
           </a:prstGeom>
           <a:solidFill>
-            <a:srgbClr val="F3F1EC"/>
+            <a:srgbClr val="E9F3DE"/>
           </a:solidFill>
-          <a:ln w="6350">
-            <a:solidFill>
-              <a:srgbClr val="E3E0D8"/>
-            </a:solidFill>
+          <a:ln>
+            <a:noFill/>
           </a:ln>
         </p:spPr>
         <p:txBody>
-          <a:bodyPr wrap="square" lIns="146304" tIns="91440" bIns="91440">
-            <a:noAutofit/>
-          </a:bodyPr>
-          <a:lstStyle/>
-          <a:p>
-            <a:r>
-              <a:rPr sz="1350" b="0">
-                <a:solidFill>
-                  <a:srgbClr val="2C2C2A"/>
-                </a:solidFill>
-                <a:latin typeface="Calibri"/>
-              </a:rPr>
-              <a:t>交集空              → client 端 UnsupportedVersionException（送出前 abort）</a:t>
-            </a:r>
-          </a:p>
-          <a:p>
-            <a:r>
-              <a:rPr sz="1350" b="0">
-                <a:solidFill>
-                  <a:srgbClr val="2C2C2A"/>
-                </a:solidFill>
-                <a:latin typeface="Calibri"/>
-              </a:rPr>
-              <a:t>直送不支援的版本    → broker 丟 UnsupportedVersionException、關閉連線</a:t>
-            </a:r>
-          </a:p>
-          <a:p>
-            <a:r>
-              <a:rPr sz="1350" b="0">
-                <a:solidFill>
-                  <a:srgbClr val="2C2C2A"/>
-                </a:solidFill>
-                <a:latin typeface="Calibri"/>
-              </a:rPr>
-              <a:t>（ApiVersions 例外：回 v0 + UNSUPPORTED_VERSION 錯誤碼）</a:t>
-            </a:r>
-          </a:p>
-        </p:txBody>
-      </p:sp>
-      <p:pic>
-        <p:nvPicPr>
-          <p:cNvPr id="5" name="Picture 4" descr="ban.png"/>
-          <p:cNvPicPr>
-            <a:picLocks noChangeAspect="1"/>
-          </p:cNvPicPr>
-          <p:nvPr/>
-        </p:nvPicPr>
-        <p:blipFill>
-          <a:blip r:embed="rId2"/>
-          <a:stretch>
-            <a:fillRect/>
-          </a:stretch>
-        </p:blipFill>
-        <p:spPr>
-          <a:xfrm>
-            <a:off x="658368" y="3749040"/>
-            <a:ext cx="274320" cy="274320"/>
-          </a:xfrm>
-          <a:prstGeom prst="rect">
-            <a:avLst/>
-          </a:prstGeom>
-        </p:spPr>
-      </p:pic>
+          <a:bodyPr wrap="square" lIns="128016" tIns="54864">
+            <a:noAutofit/>
+          </a:bodyPr>
+          <a:lstStyle/>
+          <a:p>
+            <a:r>
+              <a:rPr sz="1600" b="1">
+                <a:solidFill>
+                  <a:srgbClr val="27500A"/>
+                </a:solidFill>
+                <a:latin typeface="Calibri"/>
+              </a:rPr>
+              <a:t>B.  </a:t>
+            </a:r>
+            <a:r>
+              <a:rPr sz="1600" b="1">
+                <a:solidFill>
+                  <a:srgbClr val="27500A"/>
+                </a:solidFill>
+                <a:latin typeface="Calibri"/>
+              </a:rPr>
+              <a:t>由 finalized metadata.version 決定   ✓</a:t>
+            </a:r>
+          </a:p>
+        </p:txBody>
+      </p:sp>
       <p:sp>
         <p:nvSpPr>
           <p:cNvPr id="6" name="TextBox 5"/>
@@ -3831,7 +3759,7 @@
         </p:nvSpPr>
         <p:spPr>
           <a:xfrm>
-            <a:off x="1078992" y="3721608"/>
+            <a:off x="822960" y="3575304"/>
             <a:ext cx="10515600" cy="493776"/>
           </a:xfrm>
           <a:prstGeom prst="rect">
@@ -3846,13 +3774,22 @@
           <a:lstStyle/>
           <a:p>
             <a:r>
-              <a:rPr sz="1650" b="0">
+              <a:rPr sz="1600" b="0">
                 <a:solidFill>
                   <a:srgbClr val="1E2024"/>
                 </a:solidFill>
                 <a:latin typeface="Calibri"/>
               </a:rPr>
-              <a:t>多數情況 client 在送出前就本地中止，根本沒上網路</a:t>
+              <a:t>C.  </a:t>
+            </a:r>
+            <a:r>
+              <a:rPr sz="1600" b="0">
+                <a:solidFill>
+                  <a:srgbClr val="1E2024"/>
+                </a:solidFill>
+                <a:latin typeface="Calibri"/>
+              </a:rPr>
+              <a:t>永遠用最新版</a:t>
             </a:r>
           </a:p>
         </p:txBody>
@@ -3860,6 +3797,92 @@
       <p:sp>
         <p:nvSpPr>
           <p:cNvPr id="7" name="TextBox 6"/>
+          <p:cNvSpPr txBox="1"/>
+          <p:nvPr/>
+        </p:nvSpPr>
+        <p:spPr>
+          <a:xfrm>
+            <a:off x="822960" y="4197096"/>
+            <a:ext cx="10515600" cy="493776"/>
+          </a:xfrm>
+          <a:prstGeom prst="rect">
+            <a:avLst/>
+          </a:prstGeom>
+          <a:noFill/>
+        </p:spPr>
+        <p:txBody>
+          <a:bodyPr wrap="square">
+            <a:noAutofit/>
+          </a:bodyPr>
+          <a:lstStyle/>
+          <a:p>
+            <a:r>
+              <a:rPr sz="1600" b="0">
+                <a:solidFill>
+                  <a:srgbClr val="1E2024"/>
+                </a:solidFill>
+                <a:latin typeface="Calibri"/>
+              </a:rPr>
+              <a:t>D.  </a:t>
+            </a:r>
+            <a:r>
+              <a:rPr sz="1600" b="0">
+                <a:solidFill>
+                  <a:srgbClr val="1E2024"/>
+                </a:solidFill>
+                <a:latin typeface="Calibri"/>
+              </a:rPr>
+              <a:t>controller 每次指定</a:t>
+            </a:r>
+          </a:p>
+        </p:txBody>
+      </p:sp>
+      <p:sp>
+        <p:nvSpPr>
+          <p:cNvPr id="8" name="TextBox 7"/>
+          <p:cNvSpPr txBox="1"/>
+          <p:nvPr/>
+        </p:nvSpPr>
+        <p:spPr>
+          <a:xfrm>
+            <a:off x="640080" y="4910327"/>
+            <a:ext cx="10972800" cy="914400"/>
+          </a:xfrm>
+          <a:prstGeom prst="rect">
+            <a:avLst/>
+          </a:prstGeom>
+          <a:noFill/>
+        </p:spPr>
+        <p:txBody>
+          <a:bodyPr wrap="square">
+            <a:noAutofit/>
+          </a:bodyPr>
+          <a:lstStyle/>
+          <a:p>
+            <a:r>
+              <a:rPr sz="1400" b="1">
+                <a:solidFill>
+                  <a:srgbClr val="27500A"/>
+                </a:solidFill>
+                <a:latin typeface="Calibri"/>
+              </a:rPr>
+              <a:t>正解 B — </a:t>
+            </a:r>
+            <a:r>
+              <a:rPr sz="1400" b="0">
+                <a:solidFill>
+                  <a:srgbClr val="1E2024"/>
+                </a:solidFill>
+                <a:latin typeface="Calibri"/>
+              </a:rPr>
+              <a:t>fetchRequestVersion(MV)：MV 是集中共識，不做 per-connection 協商。</a:t>
+            </a:r>
+          </a:p>
+        </p:txBody>
+      </p:sp>
+      <p:sp>
+        <p:nvSpPr>
+          <p:cNvPr id="9" name="TextBox 8"/>
           <p:cNvSpPr txBox="1"/>
           <p:nvPr/>
         </p:nvSpPr>
@@ -3894,47 +3917,28 @@
                   <a:srgbClr val="185FA5"/>
                 </a:solidFill>
                 <a:latin typeface="Courier New"/>
+                <a:hlinkClick r:id="rId2"/>
+              </a:rPr>
+              <a:t>RemoteLeaderEndPoint.scala:215</a:t>
+            </a:r>
+            <a:r>
+              <a:rPr sz="1200" b="0">
+                <a:solidFill>
+                  <a:srgbClr val="8A8A8A"/>
+                </a:solidFill>
+                <a:latin typeface="Calibri"/>
+              </a:rPr>
+              <a:t>   ·   </a:t>
+            </a:r>
+            <a:r>
+              <a:rPr sz="1200" b="0" u="sng">
+                <a:solidFill>
+                  <a:srgbClr val="185FA5"/>
+                </a:solidFill>
+                <a:latin typeface="Courier New"/>
                 <a:hlinkClick r:id="rId3"/>
               </a:rPr>
-              <a:t>latestUsableVersion</a:t>
-            </a:r>
-            <a:r>
-              <a:rPr sz="1200" b="0">
-                <a:solidFill>
-                  <a:srgbClr val="8A8A8A"/>
-                </a:solidFill>
-                <a:latin typeface="Calibri"/>
-              </a:rPr>
-              <a:t>   ·   </a:t>
-            </a:r>
-            <a:r>
-              <a:rPr sz="1200" b="0" u="sng">
-                <a:solidFill>
-                  <a:srgbClr val="185FA5"/>
-                </a:solidFill>
-                <a:latin typeface="Courier New"/>
-                <a:hlinkClick r:id="rId4"/>
-              </a:rPr>
-              <a:t>NetworkClient</a:t>
-            </a:r>
-            <a:r>
-              <a:rPr sz="1200" b="0">
-                <a:solidFill>
-                  <a:srgbClr val="8A8A8A"/>
-                </a:solidFill>
-                <a:latin typeface="Calibri"/>
-              </a:rPr>
-              <a:t>   ·   </a:t>
-            </a:r>
-            <a:r>
-              <a:rPr sz="1200" b="0" u="sng">
-                <a:solidFill>
-                  <a:srgbClr val="185FA5"/>
-                </a:solidFill>
-                <a:latin typeface="Courier New"/>
-                <a:hlinkClick r:id="rId5"/>
-              </a:rPr>
-              <a:t>RequestContext</a:t>
+              <a:t>MetadataVersion.java:273</a:t>
             </a:r>
           </a:p>
         </p:txBody>
@@ -4020,79 +4024,21 @@
                 </a:solidFill>
                 <a:latin typeface="Calibri"/>
               </a:rPr>
-              <a:t>版本截斷：為什麼「升一點點」不夠</a:t>
-            </a:r>
-          </a:p>
-        </p:txBody>
-      </p:sp>
-      <p:pic>
-        <p:nvPicPr>
-          <p:cNvPr id="4" name="Picture 3" descr="alert-triangle.png"/>
-          <p:cNvPicPr>
-            <a:picLocks noChangeAspect="1"/>
-          </p:cNvPicPr>
-          <p:nvPr/>
-        </p:nvPicPr>
-        <p:blipFill>
-          <a:blip r:embed="rId2"/>
-          <a:stretch>
-            <a:fillRect/>
-          </a:stretch>
-        </p:blipFill>
-        <p:spPr>
-          <a:xfrm>
-            <a:off x="658368" y="2176272"/>
-            <a:ext cx="274320" cy="274320"/>
-          </a:xfrm>
-          <a:prstGeom prst="rect">
-            <a:avLst/>
-          </a:prstGeom>
-        </p:spPr>
-      </p:pic>
-      <p:sp>
-        <p:nvSpPr>
-          <p:cNvPr id="5" name="TextBox 4"/>
-          <p:cNvSpPr txBox="1"/>
-          <p:nvPr/>
-        </p:nvSpPr>
-        <p:spPr>
-          <a:xfrm>
-            <a:off x="1078992" y="2148840"/>
-            <a:ext cx="10515600" cy="493776"/>
-          </a:xfrm>
-          <a:prstGeom prst="rect">
-            <a:avLst/>
-          </a:prstGeom>
-          <a:noFill/>
-        </p:spPr>
-        <p:txBody>
-          <a:bodyPr wrap="square">
-            <a:noAutofit/>
-          </a:bodyPr>
-          <a:lstStyle/>
-          <a:p>
-            <a:r>
-              <a:rPr sz="1650" b="0">
-                <a:solidFill>
-                  <a:srgbClr val="1E2024"/>
-                </a:solidFill>
-                <a:latin typeface="Calibri"/>
-              </a:rPr>
-              <a:t>前一頁「交集空」最容易被忽略的根因——舊 wire 版本被整批移除</a:t>
-            </a:r>
-          </a:p>
-        </p:txBody>
-      </p:sp>
-      <p:sp>
-        <p:nvSpPr>
-          <p:cNvPr id="6" name="TextBox 5"/>
-          <p:cNvSpPr txBox="1"/>
-          <p:nvPr/>
-        </p:nvSpPr>
-        <p:spPr>
-          <a:xfrm>
-            <a:off x="640080" y="2788920"/>
-            <a:ext cx="10972800" cy="822959"/>
+              <a:t>通訊當下協商不出版本，會看到什麼</a:t>
+            </a:r>
+          </a:p>
+        </p:txBody>
+      </p:sp>
+      <p:sp>
+        <p:nvSpPr>
+          <p:cNvPr id="4" name="TextBox 3"/>
+          <p:cNvSpPr txBox="1"/>
+          <p:nvPr/>
+        </p:nvSpPr>
+        <p:spPr>
+          <a:xfrm>
+            <a:off x="640080" y="2148840"/>
+            <a:ext cx="10972800" cy="1371600"/>
           </a:xfrm>
           <a:prstGeom prst="rect">
             <a:avLst/>
@@ -4119,7 +4065,7 @@
                 </a:solidFill>
                 <a:latin typeface="Calibri"/>
               </a:rPr>
-              <a:t>舊 wire API version 被整個移除，min 可 &gt; 0</a:t>
+              <a:t>交集空              → client 端 UnsupportedVersionException（送出前 abort）</a:t>
             </a:r>
           </a:p>
           <a:p>
@@ -4130,7 +4076,76 @@
                 </a:solidFill>
                 <a:latin typeface="Calibri"/>
               </a:rPr>
-              <a:t>  Fetch：4–18（v0–3 在 4.0 移除）</a:t>
+              <a:t>直送不支援的版本    → broker 丟 UnsupportedVersionException、關閉連線</a:t>
+            </a:r>
+          </a:p>
+          <a:p>
+            <a:r>
+              <a:rPr sz="1350" b="0">
+                <a:solidFill>
+                  <a:srgbClr val="2C2C2A"/>
+                </a:solidFill>
+                <a:latin typeface="Calibri"/>
+              </a:rPr>
+              <a:t>（ApiVersions 例外：回 v0 + UNSUPPORTED_VERSION 錯誤碼）</a:t>
+            </a:r>
+          </a:p>
+        </p:txBody>
+      </p:sp>
+      <p:pic>
+        <p:nvPicPr>
+          <p:cNvPr id="5" name="Picture 4" descr="ban.png"/>
+          <p:cNvPicPr>
+            <a:picLocks noChangeAspect="1"/>
+          </p:cNvPicPr>
+          <p:nvPr/>
+        </p:nvPicPr>
+        <p:blipFill>
+          <a:blip r:embed="rId2"/>
+          <a:stretch>
+            <a:fillRect/>
+          </a:stretch>
+        </p:blipFill>
+        <p:spPr>
+          <a:xfrm>
+            <a:off x="658368" y="3749040"/>
+            <a:ext cx="274320" cy="274320"/>
+          </a:xfrm>
+          <a:prstGeom prst="rect">
+            <a:avLst/>
+          </a:prstGeom>
+        </p:spPr>
+      </p:pic>
+      <p:sp>
+        <p:nvSpPr>
+          <p:cNvPr id="6" name="TextBox 5"/>
+          <p:cNvSpPr txBox="1"/>
+          <p:nvPr/>
+        </p:nvSpPr>
+        <p:spPr>
+          <a:xfrm>
+            <a:off x="1078992" y="3721608"/>
+            <a:ext cx="10515600" cy="493776"/>
+          </a:xfrm>
+          <a:prstGeom prst="rect">
+            <a:avLst/>
+          </a:prstGeom>
+          <a:noFill/>
+        </p:spPr>
+        <p:txBody>
+          <a:bodyPr wrap="square">
+            <a:noAutofit/>
+          </a:bodyPr>
+          <a:lstStyle/>
+          <a:p>
+            <a:r>
+              <a:rPr sz="1650" b="0">
+                <a:solidFill>
+                  <a:srgbClr val="1E2024"/>
+                </a:solidFill>
+                <a:latin typeface="Calibri"/>
+              </a:rPr>
+              <a:t>多數情況 client 在送出前就本地中止，根本沒上網路</a:t>
             </a:r>
           </a:p>
         </p:txBody>
@@ -4138,113 +4153,6 @@
       <p:sp>
         <p:nvSpPr>
           <p:cNvPr id="7" name="TextBox 6"/>
-          <p:cNvSpPr txBox="1"/>
-          <p:nvPr/>
-        </p:nvSpPr>
-        <p:spPr>
-          <a:xfrm>
-            <a:off x="640080" y="3813048"/>
-            <a:ext cx="10972800" cy="877824"/>
-          </a:xfrm>
-          <a:prstGeom prst="rect">
-            <a:avLst/>
-          </a:prstGeom>
-          <a:solidFill>
-            <a:srgbClr val="E9F3DE"/>
-          </a:solidFill>
-          <a:ln>
-            <a:noFill/>
-          </a:ln>
-        </p:spPr>
-        <p:txBody>
-          <a:bodyPr wrap="square" lIns="146304" tIns="82296">
-            <a:noAutofit/>
-          </a:bodyPr>
-          <a:lstStyle/>
-          <a:p>
-            <a:r>
-              <a:rPr sz="1500" b="0">
-                <a:solidFill>
-                  <a:srgbClr val="27500A"/>
-                </a:solidFill>
-                <a:latin typeface="Calibri"/>
-              </a:rPr>
-              <a:t>解法：升任一端到 4.0 前，先確認另一端 ≥ 2.1（upgrade guide 明訂雙向要求），否則協商結果沒有可用版本</a:t>
-            </a:r>
-          </a:p>
-        </p:txBody>
-      </p:sp>
-      <p:sp>
-        <p:nvSpPr>
-          <p:cNvPr id="8" name="TextBox 7"/>
-          <p:cNvSpPr txBox="1"/>
-          <p:nvPr/>
-        </p:nvSpPr>
-        <p:spPr>
-          <a:xfrm>
-            <a:off x="640080" y="4873752"/>
-            <a:ext cx="10972800" cy="731520"/>
-          </a:xfrm>
-          <a:prstGeom prst="rect">
-            <a:avLst/>
-          </a:prstGeom>
-          <a:noFill/>
-        </p:spPr>
-        <p:txBody>
-          <a:bodyPr wrap="square">
-            <a:noAutofit/>
-          </a:bodyPr>
-          <a:lstStyle/>
-          <a:p>
-            <a:r>
-              <a:rPr sz="1500" b="0">
-                <a:solidFill>
-                  <a:srgbClr val="5F5E5A"/>
-                </a:solidFill>
-                <a:latin typeface="Calibri"/>
-              </a:rPr>
-              <a:t>取捨：0.8.0（2013）起九年保留每個版本——每個舊版本都是活的程式碼與測試面；4.0 用「斷 2018 年前的 client」換「刪九年的碼」，只有 major 版本邊界付得起。</a:t>
-            </a:r>
-          </a:p>
-        </p:txBody>
-      </p:sp>
-      <p:sp>
-        <p:nvSpPr>
-          <p:cNvPr id="9" name="TextBox 8"/>
-          <p:cNvSpPr txBox="1"/>
-          <p:nvPr/>
-        </p:nvSpPr>
-        <p:spPr>
-          <a:xfrm>
-            <a:off x="640080" y="5733288"/>
-            <a:ext cx="10972800" cy="731520"/>
-          </a:xfrm>
-          <a:prstGeom prst="rect">
-            <a:avLst/>
-          </a:prstGeom>
-          <a:noFill/>
-        </p:spPr>
-        <p:txBody>
-          <a:bodyPr wrap="square">
-            <a:noAutofit/>
-          </a:bodyPr>
-          <a:lstStyle/>
-          <a:p>
-            <a:r>
-              <a:rPr sz="1500" b="0">
-                <a:solidFill>
-                  <a:srgbClr val="5F5E5A"/>
-                </a:solidFill>
-                <a:latin typeface="Calibri"/>
-              </a:rPr>
-              <a:t>銜接（非本場）：finalize / 升降當下的錯誤（INVALID_UPDATE_VERSION 等）屬「運行時的版本升降」那場，本場不展開。</a:t>
-            </a:r>
-          </a:p>
-        </p:txBody>
-      </p:sp>
-      <p:sp>
-        <p:nvSpPr>
-          <p:cNvPr id="10" name="TextBox 9"/>
           <p:cNvSpPr txBox="1"/>
           <p:nvPr/>
         </p:nvSpPr>
@@ -4281,7 +4189,7 @@
                 <a:latin typeface="Courier New"/>
                 <a:hlinkClick r:id="rId3"/>
               </a:rPr>
-              <a:t>upgrade.md:229</a:t>
+              <a:t>latestUsableVersion</a:t>
             </a:r>
             <a:r>
               <a:rPr sz="1200" b="0">
@@ -4300,7 +4208,26 @@
                 <a:latin typeface="Courier New"/>
                 <a:hlinkClick r:id="rId4"/>
               </a:rPr>
-              <a:t>FetchRequest.json validVersions</a:t>
+              <a:t>NetworkClient</a:t>
+            </a:r>
+            <a:r>
+              <a:rPr sz="1200" b="0">
+                <a:solidFill>
+                  <a:srgbClr val="8A8A8A"/>
+                </a:solidFill>
+                <a:latin typeface="Calibri"/>
+              </a:rPr>
+              <a:t>   ·   </a:t>
+            </a:r>
+            <a:r>
+              <a:rPr sz="1200" b="0" u="sng">
+                <a:solidFill>
+                  <a:srgbClr val="185FA5"/>
+                </a:solidFill>
+                <a:latin typeface="Courier New"/>
+                <a:hlinkClick r:id="rId5"/>
+              </a:rPr>
+              <a:t>RequestContext</a:t>
             </a:r>
           </a:p>
         </p:txBody>
@@ -4352,7 +4279,7 @@
                 </a:solidFill>
                 <a:latin typeface="Calibri"/>
               </a:rPr>
-              <a:t>隨堂考 · 核心</a:t>
+              <a:t>Part 2 · 失敗訊息</a:t>
             </a:r>
           </a:p>
         </p:txBody>
@@ -4366,7 +4293,7 @@
         <p:spPr>
           <a:xfrm>
             <a:off x="640080" y="841248"/>
-            <a:ext cx="10972800" cy="1188720"/>
+            <a:ext cx="10972800" cy="1005840"/>
           </a:xfrm>
           <a:prstGeom prst="rect">
             <a:avLst/>
@@ -4380,26 +4307,50 @@
           <a:lstStyle/>
           <a:p>
             <a:r>
-              <a:rPr sz="2600" b="1">
+              <a:rPr sz="3200" b="1">
                 <a:solidFill>
                   <a:srgbClr val="1E2024"/>
                 </a:solidFill>
                 <a:latin typeface="Calibri"/>
               </a:rPr>
-              <a:t>client 繞過協商、直接送出 broker 不支援的 API version，會怎樣？</a:t>
-            </a:r>
-          </a:p>
-        </p:txBody>
-      </p:sp>
-      <p:sp>
-        <p:nvSpPr>
-          <p:cNvPr id="4" name="TextBox 3"/>
-          <p:cNvSpPr txBox="1"/>
-          <p:nvPr/>
-        </p:nvSpPr>
-        <p:spPr>
-          <a:xfrm>
-            <a:off x="822960" y="2331720"/>
+              <a:t>版本截斷：為什麼「升一點點」不夠</a:t>
+            </a:r>
+          </a:p>
+        </p:txBody>
+      </p:sp>
+      <p:pic>
+        <p:nvPicPr>
+          <p:cNvPr id="4" name="Picture 3" descr="alert-triangle.png"/>
+          <p:cNvPicPr>
+            <a:picLocks noChangeAspect="1"/>
+          </p:cNvPicPr>
+          <p:nvPr/>
+        </p:nvPicPr>
+        <p:blipFill>
+          <a:blip r:embed="rId2"/>
+          <a:stretch>
+            <a:fillRect/>
+          </a:stretch>
+        </p:blipFill>
+        <p:spPr>
+          <a:xfrm>
+            <a:off x="658368" y="2176272"/>
+            <a:ext cx="274320" cy="274320"/>
+          </a:xfrm>
+          <a:prstGeom prst="rect">
+            <a:avLst/>
+          </a:prstGeom>
+        </p:spPr>
+      </p:pic>
+      <p:sp>
+        <p:nvSpPr>
+          <p:cNvPr id="5" name="TextBox 4"/>
+          <p:cNvSpPr txBox="1"/>
+          <p:nvPr/>
+        </p:nvSpPr>
+        <p:spPr>
+          <a:xfrm>
+            <a:off x="1078992" y="2148840"/>
             <a:ext cx="10515600" cy="493776"/>
           </a:xfrm>
           <a:prstGeom prst="rect">
@@ -4414,36 +4365,118 @@
           <a:lstStyle/>
           <a:p>
             <a:r>
-              <a:rPr sz="1600" b="0">
+              <a:rPr sz="1650" b="0">
                 <a:solidFill>
                   <a:srgbClr val="1E2024"/>
                 </a:solidFill>
                 <a:latin typeface="Calibri"/>
               </a:rPr>
-              <a:t>A.  </a:t>
-            </a:r>
-            <a:r>
-              <a:rPr sz="1600" b="0">
-                <a:solidFill>
-                  <a:srgbClr val="1E2024"/>
-                </a:solidFill>
-                <a:latin typeface="Calibri"/>
-              </a:rPr>
-              <a:t>一律回 UNSUPPORTED_VERSION 錯誤碼</a:t>
-            </a:r>
-          </a:p>
-        </p:txBody>
-      </p:sp>
-      <p:sp>
-        <p:nvSpPr>
-          <p:cNvPr id="5" name="TextBox 4"/>
-          <p:cNvSpPr txBox="1"/>
-          <p:nvPr/>
-        </p:nvSpPr>
-        <p:spPr>
-          <a:xfrm>
-            <a:off x="822960" y="2953512"/>
-            <a:ext cx="10515600" cy="493776"/>
+              <a:t>前一頁「交集空」最容易被忽略的根因——舊 wire 版本被整批移除</a:t>
+            </a:r>
+          </a:p>
+        </p:txBody>
+      </p:sp>
+      <p:sp>
+        <p:nvSpPr>
+          <p:cNvPr id="6" name="TextBox 5"/>
+          <p:cNvSpPr txBox="1"/>
+          <p:nvPr/>
+        </p:nvSpPr>
+        <p:spPr>
+          <a:xfrm>
+            <a:off x="640080" y="2788920"/>
+            <a:ext cx="10972800" cy="822959"/>
+          </a:xfrm>
+          <a:prstGeom prst="rect">
+            <a:avLst/>
+          </a:prstGeom>
+          <a:solidFill>
+            <a:srgbClr val="F3F1EC"/>
+          </a:solidFill>
+          <a:ln w="6350">
+            <a:solidFill>
+              <a:srgbClr val="E3E0D8"/>
+            </a:solidFill>
+          </a:ln>
+        </p:spPr>
+        <p:txBody>
+          <a:bodyPr wrap="square" lIns="146304" tIns="91440" bIns="91440">
+            <a:noAutofit/>
+          </a:bodyPr>
+          <a:lstStyle/>
+          <a:p>
+            <a:r>
+              <a:rPr sz="1350" b="0">
+                <a:solidFill>
+                  <a:srgbClr val="2C2C2A"/>
+                </a:solidFill>
+                <a:latin typeface="Calibri"/>
+              </a:rPr>
+              <a:t>舊 wire API version 被整個移除，min 可 &gt; 0</a:t>
+            </a:r>
+          </a:p>
+          <a:p>
+            <a:r>
+              <a:rPr sz="1350" b="0">
+                <a:solidFill>
+                  <a:srgbClr val="2C2C2A"/>
+                </a:solidFill>
+                <a:latin typeface="Calibri"/>
+              </a:rPr>
+              <a:t>  Fetch：4–18（v0–3 在 4.0 移除）</a:t>
+            </a:r>
+          </a:p>
+        </p:txBody>
+      </p:sp>
+      <p:sp>
+        <p:nvSpPr>
+          <p:cNvPr id="7" name="TextBox 6"/>
+          <p:cNvSpPr txBox="1"/>
+          <p:nvPr/>
+        </p:nvSpPr>
+        <p:spPr>
+          <a:xfrm>
+            <a:off x="640080" y="3813048"/>
+            <a:ext cx="10972800" cy="877824"/>
+          </a:xfrm>
+          <a:prstGeom prst="rect">
+            <a:avLst/>
+          </a:prstGeom>
+          <a:solidFill>
+            <a:srgbClr val="E9F3DE"/>
+          </a:solidFill>
+          <a:ln>
+            <a:noFill/>
+          </a:ln>
+        </p:spPr>
+        <p:txBody>
+          <a:bodyPr wrap="square" lIns="146304" tIns="82296">
+            <a:noAutofit/>
+          </a:bodyPr>
+          <a:lstStyle/>
+          <a:p>
+            <a:r>
+              <a:rPr sz="1500" b="0">
+                <a:solidFill>
+                  <a:srgbClr val="27500A"/>
+                </a:solidFill>
+                <a:latin typeface="Calibri"/>
+              </a:rPr>
+              <a:t>解法：升任一端到 4.0 前，先確認另一端 ≥ 2.1（upgrade guide 明訂雙向要求），否則協商結果沒有可用版本</a:t>
+            </a:r>
+          </a:p>
+        </p:txBody>
+      </p:sp>
+      <p:sp>
+        <p:nvSpPr>
+          <p:cNvPr id="8" name="TextBox 7"/>
+          <p:cNvSpPr txBox="1"/>
+          <p:nvPr/>
+        </p:nvSpPr>
+        <p:spPr>
+          <a:xfrm>
+            <a:off x="640080" y="4873752"/>
+            <a:ext cx="10972800" cy="731520"/>
           </a:xfrm>
           <a:prstGeom prst="rect">
             <a:avLst/>
@@ -4457,36 +4490,27 @@
           <a:lstStyle/>
           <a:p>
             <a:r>
-              <a:rPr sz="1600" b="0">
-                <a:solidFill>
-                  <a:srgbClr val="1E2024"/>
-                </a:solidFill>
-                <a:latin typeface="Calibri"/>
-              </a:rPr>
-              <a:t>B.  </a:t>
-            </a:r>
-            <a:r>
-              <a:rPr sz="1600" b="0">
-                <a:solidFill>
-                  <a:srgbClr val="1E2024"/>
-                </a:solidFill>
-                <a:latin typeface="Calibri"/>
-              </a:rPr>
-              <a:t>只有 ApiVersions 例外回錯誤碼+支援範圍；其他 API 直接關閉連線</a:t>
-            </a:r>
-          </a:p>
-        </p:txBody>
-      </p:sp>
-      <p:sp>
-        <p:nvSpPr>
-          <p:cNvPr id="6" name="TextBox 5"/>
-          <p:cNvSpPr txBox="1"/>
-          <p:nvPr/>
-        </p:nvSpPr>
-        <p:spPr>
-          <a:xfrm>
-            <a:off x="822960" y="3575304"/>
-            <a:ext cx="10515600" cy="493776"/>
+              <a:rPr sz="1500" b="0">
+                <a:solidFill>
+                  <a:srgbClr val="5F5E5A"/>
+                </a:solidFill>
+                <a:latin typeface="Calibri"/>
+              </a:rPr>
+              <a:t>取捨：0.8.0（2013）起九年保留每個版本——每個舊版本都是活的程式碼與測試面；4.0 用「斷 2018 年前的 client」換「刪九年的碼」，只有 major 版本邊界付得起。</a:t>
+            </a:r>
+          </a:p>
+        </p:txBody>
+      </p:sp>
+      <p:sp>
+        <p:nvSpPr>
+          <p:cNvPr id="9" name="TextBox 8"/>
+          <p:cNvSpPr txBox="1"/>
+          <p:nvPr/>
+        </p:nvSpPr>
+        <p:spPr>
+          <a:xfrm>
+            <a:off x="640080" y="5733288"/>
+            <a:ext cx="10972800" cy="731520"/>
           </a:xfrm>
           <a:prstGeom prst="rect">
             <a:avLst/>
@@ -4500,36 +4524,27 @@
           <a:lstStyle/>
           <a:p>
             <a:r>
-              <a:rPr sz="1600" b="0">
-                <a:solidFill>
-                  <a:srgbClr val="1E2024"/>
-                </a:solidFill>
-                <a:latin typeface="Calibri"/>
-              </a:rPr>
-              <a:t>C.  </a:t>
-            </a:r>
-            <a:r>
-              <a:rPr sz="1600" b="0">
-                <a:solidFill>
-                  <a:srgbClr val="1E2024"/>
-                </a:solidFill>
-                <a:latin typeface="Calibri"/>
-              </a:rPr>
-              <a:t>broker 自動降版處理</a:t>
-            </a:r>
-          </a:p>
-        </p:txBody>
-      </p:sp>
-      <p:sp>
-        <p:nvSpPr>
-          <p:cNvPr id="7" name="TextBox 6"/>
-          <p:cNvSpPr txBox="1"/>
-          <p:nvPr/>
-        </p:nvSpPr>
-        <p:spPr>
-          <a:xfrm>
-            <a:off x="822960" y="4197096"/>
-            <a:ext cx="10515600" cy="493776"/>
+              <a:rPr sz="1500" b="0">
+                <a:solidFill>
+                  <a:srgbClr val="5F5E5A"/>
+                </a:solidFill>
+                <a:latin typeface="Calibri"/>
+              </a:rPr>
+              <a:t>銜接（非本場）：finalize / 升降當下的錯誤（INVALID_UPDATE_VERSION 等）屬「運行時的版本升降」那場，本場不展開。</a:t>
+            </a:r>
+          </a:p>
+        </p:txBody>
+      </p:sp>
+      <p:sp>
+        <p:nvSpPr>
+          <p:cNvPr id="10" name="TextBox 9"/>
+          <p:cNvSpPr txBox="1"/>
+          <p:nvPr/>
+        </p:nvSpPr>
+        <p:spPr>
+          <a:xfrm>
+            <a:off x="640080" y="6400800"/>
+            <a:ext cx="10972800" cy="384048"/>
           </a:xfrm>
           <a:prstGeom prst="rect">
             <a:avLst/>
@@ -4543,56 +4558,42 @@
           <a:lstStyle/>
           <a:p>
             <a:r>
-              <a:rPr sz="1600" b="0">
-                <a:solidFill>
-                  <a:srgbClr val="1E2024"/>
-                </a:solidFill>
-                <a:latin typeface="Calibri"/>
-              </a:rPr>
-              <a:t>D.  </a:t>
-            </a:r>
-            <a:r>
-              <a:rPr sz="1600" b="0">
-                <a:solidFill>
-                  <a:srgbClr val="1E2024"/>
-                </a:solidFill>
-                <a:latin typeface="Calibri"/>
-              </a:rPr>
-              <a:t>忽略版本照常處理</a:t>
-            </a:r>
-          </a:p>
-        </p:txBody>
-      </p:sp>
-      <p:sp>
-        <p:nvSpPr>
-          <p:cNvPr id="8" name="TextBox 7"/>
-          <p:cNvSpPr txBox="1"/>
-          <p:nvPr/>
-        </p:nvSpPr>
-        <p:spPr>
-          <a:xfrm>
-            <a:off x="640080" y="4910327"/>
-            <a:ext cx="10972800" cy="914400"/>
-          </a:xfrm>
-          <a:prstGeom prst="rect">
-            <a:avLst/>
-          </a:prstGeom>
-          <a:noFill/>
-        </p:spPr>
-        <p:txBody>
-          <a:bodyPr wrap="square">
-            <a:noAutofit/>
-          </a:bodyPr>
-          <a:lstStyle/>
-          <a:p>
-            <a:r>
-              <a:rPr sz="1400" b="0">
+              <a:rPr sz="1200" b="1">
                 <a:solidFill>
                   <a:srgbClr val="8A8A8A"/>
                 </a:solidFill>
                 <a:latin typeface="Calibri"/>
               </a:rPr>
-              <a:t>想一想 —— 下一頁公布答案</a:t>
+              <a:t>REF   </a:t>
+            </a:r>
+            <a:r>
+              <a:rPr sz="1200" b="0" u="sng">
+                <a:solidFill>
+                  <a:srgbClr val="185FA5"/>
+                </a:solidFill>
+                <a:latin typeface="Courier New"/>
+                <a:hlinkClick r:id="rId3"/>
+              </a:rPr>
+              <a:t>upgrade.md:229</a:t>
+            </a:r>
+            <a:r>
+              <a:rPr sz="1200" b="0">
+                <a:solidFill>
+                  <a:srgbClr val="8A8A8A"/>
+                </a:solidFill>
+                <a:latin typeface="Calibri"/>
+              </a:rPr>
+              <a:t>   ·   </a:t>
+            </a:r>
+            <a:r>
+              <a:rPr sz="1200" b="0" u="sng">
+                <a:solidFill>
+                  <a:srgbClr val="185FA5"/>
+                </a:solidFill>
+                <a:latin typeface="Courier New"/>
+                <a:hlinkClick r:id="rId4"/>
+              </a:rPr>
+              <a:t>FetchRequest.json validVersions</a:t>
             </a:r>
           </a:p>
         </p:txBody>
@@ -4644,7 +4645,7 @@
                 </a:solidFill>
                 <a:latin typeface="Calibri"/>
               </a:rPr>
-              <a:t>隨堂考 · 核心　（正解）</a:t>
+              <a:t>隨堂考 · 核心</a:t>
             </a:r>
           </a:p>
         </p:txBody>
@@ -4740,36 +4741,31 @@
           <a:prstGeom prst="rect">
             <a:avLst/>
           </a:prstGeom>
-          <a:solidFill>
-            <a:srgbClr val="E9F3DE"/>
-          </a:solidFill>
-          <a:ln>
-            <a:noFill/>
-          </a:ln>
-        </p:spPr>
-        <p:txBody>
-          <a:bodyPr wrap="square" lIns="128016" tIns="54864">
-            <a:noAutofit/>
-          </a:bodyPr>
-          <a:lstStyle/>
-          <a:p>
-            <a:r>
-              <a:rPr sz="1600" b="1">
-                <a:solidFill>
-                  <a:srgbClr val="27500A"/>
+          <a:noFill/>
+        </p:spPr>
+        <p:txBody>
+          <a:bodyPr wrap="square">
+            <a:noAutofit/>
+          </a:bodyPr>
+          <a:lstStyle/>
+          <a:p>
+            <a:r>
+              <a:rPr sz="1600" b="0">
+                <a:solidFill>
+                  <a:srgbClr val="1E2024"/>
                 </a:solidFill>
                 <a:latin typeface="Calibri"/>
               </a:rPr>
               <a:t>B.  </a:t>
             </a:r>
             <a:r>
-              <a:rPr sz="1600" b="1">
-                <a:solidFill>
-                  <a:srgbClr val="27500A"/>
-                </a:solidFill>
-                <a:latin typeface="Calibri"/>
-              </a:rPr>
-              <a:t>只有 ApiVersions 例外回錯誤碼+支援範圍；其他 API 直接關閉連線   ✓</a:t>
+              <a:rPr sz="1600" b="0">
+                <a:solidFill>
+                  <a:srgbClr val="1E2024"/>
+                </a:solidFill>
+                <a:latin typeface="Calibri"/>
+              </a:rPr>
+              <a:t>只有 ApiVersions 例外回錯誤碼+支援範圍；其他 API 直接關閉連線</a:t>
             </a:r>
           </a:p>
         </p:txBody>
@@ -4883,85 +4879,13 @@
           <a:lstStyle/>
           <a:p>
             <a:r>
-              <a:rPr sz="1400" b="1">
-                <a:solidFill>
-                  <a:srgbClr val="27500A"/>
-                </a:solidFill>
-                <a:latin typeface="Calibri"/>
-              </a:rPr>
-              <a:t>正解 B — </a:t>
-            </a:r>
-            <a:r>
               <a:rPr sz="1400" b="0">
                 <a:solidFill>
-                  <a:srgbClr val="1E2024"/>
-                </a:solidFill>
-                <a:latin typeface="Calibri"/>
-              </a:rPr>
-              <a:t>ApiVersions 是協商的第一支 request（此時雙方還不知道彼此版本），若它也關閉連線，client 永遠問不到支援範圍，故回 v0+錯誤碼讓 client 重新協商；其他 API 在 RequestContext 解析失敗、SocketServer 關閉連線。</a:t>
-            </a:r>
-          </a:p>
-        </p:txBody>
-      </p:sp>
-      <p:sp>
-        <p:nvSpPr>
-          <p:cNvPr id="9" name="TextBox 8"/>
-          <p:cNvSpPr txBox="1"/>
-          <p:nvPr/>
-        </p:nvSpPr>
-        <p:spPr>
-          <a:xfrm>
-            <a:off x="640080" y="6400800"/>
-            <a:ext cx="10972800" cy="384048"/>
-          </a:xfrm>
-          <a:prstGeom prst="rect">
-            <a:avLst/>
-          </a:prstGeom>
-          <a:noFill/>
-        </p:spPr>
-        <p:txBody>
-          <a:bodyPr wrap="square">
-            <a:noAutofit/>
-          </a:bodyPr>
-          <a:lstStyle/>
-          <a:p>
-            <a:r>
-              <a:rPr sz="1200" b="1">
-                <a:solidFill>
                   <a:srgbClr val="8A8A8A"/>
                 </a:solidFill>
                 <a:latin typeface="Calibri"/>
               </a:rPr>
-              <a:t>REF   </a:t>
-            </a:r>
-            <a:r>
-              <a:rPr sz="1200" b="0" u="sng">
-                <a:solidFill>
-                  <a:srgbClr val="185FA5"/>
-                </a:solidFill>
-                <a:latin typeface="Courier New"/>
-                <a:hlinkClick r:id="rId2"/>
-              </a:rPr>
-              <a:t>RequestContext.java:112</a:t>
-            </a:r>
-            <a:r>
-              <a:rPr sz="1200" b="0">
-                <a:solidFill>
-                  <a:srgbClr val="8A8A8A"/>
-                </a:solidFill>
-                <a:latin typeface="Calibri"/>
-              </a:rPr>
-              <a:t>   ·   </a:t>
-            </a:r>
-            <a:r>
-              <a:rPr sz="1200" b="0" u="sng">
-                <a:solidFill>
-                  <a:srgbClr val="185FA5"/>
-                </a:solidFill>
-                <a:latin typeface="Courier New"/>
-                <a:hlinkClick r:id="rId3"/>
-              </a:rPr>
-              <a:t>SocketServer.scala:781</a:t>
+              <a:t>想一想 —— 下一頁公布答案</a:t>
             </a:r>
           </a:p>
         </p:txBody>
@@ -5013,6 +4937,375 @@
                 </a:solidFill>
                 <a:latin typeface="Calibri"/>
               </a:rPr>
+              <a:t>隨堂考 · 核心　（正解）</a:t>
+            </a:r>
+          </a:p>
+        </p:txBody>
+      </p:sp>
+      <p:sp>
+        <p:nvSpPr>
+          <p:cNvPr id="3" name="TextBox 2"/>
+          <p:cNvSpPr txBox="1"/>
+          <p:nvPr/>
+        </p:nvSpPr>
+        <p:spPr>
+          <a:xfrm>
+            <a:off x="640080" y="841248"/>
+            <a:ext cx="10972800" cy="1188720"/>
+          </a:xfrm>
+          <a:prstGeom prst="rect">
+            <a:avLst/>
+          </a:prstGeom>
+          <a:noFill/>
+        </p:spPr>
+        <p:txBody>
+          <a:bodyPr wrap="square">
+            <a:noAutofit/>
+          </a:bodyPr>
+          <a:lstStyle/>
+          <a:p>
+            <a:r>
+              <a:rPr sz="2600" b="1">
+                <a:solidFill>
+                  <a:srgbClr val="1E2024"/>
+                </a:solidFill>
+                <a:latin typeface="Calibri"/>
+              </a:rPr>
+              <a:t>client 繞過協商、直接送出 broker 不支援的 API version，會怎樣？</a:t>
+            </a:r>
+          </a:p>
+        </p:txBody>
+      </p:sp>
+      <p:sp>
+        <p:nvSpPr>
+          <p:cNvPr id="4" name="TextBox 3"/>
+          <p:cNvSpPr txBox="1"/>
+          <p:nvPr/>
+        </p:nvSpPr>
+        <p:spPr>
+          <a:xfrm>
+            <a:off x="822960" y="2331720"/>
+            <a:ext cx="10515600" cy="493776"/>
+          </a:xfrm>
+          <a:prstGeom prst="rect">
+            <a:avLst/>
+          </a:prstGeom>
+          <a:noFill/>
+        </p:spPr>
+        <p:txBody>
+          <a:bodyPr wrap="square">
+            <a:noAutofit/>
+          </a:bodyPr>
+          <a:lstStyle/>
+          <a:p>
+            <a:r>
+              <a:rPr sz="1600" b="0">
+                <a:solidFill>
+                  <a:srgbClr val="1E2024"/>
+                </a:solidFill>
+                <a:latin typeface="Calibri"/>
+              </a:rPr>
+              <a:t>A.  </a:t>
+            </a:r>
+            <a:r>
+              <a:rPr sz="1600" b="0">
+                <a:solidFill>
+                  <a:srgbClr val="1E2024"/>
+                </a:solidFill>
+                <a:latin typeface="Calibri"/>
+              </a:rPr>
+              <a:t>一律回 UNSUPPORTED_VERSION 錯誤碼</a:t>
+            </a:r>
+          </a:p>
+        </p:txBody>
+      </p:sp>
+      <p:sp>
+        <p:nvSpPr>
+          <p:cNvPr id="5" name="TextBox 4"/>
+          <p:cNvSpPr txBox="1"/>
+          <p:nvPr/>
+        </p:nvSpPr>
+        <p:spPr>
+          <a:xfrm>
+            <a:off x="822960" y="2953512"/>
+            <a:ext cx="10515600" cy="493776"/>
+          </a:xfrm>
+          <a:prstGeom prst="rect">
+            <a:avLst/>
+          </a:prstGeom>
+          <a:solidFill>
+            <a:srgbClr val="E9F3DE"/>
+          </a:solidFill>
+          <a:ln>
+            <a:noFill/>
+          </a:ln>
+        </p:spPr>
+        <p:txBody>
+          <a:bodyPr wrap="square" lIns="128016" tIns="54864">
+            <a:noAutofit/>
+          </a:bodyPr>
+          <a:lstStyle/>
+          <a:p>
+            <a:r>
+              <a:rPr sz="1600" b="1">
+                <a:solidFill>
+                  <a:srgbClr val="27500A"/>
+                </a:solidFill>
+                <a:latin typeface="Calibri"/>
+              </a:rPr>
+              <a:t>B.  </a:t>
+            </a:r>
+            <a:r>
+              <a:rPr sz="1600" b="1">
+                <a:solidFill>
+                  <a:srgbClr val="27500A"/>
+                </a:solidFill>
+                <a:latin typeface="Calibri"/>
+              </a:rPr>
+              <a:t>只有 ApiVersions 例外回錯誤碼+支援範圍；其他 API 直接關閉連線   ✓</a:t>
+            </a:r>
+          </a:p>
+        </p:txBody>
+      </p:sp>
+      <p:sp>
+        <p:nvSpPr>
+          <p:cNvPr id="6" name="TextBox 5"/>
+          <p:cNvSpPr txBox="1"/>
+          <p:nvPr/>
+        </p:nvSpPr>
+        <p:spPr>
+          <a:xfrm>
+            <a:off x="822960" y="3575304"/>
+            <a:ext cx="10515600" cy="493776"/>
+          </a:xfrm>
+          <a:prstGeom prst="rect">
+            <a:avLst/>
+          </a:prstGeom>
+          <a:noFill/>
+        </p:spPr>
+        <p:txBody>
+          <a:bodyPr wrap="square">
+            <a:noAutofit/>
+          </a:bodyPr>
+          <a:lstStyle/>
+          <a:p>
+            <a:r>
+              <a:rPr sz="1600" b="0">
+                <a:solidFill>
+                  <a:srgbClr val="1E2024"/>
+                </a:solidFill>
+                <a:latin typeface="Calibri"/>
+              </a:rPr>
+              <a:t>C.  </a:t>
+            </a:r>
+            <a:r>
+              <a:rPr sz="1600" b="0">
+                <a:solidFill>
+                  <a:srgbClr val="1E2024"/>
+                </a:solidFill>
+                <a:latin typeface="Calibri"/>
+              </a:rPr>
+              <a:t>broker 自動降版處理</a:t>
+            </a:r>
+          </a:p>
+        </p:txBody>
+      </p:sp>
+      <p:sp>
+        <p:nvSpPr>
+          <p:cNvPr id="7" name="TextBox 6"/>
+          <p:cNvSpPr txBox="1"/>
+          <p:nvPr/>
+        </p:nvSpPr>
+        <p:spPr>
+          <a:xfrm>
+            <a:off x="822960" y="4197096"/>
+            <a:ext cx="10515600" cy="493776"/>
+          </a:xfrm>
+          <a:prstGeom prst="rect">
+            <a:avLst/>
+          </a:prstGeom>
+          <a:noFill/>
+        </p:spPr>
+        <p:txBody>
+          <a:bodyPr wrap="square">
+            <a:noAutofit/>
+          </a:bodyPr>
+          <a:lstStyle/>
+          <a:p>
+            <a:r>
+              <a:rPr sz="1600" b="0">
+                <a:solidFill>
+                  <a:srgbClr val="1E2024"/>
+                </a:solidFill>
+                <a:latin typeface="Calibri"/>
+              </a:rPr>
+              <a:t>D.  </a:t>
+            </a:r>
+            <a:r>
+              <a:rPr sz="1600" b="0">
+                <a:solidFill>
+                  <a:srgbClr val="1E2024"/>
+                </a:solidFill>
+                <a:latin typeface="Calibri"/>
+              </a:rPr>
+              <a:t>忽略版本照常處理</a:t>
+            </a:r>
+          </a:p>
+        </p:txBody>
+      </p:sp>
+      <p:sp>
+        <p:nvSpPr>
+          <p:cNvPr id="8" name="TextBox 7"/>
+          <p:cNvSpPr txBox="1"/>
+          <p:nvPr/>
+        </p:nvSpPr>
+        <p:spPr>
+          <a:xfrm>
+            <a:off x="640080" y="4910327"/>
+            <a:ext cx="10972800" cy="914400"/>
+          </a:xfrm>
+          <a:prstGeom prst="rect">
+            <a:avLst/>
+          </a:prstGeom>
+          <a:noFill/>
+        </p:spPr>
+        <p:txBody>
+          <a:bodyPr wrap="square">
+            <a:noAutofit/>
+          </a:bodyPr>
+          <a:lstStyle/>
+          <a:p>
+            <a:r>
+              <a:rPr sz="1400" b="1">
+                <a:solidFill>
+                  <a:srgbClr val="27500A"/>
+                </a:solidFill>
+                <a:latin typeface="Calibri"/>
+              </a:rPr>
+              <a:t>正解 B — </a:t>
+            </a:r>
+            <a:r>
+              <a:rPr sz="1400" b="0">
+                <a:solidFill>
+                  <a:srgbClr val="1E2024"/>
+                </a:solidFill>
+                <a:latin typeface="Calibri"/>
+              </a:rPr>
+              <a:t>ApiVersions 是協商的第一支 request（此時雙方還不知道彼此版本），若它也關閉連線，client 永遠問不到支援範圍，故回 v0+錯誤碼讓 client 重新協商；其他 API 在 RequestContext 解析失敗、SocketServer 關閉連線。</a:t>
+            </a:r>
+          </a:p>
+        </p:txBody>
+      </p:sp>
+      <p:sp>
+        <p:nvSpPr>
+          <p:cNvPr id="9" name="TextBox 8"/>
+          <p:cNvSpPr txBox="1"/>
+          <p:nvPr/>
+        </p:nvSpPr>
+        <p:spPr>
+          <a:xfrm>
+            <a:off x="640080" y="6400800"/>
+            <a:ext cx="10972800" cy="384048"/>
+          </a:xfrm>
+          <a:prstGeom prst="rect">
+            <a:avLst/>
+          </a:prstGeom>
+          <a:noFill/>
+        </p:spPr>
+        <p:txBody>
+          <a:bodyPr wrap="square">
+            <a:noAutofit/>
+          </a:bodyPr>
+          <a:lstStyle/>
+          <a:p>
+            <a:r>
+              <a:rPr sz="1200" b="1">
+                <a:solidFill>
+                  <a:srgbClr val="8A8A8A"/>
+                </a:solidFill>
+                <a:latin typeface="Calibri"/>
+              </a:rPr>
+              <a:t>REF   </a:t>
+            </a:r>
+            <a:r>
+              <a:rPr sz="1200" b="0" u="sng">
+                <a:solidFill>
+                  <a:srgbClr val="185FA5"/>
+                </a:solidFill>
+                <a:latin typeface="Courier New"/>
+                <a:hlinkClick r:id="rId2"/>
+              </a:rPr>
+              <a:t>RequestContext.java:112</a:t>
+            </a:r>
+            <a:r>
+              <a:rPr sz="1200" b="0">
+                <a:solidFill>
+                  <a:srgbClr val="8A8A8A"/>
+                </a:solidFill>
+                <a:latin typeface="Calibri"/>
+              </a:rPr>
+              <a:t>   ·   </a:t>
+            </a:r>
+            <a:r>
+              <a:rPr sz="1200" b="0" u="sng">
+                <a:solidFill>
+                  <a:srgbClr val="185FA5"/>
+                </a:solidFill>
+                <a:latin typeface="Courier New"/>
+                <a:hlinkClick r:id="rId3"/>
+              </a:rPr>
+              <a:t>SocketServer.scala:781</a:t>
+            </a:r>
+          </a:p>
+        </p:txBody>
+      </p:sp>
+    </p:spTree>
+  </p:cSld>
+  <p:clrMapOvr>
+    <a:masterClrMapping/>
+  </p:clrMapOvr>
+</p:sld>
+</file>
+
+<file path=ppt/slides/slide16.xml><?xml version="1.0" encoding="utf-8"?>
+<p:sld xmlns:a="http://schemas.openxmlformats.org/drawingml/2006/main" xmlns:p="http://schemas.openxmlformats.org/presentationml/2006/main" xmlns:r="http://schemas.openxmlformats.org/officeDocument/2006/relationships">
+  <p:cSld>
+    <p:spTree>
+      <p:nvGrpSpPr>
+        <p:cNvPr id="1" name=""/>
+        <p:cNvGrpSpPr/>
+        <p:nvPr/>
+      </p:nvGrpSpPr>
+      <p:grpSpPr/>
+      <p:sp>
+        <p:nvSpPr>
+          <p:cNvPr id="2" name="TextBox 1"/>
+          <p:cNvSpPr txBox="1"/>
+          <p:nvPr/>
+        </p:nvSpPr>
+        <p:spPr>
+          <a:xfrm>
+            <a:off x="640080" y="457200"/>
+            <a:ext cx="10972800" cy="365760"/>
+          </a:xfrm>
+          <a:prstGeom prst="rect">
+            <a:avLst/>
+          </a:prstGeom>
+          <a:noFill/>
+        </p:spPr>
+        <p:txBody>
+          <a:bodyPr wrap="square">
+            <a:noAutofit/>
+          </a:bodyPr>
+          <a:lstStyle/>
+          <a:p>
+            <a:r>
+              <a:rPr sz="1300" b="1">
+                <a:solidFill>
+                  <a:srgbClr val="185FA5"/>
+                </a:solidFill>
+                <a:latin typeface="Calibri"/>
+              </a:rPr>
               <a:t>Recap</a:t>
             </a:r>
           </a:p>
@@ -7434,7 +7727,7 @@
                 </a:solidFill>
                 <a:latin typeface="Calibri"/>
               </a:rPr>
-              <a:t>隨堂考 · 核心</a:t>
+              <a:t>Part 1 · 帳單</a:t>
             </a:r>
           </a:p>
         </p:txBody>
@@ -7448,7 +7741,7 @@
         <p:spPr>
           <a:xfrm>
             <a:off x="640080" y="841248"/>
-            <a:ext cx="10972800" cy="1188720"/>
+            <a:ext cx="10972800" cy="1005840"/>
           </a:xfrm>
           <a:prstGeom prst="rect">
             <a:avLst/>
@@ -7462,13 +7755,13 @@
           <a:lstStyle/>
           <a:p>
             <a:r>
-              <a:rPr sz="2600" b="1">
+              <a:rPr sz="3200" b="1">
                 <a:solidFill>
                   <a:srgbClr val="1E2024"/>
                 </a:solidFill>
                 <a:latin typeface="Calibri"/>
               </a:rPr>
-              <a:t>replica fetch（broker↔broker）的 Fetch 版本怎麼決定？</a:t>
+              <a:t>Kafka 這個選擇有多貴（實測數字）</a:t>
             </a:r>
           </a:p>
         </p:txBody>
@@ -7481,8 +7774,95 @@
         </p:nvSpPr>
         <p:spPr>
           <a:xfrm>
-            <a:off x="822960" y="2331720"/>
-            <a:ext cx="10515600" cy="493776"/>
+            <a:off x="640080" y="2148840"/>
+            <a:ext cx="10972800" cy="1097280"/>
+          </a:xfrm>
+          <a:prstGeom prst="rect">
+            <a:avLst/>
+          </a:prstGeom>
+          <a:solidFill>
+            <a:srgbClr val="F3F1EC"/>
+          </a:solidFill>
+          <a:ln w="6350">
+            <a:solidFill>
+              <a:srgbClr val="E3E0D8"/>
+            </a:solidFill>
+          </a:ln>
+        </p:spPr>
+        <p:txBody>
+          <a:bodyPr wrap="square" lIns="146304" tIns="91440" bIns="91440">
+            <a:noAutofit/>
+          </a:bodyPr>
+          <a:lstStyle/>
+          <a:p>
+            <a:r>
+              <a:rPr sz="1350" b="0">
+                <a:solidFill>
+                  <a:srgbClr val="2C2C2A"/>
+                </a:solidFill>
+                <a:latin typeface="Calibri"/>
+              </a:rPr>
+              <a:t>90 支 API × 308 個現役 wire 版本</a:t>
+            </a:r>
+          </a:p>
+          <a:p>
+            <a:r>
+              <a:rPr sz="1350" b="0">
+                <a:solidFill>
+                  <a:srgbClr val="2C2C2A"/>
+                </a:solidFill>
+                <a:latin typeface="Calibri"/>
+              </a:rPr>
+              <a:t>9,890 行 schema JSON → 約 18 萬行生成碼（≈18×）</a:t>
+            </a:r>
+          </a:p>
+          <a:p>
+            <a:r>
+              <a:rPr sz="1350" b="0">
+                <a:solidFill>
+                  <a:srgbClr val="2C2C2A"/>
+                </a:solidFill>
+                <a:latin typeface="Calibri"/>
+              </a:rPr>
+              <a:t>相容性系統測試涵蓋 23 個 broker 版本</a:t>
+            </a:r>
+          </a:p>
+        </p:txBody>
+      </p:sp>
+      <p:pic>
+        <p:nvPicPr>
+          <p:cNvPr id="5" name="Picture 4" descr="arrows-split.png"/>
+          <p:cNvPicPr>
+            <a:picLocks noChangeAspect="1"/>
+          </p:cNvPicPr>
+          <p:nvPr/>
+        </p:nvPicPr>
+        <p:blipFill>
+          <a:blip r:embed="rId2"/>
+          <a:stretch>
+            <a:fillRect/>
+          </a:stretch>
+        </p:blipFill>
+        <p:spPr>
+          <a:xfrm>
+            <a:off x="658368" y="3474720"/>
+            <a:ext cx="274320" cy="274320"/>
+          </a:xfrm>
+          <a:prstGeom prst="rect">
+            <a:avLst/>
+          </a:prstGeom>
+        </p:spPr>
+      </p:pic>
+      <p:sp>
+        <p:nvSpPr>
+          <p:cNvPr id="6" name="TextBox 5"/>
+          <p:cNvSpPr txBox="1"/>
+          <p:nvPr/>
+        </p:nvSpPr>
+        <p:spPr>
+          <a:xfrm>
+            <a:off x="1078992" y="3447288"/>
+            <a:ext cx="10515600" cy="841248"/>
           </a:xfrm>
           <a:prstGeom prst="rect">
             <a:avLst/>
@@ -7496,36 +7876,66 @@
           <a:lstStyle/>
           <a:p>
             <a:r>
-              <a:rPr sz="1600" b="0">
+              <a:rPr sz="1650" b="0">
                 <a:solidFill>
                   <a:srgbClr val="1E2024"/>
                 </a:solidFill>
                 <a:latin typeface="Calibri"/>
               </a:rPr>
-              <a:t>A.  </a:t>
-            </a:r>
-            <a:r>
-              <a:rPr sz="1600" b="0">
-                <a:solidFill>
-                  <a:srgbClr val="1E2024"/>
-                </a:solidFill>
-                <a:latin typeface="Calibri"/>
-              </a:rPr>
-              <a:t>兩 broker ApiVersions 協商取交集</a:t>
-            </a:r>
-          </a:p>
-        </p:txBody>
-      </p:sp>
-      <p:sp>
-        <p:nvSpPr>
-          <p:cNvPr id="5" name="TextBox 4"/>
-          <p:cNvSpPr txBox="1"/>
-          <p:nvPr/>
-        </p:nvSpPr>
-        <p:spPr>
-          <a:xfrm>
-            <a:off x="822960" y="2953512"/>
-            <a:ext cx="10515600" cy="493776"/>
+              <a:t>每加一版牽動 .json、generator 逐版讀寫、ApiKeys、全版本 round-trip 測試；成本隨 API 數 × 版本數乘積成長</a:t>
+            </a:r>
+          </a:p>
+        </p:txBody>
+      </p:sp>
+      <p:sp>
+        <p:nvSpPr>
+          <p:cNvPr id="7" name="TextBox 6"/>
+          <p:cNvSpPr txBox="1"/>
+          <p:nvPr/>
+        </p:nvSpPr>
+        <p:spPr>
+          <a:xfrm>
+            <a:off x="640080" y="4434840"/>
+            <a:ext cx="10972800" cy="877824"/>
+          </a:xfrm>
+          <a:prstGeom prst="rect">
+            <a:avLst/>
+          </a:prstGeom>
+          <a:solidFill>
+            <a:srgbClr val="E9F3DE"/>
+          </a:solidFill>
+          <a:ln>
+            <a:noFill/>
+          </a:ln>
+        </p:spPr>
+        <p:txBody>
+          <a:bodyPr wrap="square" lIns="146304" tIns="82296">
+            <a:noAutofit/>
+          </a:bodyPr>
+          <a:lstStyle/>
+          <a:p>
+            <a:r>
+              <a:rPr sz="1500" b="0">
+                <a:solidFill>
+                  <a:srgbClr val="27500A"/>
+                </a:solidFill>
+                <a:latin typeface="Calibri"/>
+              </a:rPr>
+              <a:t>貴到 Kafka 自己在 KIP-896 承認「maintenance cost goes up, value goes down」，4.0 砍掉 2.1 以前的舊版本止血</a:t>
+            </a:r>
+          </a:p>
+        </p:txBody>
+      </p:sp>
+      <p:sp>
+        <p:nvSpPr>
+          <p:cNvPr id="8" name="TextBox 7"/>
+          <p:cNvSpPr txBox="1"/>
+          <p:nvPr/>
+        </p:nvSpPr>
+        <p:spPr>
+          <a:xfrm>
+            <a:off x="640080" y="6400800"/>
+            <a:ext cx="10972800" cy="384048"/>
           </a:xfrm>
           <a:prstGeom prst="rect">
             <a:avLst/>
@@ -7539,142 +7949,42 @@
           <a:lstStyle/>
           <a:p>
             <a:r>
-              <a:rPr sz="1600" b="0">
-                <a:solidFill>
-                  <a:srgbClr val="1E2024"/>
-                </a:solidFill>
-                <a:latin typeface="Calibri"/>
-              </a:rPr>
-              <a:t>B.  </a:t>
-            </a:r>
-            <a:r>
-              <a:rPr sz="1600" b="0">
-                <a:solidFill>
-                  <a:srgbClr val="1E2024"/>
-                </a:solidFill>
-                <a:latin typeface="Calibri"/>
-              </a:rPr>
-              <a:t>由 finalized metadata.version 決定</a:t>
-            </a:r>
-          </a:p>
-        </p:txBody>
-      </p:sp>
-      <p:sp>
-        <p:nvSpPr>
-          <p:cNvPr id="6" name="TextBox 5"/>
-          <p:cNvSpPr txBox="1"/>
-          <p:nvPr/>
-        </p:nvSpPr>
-        <p:spPr>
-          <a:xfrm>
-            <a:off x="822960" y="3575304"/>
-            <a:ext cx="10515600" cy="493776"/>
-          </a:xfrm>
-          <a:prstGeom prst="rect">
-            <a:avLst/>
-          </a:prstGeom>
-          <a:noFill/>
-        </p:spPr>
-        <p:txBody>
-          <a:bodyPr wrap="square">
-            <a:noAutofit/>
-          </a:bodyPr>
-          <a:lstStyle/>
-          <a:p>
-            <a:r>
-              <a:rPr sz="1600" b="0">
-                <a:solidFill>
-                  <a:srgbClr val="1E2024"/>
-                </a:solidFill>
-                <a:latin typeface="Calibri"/>
-              </a:rPr>
-              <a:t>C.  </a:t>
-            </a:r>
-            <a:r>
-              <a:rPr sz="1600" b="0">
-                <a:solidFill>
-                  <a:srgbClr val="1E2024"/>
-                </a:solidFill>
-                <a:latin typeface="Calibri"/>
-              </a:rPr>
-              <a:t>永遠用最新版</a:t>
-            </a:r>
-          </a:p>
-        </p:txBody>
-      </p:sp>
-      <p:sp>
-        <p:nvSpPr>
-          <p:cNvPr id="7" name="TextBox 6"/>
-          <p:cNvSpPr txBox="1"/>
-          <p:nvPr/>
-        </p:nvSpPr>
-        <p:spPr>
-          <a:xfrm>
-            <a:off x="822960" y="4197096"/>
-            <a:ext cx="10515600" cy="493776"/>
-          </a:xfrm>
-          <a:prstGeom prst="rect">
-            <a:avLst/>
-          </a:prstGeom>
-          <a:noFill/>
-        </p:spPr>
-        <p:txBody>
-          <a:bodyPr wrap="square">
-            <a:noAutofit/>
-          </a:bodyPr>
-          <a:lstStyle/>
-          <a:p>
-            <a:r>
-              <a:rPr sz="1600" b="0">
-                <a:solidFill>
-                  <a:srgbClr val="1E2024"/>
-                </a:solidFill>
-                <a:latin typeface="Calibri"/>
-              </a:rPr>
-              <a:t>D.  </a:t>
-            </a:r>
-            <a:r>
-              <a:rPr sz="1600" b="0">
-                <a:solidFill>
-                  <a:srgbClr val="1E2024"/>
-                </a:solidFill>
-                <a:latin typeface="Calibri"/>
-              </a:rPr>
-              <a:t>controller 每次指定</a:t>
-            </a:r>
-          </a:p>
-        </p:txBody>
-      </p:sp>
-      <p:sp>
-        <p:nvSpPr>
-          <p:cNvPr id="8" name="TextBox 7"/>
-          <p:cNvSpPr txBox="1"/>
-          <p:nvPr/>
-        </p:nvSpPr>
-        <p:spPr>
-          <a:xfrm>
-            <a:off x="640080" y="4910327"/>
-            <a:ext cx="10972800" cy="914400"/>
-          </a:xfrm>
-          <a:prstGeom prst="rect">
-            <a:avLst/>
-          </a:prstGeom>
-          <a:noFill/>
-        </p:spPr>
-        <p:txBody>
-          <a:bodyPr wrap="square">
-            <a:noAutofit/>
-          </a:bodyPr>
-          <a:lstStyle/>
-          <a:p>
-            <a:r>
-              <a:rPr sz="1400" b="0">
+              <a:rPr sz="1200" b="1">
                 <a:solidFill>
                   <a:srgbClr val="8A8A8A"/>
                 </a:solidFill>
                 <a:latin typeface="Calibri"/>
               </a:rPr>
-              <a:t>想一想 —— 下一頁公布答案</a:t>
+              <a:t>REF   </a:t>
+            </a:r>
+            <a:r>
+              <a:rPr sz="1200" b="0" u="sng">
+                <a:solidFill>
+                  <a:srgbClr val="185FA5"/>
+                </a:solidFill>
+                <a:latin typeface="Calibri"/>
+                <a:hlinkClick r:id="rId3"/>
+              </a:rPr>
+              <a:t>KIP-896</a:t>
+            </a:r>
+            <a:r>
+              <a:rPr sz="1200" b="0">
+                <a:solidFill>
+                  <a:srgbClr val="8A8A8A"/>
+                </a:solidFill>
+                <a:latin typeface="Calibri"/>
+              </a:rPr>
+              <a:t>   ·   </a:t>
+            </a:r>
+            <a:r>
+              <a:rPr sz="1200" b="0" u="sng">
+                <a:solidFill>
+                  <a:srgbClr val="185FA5"/>
+                </a:solidFill>
+                <a:latin typeface="Courier New"/>
+                <a:hlinkClick r:id="rId4"/>
+              </a:rPr>
+              <a:t>FetchRequest.json 4-18</a:t>
             </a:r>
           </a:p>
         </p:txBody>

</xml_diff>

<commit_message>
study(version-control): 連線改名「follower→leader 複製流程」——replica fetch 是 RPC 角色非連線名
- 該路徑本質是複製流程（對齊 OffsetsForLeaderEpoch → 定位 ListOffsets → 抓資料 Fetch，三支輪流走同一 blockingSender）
- deck 架構(a)/(b)、Recap、quiz 0：連線一律稱「複製流程」，Fetch 只指 RPC；replica fetch 保留給舉例張（Fetch 的 replica 身分）
- rpc-version-selection.md 同步用詞
</commit_message>
<xml_diff>
--- a/study/version-control/kafka-version-negotiation.pptx
+++ b/study/version-control/kafka-version-negotiation.pptx
@@ -4076,7 +4076,7 @@
                 </a:solidFill>
                 <a:latin typeface="Calibri"/>
               </a:rPr>
-              <a:t>replica fetch（broker↔broker）的 Fetch 版本怎麼決定？</a:t>
+              <a:t>follower→leader 複製流程裡，Fetch 的版本怎麼決定？</a:t>
             </a:r>
           </a:p>
         </p:txBody>
@@ -4368,7 +4368,7 @@
                 </a:solidFill>
                 <a:latin typeface="Calibri"/>
               </a:rPr>
-              <a:t>replica fetch（broker↔broker）的 Fetch 版本怎麼決定？</a:t>
+              <a:t>follower→leader 複製流程裡，Fetch 的版本怎麼決定？</a:t>
             </a:r>
           </a:p>
         </p:txBody>
@@ -6197,7 +6197,7 @@
                 </a:solidFill>
                 <a:latin typeface="Calibri"/>
               </a:rPr>
-              <a:t>Part 1：不能「一個版本打天下」（client 長壽、broker 滾動升級）；多數路徑靠協商，唯一不協商的「連線」是 replica fetch——上面 Fetch/ListOffsets 等由 MV 釘版（其餘 broker↔broker 仍協商）</a:t>
+              <a:t>Part 1：不能「一個版本打天下」（client 長壽、broker 滾動升級）；多數路徑靠協商，唯一不協商的是 follower→leader 複製流程——上面 Fetch/ListOffsets 等由 MV 釘版（其餘 broker↔broker 仍協商）</a:t>
             </a:r>
           </a:p>
         </p:txBody>
@@ -7380,7 +7380,7 @@
                 </a:solidFill>
                 <a:latin typeface="Calibri"/>
               </a:rPr>
-              <a:t>機制二 · 由叢集 MV 事先釘版（KIP-584）：只有 replica fetch（partition replication）這條不協商</a:t>
+              <a:t>機制二 · 由叢集 MV 事先釘版（KIP-584）：只有 follower→leader 複製流程這條不協商</a:t>
             </a:r>
           </a:p>
         </p:txBody>
@@ -7394,7 +7394,7 @@
         <p:spPr>
           <a:xfrm>
             <a:off x="640080" y="4123944"/>
-            <a:ext cx="10972800" cy="1371600"/>
+            <a:ext cx="10972800" cy="1097280"/>
           </a:xfrm>
           <a:prstGeom prst="rect">
             <a:avLst/>
@@ -7432,7 +7432,7 @@
                 </a:solidFill>
                 <a:latin typeface="Calibri"/>
               </a:rPr>
-              <a:t>MV 釘版    replica fetch（follower → leader partition replication）—— 唯一不協商的連線</a:t>
+              <a:t>MV 釘版    follower→leader 複製流程（replica fetcher）—— 唯一不協商的路徑</a:t>
             </a:r>
           </a:p>
         </p:txBody>
@@ -7445,7 +7445,7 @@
         </p:nvSpPr>
         <p:spPr>
           <a:xfrm>
-            <a:off x="640080" y="5696712"/>
+            <a:off x="640080" y="5422392"/>
             <a:ext cx="10972800" cy="1024127"/>
           </a:xfrm>
           <a:prstGeom prst="rect">
@@ -7466,7 +7466,7 @@
                 </a:solidFill>
                 <a:latin typeface="Calibri"/>
               </a:rPr>
-              <a:t>精確講：唯一不協商的是 replica fetch 這一「連線」——上面 Fetch/ListOffsets/OffsetsForLeaderEpoch 三支 RPC 都不協商；同是 broker↔broker 的 transaction markers 仍協商。</a:t>
+              <a:t>唯一不協商的是 follower→leader 複製流程——發三支 RPC：OffsetsForLeaderEpoch 對齊、ListOffsets 定位、Fetch 抓資料，版本都由 MV／寫死；同是 broker↔broker 的 transaction markers 仍協商。</a:t>
             </a:r>
           </a:p>
         </p:txBody>
@@ -7694,7 +7694,7 @@
                 </a:solidFill>
                 <a:latin typeface="Calibri"/>
               </a:rPr>
-              <a:t>協商           取交集最高（client↔broker、broker↔controller、Raft、txn markers）</a:t>
+              <a:t>協商        取交集最高（client↔broker、broker↔controller、Raft、txn markers）</a:t>
             </a:r>
           </a:p>
           <a:p>
@@ -7705,7 +7705,7 @@
                 </a:solidFill>
                 <a:latin typeface="Calibri"/>
               </a:rPr>
-              <a:t>replica fetch  不協商——Fetch/ListOffsets 由 finalized MV、OffsetsForLeaderEpoch 寫死 v4</a:t>
+              <a:t>複製流程    不協商——Fetch/ListOffsets 由 finalized MV、OffsetsForLeaderEpoch 寫死 v4</a:t>
             </a:r>
           </a:p>
         </p:txBody>
@@ -7763,7 +7763,7 @@
                 </a:solidFill>
                 <a:latin typeface="Calibri"/>
               </a:rPr>
-              <a:t>replica fetch 連 ApiVersionsRequest 都不送（discoverBrokerVersions=false）：這條路上一整組 RPC 版本都不看對端能力，改由叢集事先決定</a:t>
+              <a:t>follower→leader 複製流程連 ApiVersionsRequest 都不送（discoverBrokerVersions=false）：這條路上一整組 RPC 版本都不看對端能力，改由叢集事先決定</a:t>
             </a:r>
           </a:p>
         </p:txBody>
@@ -7777,7 +7777,7 @@
         <p:spPr>
           <a:xfrm>
             <a:off x="640080" y="5056632"/>
-            <a:ext cx="10972800" cy="1188720"/>
+            <a:ext cx="10972800" cy="877824"/>
           </a:xfrm>
           <a:prstGeom prst="rect">
             <a:avLst/>
@@ -7802,7 +7802,7 @@
                 </a:solidFill>
                 <a:latin typeface="Calibri"/>
               </a:rPr>
-              <a:t>為什麼 replica fetch 交給 MV？它要求 follower↔leader 全講同一版、沒法各連線各挑。代價『升級變兩階段』其實是 MV 治理的通性（凡版本由 MV 決定者皆然），非它專屬；協商連線則自動挑上去</a:t>
+              <a:t>為什麼複製流程交給 MV？它要求 follower↔leader 全講同一版、沒法各連線各挑。代價『升級變兩階段』其實是 MV 治理的通性（凡版本由 MV 決定者皆然），非它專屬；協商連線則自動挑上去</a:t>
             </a:r>
           </a:p>
         </p:txBody>

</xml_diff>

<commit_message>
study(version-control): 路徑正名為 Kafka 官方詞「partition replication」（元件 replica fetcher、RPC 用 Fetch）
- deck 架構(a)/(b)、Recap、quiz 0：路徑一律稱 partition replication（follower→leader），replica fetcher 留作元件註解
- 正名層級：partition replication（概念/路徑）→ replica fetcher（元件）→ Fetch/ListOffsets/OffsetsForLeaderEpoch（RPC）
- rpc-version-selection.md 同步
</commit_message>
<xml_diff>
--- a/study/version-control/kafka-version-negotiation.pptx
+++ b/study/version-control/kafka-version-negotiation.pptx
@@ -4076,7 +4076,7 @@
                 </a:solidFill>
                 <a:latin typeface="Calibri"/>
               </a:rPr>
-              <a:t>follower→leader 複製流程裡，Fetch 的版本怎麼決定？</a:t>
+              <a:t>partition replication（follower→leader）裡，Fetch 的版本怎麼決定？</a:t>
             </a:r>
           </a:p>
         </p:txBody>
@@ -4368,7 +4368,7 @@
                 </a:solidFill>
                 <a:latin typeface="Calibri"/>
               </a:rPr>
-              <a:t>follower→leader 複製流程裡，Fetch 的版本怎麼決定？</a:t>
+              <a:t>partition replication（follower→leader）裡，Fetch 的版本怎麼決定？</a:t>
             </a:r>
           </a:p>
         </p:txBody>
@@ -6197,7 +6197,7 @@
                 </a:solidFill>
                 <a:latin typeface="Calibri"/>
               </a:rPr>
-              <a:t>Part 1：不能「一個版本打天下」（client 長壽、broker 滾動升級）；多數路徑靠協商，唯一不協商的是 follower→leader 複製流程——上面 Fetch/ListOffsets 等由 MV 釘版（其餘 broker↔broker 仍協商）</a:t>
+              <a:t>Part 1：不能「一個版本打天下」（client 長壽、broker 滾動升級）；多數路徑靠協商，唯一不協商的是 partition replication（follower→leader）——上面 Fetch/ListOffsets 等由 MV 釘版（其餘 broker↔broker 仍協商）</a:t>
             </a:r>
           </a:p>
         </p:txBody>
@@ -7380,7 +7380,7 @@
                 </a:solidFill>
                 <a:latin typeface="Calibri"/>
               </a:rPr>
-              <a:t>機制二 · 由叢集 MV 事先釘版（KIP-584）：只有 follower→leader 複製流程這條不協商</a:t>
+              <a:t>機制二 · 由叢集 MV 事先釘版（KIP-584）：只有 partition replication（follower→leader）這條不協商</a:t>
             </a:r>
           </a:p>
         </p:txBody>
@@ -7394,7 +7394,7 @@
         <p:spPr>
           <a:xfrm>
             <a:off x="640080" y="4123944"/>
-            <a:ext cx="10972800" cy="1097280"/>
+            <a:ext cx="10972800" cy="1371600"/>
           </a:xfrm>
           <a:prstGeom prst="rect">
             <a:avLst/>
@@ -7432,7 +7432,7 @@
                 </a:solidFill>
                 <a:latin typeface="Calibri"/>
               </a:rPr>
-              <a:t>MV 釘版    follower→leader 複製流程（replica fetcher）—— 唯一不協商的路徑</a:t>
+              <a:t>MV 釘版    partition replication（follower→leader，replica fetcher）—— 唯一不協商</a:t>
             </a:r>
           </a:p>
         </p:txBody>
@@ -7445,7 +7445,7 @@
         </p:nvSpPr>
         <p:spPr>
           <a:xfrm>
-            <a:off x="640080" y="5422392"/>
+            <a:off x="640080" y="5696712"/>
             <a:ext cx="10972800" cy="1024127"/>
           </a:xfrm>
           <a:prstGeom prst="rect">
@@ -7466,7 +7466,7 @@
                 </a:solidFill>
                 <a:latin typeface="Calibri"/>
               </a:rPr>
-              <a:t>唯一不協商的是 follower→leader 複製流程——發三支 RPC：OffsetsForLeaderEpoch 對齊、ListOffsets 定位、Fetch 抓資料，版本都由 MV／寫死；同是 broker↔broker 的 transaction markers 仍協商。</a:t>
+              <a:t>唯一不協商的是 partition replication（follower→leader）——這條流程發三支 RPC：OffsetsForLeaderEpoch 對齊、ListOffsets 定位、Fetch 抓資料，版本都由 MV／寫死；同是 broker↔broker 的 transaction markers 仍協商。</a:t>
             </a:r>
           </a:p>
         </p:txBody>
@@ -7694,7 +7694,7 @@
                 </a:solidFill>
                 <a:latin typeface="Calibri"/>
               </a:rPr>
-              <a:t>協商        取交集最高（client↔broker、broker↔controller、Raft、txn markers）</a:t>
+              <a:t>協商                    取交集最高（client↔broker、broker↔controller、Raft、txn markers）</a:t>
             </a:r>
           </a:p>
           <a:p>
@@ -7705,7 +7705,7 @@
                 </a:solidFill>
                 <a:latin typeface="Calibri"/>
               </a:rPr>
-              <a:t>複製流程    不協商——Fetch/ListOffsets 由 finalized MV、OffsetsForLeaderEpoch 寫死 v4</a:t>
+              <a:t>partition replication   不協商——Fetch/ListOffsets 由 finalized MV、OffsetsForLeaderEpoch 寫死 v4</a:t>
             </a:r>
           </a:p>
         </p:txBody>
@@ -7763,7 +7763,7 @@
                 </a:solidFill>
                 <a:latin typeface="Calibri"/>
               </a:rPr>
-              <a:t>follower→leader 複製流程連 ApiVersionsRequest 都不送（discoverBrokerVersions=false）：這條路上一整組 RPC 版本都不看對端能力，改由叢集事先決定</a:t>
+              <a:t>partition replication（follower→leader）連 ApiVersionsRequest 都不送（discoverBrokerVersions=false）：這條路上一整組 RPC 版本都不看對端能力，改由叢集事先決定</a:t>
             </a:r>
           </a:p>
         </p:txBody>
@@ -7777,7 +7777,7 @@
         <p:spPr>
           <a:xfrm>
             <a:off x="640080" y="5056632"/>
-            <a:ext cx="10972800" cy="877824"/>
+            <a:ext cx="10972800" cy="1188720"/>
           </a:xfrm>
           <a:prstGeom prst="rect">
             <a:avLst/>
@@ -7802,7 +7802,7 @@
                 </a:solidFill>
                 <a:latin typeface="Calibri"/>
               </a:rPr>
-              <a:t>為什麼複製流程交給 MV？它要求 follower↔leader 全講同一版、沒法各連線各挑。代價『升級變兩階段』其實是 MV 治理的通性（凡版本由 MV 決定者皆然），非它專屬；協商連線則自動挑上去</a:t>
+              <a:t>為什麼 partition replication 交給 MV？它要求 follower↔leader 全講同一版、沒法各連線各挑。代價『升級變兩階段』其實是 MV 治理的通性（凡版本由 MV 決定者皆然），非它專屬；協商連線則自動挑上去</a:t>
             </a:r>
           </a:p>
         </p:txBody>

</xml_diff>

<commit_message>
study(version-control): 用 Kafka 正名 finalize 取代自創「釘版」＋套 codex review 兩處修正
- 「MV 釘版」→「finalized MV 決定」（deck 7 處：架構(a)標題/機制二/code、對照、WHAT④、Part2 note、Recap；docs 2 處）
- codex review 抓到的真 bug：Part2 note「broker↔broker 版本由 MV 決定」與 txn markers 協商自相矛盾 → 改「partition replication」
- codex：WHAT solve「這四條就是相容承諾全部內容」過度絕對 → 軟化＋註明 tagged fields/第三方 client 外圍成本
- 測試設定義的「釘 DEV／version.py 釘住」保留（與 finalize 無關）
</commit_message>
<xml_diff>
--- a/study/version-control/kafka-version-negotiation.pptx
+++ b/study/version-control/kafka-version-negotiation.pptx
@@ -3597,7 +3597,7 @@
                 </a:solidFill>
                 <a:latin typeface="Calibri"/>
               </a:rPr>
-              <a:t>④ 滾動升級混版：新舊 broker 並存，inter-broker（MV 釘版）＋對 client 都不掉資料</a:t>
+              <a:t>④ 滾動升級混版：新舊 broker 並存，inter-broker（finalized MV 決定）＋對 client 都不掉資料</a:t>
             </a:r>
           </a:p>
         </p:txBody>
@@ -3611,7 +3611,7 @@
         <p:spPr>
           <a:xfrm>
             <a:off x="640080" y="5751576"/>
-            <a:ext cx="10972800" cy="566928"/>
+            <a:ext cx="10972800" cy="877824"/>
           </a:xfrm>
           <a:prstGeom prst="rect">
             <a:avLst/>
@@ -3636,7 +3636,7 @@
                 </a:solidFill>
                 <a:latin typeface="Calibri"/>
               </a:rPr>
-              <a:t>這四條就是「相容承諾」的全部內容——每一條都得有測試長期盯著</a:t>
+              <a:t>這四條是本場最相關的相容承諾——每一條都得有測試長期盯著（tagged fields、第三方 client 等外圍成本另計）</a:t>
             </a:r>
           </a:p>
         </p:txBody>
@@ -4981,7 +4981,7 @@
                 </a:solidFill>
                 <a:latin typeface="Calibri"/>
               </a:rPr>
-              <a:t>「硬送」指 client↔broker：自刻或有 bug 的 client 繞過協商；broker↔broker 版本已由 MV 事先釘住，不會送出對方不懂的版本。</a:t>
+              <a:t>「硬送」指 client↔broker：自刻或有 bug 的 client 繞過協商；partition replication 的版本已由 finalized MV 事先決定，不會送出對方不懂的版本。</a:t>
             </a:r>
           </a:p>
         </p:txBody>
@@ -6286,7 +6286,7 @@
                 </a:solidFill>
                 <a:latin typeface="Calibri"/>
               </a:rPr>
-              <a:t>Part 1：不能「一個版本打天下」（client 長壽、broker 滾動升級）；多數路徑靠協商，唯一不協商的是 partition replication（follower→leader）——上面 Fetch/ListOffsets 等由 MV 釘版（其餘 broker↔broker 仍協商）</a:t>
+              <a:t>Part 1：不能「一個版本打天下」（client 長壽、broker 滾動升級）；多數路徑靠協商，唯一不協商的是 partition replication（follower→leader）——上面 Fetch/ListOffsets 等由 finalized MV 決定（其餘 broker↔broker 仍協商）</a:t>
             </a:r>
           </a:p>
         </p:txBody>
@@ -7353,7 +7353,7 @@
                 </a:solidFill>
                 <a:latin typeface="Calibri"/>
               </a:rPr>
-              <a:t>版本怎麼定：協商，還是由 MV 事先釘版</a:t>
+              <a:t>版本怎麼定：協商，還是由 finalized MV 決定</a:t>
             </a:r>
           </a:p>
         </p:txBody>
@@ -7469,7 +7469,7 @@
                 </a:solidFill>
                 <a:latin typeface="Calibri"/>
               </a:rPr>
-              <a:t>機制二 · 由叢集 MV 事先釘版（KIP-584）：只有 partition replication（follower→leader）這條不協商</a:t>
+              <a:t>機制二 · 由 finalized MV 事先決定（KIP-584）：只有 partition replication（follower→leader）這條不協商</a:t>
             </a:r>
           </a:p>
         </p:txBody>
@@ -7510,7 +7510,7 @@
                 </a:solidFill>
                 <a:latin typeface="Calibri"/>
               </a:rPr>
-              <a:t>協商定版   client↔broker · broker↔controller · Raft · broker↔broker txn markers</a:t>
+              <a:t>協商           client↔broker · broker↔controller · Raft · broker↔broker txn markers</a:t>
             </a:r>
           </a:p>
           <a:p>
@@ -7521,7 +7521,7 @@
                 </a:solidFill>
                 <a:latin typeface="Calibri"/>
               </a:rPr>
-              <a:t>MV 釘版    partition replication（follower→leader，replica fetcher）—— 唯一不協商</a:t>
+              <a:t>finalized MV   partition replication（follower→leader，replica fetcher）—— 唯一不協商</a:t>
             </a:r>
           </a:p>
         </p:txBody>
@@ -8362,7 +8362,7 @@
                 </a:solidFill>
                 <a:latin typeface="Calibri"/>
               </a:rPr>
-              <a:t>Kafka：per-API 協商，replica fetch 交給 MV 釘版。買到單支 API 獨立演進、複製層可線上滾動升級；代價＝協定面積最大、相容性測試按 API × 版本數放大</a:t>
+              <a:t>Kafka：per-API 協商，partition replication 交給 finalized MV 決定。買到單支 API 獨立演進、複製層可線上滾動升級；代價＝協定面積最大、相容性測試按 API × 版本數放大</a:t>
             </a:r>
           </a:p>
         </p:txBody>

</xml_diff>

<commit_message>
study(version-control): 砍測試 SO-WHAT 那張（太細節）＋架構(b) solve 收尾
- 移除「守住相容，為什麼越來越貴」（乘積/自動擴張 太細節），留 WHAT 四相容義務那張
- 代價頁 note：下兩張→下一張
- 架構(b) solve 去掉尾句「operator 原子切換…兩階段由來」，收在『能看懂≠跨版本行為正確』（前句已夠強）
- deck 18→17 張
</commit_message>
<xml_diff>
--- a/study/version-control/kafka-version-negotiation.pptx
+++ b/study/version-control/kafka-version-negotiation.pptx
@@ -22,7 +22,6 @@
     <p:sldId id="270" r:id="rId21"/>
     <p:sldId id="271" r:id="rId22"/>
     <p:sldId id="272" r:id="rId23"/>
-    <p:sldId id="273" r:id="rId24"/>
   </p:sldIdLst>
   <p:sldSz cx="12191695" cy="6858000" type="screen4x3"/>
   <p:notesSz cx="6858000" cy="9144000"/>
@@ -3789,7 +3788,7 @@
                 </a:solidFill>
                 <a:latin typeface="Calibri"/>
               </a:rPr>
-              <a:t>Part 1 · 代價 · 測試</a:t>
+              <a:t>隨堂考 · 核心</a:t>
             </a:r>
           </a:p>
         </p:txBody>
@@ -3803,55 +3802,74 @@
         <p:spPr>
           <a:xfrm>
             <a:off x="640080" y="841248"/>
-            <a:ext cx="10972800" cy="1005840"/>
-          </a:xfrm>
-          <a:prstGeom prst="rect">
-            <a:avLst/>
-          </a:prstGeom>
-          <a:noFill/>
-        </p:spPr>
-        <p:txBody>
-          <a:bodyPr wrap="square">
-            <a:noAutofit/>
-          </a:bodyPr>
-          <a:lstStyle/>
-          <a:p>
-            <a:r>
-              <a:rPr sz="3200" b="1">
+            <a:ext cx="10972800" cy="1188720"/>
+          </a:xfrm>
+          <a:prstGeom prst="rect">
+            <a:avLst/>
+          </a:prstGeom>
+          <a:noFill/>
+        </p:spPr>
+        <p:txBody>
+          <a:bodyPr wrap="square">
+            <a:noAutofit/>
+          </a:bodyPr>
+          <a:lstStyle/>
+          <a:p>
+            <a:r>
+              <a:rPr sz="2600" b="1">
                 <a:solidFill>
                   <a:srgbClr val="1E2024"/>
                 </a:solidFill>
                 <a:latin typeface="Calibri"/>
               </a:rPr>
-              <a:t>守住相容，為什麼越來越貴</a:t>
-            </a:r>
-          </a:p>
-        </p:txBody>
-      </p:sp>
-      <p:pic>
-        <p:nvPicPr>
-          <p:cNvPr id="4" name="Picture 3" descr="arrows-split.png"/>
-          <p:cNvPicPr>
-            <a:picLocks noChangeAspect="1"/>
-          </p:cNvPicPr>
-          <p:nvPr/>
-        </p:nvPicPr>
-        <p:blipFill>
-          <a:blip r:embed="rId2"/>
-          <a:stretch>
-            <a:fillRect/>
-          </a:stretch>
-        </p:blipFill>
-        <p:spPr>
-          <a:xfrm>
-            <a:off x="658368" y="2176272"/>
-            <a:ext cx="274320" cy="274320"/>
-          </a:xfrm>
-          <a:prstGeom prst="rect">
-            <a:avLst/>
-          </a:prstGeom>
-        </p:spPr>
-      </p:pic>
+              <a:t>partition replication（follower→leader）裡，Fetch 的版本怎麼決定？</a:t>
+            </a:r>
+          </a:p>
+        </p:txBody>
+      </p:sp>
+      <p:sp>
+        <p:nvSpPr>
+          <p:cNvPr id="4" name="TextBox 3"/>
+          <p:cNvSpPr txBox="1"/>
+          <p:nvPr/>
+        </p:nvSpPr>
+        <p:spPr>
+          <a:xfrm>
+            <a:off x="822960" y="2331720"/>
+            <a:ext cx="10515600" cy="493776"/>
+          </a:xfrm>
+          <a:prstGeom prst="rect">
+            <a:avLst/>
+          </a:prstGeom>
+          <a:noFill/>
+        </p:spPr>
+        <p:txBody>
+          <a:bodyPr wrap="square">
+            <a:noAutofit/>
+          </a:bodyPr>
+          <a:lstStyle/>
+          <a:p>
+            <a:r>
+              <a:rPr sz="1600" b="0">
+                <a:solidFill>
+                  <a:srgbClr val="1E2024"/>
+                </a:solidFill>
+                <a:latin typeface="Calibri"/>
+              </a:rPr>
+              <a:t>A.  </a:t>
+            </a:r>
+            <a:r>
+              <a:rPr sz="1600" b="0">
+                <a:solidFill>
+                  <a:srgbClr val="1E2024"/>
+                </a:solidFill>
+                <a:latin typeface="Calibri"/>
+              </a:rPr>
+              <a:t>兩 broker ApiVersions 協商取交集</a:t>
+            </a:r>
+          </a:p>
+        </p:txBody>
+      </p:sp>
       <p:sp>
         <p:nvSpPr>
           <p:cNvPr id="5" name="TextBox 4"/>
@@ -3860,7 +3878,7 @@
         </p:nvSpPr>
         <p:spPr>
           <a:xfrm>
-            <a:off x="1078992" y="2148840"/>
+            <a:off x="822960" y="2953512"/>
             <a:ext cx="10515600" cy="493776"/>
           </a:xfrm>
           <a:prstGeom prst="rect">
@@ -3875,41 +3893,69 @@
           <a:lstStyle/>
           <a:p>
             <a:r>
-              <a:rPr sz="1650" b="0">
+              <a:rPr sz="1600" b="0">
                 <a:solidFill>
                   <a:srgbClr val="1E2024"/>
                 </a:solidFill>
                 <a:latin typeface="Calibri"/>
               </a:rPr>
-              <a:t>① 是「API × 版本」、②③④ 是「版本 × 版本」——測試面是乘積，不是加總</a:t>
-            </a:r>
-          </a:p>
-        </p:txBody>
-      </p:sp>
-      <p:pic>
-        <p:nvPicPr>
-          <p:cNvPr id="6" name="Picture 5" descr="point.png"/>
-          <p:cNvPicPr>
-            <a:picLocks noChangeAspect="1"/>
-          </p:cNvPicPr>
-          <p:nvPr/>
-        </p:nvPicPr>
-        <p:blipFill>
-          <a:blip r:embed="rId3"/>
-          <a:stretch>
-            <a:fillRect/>
-          </a:stretch>
-        </p:blipFill>
-        <p:spPr>
-          <a:xfrm>
-            <a:off x="658368" y="2816352"/>
-            <a:ext cx="274320" cy="274320"/>
-          </a:xfrm>
-          <a:prstGeom prst="rect">
-            <a:avLst/>
-          </a:prstGeom>
-        </p:spPr>
-      </p:pic>
+              <a:t>B.  </a:t>
+            </a:r>
+            <a:r>
+              <a:rPr sz="1600" b="0">
+                <a:solidFill>
+                  <a:srgbClr val="1E2024"/>
+                </a:solidFill>
+                <a:latin typeface="Calibri"/>
+              </a:rPr>
+              <a:t>由 finalized metadata.version 決定</a:t>
+            </a:r>
+          </a:p>
+        </p:txBody>
+      </p:sp>
+      <p:sp>
+        <p:nvSpPr>
+          <p:cNvPr id="6" name="TextBox 5"/>
+          <p:cNvSpPr txBox="1"/>
+          <p:nvPr/>
+        </p:nvSpPr>
+        <p:spPr>
+          <a:xfrm>
+            <a:off x="822960" y="3575304"/>
+            <a:ext cx="10515600" cy="493776"/>
+          </a:xfrm>
+          <a:prstGeom prst="rect">
+            <a:avLst/>
+          </a:prstGeom>
+          <a:noFill/>
+        </p:spPr>
+        <p:txBody>
+          <a:bodyPr wrap="square">
+            <a:noAutofit/>
+          </a:bodyPr>
+          <a:lstStyle/>
+          <a:p>
+            <a:r>
+              <a:rPr sz="1600" b="0">
+                <a:solidFill>
+                  <a:srgbClr val="1E2024"/>
+                </a:solidFill>
+                <a:latin typeface="Calibri"/>
+              </a:rPr>
+              <a:t>C.  </a:t>
+            </a:r>
+            <a:r>
+              <a:rPr sz="1600" b="0">
+                <a:solidFill>
+                  <a:srgbClr val="1E2024"/>
+                </a:solidFill>
+                <a:latin typeface="Calibri"/>
+              </a:rPr>
+              <a:t>永遠用最新版</a:t>
+            </a:r>
+          </a:p>
+        </p:txBody>
+      </p:sp>
       <p:sp>
         <p:nvSpPr>
           <p:cNvPr id="7" name="TextBox 6"/>
@@ -3918,28 +3964,37 @@
         </p:nvSpPr>
         <p:spPr>
           <a:xfrm>
-            <a:off x="1078992" y="2788920"/>
-            <a:ext cx="10515600" cy="841248"/>
-          </a:xfrm>
-          <a:prstGeom prst="rect">
-            <a:avLst/>
-          </a:prstGeom>
-          <a:noFill/>
-        </p:spPr>
-        <p:txBody>
-          <a:bodyPr wrap="square">
-            <a:noAutofit/>
-          </a:bodyPr>
-          <a:lstStyle/>
-          <a:p>
-            <a:r>
-              <a:rPr sz="1650" b="0">
+            <a:off x="822960" y="4197096"/>
+            <a:ext cx="10515600" cy="493776"/>
+          </a:xfrm>
+          <a:prstGeom prst="rect">
+            <a:avLst/>
+          </a:prstGeom>
+          <a:noFill/>
+        </p:spPr>
+        <p:txBody>
+          <a:bodyPr wrap="square">
+            <a:noAutofit/>
+          </a:bodyPr>
+          <a:lstStyle/>
+          <a:p>
+            <a:r>
+              <a:rPr sz="1600" b="0">
                 <a:solidFill>
                   <a:srgbClr val="1E2024"/>
                 </a:solidFill>
                 <a:latin typeface="Calibri"/>
               </a:rPr>
-              <a:t>有些自動擴張（新版本免補測試、但每次 build 越跑越久），有些得手動 +1（多養一個歷史版本、多一組參數）</a:t>
+              <a:t>D.  </a:t>
+            </a:r>
+            <a:r>
+              <a:rPr sz="1600" b="0">
+                <a:solidFill>
+                  <a:srgbClr val="1E2024"/>
+                </a:solidFill>
+                <a:latin typeface="Calibri"/>
+              </a:rPr>
+              <a:t>controller 每次指定</a:t>
             </a:r>
           </a:p>
         </p:txBody>
@@ -3952,134 +4007,28 @@
         </p:nvSpPr>
         <p:spPr>
           <a:xfrm>
-            <a:off x="640080" y="3776472"/>
-            <a:ext cx="10972800" cy="566928"/>
-          </a:xfrm>
-          <a:prstGeom prst="rect">
-            <a:avLst/>
-          </a:prstGeom>
-          <a:solidFill>
-            <a:srgbClr val="E9F3DE"/>
-          </a:solidFill>
-          <a:ln>
-            <a:noFill/>
-          </a:ln>
-        </p:spPr>
-        <p:txBody>
-          <a:bodyPr wrap="square" lIns="146304" tIns="82296">
-            <a:noAutofit/>
-          </a:bodyPr>
-          <a:lstStyle/>
-          <a:p>
-            <a:r>
-              <a:rPr sz="1500" b="0">
-                <a:solidFill>
-                  <a:srgbClr val="27500A"/>
-                </a:solidFill>
-                <a:latin typeface="Calibri"/>
-              </a:rPr>
-              <a:t>所以它是只增不減的持續支出——貴到 Kafka 在 KIP-896 得砍掉 2.1 以前的舊版本止血</a:t>
-            </a:r>
-          </a:p>
-        </p:txBody>
-      </p:sp>
-      <p:sp>
-        <p:nvSpPr>
-          <p:cNvPr id="9" name="TextBox 8"/>
-          <p:cNvSpPr txBox="1"/>
-          <p:nvPr/>
-        </p:nvSpPr>
-        <p:spPr>
-          <a:xfrm>
-            <a:off x="640080" y="6400800"/>
-            <a:ext cx="10972800" cy="384048"/>
-          </a:xfrm>
-          <a:prstGeom prst="rect">
-            <a:avLst/>
-          </a:prstGeom>
-          <a:noFill/>
-        </p:spPr>
-        <p:txBody>
-          <a:bodyPr wrap="square">
-            <a:noAutofit/>
-          </a:bodyPr>
-          <a:lstStyle/>
-          <a:p>
-            <a:r>
-              <a:rPr sz="1200" b="1">
+            <a:off x="640080" y="4910327"/>
+            <a:ext cx="10972800" cy="914400"/>
+          </a:xfrm>
+          <a:prstGeom prst="rect">
+            <a:avLst/>
+          </a:prstGeom>
+          <a:noFill/>
+        </p:spPr>
+        <p:txBody>
+          <a:bodyPr wrap="square">
+            <a:noAutofit/>
+          </a:bodyPr>
+          <a:lstStyle/>
+          <a:p>
+            <a:r>
+              <a:rPr sz="1400" b="0">
                 <a:solidFill>
                   <a:srgbClr val="8A8A8A"/>
                 </a:solidFill>
                 <a:latin typeface="Calibri"/>
               </a:rPr>
-              <a:t>REF   </a:t>
-            </a:r>
-            <a:r>
-              <a:rPr sz="1200" b="0" u="sng">
-                <a:solidFill>
-                  <a:srgbClr val="185FA5"/>
-                </a:solidFill>
-                <a:latin typeface="Calibri"/>
-                <a:hlinkClick r:id="rId4"/>
-              </a:rPr>
-              <a:t>KIP-896</a:t>
-            </a:r>
-            <a:r>
-              <a:rPr sz="1200" b="0">
-                <a:solidFill>
-                  <a:srgbClr val="8A8A8A"/>
-                </a:solidFill>
-                <a:latin typeface="Calibri"/>
-              </a:rPr>
-              <a:t>   ·   </a:t>
-            </a:r>
-            <a:r>
-              <a:rPr sz="1200" b="0" u="sng">
-                <a:solidFill>
-                  <a:srgbClr val="185FA5"/>
-                </a:solidFill>
-                <a:latin typeface="Courier New"/>
-                <a:hlinkClick r:id="rId5"/>
-              </a:rPr>
-              <a:t>版本清單手動+1</a:t>
-            </a:r>
-            <a:r>
-              <a:rPr sz="1200" b="0">
-                <a:solidFill>
-                  <a:srgbClr val="8A8A8A"/>
-                </a:solidFill>
-                <a:latin typeface="Calibri"/>
-              </a:rPr>
-              <a:t>   ·   </a:t>
-            </a:r>
-            <a:r>
-              <a:rPr sz="1200" b="0" u="sng">
-                <a:solidFill>
-                  <a:srgbClr val="185FA5"/>
-                </a:solidFill>
-                <a:latin typeface="Courier New"/>
-                <a:hlinkClick r:id="rId6"/>
-              </a:rPr>
-              <a:t>養 22 個歷史版本</a:t>
-            </a:r>
-            <a:r>
-              <a:rPr sz="1200" b="0">
-                <a:solidFill>
-                  <a:srgbClr val="8A8A8A"/>
-                </a:solidFill>
-                <a:latin typeface="Calibri"/>
-              </a:rPr>
-              <a:t>   ·   </a:t>
-            </a:r>
-            <a:r>
-              <a:rPr sz="1200" b="0" u="sng">
-                <a:solidFill>
-                  <a:srgbClr val="185FA5"/>
-                </a:solidFill>
-                <a:latin typeface="Courier New"/>
-                <a:hlinkClick r:id="rId7"/>
-              </a:rPr>
-              <a:t>MV 矩陣</a:t>
+              <a:t>想一想 —— 下一頁公布答案</a:t>
             </a:r>
           </a:p>
         </p:txBody>
@@ -4131,7 +4080,7 @@
                 </a:solidFill>
                 <a:latin typeface="Calibri"/>
               </a:rPr>
-              <a:t>隨堂考 · 核心</a:t>
+              <a:t>隨堂考 · 核心　（正解）</a:t>
             </a:r>
           </a:p>
         </p:txBody>
@@ -4227,31 +4176,36 @@
           <a:prstGeom prst="rect">
             <a:avLst/>
           </a:prstGeom>
-          <a:noFill/>
-        </p:spPr>
-        <p:txBody>
-          <a:bodyPr wrap="square">
-            <a:noAutofit/>
-          </a:bodyPr>
-          <a:lstStyle/>
-          <a:p>
-            <a:r>
-              <a:rPr sz="1600" b="0">
-                <a:solidFill>
-                  <a:srgbClr val="1E2024"/>
+          <a:solidFill>
+            <a:srgbClr val="E9F3DE"/>
+          </a:solidFill>
+          <a:ln>
+            <a:noFill/>
+          </a:ln>
+        </p:spPr>
+        <p:txBody>
+          <a:bodyPr wrap="square" lIns="128016" tIns="54864">
+            <a:noAutofit/>
+          </a:bodyPr>
+          <a:lstStyle/>
+          <a:p>
+            <a:r>
+              <a:rPr sz="1600" b="1">
+                <a:solidFill>
+                  <a:srgbClr val="27500A"/>
                 </a:solidFill>
                 <a:latin typeface="Calibri"/>
               </a:rPr>
               <a:t>B.  </a:t>
             </a:r>
             <a:r>
-              <a:rPr sz="1600" b="0">
-                <a:solidFill>
-                  <a:srgbClr val="1E2024"/>
-                </a:solidFill>
-                <a:latin typeface="Calibri"/>
-              </a:rPr>
-              <a:t>由 finalized metadata.version 決定</a:t>
+              <a:rPr sz="1600" b="1">
+                <a:solidFill>
+                  <a:srgbClr val="27500A"/>
+                </a:solidFill>
+                <a:latin typeface="Calibri"/>
+              </a:rPr>
+              <a:t>由 finalized metadata.version 決定   ✓</a:t>
             </a:r>
           </a:p>
         </p:txBody>
@@ -4365,13 +4319,85 @@
           <a:lstStyle/>
           <a:p>
             <a:r>
+              <a:rPr sz="1400" b="1">
+                <a:solidFill>
+                  <a:srgbClr val="27500A"/>
+                </a:solidFill>
+                <a:latin typeface="Calibri"/>
+              </a:rPr>
+              <a:t>正解 B — </a:t>
+            </a:r>
+            <a:r>
               <a:rPr sz="1400" b="0">
                 <a:solidFill>
+                  <a:srgbClr val="1E2024"/>
+                </a:solidFill>
+                <a:latin typeface="Calibri"/>
+              </a:rPr>
+              <a:t>fetchRequestVersion(MV)：MV 是集中共識，不做 per-connection 協商。</a:t>
+            </a:r>
+          </a:p>
+        </p:txBody>
+      </p:sp>
+      <p:sp>
+        <p:nvSpPr>
+          <p:cNvPr id="9" name="TextBox 8"/>
+          <p:cNvSpPr txBox="1"/>
+          <p:nvPr/>
+        </p:nvSpPr>
+        <p:spPr>
+          <a:xfrm>
+            <a:off x="640080" y="6400800"/>
+            <a:ext cx="10972800" cy="384048"/>
+          </a:xfrm>
+          <a:prstGeom prst="rect">
+            <a:avLst/>
+          </a:prstGeom>
+          <a:noFill/>
+        </p:spPr>
+        <p:txBody>
+          <a:bodyPr wrap="square">
+            <a:noAutofit/>
+          </a:bodyPr>
+          <a:lstStyle/>
+          <a:p>
+            <a:r>
+              <a:rPr sz="1200" b="1">
+                <a:solidFill>
                   <a:srgbClr val="8A8A8A"/>
                 </a:solidFill>
                 <a:latin typeface="Calibri"/>
               </a:rPr>
-              <a:t>想一想 —— 下一頁公布答案</a:t>
+              <a:t>REF   </a:t>
+            </a:r>
+            <a:r>
+              <a:rPr sz="1200" b="0" u="sng">
+                <a:solidFill>
+                  <a:srgbClr val="185FA5"/>
+                </a:solidFill>
+                <a:latin typeface="Courier New"/>
+                <a:hlinkClick r:id="rId2"/>
+              </a:rPr>
+              <a:t>RemoteLeaderEndPoint.scala:215</a:t>
+            </a:r>
+            <a:r>
+              <a:rPr sz="1200" b="0">
+                <a:solidFill>
+                  <a:srgbClr val="8A8A8A"/>
+                </a:solidFill>
+                <a:latin typeface="Calibri"/>
+              </a:rPr>
+              <a:t>   ·   </a:t>
+            </a:r>
+            <a:r>
+              <a:rPr sz="1200" b="0" u="sng">
+                <a:solidFill>
+                  <a:srgbClr val="185FA5"/>
+                </a:solidFill>
+                <a:latin typeface="Courier New"/>
+                <a:hlinkClick r:id="rId3"/>
+              </a:rPr>
+              <a:t>MetadataVersion.java:273</a:t>
             </a:r>
           </a:p>
         </p:txBody>
@@ -4423,7 +4449,7 @@
                 </a:solidFill>
                 <a:latin typeface="Calibri"/>
               </a:rPr>
-              <a:t>隨堂考 · 核心　（正解）</a:t>
+              <a:t>Part 2 · 失敗訊息</a:t>
             </a:r>
           </a:p>
         </p:txBody>
@@ -4437,27 +4463,27 @@
         <p:spPr>
           <a:xfrm>
             <a:off x="640080" y="841248"/>
-            <a:ext cx="10972800" cy="1188720"/>
-          </a:xfrm>
-          <a:prstGeom prst="rect">
-            <a:avLst/>
-          </a:prstGeom>
-          <a:noFill/>
-        </p:spPr>
-        <p:txBody>
-          <a:bodyPr wrap="square">
-            <a:noAutofit/>
-          </a:bodyPr>
-          <a:lstStyle/>
-          <a:p>
-            <a:r>
-              <a:rPr sz="2600" b="1">
+            <a:ext cx="10972800" cy="1005840"/>
+          </a:xfrm>
+          <a:prstGeom prst="rect">
+            <a:avLst/>
+          </a:prstGeom>
+          <a:noFill/>
+        </p:spPr>
+        <p:txBody>
+          <a:bodyPr wrap="square">
+            <a:noAutofit/>
+          </a:bodyPr>
+          <a:lstStyle/>
+          <a:p>
+            <a:r>
+              <a:rPr sz="3200" b="1">
                 <a:solidFill>
                   <a:srgbClr val="1E2024"/>
                 </a:solidFill>
                 <a:latin typeface="Calibri"/>
               </a:rPr>
-              <a:t>partition replication（follower→leader）裡，Fetch 的版本怎麼決定？</a:t>
+              <a:t>通訊當下協商不出版本，會看到什麼</a:t>
             </a:r>
           </a:p>
         </p:txBody>
@@ -4470,7 +4496,94 @@
         </p:nvSpPr>
         <p:spPr>
           <a:xfrm>
-            <a:off x="822960" y="2331720"/>
+            <a:off x="640080" y="2148840"/>
+            <a:ext cx="10972800" cy="1645920"/>
+          </a:xfrm>
+          <a:prstGeom prst="rect">
+            <a:avLst/>
+          </a:prstGeom>
+          <a:solidFill>
+            <a:srgbClr val="F3F1EC"/>
+          </a:solidFill>
+          <a:ln w="6350">
+            <a:solidFill>
+              <a:srgbClr val="E3E0D8"/>
+            </a:solidFill>
+          </a:ln>
+        </p:spPr>
+        <p:txBody>
+          <a:bodyPr wrap="square" lIns="146304" tIns="91440" bIns="91440">
+            <a:noAutofit/>
+          </a:bodyPr>
+          <a:lstStyle/>
+          <a:p>
+            <a:r>
+              <a:rPr sz="1350" b="0">
+                <a:solidFill>
+                  <a:srgbClr val="2C2C2A"/>
+                </a:solidFill>
+                <a:latin typeface="Calibri"/>
+              </a:rPr>
+              <a:t>交集空                       → client 端 UnsupportedVersionException（送出前 abort）</a:t>
+            </a:r>
+          </a:p>
+          <a:p>
+            <a:r>
+              <a:rPr sz="1350" b="0">
+                <a:solidFill>
+                  <a:srgbClr val="2C2C2A"/>
+                </a:solidFill>
+                <a:latin typeface="Calibri"/>
+              </a:rPr>
+              <a:t>client 繞過協商、硬送不支援版本 → broker 丟 UnsupportedVersionException、關閉連線</a:t>
+            </a:r>
+          </a:p>
+          <a:p>
+            <a:r>
+              <a:rPr sz="1350" b="0">
+                <a:solidFill>
+                  <a:srgbClr val="2C2C2A"/>
+                </a:solidFill>
+                <a:latin typeface="Calibri"/>
+              </a:rPr>
+              <a:t>（ApiVersions 例外：回 v0 + UNSUPPORTED_VERSION 錯誤碼）</a:t>
+            </a:r>
+          </a:p>
+        </p:txBody>
+      </p:sp>
+      <p:pic>
+        <p:nvPicPr>
+          <p:cNvPr id="5" name="Picture 4" descr="ban.png"/>
+          <p:cNvPicPr>
+            <a:picLocks noChangeAspect="1"/>
+          </p:cNvPicPr>
+          <p:nvPr/>
+        </p:nvPicPr>
+        <p:blipFill>
+          <a:blip r:embed="rId2"/>
+          <a:stretch>
+            <a:fillRect/>
+          </a:stretch>
+        </p:blipFill>
+        <p:spPr>
+          <a:xfrm>
+            <a:off x="658368" y="4023360"/>
+            <a:ext cx="274320" cy="274320"/>
+          </a:xfrm>
+          <a:prstGeom prst="rect">
+            <a:avLst/>
+          </a:prstGeom>
+        </p:spPr>
+      </p:pic>
+      <p:sp>
+        <p:nvSpPr>
+          <p:cNvPr id="6" name="TextBox 5"/>
+          <p:cNvSpPr txBox="1"/>
+          <p:nvPr/>
+        </p:nvSpPr>
+        <p:spPr>
+          <a:xfrm>
+            <a:off x="1078992" y="3995928"/>
             <a:ext cx="10515600" cy="493776"/>
           </a:xfrm>
           <a:prstGeom prst="rect">
@@ -4485,113 +4598,13 @@
           <a:lstStyle/>
           <a:p>
             <a:r>
-              <a:rPr sz="1600" b="0">
+              <a:rPr sz="1650" b="0">
                 <a:solidFill>
                   <a:srgbClr val="1E2024"/>
                 </a:solidFill>
                 <a:latin typeface="Calibri"/>
               </a:rPr>
-              <a:t>A.  </a:t>
-            </a:r>
-            <a:r>
-              <a:rPr sz="1600" b="0">
-                <a:solidFill>
-                  <a:srgbClr val="1E2024"/>
-                </a:solidFill>
-                <a:latin typeface="Calibri"/>
-              </a:rPr>
-              <a:t>兩 broker ApiVersions 協商取交集</a:t>
-            </a:r>
-          </a:p>
-        </p:txBody>
-      </p:sp>
-      <p:sp>
-        <p:nvSpPr>
-          <p:cNvPr id="5" name="TextBox 4"/>
-          <p:cNvSpPr txBox="1"/>
-          <p:nvPr/>
-        </p:nvSpPr>
-        <p:spPr>
-          <a:xfrm>
-            <a:off x="822960" y="2953512"/>
-            <a:ext cx="10515600" cy="493776"/>
-          </a:xfrm>
-          <a:prstGeom prst="rect">
-            <a:avLst/>
-          </a:prstGeom>
-          <a:solidFill>
-            <a:srgbClr val="E9F3DE"/>
-          </a:solidFill>
-          <a:ln>
-            <a:noFill/>
-          </a:ln>
-        </p:spPr>
-        <p:txBody>
-          <a:bodyPr wrap="square" lIns="128016" tIns="54864">
-            <a:noAutofit/>
-          </a:bodyPr>
-          <a:lstStyle/>
-          <a:p>
-            <a:r>
-              <a:rPr sz="1600" b="1">
-                <a:solidFill>
-                  <a:srgbClr val="27500A"/>
-                </a:solidFill>
-                <a:latin typeface="Calibri"/>
-              </a:rPr>
-              <a:t>B.  </a:t>
-            </a:r>
-            <a:r>
-              <a:rPr sz="1600" b="1">
-                <a:solidFill>
-                  <a:srgbClr val="27500A"/>
-                </a:solidFill>
-                <a:latin typeface="Calibri"/>
-              </a:rPr>
-              <a:t>由 finalized metadata.version 決定   ✓</a:t>
-            </a:r>
-          </a:p>
-        </p:txBody>
-      </p:sp>
-      <p:sp>
-        <p:nvSpPr>
-          <p:cNvPr id="6" name="TextBox 5"/>
-          <p:cNvSpPr txBox="1"/>
-          <p:nvPr/>
-        </p:nvSpPr>
-        <p:spPr>
-          <a:xfrm>
-            <a:off x="822960" y="3575304"/>
-            <a:ext cx="10515600" cy="493776"/>
-          </a:xfrm>
-          <a:prstGeom prst="rect">
-            <a:avLst/>
-          </a:prstGeom>
-          <a:noFill/>
-        </p:spPr>
-        <p:txBody>
-          <a:bodyPr wrap="square">
-            <a:noAutofit/>
-          </a:bodyPr>
-          <a:lstStyle/>
-          <a:p>
-            <a:r>
-              <a:rPr sz="1600" b="0">
-                <a:solidFill>
-                  <a:srgbClr val="1E2024"/>
-                </a:solidFill>
-                <a:latin typeface="Calibri"/>
-              </a:rPr>
-              <a:t>C.  </a:t>
-            </a:r>
-            <a:r>
-              <a:rPr sz="1600" b="0">
-                <a:solidFill>
-                  <a:srgbClr val="1E2024"/>
-                </a:solidFill>
-                <a:latin typeface="Calibri"/>
-              </a:rPr>
-              <a:t>永遠用最新版</a:t>
+              <a:t>多數情況 client 在送出前就本地中止，根本沒上網路</a:t>
             </a:r>
           </a:p>
         </p:txBody>
@@ -4604,37 +4617,28 @@
         </p:nvSpPr>
         <p:spPr>
           <a:xfrm>
-            <a:off x="822960" y="4197096"/>
-            <a:ext cx="10515600" cy="493776"/>
-          </a:xfrm>
-          <a:prstGeom prst="rect">
-            <a:avLst/>
-          </a:prstGeom>
-          <a:noFill/>
-        </p:spPr>
-        <p:txBody>
-          <a:bodyPr wrap="square">
-            <a:noAutofit/>
-          </a:bodyPr>
-          <a:lstStyle/>
-          <a:p>
-            <a:r>
-              <a:rPr sz="1600" b="0">
-                <a:solidFill>
-                  <a:srgbClr val="1E2024"/>
-                </a:solidFill>
-                <a:latin typeface="Calibri"/>
-              </a:rPr>
-              <a:t>D.  </a:t>
-            </a:r>
-            <a:r>
-              <a:rPr sz="1600" b="0">
-                <a:solidFill>
-                  <a:srgbClr val="1E2024"/>
-                </a:solidFill>
-                <a:latin typeface="Calibri"/>
-              </a:rPr>
-              <a:t>controller 每次指定</a:t>
+            <a:off x="640080" y="4636008"/>
+            <a:ext cx="10972800" cy="731520"/>
+          </a:xfrm>
+          <a:prstGeom prst="rect">
+            <a:avLst/>
+          </a:prstGeom>
+          <a:noFill/>
+        </p:spPr>
+        <p:txBody>
+          <a:bodyPr wrap="square">
+            <a:noAutofit/>
+          </a:bodyPr>
+          <a:lstStyle/>
+          <a:p>
+            <a:r>
+              <a:rPr sz="1500" b="0">
+                <a:solidFill>
+                  <a:srgbClr val="5F5E5A"/>
+                </a:solidFill>
+                <a:latin typeface="Calibri"/>
+              </a:rPr>
+              <a:t>「硬送」指 client↔broker：自刻或有 bug 的 client 繞過協商；partition replication 的版本已由 finalized MV 事先決定，不會送出對方不懂的版本。</a:t>
             </a:r>
           </a:p>
         </p:txBody>
@@ -4642,49 +4646,6 @@
       <p:sp>
         <p:nvSpPr>
           <p:cNvPr id="8" name="TextBox 7"/>
-          <p:cNvSpPr txBox="1"/>
-          <p:nvPr/>
-        </p:nvSpPr>
-        <p:spPr>
-          <a:xfrm>
-            <a:off x="640080" y="4910327"/>
-            <a:ext cx="10972800" cy="914400"/>
-          </a:xfrm>
-          <a:prstGeom prst="rect">
-            <a:avLst/>
-          </a:prstGeom>
-          <a:noFill/>
-        </p:spPr>
-        <p:txBody>
-          <a:bodyPr wrap="square">
-            <a:noAutofit/>
-          </a:bodyPr>
-          <a:lstStyle/>
-          <a:p>
-            <a:r>
-              <a:rPr sz="1400" b="1">
-                <a:solidFill>
-                  <a:srgbClr val="27500A"/>
-                </a:solidFill>
-                <a:latin typeface="Calibri"/>
-              </a:rPr>
-              <a:t>正解 B — </a:t>
-            </a:r>
-            <a:r>
-              <a:rPr sz="1400" b="0">
-                <a:solidFill>
-                  <a:srgbClr val="1E2024"/>
-                </a:solidFill>
-                <a:latin typeface="Calibri"/>
-              </a:rPr>
-              <a:t>fetchRequestVersion(MV)：MV 是集中共識，不做 per-connection 協商。</a:t>
-            </a:r>
-          </a:p>
-        </p:txBody>
-      </p:sp>
-      <p:sp>
-        <p:nvSpPr>
-          <p:cNvPr id="9" name="TextBox 8"/>
           <p:cNvSpPr txBox="1"/>
           <p:nvPr/>
         </p:nvSpPr>
@@ -4719,9 +4680,9 @@
                   <a:srgbClr val="185FA5"/>
                 </a:solidFill>
                 <a:latin typeface="Courier New"/>
-                <a:hlinkClick r:id="rId2"/>
-              </a:rPr>
-              <a:t>RemoteLeaderEndPoint.scala:215</a:t>
+                <a:hlinkClick r:id="rId3"/>
+              </a:rPr>
+              <a:t>latestUsableVersion</a:t>
             </a:r>
             <a:r>
               <a:rPr sz="1200" b="0">
@@ -4738,9 +4699,28 @@
                   <a:srgbClr val="185FA5"/>
                 </a:solidFill>
                 <a:latin typeface="Courier New"/>
-                <a:hlinkClick r:id="rId3"/>
-              </a:rPr>
-              <a:t>MetadataVersion.java:273</a:t>
+                <a:hlinkClick r:id="rId4"/>
+              </a:rPr>
+              <a:t>NetworkClient</a:t>
+            </a:r>
+            <a:r>
+              <a:rPr sz="1200" b="0">
+                <a:solidFill>
+                  <a:srgbClr val="8A8A8A"/>
+                </a:solidFill>
+                <a:latin typeface="Calibri"/>
+              </a:rPr>
+              <a:t>   ·   </a:t>
+            </a:r>
+            <a:r>
+              <a:rPr sz="1200" b="0" u="sng">
+                <a:solidFill>
+                  <a:srgbClr val="185FA5"/>
+                </a:solidFill>
+                <a:latin typeface="Courier New"/>
+                <a:hlinkClick r:id="rId5"/>
+              </a:rPr>
+              <a:t>RequestContext</a:t>
             </a:r>
           </a:p>
         </p:txBody>
@@ -4826,21 +4806,79 @@
                 </a:solidFill>
                 <a:latin typeface="Calibri"/>
               </a:rPr>
-              <a:t>通訊當下協商不出版本，會看到什麼</a:t>
-            </a:r>
-          </a:p>
-        </p:txBody>
-      </p:sp>
-      <p:sp>
-        <p:nvSpPr>
-          <p:cNvPr id="4" name="TextBox 3"/>
-          <p:cNvSpPr txBox="1"/>
-          <p:nvPr/>
-        </p:nvSpPr>
-        <p:spPr>
-          <a:xfrm>
-            <a:off x="640080" y="2148840"/>
-            <a:ext cx="10972800" cy="1645920"/>
+              <a:t>版本截斷：為什麼「升一點點」不夠</a:t>
+            </a:r>
+          </a:p>
+        </p:txBody>
+      </p:sp>
+      <p:pic>
+        <p:nvPicPr>
+          <p:cNvPr id="4" name="Picture 3" descr="alert-triangle.png"/>
+          <p:cNvPicPr>
+            <a:picLocks noChangeAspect="1"/>
+          </p:cNvPicPr>
+          <p:nvPr/>
+        </p:nvPicPr>
+        <p:blipFill>
+          <a:blip r:embed="rId2"/>
+          <a:stretch>
+            <a:fillRect/>
+          </a:stretch>
+        </p:blipFill>
+        <p:spPr>
+          <a:xfrm>
+            <a:off x="658368" y="2176272"/>
+            <a:ext cx="274320" cy="274320"/>
+          </a:xfrm>
+          <a:prstGeom prst="rect">
+            <a:avLst/>
+          </a:prstGeom>
+        </p:spPr>
+      </p:pic>
+      <p:sp>
+        <p:nvSpPr>
+          <p:cNvPr id="5" name="TextBox 4"/>
+          <p:cNvSpPr txBox="1"/>
+          <p:nvPr/>
+        </p:nvSpPr>
+        <p:spPr>
+          <a:xfrm>
+            <a:off x="1078992" y="2148840"/>
+            <a:ext cx="10515600" cy="493776"/>
+          </a:xfrm>
+          <a:prstGeom prst="rect">
+            <a:avLst/>
+          </a:prstGeom>
+          <a:noFill/>
+        </p:spPr>
+        <p:txBody>
+          <a:bodyPr wrap="square">
+            <a:noAutofit/>
+          </a:bodyPr>
+          <a:lstStyle/>
+          <a:p>
+            <a:r>
+              <a:rPr sz="1650" b="0">
+                <a:solidFill>
+                  <a:srgbClr val="1E2024"/>
+                </a:solidFill>
+                <a:latin typeface="Calibri"/>
+              </a:rPr>
+              <a:t>前一頁「交集空」最容易被忽略的根因——舊 wire 版本被整批移除</a:t>
+            </a:r>
+          </a:p>
+        </p:txBody>
+      </p:sp>
+      <p:sp>
+        <p:nvSpPr>
+          <p:cNvPr id="6" name="TextBox 5"/>
+          <p:cNvSpPr txBox="1"/>
+          <p:nvPr/>
+        </p:nvSpPr>
+        <p:spPr>
+          <a:xfrm>
+            <a:off x="640080" y="2788920"/>
+            <a:ext cx="10972800" cy="822959"/>
           </a:xfrm>
           <a:prstGeom prst="rect">
             <a:avLst/>
@@ -4867,7 +4905,7 @@
                 </a:solidFill>
                 <a:latin typeface="Calibri"/>
               </a:rPr>
-              <a:t>交集空                       → client 端 UnsupportedVersionException（送出前 abort）</a:t>
+              <a:t>舊 wire API version 被整個移除，min 可 &gt; 0</a:t>
             </a:r>
           </a:p>
           <a:p>
@@ -4878,76 +4916,7 @@
                 </a:solidFill>
                 <a:latin typeface="Calibri"/>
               </a:rPr>
-              <a:t>client 繞過協商、硬送不支援版本 → broker 丟 UnsupportedVersionException、關閉連線</a:t>
-            </a:r>
-          </a:p>
-          <a:p>
-            <a:r>
-              <a:rPr sz="1350" b="0">
-                <a:solidFill>
-                  <a:srgbClr val="2C2C2A"/>
-                </a:solidFill>
-                <a:latin typeface="Calibri"/>
-              </a:rPr>
-              <a:t>（ApiVersions 例外：回 v0 + UNSUPPORTED_VERSION 錯誤碼）</a:t>
-            </a:r>
-          </a:p>
-        </p:txBody>
-      </p:sp>
-      <p:pic>
-        <p:nvPicPr>
-          <p:cNvPr id="5" name="Picture 4" descr="ban.png"/>
-          <p:cNvPicPr>
-            <a:picLocks noChangeAspect="1"/>
-          </p:cNvPicPr>
-          <p:nvPr/>
-        </p:nvPicPr>
-        <p:blipFill>
-          <a:blip r:embed="rId2"/>
-          <a:stretch>
-            <a:fillRect/>
-          </a:stretch>
-        </p:blipFill>
-        <p:spPr>
-          <a:xfrm>
-            <a:off x="658368" y="4023360"/>
-            <a:ext cx="274320" cy="274320"/>
-          </a:xfrm>
-          <a:prstGeom prst="rect">
-            <a:avLst/>
-          </a:prstGeom>
-        </p:spPr>
-      </p:pic>
-      <p:sp>
-        <p:nvSpPr>
-          <p:cNvPr id="6" name="TextBox 5"/>
-          <p:cNvSpPr txBox="1"/>
-          <p:nvPr/>
-        </p:nvSpPr>
-        <p:spPr>
-          <a:xfrm>
-            <a:off x="1078992" y="3995928"/>
-            <a:ext cx="10515600" cy="493776"/>
-          </a:xfrm>
-          <a:prstGeom prst="rect">
-            <a:avLst/>
-          </a:prstGeom>
-          <a:noFill/>
-        </p:spPr>
-        <p:txBody>
-          <a:bodyPr wrap="square">
-            <a:noAutofit/>
-          </a:bodyPr>
-          <a:lstStyle/>
-          <a:p>
-            <a:r>
-              <a:rPr sz="1650" b="0">
-                <a:solidFill>
-                  <a:srgbClr val="1E2024"/>
-                </a:solidFill>
-                <a:latin typeface="Calibri"/>
-              </a:rPr>
-              <a:t>多數情況 client 在送出前就本地中止，根本沒上網路</a:t>
+              <a:t>  Fetch：4–18（v0–3 在 4.0 移除）</a:t>
             </a:r>
           </a:p>
         </p:txBody>
@@ -4960,7 +4929,46 @@
         </p:nvSpPr>
         <p:spPr>
           <a:xfrm>
-            <a:off x="640080" y="4636008"/>
+            <a:off x="640080" y="3813048"/>
+            <a:ext cx="10972800" cy="877824"/>
+          </a:xfrm>
+          <a:prstGeom prst="rect">
+            <a:avLst/>
+          </a:prstGeom>
+          <a:solidFill>
+            <a:srgbClr val="E9F3DE"/>
+          </a:solidFill>
+          <a:ln>
+            <a:noFill/>
+          </a:ln>
+        </p:spPr>
+        <p:txBody>
+          <a:bodyPr wrap="square" lIns="146304" tIns="82296">
+            <a:noAutofit/>
+          </a:bodyPr>
+          <a:lstStyle/>
+          <a:p>
+            <a:r>
+              <a:rPr sz="1500" b="0">
+                <a:solidFill>
+                  <a:srgbClr val="27500A"/>
+                </a:solidFill>
+                <a:latin typeface="Calibri"/>
+              </a:rPr>
+              <a:t>解法：升任一端到 4.0 前，先確認另一端 ≥ 2.1（upgrade guide 明訂雙向要求），否則協商結果沒有可用版本</a:t>
+            </a:r>
+          </a:p>
+        </p:txBody>
+      </p:sp>
+      <p:sp>
+        <p:nvSpPr>
+          <p:cNvPr id="8" name="TextBox 7"/>
+          <p:cNvSpPr txBox="1"/>
+          <p:nvPr/>
+        </p:nvSpPr>
+        <p:spPr>
+          <a:xfrm>
+            <a:off x="640080" y="4873752"/>
             <a:ext cx="10972800" cy="731520"/>
           </a:xfrm>
           <a:prstGeom prst="rect">
@@ -4981,14 +4989,48 @@
                 </a:solidFill>
                 <a:latin typeface="Calibri"/>
               </a:rPr>
-              <a:t>「硬送」指 client↔broker：自刻或有 bug 的 client 繞過協商；partition replication 的版本已由 finalized MV 事先決定，不會送出對方不懂的版本。</a:t>
-            </a:r>
-          </a:p>
-        </p:txBody>
-      </p:sp>
-      <p:sp>
-        <p:nvSpPr>
-          <p:cNvPr id="8" name="TextBox 7"/>
+              <a:t>取捨：0.8.0（2013）起九年保留每個版本——每個舊版本都是活的程式碼與測試面；4.0 用「斷 2018 年前的 client」換「刪九年的碼」，只有 major 版本邊界付得起。</a:t>
+            </a:r>
+          </a:p>
+        </p:txBody>
+      </p:sp>
+      <p:sp>
+        <p:nvSpPr>
+          <p:cNvPr id="9" name="TextBox 8"/>
+          <p:cNvSpPr txBox="1"/>
+          <p:nvPr/>
+        </p:nvSpPr>
+        <p:spPr>
+          <a:xfrm>
+            <a:off x="640080" y="5733288"/>
+            <a:ext cx="10972800" cy="731520"/>
+          </a:xfrm>
+          <a:prstGeom prst="rect">
+            <a:avLst/>
+          </a:prstGeom>
+          <a:noFill/>
+        </p:spPr>
+        <p:txBody>
+          <a:bodyPr wrap="square">
+            <a:noAutofit/>
+          </a:bodyPr>
+          <a:lstStyle/>
+          <a:p>
+            <a:r>
+              <a:rPr sz="1500" b="0">
+                <a:solidFill>
+                  <a:srgbClr val="5F5E5A"/>
+                </a:solidFill>
+                <a:latin typeface="Calibri"/>
+              </a:rPr>
+              <a:t>銜接（非本場）：finalize / 升降當下的錯誤（INVALID_UPDATE_VERSION 等）屬「運行時的版本升降」那場，本場不展開。</a:t>
+            </a:r>
+          </a:p>
+        </p:txBody>
+      </p:sp>
+      <p:sp>
+        <p:nvSpPr>
+          <p:cNvPr id="10" name="TextBox 9"/>
           <p:cNvSpPr txBox="1"/>
           <p:nvPr/>
         </p:nvSpPr>
@@ -5025,7 +5067,7 @@
                 <a:latin typeface="Courier New"/>
                 <a:hlinkClick r:id="rId3"/>
               </a:rPr>
-              <a:t>latestUsableVersion</a:t>
+              <a:t>upgrade.md:229</a:t>
             </a:r>
             <a:r>
               <a:rPr sz="1200" b="0">
@@ -5044,26 +5086,7 @@
                 <a:latin typeface="Courier New"/>
                 <a:hlinkClick r:id="rId4"/>
               </a:rPr>
-              <a:t>NetworkClient</a:t>
-            </a:r>
-            <a:r>
-              <a:rPr sz="1200" b="0">
-                <a:solidFill>
-                  <a:srgbClr val="8A8A8A"/>
-                </a:solidFill>
-                <a:latin typeface="Calibri"/>
-              </a:rPr>
-              <a:t>   ·   </a:t>
-            </a:r>
-            <a:r>
-              <a:rPr sz="1200" b="0" u="sng">
-                <a:solidFill>
-                  <a:srgbClr val="185FA5"/>
-                </a:solidFill>
-                <a:latin typeface="Courier New"/>
-                <a:hlinkClick r:id="rId5"/>
-              </a:rPr>
-              <a:t>RequestContext</a:t>
+              <a:t>FetchRequest.json validVersions</a:t>
             </a:r>
           </a:p>
         </p:txBody>
@@ -5115,7 +5138,7 @@
                 </a:solidFill>
                 <a:latin typeface="Calibri"/>
               </a:rPr>
-              <a:t>Part 2 · 失敗訊息</a:t>
+              <a:t>隨堂考 · 核心</a:t>
             </a:r>
           </a:p>
         </p:txBody>
@@ -5129,55 +5152,74 @@
         <p:spPr>
           <a:xfrm>
             <a:off x="640080" y="841248"/>
-            <a:ext cx="10972800" cy="1005840"/>
-          </a:xfrm>
-          <a:prstGeom prst="rect">
-            <a:avLst/>
-          </a:prstGeom>
-          <a:noFill/>
-        </p:spPr>
-        <p:txBody>
-          <a:bodyPr wrap="square">
-            <a:noAutofit/>
-          </a:bodyPr>
-          <a:lstStyle/>
-          <a:p>
-            <a:r>
-              <a:rPr sz="3200" b="1">
+            <a:ext cx="10972800" cy="1188720"/>
+          </a:xfrm>
+          <a:prstGeom prst="rect">
+            <a:avLst/>
+          </a:prstGeom>
+          <a:noFill/>
+        </p:spPr>
+        <p:txBody>
+          <a:bodyPr wrap="square">
+            <a:noAutofit/>
+          </a:bodyPr>
+          <a:lstStyle/>
+          <a:p>
+            <a:r>
+              <a:rPr sz="2600" b="1">
                 <a:solidFill>
                   <a:srgbClr val="1E2024"/>
                 </a:solidFill>
                 <a:latin typeface="Calibri"/>
               </a:rPr>
-              <a:t>版本截斷：為什麼「升一點點」不夠</a:t>
-            </a:r>
-          </a:p>
-        </p:txBody>
-      </p:sp>
-      <p:pic>
-        <p:nvPicPr>
-          <p:cNvPr id="4" name="Picture 3" descr="alert-triangle.png"/>
-          <p:cNvPicPr>
-            <a:picLocks noChangeAspect="1"/>
-          </p:cNvPicPr>
-          <p:nvPr/>
-        </p:nvPicPr>
-        <p:blipFill>
-          <a:blip r:embed="rId2"/>
-          <a:stretch>
-            <a:fillRect/>
-          </a:stretch>
-        </p:blipFill>
-        <p:spPr>
-          <a:xfrm>
-            <a:off x="658368" y="2176272"/>
-            <a:ext cx="274320" cy="274320"/>
-          </a:xfrm>
-          <a:prstGeom prst="rect">
-            <a:avLst/>
-          </a:prstGeom>
-        </p:spPr>
-      </p:pic>
+              <a:t>client 繞過協商、直接送出 broker 不支援的 API version，會怎樣？</a:t>
+            </a:r>
+          </a:p>
+        </p:txBody>
+      </p:sp>
+      <p:sp>
+        <p:nvSpPr>
+          <p:cNvPr id="4" name="TextBox 3"/>
+          <p:cNvSpPr txBox="1"/>
+          <p:nvPr/>
+        </p:nvSpPr>
+        <p:spPr>
+          <a:xfrm>
+            <a:off x="822960" y="2331720"/>
+            <a:ext cx="10515600" cy="493776"/>
+          </a:xfrm>
+          <a:prstGeom prst="rect">
+            <a:avLst/>
+          </a:prstGeom>
+          <a:noFill/>
+        </p:spPr>
+        <p:txBody>
+          <a:bodyPr wrap="square">
+            <a:noAutofit/>
+          </a:bodyPr>
+          <a:lstStyle/>
+          <a:p>
+            <a:r>
+              <a:rPr sz="1600" b="0">
+                <a:solidFill>
+                  <a:srgbClr val="1E2024"/>
+                </a:solidFill>
+                <a:latin typeface="Calibri"/>
+              </a:rPr>
+              <a:t>A.  </a:t>
+            </a:r>
+            <a:r>
+              <a:rPr sz="1600" b="0">
+                <a:solidFill>
+                  <a:srgbClr val="1E2024"/>
+                </a:solidFill>
+                <a:latin typeface="Calibri"/>
+              </a:rPr>
+              <a:t>一律回 UNSUPPORTED_VERSION 錯誤碼</a:t>
+            </a:r>
+          </a:p>
+        </p:txBody>
+      </p:sp>
       <p:sp>
         <p:nvSpPr>
           <p:cNvPr id="5" name="TextBox 4"/>
@@ -5186,7 +5228,7 @@
         </p:nvSpPr>
         <p:spPr>
           <a:xfrm>
-            <a:off x="1078992" y="2148840"/>
+            <a:off x="822960" y="2953512"/>
             <a:ext cx="10515600" cy="493776"/>
           </a:xfrm>
           <a:prstGeom prst="rect">
@@ -5201,13 +5243,22 @@
           <a:lstStyle/>
           <a:p>
             <a:r>
-              <a:rPr sz="1650" b="0">
+              <a:rPr sz="1600" b="0">
                 <a:solidFill>
                   <a:srgbClr val="1E2024"/>
                 </a:solidFill>
                 <a:latin typeface="Calibri"/>
               </a:rPr>
-              <a:t>前一頁「交集空」最容易被忽略的根因——舊 wire 版本被整批移除</a:t>
+              <a:t>B.  </a:t>
+            </a:r>
+            <a:r>
+              <a:rPr sz="1600" b="0">
+                <a:solidFill>
+                  <a:srgbClr val="1E2024"/>
+                </a:solidFill>
+                <a:latin typeface="Calibri"/>
+              </a:rPr>
+              <a:t>只有 ApiVersions 例外回錯誤碼+支援範圍；其他 API 直接關閉連線</a:t>
             </a:r>
           </a:p>
         </p:txBody>
@@ -5220,46 +5271,37 @@
         </p:nvSpPr>
         <p:spPr>
           <a:xfrm>
-            <a:off x="640080" y="2788920"/>
-            <a:ext cx="10972800" cy="822959"/>
-          </a:xfrm>
-          <a:prstGeom prst="rect">
-            <a:avLst/>
-          </a:prstGeom>
-          <a:solidFill>
-            <a:srgbClr val="F3F1EC"/>
-          </a:solidFill>
-          <a:ln w="6350">
-            <a:solidFill>
-              <a:srgbClr val="E3E0D8"/>
-            </a:solidFill>
-          </a:ln>
-        </p:spPr>
-        <p:txBody>
-          <a:bodyPr wrap="square" lIns="146304" tIns="91440" bIns="91440">
-            <a:noAutofit/>
-          </a:bodyPr>
-          <a:lstStyle/>
-          <a:p>
-            <a:r>
-              <a:rPr sz="1350" b="0">
-                <a:solidFill>
-                  <a:srgbClr val="2C2C2A"/>
-                </a:solidFill>
-                <a:latin typeface="Calibri"/>
-              </a:rPr>
-              <a:t>舊 wire API version 被整個移除，min 可 &gt; 0</a:t>
-            </a:r>
-          </a:p>
-          <a:p>
-            <a:r>
-              <a:rPr sz="1350" b="0">
-                <a:solidFill>
-                  <a:srgbClr val="2C2C2A"/>
-                </a:solidFill>
-                <a:latin typeface="Calibri"/>
-              </a:rPr>
-              <a:t>  Fetch：4–18（v0–3 在 4.0 移除）</a:t>
+            <a:off x="822960" y="3575304"/>
+            <a:ext cx="10515600" cy="493776"/>
+          </a:xfrm>
+          <a:prstGeom prst="rect">
+            <a:avLst/>
+          </a:prstGeom>
+          <a:noFill/>
+        </p:spPr>
+        <p:txBody>
+          <a:bodyPr wrap="square">
+            <a:noAutofit/>
+          </a:bodyPr>
+          <a:lstStyle/>
+          <a:p>
+            <a:r>
+              <a:rPr sz="1600" b="0">
+                <a:solidFill>
+                  <a:srgbClr val="1E2024"/>
+                </a:solidFill>
+                <a:latin typeface="Calibri"/>
+              </a:rPr>
+              <a:t>C.  </a:t>
+            </a:r>
+            <a:r>
+              <a:rPr sz="1600" b="0">
+                <a:solidFill>
+                  <a:srgbClr val="1E2024"/>
+                </a:solidFill>
+                <a:latin typeface="Calibri"/>
+              </a:rPr>
+              <a:t>broker 自動降版處理</a:t>
             </a:r>
           </a:p>
         </p:txBody>
@@ -5272,33 +5314,37 @@
         </p:nvSpPr>
         <p:spPr>
           <a:xfrm>
-            <a:off x="640080" y="3813048"/>
-            <a:ext cx="10972800" cy="877824"/>
-          </a:xfrm>
-          <a:prstGeom prst="rect">
-            <a:avLst/>
-          </a:prstGeom>
-          <a:solidFill>
-            <a:srgbClr val="E9F3DE"/>
-          </a:solidFill>
-          <a:ln>
-            <a:noFill/>
-          </a:ln>
-        </p:spPr>
-        <p:txBody>
-          <a:bodyPr wrap="square" lIns="146304" tIns="82296">
-            <a:noAutofit/>
-          </a:bodyPr>
-          <a:lstStyle/>
-          <a:p>
-            <a:r>
-              <a:rPr sz="1500" b="0">
-                <a:solidFill>
-                  <a:srgbClr val="27500A"/>
-                </a:solidFill>
-                <a:latin typeface="Calibri"/>
-              </a:rPr>
-              <a:t>解法：升任一端到 4.0 前，先確認另一端 ≥ 2.1（upgrade guide 明訂雙向要求），否則協商結果沒有可用版本</a:t>
+            <a:off x="822960" y="4197096"/>
+            <a:ext cx="10515600" cy="493776"/>
+          </a:xfrm>
+          <a:prstGeom prst="rect">
+            <a:avLst/>
+          </a:prstGeom>
+          <a:noFill/>
+        </p:spPr>
+        <p:txBody>
+          <a:bodyPr wrap="square">
+            <a:noAutofit/>
+          </a:bodyPr>
+          <a:lstStyle/>
+          <a:p>
+            <a:r>
+              <a:rPr sz="1600" b="0">
+                <a:solidFill>
+                  <a:srgbClr val="1E2024"/>
+                </a:solidFill>
+                <a:latin typeface="Calibri"/>
+              </a:rPr>
+              <a:t>D.  </a:t>
+            </a:r>
+            <a:r>
+              <a:rPr sz="1600" b="0">
+                <a:solidFill>
+                  <a:srgbClr val="1E2024"/>
+                </a:solidFill>
+                <a:latin typeface="Calibri"/>
+              </a:rPr>
+              <a:t>忽略版本照常處理</a:t>
             </a:r>
           </a:p>
         </p:txBody>
@@ -5311,125 +5357,28 @@
         </p:nvSpPr>
         <p:spPr>
           <a:xfrm>
-            <a:off x="640080" y="4873752"/>
-            <a:ext cx="10972800" cy="731520"/>
-          </a:xfrm>
-          <a:prstGeom prst="rect">
-            <a:avLst/>
-          </a:prstGeom>
-          <a:noFill/>
-        </p:spPr>
-        <p:txBody>
-          <a:bodyPr wrap="square">
-            <a:noAutofit/>
-          </a:bodyPr>
-          <a:lstStyle/>
-          <a:p>
-            <a:r>
-              <a:rPr sz="1500" b="0">
-                <a:solidFill>
-                  <a:srgbClr val="5F5E5A"/>
-                </a:solidFill>
-                <a:latin typeface="Calibri"/>
-              </a:rPr>
-              <a:t>取捨：0.8.0（2013）起九年保留每個版本——每個舊版本都是活的程式碼與測試面；4.0 用「斷 2018 年前的 client」換「刪九年的碼」，只有 major 版本邊界付得起。</a:t>
-            </a:r>
-          </a:p>
-        </p:txBody>
-      </p:sp>
-      <p:sp>
-        <p:nvSpPr>
-          <p:cNvPr id="9" name="TextBox 8"/>
-          <p:cNvSpPr txBox="1"/>
-          <p:nvPr/>
-        </p:nvSpPr>
-        <p:spPr>
-          <a:xfrm>
-            <a:off x="640080" y="5733288"/>
-            <a:ext cx="10972800" cy="731520"/>
-          </a:xfrm>
-          <a:prstGeom prst="rect">
-            <a:avLst/>
-          </a:prstGeom>
-          <a:noFill/>
-        </p:spPr>
-        <p:txBody>
-          <a:bodyPr wrap="square">
-            <a:noAutofit/>
-          </a:bodyPr>
-          <a:lstStyle/>
-          <a:p>
-            <a:r>
-              <a:rPr sz="1500" b="0">
-                <a:solidFill>
-                  <a:srgbClr val="5F5E5A"/>
-                </a:solidFill>
-                <a:latin typeface="Calibri"/>
-              </a:rPr>
-              <a:t>銜接（非本場）：finalize / 升降當下的錯誤（INVALID_UPDATE_VERSION 等）屬「運行時的版本升降」那場，本場不展開。</a:t>
-            </a:r>
-          </a:p>
-        </p:txBody>
-      </p:sp>
-      <p:sp>
-        <p:nvSpPr>
-          <p:cNvPr id="10" name="TextBox 9"/>
-          <p:cNvSpPr txBox="1"/>
-          <p:nvPr/>
-        </p:nvSpPr>
-        <p:spPr>
-          <a:xfrm>
-            <a:off x="640080" y="6400800"/>
-            <a:ext cx="10972800" cy="384048"/>
-          </a:xfrm>
-          <a:prstGeom prst="rect">
-            <a:avLst/>
-          </a:prstGeom>
-          <a:noFill/>
-        </p:spPr>
-        <p:txBody>
-          <a:bodyPr wrap="square">
-            <a:noAutofit/>
-          </a:bodyPr>
-          <a:lstStyle/>
-          <a:p>
-            <a:r>
-              <a:rPr sz="1200" b="1">
+            <a:off x="640080" y="4910327"/>
+            <a:ext cx="10972800" cy="914400"/>
+          </a:xfrm>
+          <a:prstGeom prst="rect">
+            <a:avLst/>
+          </a:prstGeom>
+          <a:noFill/>
+        </p:spPr>
+        <p:txBody>
+          <a:bodyPr wrap="square">
+            <a:noAutofit/>
+          </a:bodyPr>
+          <a:lstStyle/>
+          <a:p>
+            <a:r>
+              <a:rPr sz="1400" b="0">
                 <a:solidFill>
                   <a:srgbClr val="8A8A8A"/>
                 </a:solidFill>
                 <a:latin typeface="Calibri"/>
               </a:rPr>
-              <a:t>REF   </a:t>
-            </a:r>
-            <a:r>
-              <a:rPr sz="1200" b="0" u="sng">
-                <a:solidFill>
-                  <a:srgbClr val="185FA5"/>
-                </a:solidFill>
-                <a:latin typeface="Courier New"/>
-                <a:hlinkClick r:id="rId3"/>
-              </a:rPr>
-              <a:t>upgrade.md:229</a:t>
-            </a:r>
-            <a:r>
-              <a:rPr sz="1200" b="0">
-                <a:solidFill>
-                  <a:srgbClr val="8A8A8A"/>
-                </a:solidFill>
-                <a:latin typeface="Calibri"/>
-              </a:rPr>
-              <a:t>   ·   </a:t>
-            </a:r>
-            <a:r>
-              <a:rPr sz="1200" b="0" u="sng">
-                <a:solidFill>
-                  <a:srgbClr val="185FA5"/>
-                </a:solidFill>
-                <a:latin typeface="Courier New"/>
-                <a:hlinkClick r:id="rId4"/>
-              </a:rPr>
-              <a:t>FetchRequest.json validVersions</a:t>
+              <a:t>想一想 —— 下一頁公布答案</a:t>
             </a:r>
           </a:p>
         </p:txBody>
@@ -5481,7 +5430,7 @@
                 </a:solidFill>
                 <a:latin typeface="Calibri"/>
               </a:rPr>
-              <a:t>隨堂考 · 核心</a:t>
+              <a:t>隨堂考 · 核心　（正解）</a:t>
             </a:r>
           </a:p>
         </p:txBody>
@@ -5577,31 +5526,36 @@
           <a:prstGeom prst="rect">
             <a:avLst/>
           </a:prstGeom>
-          <a:noFill/>
-        </p:spPr>
-        <p:txBody>
-          <a:bodyPr wrap="square">
-            <a:noAutofit/>
-          </a:bodyPr>
-          <a:lstStyle/>
-          <a:p>
-            <a:r>
-              <a:rPr sz="1600" b="0">
-                <a:solidFill>
-                  <a:srgbClr val="1E2024"/>
+          <a:solidFill>
+            <a:srgbClr val="E9F3DE"/>
+          </a:solidFill>
+          <a:ln>
+            <a:noFill/>
+          </a:ln>
+        </p:spPr>
+        <p:txBody>
+          <a:bodyPr wrap="square" lIns="128016" tIns="54864">
+            <a:noAutofit/>
+          </a:bodyPr>
+          <a:lstStyle/>
+          <a:p>
+            <a:r>
+              <a:rPr sz="1600" b="1">
+                <a:solidFill>
+                  <a:srgbClr val="27500A"/>
                 </a:solidFill>
                 <a:latin typeface="Calibri"/>
               </a:rPr>
               <a:t>B.  </a:t>
             </a:r>
             <a:r>
-              <a:rPr sz="1600" b="0">
-                <a:solidFill>
-                  <a:srgbClr val="1E2024"/>
-                </a:solidFill>
-                <a:latin typeface="Calibri"/>
-              </a:rPr>
-              <a:t>只有 ApiVersions 例外回錯誤碼+支援範圍；其他 API 直接關閉連線</a:t>
+              <a:rPr sz="1600" b="1">
+                <a:solidFill>
+                  <a:srgbClr val="27500A"/>
+                </a:solidFill>
+                <a:latin typeface="Calibri"/>
+              </a:rPr>
+              <a:t>只有 ApiVersions 例外回錯誤碼+支援範圍；其他 API 直接關閉連線   ✓</a:t>
             </a:r>
           </a:p>
         </p:txBody>
@@ -5715,13 +5669,85 @@
           <a:lstStyle/>
           <a:p>
             <a:r>
+              <a:rPr sz="1400" b="1">
+                <a:solidFill>
+                  <a:srgbClr val="27500A"/>
+                </a:solidFill>
+                <a:latin typeface="Calibri"/>
+              </a:rPr>
+              <a:t>正解 B — </a:t>
+            </a:r>
+            <a:r>
               <a:rPr sz="1400" b="0">
                 <a:solidFill>
+                  <a:srgbClr val="1E2024"/>
+                </a:solidFill>
+                <a:latin typeface="Calibri"/>
+              </a:rPr>
+              <a:t>ApiVersions 是協商的第一支 request（此時雙方還不知道彼此版本），若它也關閉連線，client 永遠問不到支援範圍，故回 v0+錯誤碼讓 client 重新協商；其他 API 在 RequestContext 解析失敗、SocketServer 關閉連線。</a:t>
+            </a:r>
+          </a:p>
+        </p:txBody>
+      </p:sp>
+      <p:sp>
+        <p:nvSpPr>
+          <p:cNvPr id="9" name="TextBox 8"/>
+          <p:cNvSpPr txBox="1"/>
+          <p:nvPr/>
+        </p:nvSpPr>
+        <p:spPr>
+          <a:xfrm>
+            <a:off x="640080" y="6400800"/>
+            <a:ext cx="10972800" cy="384048"/>
+          </a:xfrm>
+          <a:prstGeom prst="rect">
+            <a:avLst/>
+          </a:prstGeom>
+          <a:noFill/>
+        </p:spPr>
+        <p:txBody>
+          <a:bodyPr wrap="square">
+            <a:noAutofit/>
+          </a:bodyPr>
+          <a:lstStyle/>
+          <a:p>
+            <a:r>
+              <a:rPr sz="1200" b="1">
+                <a:solidFill>
                   <a:srgbClr val="8A8A8A"/>
                 </a:solidFill>
                 <a:latin typeface="Calibri"/>
               </a:rPr>
-              <a:t>想一想 —— 下一頁公布答案</a:t>
+              <a:t>REF   </a:t>
+            </a:r>
+            <a:r>
+              <a:rPr sz="1200" b="0" u="sng">
+                <a:solidFill>
+                  <a:srgbClr val="185FA5"/>
+                </a:solidFill>
+                <a:latin typeface="Courier New"/>
+                <a:hlinkClick r:id="rId2"/>
+              </a:rPr>
+              <a:t>RequestContext.java:112</a:t>
+            </a:r>
+            <a:r>
+              <a:rPr sz="1200" b="0">
+                <a:solidFill>
+                  <a:srgbClr val="8A8A8A"/>
+                </a:solidFill>
+                <a:latin typeface="Calibri"/>
+              </a:rPr>
+              <a:t>   ·   </a:t>
+            </a:r>
+            <a:r>
+              <a:rPr sz="1200" b="0" u="sng">
+                <a:solidFill>
+                  <a:srgbClr val="185FA5"/>
+                </a:solidFill>
+                <a:latin typeface="Courier New"/>
+                <a:hlinkClick r:id="rId3"/>
+              </a:rPr>
+              <a:t>SocketServer.scala:781</a:t>
             </a:r>
           </a:p>
         </p:txBody>
@@ -5773,375 +5799,6 @@
                 </a:solidFill>
                 <a:latin typeface="Calibri"/>
               </a:rPr>
-              <a:t>隨堂考 · 核心　（正解）</a:t>
-            </a:r>
-          </a:p>
-        </p:txBody>
-      </p:sp>
-      <p:sp>
-        <p:nvSpPr>
-          <p:cNvPr id="3" name="TextBox 2"/>
-          <p:cNvSpPr txBox="1"/>
-          <p:nvPr/>
-        </p:nvSpPr>
-        <p:spPr>
-          <a:xfrm>
-            <a:off x="640080" y="841248"/>
-            <a:ext cx="10972800" cy="1188720"/>
-          </a:xfrm>
-          <a:prstGeom prst="rect">
-            <a:avLst/>
-          </a:prstGeom>
-          <a:noFill/>
-        </p:spPr>
-        <p:txBody>
-          <a:bodyPr wrap="square">
-            <a:noAutofit/>
-          </a:bodyPr>
-          <a:lstStyle/>
-          <a:p>
-            <a:r>
-              <a:rPr sz="2600" b="1">
-                <a:solidFill>
-                  <a:srgbClr val="1E2024"/>
-                </a:solidFill>
-                <a:latin typeface="Calibri"/>
-              </a:rPr>
-              <a:t>client 繞過協商、直接送出 broker 不支援的 API version，會怎樣？</a:t>
-            </a:r>
-          </a:p>
-        </p:txBody>
-      </p:sp>
-      <p:sp>
-        <p:nvSpPr>
-          <p:cNvPr id="4" name="TextBox 3"/>
-          <p:cNvSpPr txBox="1"/>
-          <p:nvPr/>
-        </p:nvSpPr>
-        <p:spPr>
-          <a:xfrm>
-            <a:off x="822960" y="2331720"/>
-            <a:ext cx="10515600" cy="493776"/>
-          </a:xfrm>
-          <a:prstGeom prst="rect">
-            <a:avLst/>
-          </a:prstGeom>
-          <a:noFill/>
-        </p:spPr>
-        <p:txBody>
-          <a:bodyPr wrap="square">
-            <a:noAutofit/>
-          </a:bodyPr>
-          <a:lstStyle/>
-          <a:p>
-            <a:r>
-              <a:rPr sz="1600" b="0">
-                <a:solidFill>
-                  <a:srgbClr val="1E2024"/>
-                </a:solidFill>
-                <a:latin typeface="Calibri"/>
-              </a:rPr>
-              <a:t>A.  </a:t>
-            </a:r>
-            <a:r>
-              <a:rPr sz="1600" b="0">
-                <a:solidFill>
-                  <a:srgbClr val="1E2024"/>
-                </a:solidFill>
-                <a:latin typeface="Calibri"/>
-              </a:rPr>
-              <a:t>一律回 UNSUPPORTED_VERSION 錯誤碼</a:t>
-            </a:r>
-          </a:p>
-        </p:txBody>
-      </p:sp>
-      <p:sp>
-        <p:nvSpPr>
-          <p:cNvPr id="5" name="TextBox 4"/>
-          <p:cNvSpPr txBox="1"/>
-          <p:nvPr/>
-        </p:nvSpPr>
-        <p:spPr>
-          <a:xfrm>
-            <a:off x="822960" y="2953512"/>
-            <a:ext cx="10515600" cy="493776"/>
-          </a:xfrm>
-          <a:prstGeom prst="rect">
-            <a:avLst/>
-          </a:prstGeom>
-          <a:solidFill>
-            <a:srgbClr val="E9F3DE"/>
-          </a:solidFill>
-          <a:ln>
-            <a:noFill/>
-          </a:ln>
-        </p:spPr>
-        <p:txBody>
-          <a:bodyPr wrap="square" lIns="128016" tIns="54864">
-            <a:noAutofit/>
-          </a:bodyPr>
-          <a:lstStyle/>
-          <a:p>
-            <a:r>
-              <a:rPr sz="1600" b="1">
-                <a:solidFill>
-                  <a:srgbClr val="27500A"/>
-                </a:solidFill>
-                <a:latin typeface="Calibri"/>
-              </a:rPr>
-              <a:t>B.  </a:t>
-            </a:r>
-            <a:r>
-              <a:rPr sz="1600" b="1">
-                <a:solidFill>
-                  <a:srgbClr val="27500A"/>
-                </a:solidFill>
-                <a:latin typeface="Calibri"/>
-              </a:rPr>
-              <a:t>只有 ApiVersions 例外回錯誤碼+支援範圍；其他 API 直接關閉連線   ✓</a:t>
-            </a:r>
-          </a:p>
-        </p:txBody>
-      </p:sp>
-      <p:sp>
-        <p:nvSpPr>
-          <p:cNvPr id="6" name="TextBox 5"/>
-          <p:cNvSpPr txBox="1"/>
-          <p:nvPr/>
-        </p:nvSpPr>
-        <p:spPr>
-          <a:xfrm>
-            <a:off x="822960" y="3575304"/>
-            <a:ext cx="10515600" cy="493776"/>
-          </a:xfrm>
-          <a:prstGeom prst="rect">
-            <a:avLst/>
-          </a:prstGeom>
-          <a:noFill/>
-        </p:spPr>
-        <p:txBody>
-          <a:bodyPr wrap="square">
-            <a:noAutofit/>
-          </a:bodyPr>
-          <a:lstStyle/>
-          <a:p>
-            <a:r>
-              <a:rPr sz="1600" b="0">
-                <a:solidFill>
-                  <a:srgbClr val="1E2024"/>
-                </a:solidFill>
-                <a:latin typeface="Calibri"/>
-              </a:rPr>
-              <a:t>C.  </a:t>
-            </a:r>
-            <a:r>
-              <a:rPr sz="1600" b="0">
-                <a:solidFill>
-                  <a:srgbClr val="1E2024"/>
-                </a:solidFill>
-                <a:latin typeface="Calibri"/>
-              </a:rPr>
-              <a:t>broker 自動降版處理</a:t>
-            </a:r>
-          </a:p>
-        </p:txBody>
-      </p:sp>
-      <p:sp>
-        <p:nvSpPr>
-          <p:cNvPr id="7" name="TextBox 6"/>
-          <p:cNvSpPr txBox="1"/>
-          <p:nvPr/>
-        </p:nvSpPr>
-        <p:spPr>
-          <a:xfrm>
-            <a:off x="822960" y="4197096"/>
-            <a:ext cx="10515600" cy="493776"/>
-          </a:xfrm>
-          <a:prstGeom prst="rect">
-            <a:avLst/>
-          </a:prstGeom>
-          <a:noFill/>
-        </p:spPr>
-        <p:txBody>
-          <a:bodyPr wrap="square">
-            <a:noAutofit/>
-          </a:bodyPr>
-          <a:lstStyle/>
-          <a:p>
-            <a:r>
-              <a:rPr sz="1600" b="0">
-                <a:solidFill>
-                  <a:srgbClr val="1E2024"/>
-                </a:solidFill>
-                <a:latin typeface="Calibri"/>
-              </a:rPr>
-              <a:t>D.  </a:t>
-            </a:r>
-            <a:r>
-              <a:rPr sz="1600" b="0">
-                <a:solidFill>
-                  <a:srgbClr val="1E2024"/>
-                </a:solidFill>
-                <a:latin typeface="Calibri"/>
-              </a:rPr>
-              <a:t>忽略版本照常處理</a:t>
-            </a:r>
-          </a:p>
-        </p:txBody>
-      </p:sp>
-      <p:sp>
-        <p:nvSpPr>
-          <p:cNvPr id="8" name="TextBox 7"/>
-          <p:cNvSpPr txBox="1"/>
-          <p:nvPr/>
-        </p:nvSpPr>
-        <p:spPr>
-          <a:xfrm>
-            <a:off x="640080" y="4910327"/>
-            <a:ext cx="10972800" cy="914400"/>
-          </a:xfrm>
-          <a:prstGeom prst="rect">
-            <a:avLst/>
-          </a:prstGeom>
-          <a:noFill/>
-        </p:spPr>
-        <p:txBody>
-          <a:bodyPr wrap="square">
-            <a:noAutofit/>
-          </a:bodyPr>
-          <a:lstStyle/>
-          <a:p>
-            <a:r>
-              <a:rPr sz="1400" b="1">
-                <a:solidFill>
-                  <a:srgbClr val="27500A"/>
-                </a:solidFill>
-                <a:latin typeface="Calibri"/>
-              </a:rPr>
-              <a:t>正解 B — </a:t>
-            </a:r>
-            <a:r>
-              <a:rPr sz="1400" b="0">
-                <a:solidFill>
-                  <a:srgbClr val="1E2024"/>
-                </a:solidFill>
-                <a:latin typeface="Calibri"/>
-              </a:rPr>
-              <a:t>ApiVersions 是協商的第一支 request（此時雙方還不知道彼此版本），若它也關閉連線，client 永遠問不到支援範圍，故回 v0+錯誤碼讓 client 重新協商；其他 API 在 RequestContext 解析失敗、SocketServer 關閉連線。</a:t>
-            </a:r>
-          </a:p>
-        </p:txBody>
-      </p:sp>
-      <p:sp>
-        <p:nvSpPr>
-          <p:cNvPr id="9" name="TextBox 8"/>
-          <p:cNvSpPr txBox="1"/>
-          <p:nvPr/>
-        </p:nvSpPr>
-        <p:spPr>
-          <a:xfrm>
-            <a:off x="640080" y="6400800"/>
-            <a:ext cx="10972800" cy="384048"/>
-          </a:xfrm>
-          <a:prstGeom prst="rect">
-            <a:avLst/>
-          </a:prstGeom>
-          <a:noFill/>
-        </p:spPr>
-        <p:txBody>
-          <a:bodyPr wrap="square">
-            <a:noAutofit/>
-          </a:bodyPr>
-          <a:lstStyle/>
-          <a:p>
-            <a:r>
-              <a:rPr sz="1200" b="1">
-                <a:solidFill>
-                  <a:srgbClr val="8A8A8A"/>
-                </a:solidFill>
-                <a:latin typeface="Calibri"/>
-              </a:rPr>
-              <a:t>REF   </a:t>
-            </a:r>
-            <a:r>
-              <a:rPr sz="1200" b="0" u="sng">
-                <a:solidFill>
-                  <a:srgbClr val="185FA5"/>
-                </a:solidFill>
-                <a:latin typeface="Courier New"/>
-                <a:hlinkClick r:id="rId2"/>
-              </a:rPr>
-              <a:t>RequestContext.java:112</a:t>
-            </a:r>
-            <a:r>
-              <a:rPr sz="1200" b="0">
-                <a:solidFill>
-                  <a:srgbClr val="8A8A8A"/>
-                </a:solidFill>
-                <a:latin typeface="Calibri"/>
-              </a:rPr>
-              <a:t>   ·   </a:t>
-            </a:r>
-            <a:r>
-              <a:rPr sz="1200" b="0" u="sng">
-                <a:solidFill>
-                  <a:srgbClr val="185FA5"/>
-                </a:solidFill>
-                <a:latin typeface="Courier New"/>
-                <a:hlinkClick r:id="rId3"/>
-              </a:rPr>
-              <a:t>SocketServer.scala:781</a:t>
-            </a:r>
-          </a:p>
-        </p:txBody>
-      </p:sp>
-    </p:spTree>
-  </p:cSld>
-  <p:clrMapOvr>
-    <a:masterClrMapping/>
-  </p:clrMapOvr>
-</p:sld>
-</file>
-
-<file path=ppt/slides/slide18.xml><?xml version="1.0" encoding="utf-8"?>
-<p:sld xmlns:a="http://schemas.openxmlformats.org/drawingml/2006/main" xmlns:p="http://schemas.openxmlformats.org/presentationml/2006/main" xmlns:r="http://schemas.openxmlformats.org/officeDocument/2006/relationships">
-  <p:cSld>
-    <p:spTree>
-      <p:nvGrpSpPr>
-        <p:cNvPr id="1" name=""/>
-        <p:cNvGrpSpPr/>
-        <p:nvPr/>
-      </p:nvGrpSpPr>
-      <p:grpSpPr/>
-      <p:sp>
-        <p:nvSpPr>
-          <p:cNvPr id="2" name="TextBox 1"/>
-          <p:cNvSpPr txBox="1"/>
-          <p:nvPr/>
-        </p:nvSpPr>
-        <p:spPr>
-          <a:xfrm>
-            <a:off x="640080" y="457200"/>
-            <a:ext cx="10972800" cy="365760"/>
-          </a:xfrm>
-          <a:prstGeom prst="rect">
-            <a:avLst/>
-          </a:prstGeom>
-          <a:noFill/>
-        </p:spPr>
-        <p:txBody>
-          <a:bodyPr wrap="square">
-            <a:noAutofit/>
-          </a:bodyPr>
-          <a:lstStyle/>
-          <a:p>
-            <a:r>
-              <a:rPr sz="1300" b="1">
-                <a:solidFill>
-                  <a:srgbClr val="185FA5"/>
-                </a:solidFill>
-                <a:latin typeface="Calibri"/>
-              </a:rPr>
               <a:t>Recap</a:t>
             </a:r>
           </a:p>
@@ -7866,7 +7523,7 @@
         <p:spPr>
           <a:xfrm>
             <a:off x="640080" y="5056632"/>
-            <a:ext cx="10972800" cy="1499616"/>
+            <a:ext cx="10972800" cy="1188720"/>
           </a:xfrm>
           <a:prstGeom prst="rect">
             <a:avLst/>
@@ -7891,7 +7548,7 @@
                 </a:solidFill>
                 <a:latin typeface="Calibri"/>
               </a:rPr>
-              <a:t>為什麼交給 MV，不各連線協商？協商能讓 broker 互相『讀得懂』——但讀得懂不代表跨版本行為正確（如 KIP-903 replica-epoch fencing 要全叢集一致生效，才擋得住舊 epoch 的 follower 進 ISR）。MV 讓 operator 一次原子切換、與滾 binary 脫鉤，這就是升級兩階段的由來</a:t>
+              <a:t>為什麼交給 MV，不各連線協商？協商能讓 broker 互相『讀得懂』——但讀得懂不代表跨版本行為正確（如 KIP-903 replica-epoch fencing 要全叢集一致生效，才擋得住舊 epoch 的 follower 進 ISR）</a:t>
             </a:r>
           </a:p>
         </p:txBody>
@@ -8840,7 +8497,7 @@
                 </a:solidFill>
                 <a:latin typeface="Calibri"/>
               </a:rPr>
-              <a:t>另一條更大的隱形帳單是相容性測試（下兩張細看）——每個版本、每個歷史 release 都得長期盯著。</a:t>
+              <a:t>另一條更大的隱形帳單是相容性測試（下一張細看）——每個版本、每個歷史 release 都得長期盯著。</a:t>
             </a:r>
           </a:p>
         </p:txBody>

</xml_diff>